<commit_message>
Simplifie l'offre : un seul Windows Server (AD, DNS, DHCP, GPO), administration via Tailscale, sans abonnement Proxmox ni sauvegarde
Co-Authored-By: Claude Opus 5.5 <noreply@anthropic.com>
Claude-Session: https://claude.ai/code/session_01FnPw3bDfKWoxE5ktD8jdcy
</commit_message>
<xml_diff>
--- a/proposition-serveur/Proposition_Serveur_Proxmox_WindowsServer.pptx
+++ b/proposition-serveur/Proposition_Serveur_Proxmox_WindowsServer.pptx
@@ -116,18 +116,18 @@
   <p:extLst>
     <p:ext uri="{521415D9-36F7-43E2-AB2F-B90AF26B5E84}">
       <p14:sectionLst xmlns:p14="http://schemas.microsoft.com/office/powerpoint/2010/main">
-        <p14:section name="Introduction" id="{a4b35d0f-1a45-78d8-3551-54b5c4c64f43}">
+        <p14:section name="Introduction" id="{531845ff-e435-1021-e2a8-de9532888a5a}">
           <p14:sldIdLst>
             <p14:sldId id="256"/>
             <p14:sldId id="257"/>
           </p14:sldIdLst>
         </p14:section>
-        <p14:section name="Architecture" id="{44f702a3-7792-4969-58eb-27c21362a23f}">
+        <p14:section name="Architecture" id="{02fb933c-06f8-335f-cff1-22cf8cf0f4b0}">
           <p14:sldIdLst>
             <p14:sldId id="258"/>
           </p14:sldIdLst>
         </p14:section>
-        <p14:section name="Chiffrage" id="{0eae6716-0788-0a06-789c-39c58114b044}">
+        <p14:section name="Chiffrage" id="{231008ae-1c29-e82b-d3a5-c8e5a55a0693}">
           <p14:sldIdLst>
             <p14:sldId id="259"/>
             <p14:sldId id="260"/>
@@ -136,12 +136,12 @@
             <p14:sldId id="263"/>
           </p14:sldIdLst>
         </p14:section>
-        <p14:section name="Bonus" id="{602681ad-17b1-d410-ed3b-14f0cfeabe1b}">
+        <p14:section name="Bonus" id="{d3b79514-d062-8d83-1091-922799da4130}">
           <p14:sldIdLst>
             <p14:sldId id="264"/>
           </p14:sldIdLst>
         </p14:section>
-        <p14:section name="Conclusion" id="{a982de02-e827-7c90-1884-f6959f4ef23b}">
+        <p14:section name="Conclusion" id="{f633fc03-2448-30ee-eb50-c648057322dc}">
           <p14:sldIdLst>
             <p14:sldId id="265"/>
           </p14:sldIdLst>
@@ -344,13 +344,13 @@
               <c:numCache>
                 <c:ptCount val="3"/>
                 <c:pt idx="0">
-                  <c:v>4950000</c:v>
+                  <c:v>2200000</c:v>
                 </c:pt>
                 <c:pt idx="1">
-                  <c:v>2925000</c:v>
+                  <c:v>1300000</c:v>
                 </c:pt>
                 <c:pt idx="2">
-                  <c:v>1200000</c:v>
+                  <c:v>750000</c:v>
                 </c:pt>
               </c:numCache>
             </c:numRef>
@@ -2341,7 +2341,7 @@
                   <a:schemeClr val="accent4"/>
                 </a:solidFill>
               </a:rPr>
-              <a:t>Serveur Proxmox + Windows Server pour une petite entreprise de 10 à 25 utilisateurs — et votre site web vitrine offert</a:t>
+              <a:t>Serveur Proxmox + Windows Server (Active Directory, DNS, DHCP, GPO) pour une petite entreprise de 10 à 25 utilisateurs — et votre site web vitrine offert</a:t>
             </a:r>
             <a:endParaRPr lang="en-US" sz="2000" dirty="0"/>
           </a:p>
@@ -2445,7 +2445,7 @@
                   <a:schemeClr val="accent4"/>
                 </a:solidFill>
               </a:rPr>
-              <a:t>1. Visite technique et validation du nombre d'utilisateurs   2. Signature du devis   3. Livraison et installation en 2 à 3 semaines</a:t>
+              <a:t>1. Valider le nombre d'utilisateurs et les GPO souhaitées   2. Définir plus tard sauvegarde et stockage   3. Signature et installation en 1 à 2 semaines</a:t>
             </a:r>
             <a:endParaRPr lang="en-US" sz="2000" dirty="0"/>
           </a:p>
@@ -2635,7 +2635,7 @@
                   <a:schemeClr val="tx2"/>
                 </a:solidFill>
               </a:rPr>
-              <a:t>Un serveur unique, virtualisé</a:t>
+              <a:t>Un serveur virtualisé</a:t>
             </a:r>
             <a:endParaRPr lang="en-US" sz="2000" dirty="0"/>
           </a:p>
@@ -2671,7 +2671,7 @@
                   <a:schemeClr val="tx1"/>
                 </a:solidFill>
               </a:rPr>
-              <a:t>Proxmox VE héberge tous vos services sur une seule machine robuste</a:t>
+              <a:t>Proxmox VE (gratuit) héberge Windows Server et laisse de la place pour évoluer</a:t>
             </a:r>
             <a:endParaRPr lang="en-US" sz="1500" dirty="0"/>
           </a:p>
@@ -2795,7 +2795,7 @@
                   <a:schemeClr val="tx2"/>
                 </a:solidFill>
               </a:rPr>
-              <a:t>Une administration centralisée</a:t>
+              <a:t>Des comptes centralisés</a:t>
             </a:r>
             <a:endParaRPr lang="en-US" sz="2000" dirty="0"/>
           </a:p>
@@ -2831,7 +2831,7 @@
                   <a:schemeClr val="tx1"/>
                 </a:solidFill>
               </a:rPr>
-              <a:t>Comptes, droits, postes et imprimantes gérés depuis Windows Server</a:t>
+              <a:t>Active Directory : un compte par employé, connexion sur n'importe quel poste</a:t>
             </a:r>
             <a:endParaRPr lang="en-US" sz="1500" dirty="0"/>
           </a:p>
@@ -2955,7 +2955,7 @@
                   <a:schemeClr val="tx2"/>
                 </a:solidFill>
               </a:rPr>
-              <a:t>Vos données protégées</a:t>
+              <a:t>Des postes maîtrisés (GPO)</a:t>
             </a:r>
             <a:endParaRPr lang="en-US" sz="2000" dirty="0"/>
           </a:p>
@@ -2991,7 +2991,7 @@
                   <a:schemeClr val="tx1"/>
                 </a:solidFill>
               </a:rPr>
-              <a:t>Sauvegardes automatiques quotidiennes, onduleur, RAID</a:t>
+              <a:t>Mots de passe, mises à jour, restrictions et paramètres appliqués automatiquement</a:t>
             </a:r>
             <a:endParaRPr lang="en-US" sz="1500" dirty="0"/>
           </a:p>
@@ -3115,7 +3115,7 @@
                   <a:schemeClr val="tx2"/>
                 </a:solidFill>
               </a:rPr>
-              <a:t>Votre vitrine sur le web</a:t>
+              <a:t>Une administration à distance</a:t>
             </a:r>
             <a:endParaRPr lang="en-US" sz="2000" dirty="0"/>
           </a:p>
@@ -3151,7 +3151,7 @@
                   <a:schemeClr val="tx1"/>
                 </a:solidFill>
               </a:rPr>
-              <a:t>Un site professionnel offert pour présenter l'entreprise</a:t>
+              <a:t>L'administrateur gère tout depuis n'importe où, en sécurité, via Tailscale</a:t>
             </a:r>
             <a:endParaRPr lang="en-US" sz="1500" dirty="0"/>
           </a:p>
@@ -3262,7 +3262,7 @@
                 <a:ea typeface="Cambria" pitchFamily="34" charset="-122"/>
                 <a:cs typeface="Cambria" pitchFamily="34" charset="-120"/>
               </a:rPr>
-              <a:t>Architecture : un hôte, quatre services</a:t>
+              <a:t>Architecture : simple et évolutive</a:t>
             </a:r>
             <a:endParaRPr lang="en-US" sz="3200" dirty="0"/>
           </a:p>
@@ -3277,7 +3277,7 @@
         <p:spPr>
           <a:xfrm>
             <a:off x="548640" y="1371600"/>
-            <a:ext cx="11064240" cy="731520"/>
+            <a:ext cx="7498080" cy="731520"/>
           </a:xfrm>
           <a:prstGeom prst="roundRect">
             <a:avLst>
@@ -3304,7 +3304,7 @@
         <p:spPr>
           <a:xfrm>
             <a:off x="548640" y="1371600"/>
-            <a:ext cx="11064240" cy="731520"/>
+            <a:ext cx="7498080" cy="731520"/>
           </a:xfrm>
           <a:prstGeom prst="rect">
             <a:avLst/>
@@ -3325,7 +3325,7 @@
                   <a:schemeClr val="bg1"/>
                 </a:solidFill>
               </a:rPr>
-              <a:t>Hôte physique — Proxmox VE (hyperviseur)</a:t>
+              <a:t>Serveur physique — Proxmox VE</a:t>
             </a:r>
             <a:endParaRPr lang="en-US" sz="2000" dirty="0"/>
           </a:p>
@@ -3340,11 +3340,11 @@
         <p:spPr>
           <a:xfrm>
             <a:off x="548640" y="2377440"/>
-            <a:ext cx="2651760" cy="2377440"/>
+            <a:ext cx="7498080" cy="2743200"/>
           </a:xfrm>
           <a:prstGeom prst="roundRect">
             <a:avLst>
-              <a:gd name="adj" fmla="val 4615"/>
+              <a:gd name="adj" fmla="val 4000"/>
             </a:avLst>
           </a:prstGeom>
           <a:solidFill>
@@ -3366,8 +3366,8 @@
         </p:nvSpPr>
         <p:spPr>
           <a:xfrm>
-            <a:off x="731520" y="2560320"/>
-            <a:ext cx="2286000" cy="548640"/>
+            <a:off x="822960" y="2560320"/>
+            <a:ext cx="6949440" cy="457200"/>
           </a:xfrm>
           <a:prstGeom prst="rect">
             <a:avLst/>
@@ -3383,27 +3383,54 @@
               <a:buNone/>
             </a:pPr>
             <a:r>
-              <a:rPr lang="en-US" sz="1400" b="1" dirty="0">
+              <a:rPr lang="en-US" sz="1800" b="1" dirty="0">
                 <a:solidFill>
                   <a:schemeClr val="accent1"/>
                 </a:solidFill>
               </a:rPr>
-              <a:t>VM 1 · Windows Server</a:t>
+              <a:t>VM · Windows Server 2025</a:t>
             </a:r>
-            <a:endParaRPr lang="en-US" sz="1400" dirty="0"/>
-          </a:p>
-        </p:txBody>
-      </p:sp>
-      <p:sp>
-        <p:nvSpPr>
-          <p:cNvPr id="7" name="Text 5"/>
+            <a:endParaRPr lang="en-US" sz="1800" dirty="0"/>
+          </a:p>
+        </p:txBody>
+      </p:sp>
+      <p:sp>
+        <p:nvSpPr>
+          <p:cNvPr id="7" name="Shape 5"/>
+          <p:cNvSpPr/>
+          <p:nvPr/>
+        </p:nvSpPr>
+        <p:spPr>
+          <a:xfrm>
+            <a:off x="822960" y="3200400"/>
+            <a:ext cx="1645920" cy="1645920"/>
+          </a:xfrm>
+          <a:prstGeom prst="roundRect">
+            <a:avLst>
+              <a:gd name="adj" fmla="val 6667"/>
+            </a:avLst>
+          </a:prstGeom>
+          <a:solidFill>
+            <a:schemeClr val="bg1"/>
+          </a:solidFill>
+          <a:ln w="12700">
+            <a:solidFill>
+              <a:schemeClr val="bg1"/>
+            </a:solidFill>
+            <a:prstDash val="solid"/>
+          </a:ln>
+        </p:spPr>
+      </p:sp>
+      <p:sp>
+        <p:nvSpPr>
+          <p:cNvPr id="8" name="Text 6"/>
           <p:cNvSpPr txBox="1"/>
           <p:nvPr/>
         </p:nvSpPr>
         <p:spPr>
           <a:xfrm>
-            <a:off x="731520" y="3154680"/>
-            <a:ext cx="2286000" cy="1463040"/>
+            <a:off x="914400" y="3337560"/>
+            <a:ext cx="1463040" cy="548640"/>
           </a:xfrm>
           <a:prstGeom prst="rect">
             <a:avLst/>
@@ -3412,386 +3439,449 @@
           <a:ln/>
         </p:spPr>
         <p:txBody>
-          <a:bodyPr wrap="square" lIns="0" tIns="0" rIns="0" bIns="0" rtlCol="0" anchor="t"/>
+          <a:bodyPr wrap="square" lIns="0" tIns="0" rIns="0" bIns="0" rtlCol="0" anchor="ctr"/>
+          <a:lstStyle/>
+          <a:p>
+            <a:pPr algn="ctr" indent="0" marL="0">
+              <a:buNone/>
+            </a:pPr>
+            <a:r>
+              <a:rPr lang="en-US" sz="1500" b="1" dirty="0">
+                <a:solidFill>
+                  <a:schemeClr val="tx2"/>
+                </a:solidFill>
+              </a:rPr>
+              <a:t>Active Directory</a:t>
+            </a:r>
+            <a:endParaRPr lang="en-US" sz="1500" dirty="0"/>
+          </a:p>
+        </p:txBody>
+      </p:sp>
+      <p:sp>
+        <p:nvSpPr>
+          <p:cNvPr id="9" name="Text 7"/>
+          <p:cNvSpPr txBox="1"/>
+          <p:nvPr/>
+        </p:nvSpPr>
+        <p:spPr>
+          <a:xfrm>
+            <a:off x="914400" y="3931920"/>
+            <a:ext cx="1463040" cy="731520"/>
+          </a:xfrm>
+          <a:prstGeom prst="rect">
+            <a:avLst/>
+          </a:prstGeom>
+          <a:noFill/>
+          <a:ln/>
+        </p:spPr>
+        <p:txBody>
+          <a:bodyPr wrap="square" lIns="0" tIns="0" rIns="0" bIns="0" rtlCol="0" anchor="ctr"/>
+          <a:lstStyle/>
+          <a:p>
+            <a:pPr algn="ctr" indent="0" marL="0">
+              <a:buNone/>
+            </a:pPr>
+            <a:r>
+              <a:rPr lang="en-US" sz="1300" dirty="0">
+                <a:solidFill>
+                  <a:schemeClr val="tx1"/>
+                </a:solidFill>
+              </a:rPr>
+              <a:t>Comptes et groupes</a:t>
+            </a:r>
+            <a:endParaRPr lang="en-US" sz="1300" dirty="0"/>
+          </a:p>
+        </p:txBody>
+      </p:sp>
+      <p:sp>
+        <p:nvSpPr>
+          <p:cNvPr id="10" name="Shape 8"/>
+          <p:cNvSpPr/>
+          <p:nvPr/>
+        </p:nvSpPr>
+        <p:spPr>
+          <a:xfrm>
+            <a:off x="2606040" y="3200400"/>
+            <a:ext cx="1645920" cy="1645920"/>
+          </a:xfrm>
+          <a:prstGeom prst="roundRect">
+            <a:avLst>
+              <a:gd name="adj" fmla="val 6667"/>
+            </a:avLst>
+          </a:prstGeom>
+          <a:solidFill>
+            <a:schemeClr val="bg1"/>
+          </a:solidFill>
+          <a:ln w="12700">
+            <a:solidFill>
+              <a:schemeClr val="bg1"/>
+            </a:solidFill>
+            <a:prstDash val="solid"/>
+          </a:ln>
+        </p:spPr>
+      </p:sp>
+      <p:sp>
+        <p:nvSpPr>
+          <p:cNvPr id="11" name="Text 9"/>
+          <p:cNvSpPr txBox="1"/>
+          <p:nvPr/>
+        </p:nvSpPr>
+        <p:spPr>
+          <a:xfrm>
+            <a:off x="2697480" y="3337560"/>
+            <a:ext cx="1463040" cy="548640"/>
+          </a:xfrm>
+          <a:prstGeom prst="rect">
+            <a:avLst/>
+          </a:prstGeom>
+          <a:noFill/>
+          <a:ln/>
+        </p:spPr>
+        <p:txBody>
+          <a:bodyPr wrap="square" lIns="0" tIns="0" rIns="0" bIns="0" rtlCol="0" anchor="ctr"/>
+          <a:lstStyle/>
+          <a:p>
+            <a:pPr algn="ctr" indent="0" marL="0">
+              <a:buNone/>
+            </a:pPr>
+            <a:r>
+              <a:rPr lang="en-US" sz="1500" b="1" dirty="0">
+                <a:solidFill>
+                  <a:schemeClr val="tx2"/>
+                </a:solidFill>
+              </a:rPr>
+              <a:t>DNS</a:t>
+            </a:r>
+            <a:endParaRPr lang="en-US" sz="1500" dirty="0"/>
+          </a:p>
+        </p:txBody>
+      </p:sp>
+      <p:sp>
+        <p:nvSpPr>
+          <p:cNvPr id="12" name="Text 10"/>
+          <p:cNvSpPr txBox="1"/>
+          <p:nvPr/>
+        </p:nvSpPr>
+        <p:spPr>
+          <a:xfrm>
+            <a:off x="2697480" y="3931920"/>
+            <a:ext cx="1463040" cy="731520"/>
+          </a:xfrm>
+          <a:prstGeom prst="rect">
+            <a:avLst/>
+          </a:prstGeom>
+          <a:noFill/>
+          <a:ln/>
+        </p:spPr>
+        <p:txBody>
+          <a:bodyPr wrap="square" lIns="0" tIns="0" rIns="0" bIns="0" rtlCol="0" anchor="ctr"/>
+          <a:lstStyle/>
+          <a:p>
+            <a:pPr algn="ctr" indent="0" marL="0">
+              <a:buNone/>
+            </a:pPr>
+            <a:r>
+              <a:rPr lang="en-US" sz="1300" dirty="0">
+                <a:solidFill>
+                  <a:schemeClr val="tx1"/>
+                </a:solidFill>
+              </a:rPr>
+              <a:t>Résolution des noms</a:t>
+            </a:r>
+            <a:endParaRPr lang="en-US" sz="1300" dirty="0"/>
+          </a:p>
+        </p:txBody>
+      </p:sp>
+      <p:sp>
+        <p:nvSpPr>
+          <p:cNvPr id="13" name="Shape 11"/>
+          <p:cNvSpPr/>
+          <p:nvPr/>
+        </p:nvSpPr>
+        <p:spPr>
+          <a:xfrm>
+            <a:off x="4389120" y="3200400"/>
+            <a:ext cx="1645920" cy="1645920"/>
+          </a:xfrm>
+          <a:prstGeom prst="roundRect">
+            <a:avLst>
+              <a:gd name="adj" fmla="val 6667"/>
+            </a:avLst>
+          </a:prstGeom>
+          <a:solidFill>
+            <a:schemeClr val="bg1"/>
+          </a:solidFill>
+          <a:ln w="12700">
+            <a:solidFill>
+              <a:schemeClr val="bg1"/>
+            </a:solidFill>
+            <a:prstDash val="solid"/>
+          </a:ln>
+        </p:spPr>
+      </p:sp>
+      <p:sp>
+        <p:nvSpPr>
+          <p:cNvPr id="14" name="Text 12"/>
+          <p:cNvSpPr txBox="1"/>
+          <p:nvPr/>
+        </p:nvSpPr>
+        <p:spPr>
+          <a:xfrm>
+            <a:off x="4480560" y="3337560"/>
+            <a:ext cx="1463040" cy="548640"/>
+          </a:xfrm>
+          <a:prstGeom prst="rect">
+            <a:avLst/>
+          </a:prstGeom>
+          <a:noFill/>
+          <a:ln/>
+        </p:spPr>
+        <p:txBody>
+          <a:bodyPr wrap="square" lIns="0" tIns="0" rIns="0" bIns="0" rtlCol="0" anchor="ctr"/>
+          <a:lstStyle/>
+          <a:p>
+            <a:pPr algn="ctr" indent="0" marL="0">
+              <a:buNone/>
+            </a:pPr>
+            <a:r>
+              <a:rPr lang="en-US" sz="1500" b="1" dirty="0">
+                <a:solidFill>
+                  <a:schemeClr val="tx2"/>
+                </a:solidFill>
+              </a:rPr>
+              <a:t>DHCP</a:t>
+            </a:r>
+            <a:endParaRPr lang="en-US" sz="1500" dirty="0"/>
+          </a:p>
+        </p:txBody>
+      </p:sp>
+      <p:sp>
+        <p:nvSpPr>
+          <p:cNvPr id="15" name="Text 13"/>
+          <p:cNvSpPr txBox="1"/>
+          <p:nvPr/>
+        </p:nvSpPr>
+        <p:spPr>
+          <a:xfrm>
+            <a:off x="4480560" y="3931920"/>
+            <a:ext cx="1463040" cy="731520"/>
+          </a:xfrm>
+          <a:prstGeom prst="rect">
+            <a:avLst/>
+          </a:prstGeom>
+          <a:noFill/>
+          <a:ln/>
+        </p:spPr>
+        <p:txBody>
+          <a:bodyPr wrap="square" lIns="0" tIns="0" rIns="0" bIns="0" rtlCol="0" anchor="ctr"/>
+          <a:lstStyle/>
+          <a:p>
+            <a:pPr algn="ctr" indent="0" marL="0">
+              <a:buNone/>
+            </a:pPr>
+            <a:r>
+              <a:rPr lang="en-US" sz="1300" dirty="0">
+                <a:solidFill>
+                  <a:schemeClr val="tx1"/>
+                </a:solidFill>
+              </a:rPr>
+              <a:t>Adresses IP des postes</a:t>
+            </a:r>
+            <a:endParaRPr lang="en-US" sz="1300" dirty="0"/>
+          </a:p>
+        </p:txBody>
+      </p:sp>
+      <p:sp>
+        <p:nvSpPr>
+          <p:cNvPr id="16" name="Shape 14"/>
+          <p:cNvSpPr/>
+          <p:nvPr/>
+        </p:nvSpPr>
+        <p:spPr>
+          <a:xfrm>
+            <a:off x="6172200" y="3200400"/>
+            <a:ext cx="1645920" cy="1645920"/>
+          </a:xfrm>
+          <a:prstGeom prst="roundRect">
+            <a:avLst>
+              <a:gd name="adj" fmla="val 6667"/>
+            </a:avLst>
+          </a:prstGeom>
+          <a:solidFill>
+            <a:schemeClr val="bg1"/>
+          </a:solidFill>
+          <a:ln w="12700">
+            <a:solidFill>
+              <a:schemeClr val="bg1"/>
+            </a:solidFill>
+            <a:prstDash val="solid"/>
+          </a:ln>
+        </p:spPr>
+      </p:sp>
+      <p:sp>
+        <p:nvSpPr>
+          <p:cNvPr id="17" name="Text 15"/>
+          <p:cNvSpPr txBox="1"/>
+          <p:nvPr/>
+        </p:nvSpPr>
+        <p:spPr>
+          <a:xfrm>
+            <a:off x="6263640" y="3337560"/>
+            <a:ext cx="1463040" cy="548640"/>
+          </a:xfrm>
+          <a:prstGeom prst="rect">
+            <a:avLst/>
+          </a:prstGeom>
+          <a:noFill/>
+          <a:ln/>
+        </p:spPr>
+        <p:txBody>
+          <a:bodyPr wrap="square" lIns="0" tIns="0" rIns="0" bIns="0" rtlCol="0" anchor="ctr"/>
+          <a:lstStyle/>
+          <a:p>
+            <a:pPr algn="ctr" indent="0" marL="0">
+              <a:buNone/>
+            </a:pPr>
+            <a:r>
+              <a:rPr lang="en-US" sz="1500" b="1" dirty="0">
+                <a:solidFill>
+                  <a:schemeClr val="tx2"/>
+                </a:solidFill>
+              </a:rPr>
+              <a:t>GPO</a:t>
+            </a:r>
+            <a:endParaRPr lang="en-US" sz="1500" dirty="0"/>
+          </a:p>
+        </p:txBody>
+      </p:sp>
+      <p:sp>
+        <p:nvSpPr>
+          <p:cNvPr id="18" name="Text 16"/>
+          <p:cNvSpPr txBox="1"/>
+          <p:nvPr/>
+        </p:nvSpPr>
+        <p:spPr>
+          <a:xfrm>
+            <a:off x="6263640" y="3931920"/>
+            <a:ext cx="1463040" cy="731520"/>
+          </a:xfrm>
+          <a:prstGeom prst="rect">
+            <a:avLst/>
+          </a:prstGeom>
+          <a:noFill/>
+          <a:ln/>
+        </p:spPr>
+        <p:txBody>
+          <a:bodyPr wrap="square" lIns="0" tIns="0" rIns="0" bIns="0" rtlCol="0" anchor="ctr"/>
+          <a:lstStyle/>
+          <a:p>
+            <a:pPr algn="ctr" indent="0" marL="0">
+              <a:buNone/>
+            </a:pPr>
+            <a:r>
+              <a:rPr lang="en-US" sz="1300" dirty="0">
+                <a:solidFill>
+                  <a:schemeClr val="tx1"/>
+                </a:solidFill>
+              </a:rPr>
+              <a:t>Règles sur les postes</a:t>
+            </a:r>
+            <a:endParaRPr lang="en-US" sz="1300" dirty="0"/>
+          </a:p>
+        </p:txBody>
+      </p:sp>
+      <p:sp>
+        <p:nvSpPr>
+          <p:cNvPr id="19" name="Shape 17"/>
+          <p:cNvSpPr/>
+          <p:nvPr/>
+        </p:nvSpPr>
+        <p:spPr>
+          <a:xfrm>
+            <a:off x="8412480" y="1371600"/>
+            <a:ext cx="3200400" cy="3749040"/>
+          </a:xfrm>
+          <a:prstGeom prst="roundRect">
+            <a:avLst>
+              <a:gd name="adj" fmla="val 3429"/>
+            </a:avLst>
+          </a:prstGeom>
+          <a:solidFill>
+            <a:schemeClr val="accent2"/>
+          </a:solidFill>
+          <a:ln w="12700">
+            <a:solidFill>
+              <a:schemeClr val="accent2"/>
+            </a:solidFill>
+            <a:prstDash val="solid"/>
+          </a:ln>
+        </p:spPr>
+      </p:sp>
+      <p:sp>
+        <p:nvSpPr>
+          <p:cNvPr id="20" name="Text 18"/>
+          <p:cNvSpPr txBox="1"/>
+          <p:nvPr/>
+        </p:nvSpPr>
+        <p:spPr>
+          <a:xfrm>
+            <a:off x="8641080" y="1645920"/>
+            <a:ext cx="2743200" cy="3200400"/>
+          </a:xfrm>
+          <a:prstGeom prst="rect">
+            <a:avLst/>
+          </a:prstGeom>
+          <a:noFill/>
+          <a:ln/>
+        </p:spPr>
+        <p:txBody>
+          <a:bodyPr wrap="square" rtlCol="0" anchor="t"/>
           <a:lstStyle/>
           <a:p>
             <a:pPr indent="0" marL="0">
+              <a:spcAft>
+                <a:spcPts val="1000"/>
+              </a:spcAft>
+              <a:buNone/>
+            </a:pPr>
+            <a:r>
+              <a:rPr lang="en-US" sz="1800" b="1" dirty="0">
+                <a:solidFill>
+                  <a:schemeClr val="bg1"/>
+                </a:solidFill>
+              </a:rPr>
+              <a:t>Administrateur à distance</a:t>
+            </a:r>
+            <a:endParaRPr lang="en-US" sz="1800" dirty="0"/>
+          </a:p>
+          <a:p>
+            <a:pPr indent="0" marL="0">
+              <a:spcAft>
+                <a:spcPts val="1000"/>
+              </a:spcAft>
               <a:buNone/>
             </a:pPr>
             <a:r>
               <a:rPr lang="en-US" sz="1500" dirty="0">
                 <a:solidFill>
-                  <a:schemeClr val="tx1"/>
+                  <a:schemeClr val="bg1"/>
                 </a:solidFill>
               </a:rPr>
-              <a:t>Contrôleur de domaine</a:t>
+              <a:t>Tunnel chiffré Tailscale vers le serveur : aucun port ouvert sur Internet</a:t>
             </a:r>
-            <a:endParaRPr lang="en-US" sz="1500" dirty="0"/>
-          </a:p>
-          <a:p>
-            <a:pPr indent="0" marL="0">
-              <a:buNone/>
-            </a:pPr>
-            <a:r>
-              <a:rPr lang="en-US" sz="1500" dirty="0">
-                <a:solidFill>
-                  <a:schemeClr val="tx1"/>
-                </a:solidFill>
-              </a:rPr>
-              <a:t>Active Directory, DNS, DHCP, GPO</a:t>
-            </a:r>
-            <a:endParaRPr lang="en-US" sz="1500" dirty="0"/>
-          </a:p>
-        </p:txBody>
-      </p:sp>
-      <p:sp>
-        <p:nvSpPr>
-          <p:cNvPr id="8" name="Shape 6"/>
-          <p:cNvSpPr/>
-          <p:nvPr/>
-        </p:nvSpPr>
-        <p:spPr>
-          <a:xfrm>
-            <a:off x="3364992" y="2377440"/>
-            <a:ext cx="2651760" cy="2377440"/>
-          </a:xfrm>
-          <a:prstGeom prst="roundRect">
-            <a:avLst>
-              <a:gd name="adj" fmla="val 4615"/>
-            </a:avLst>
-          </a:prstGeom>
-          <a:solidFill>
-            <a:schemeClr val="bg2"/>
-          </a:solidFill>
-          <a:ln w="12700">
-            <a:solidFill>
-              <a:schemeClr val="bg2"/>
-            </a:solidFill>
-            <a:prstDash val="solid"/>
-          </a:ln>
-        </p:spPr>
-      </p:sp>
-      <p:sp>
-        <p:nvSpPr>
-          <p:cNvPr id="9" name="Text 7"/>
+            <a:endParaRPr lang="en-US" sz="1800" dirty="0"/>
+          </a:p>
+        </p:txBody>
+      </p:sp>
+      <p:sp>
+        <p:nvSpPr>
+          <p:cNvPr id="21" name="Text 19"/>
           <p:cNvSpPr txBox="1"/>
           <p:nvPr/>
         </p:nvSpPr>
         <p:spPr>
           <a:xfrm>
-            <a:off x="3547872" y="2560320"/>
-            <a:ext cx="2286000" cy="548640"/>
-          </a:xfrm>
-          <a:prstGeom prst="rect">
-            <a:avLst/>
-          </a:prstGeom>
-          <a:noFill/>
-          <a:ln/>
-        </p:spPr>
-        <p:txBody>
-          <a:bodyPr wrap="square" lIns="0" tIns="0" rIns="0" bIns="0" rtlCol="0" anchor="ctr"/>
-          <a:lstStyle/>
-          <a:p>
-            <a:pPr indent="0" marL="0">
-              <a:buNone/>
-            </a:pPr>
-            <a:r>
-              <a:rPr lang="en-US" sz="1400" b="1" dirty="0">
-                <a:solidFill>
-                  <a:schemeClr val="accent1"/>
-                </a:solidFill>
-              </a:rPr>
-              <a:t>VM 2 · Windows Server</a:t>
-            </a:r>
-            <a:endParaRPr lang="en-US" sz="1400" dirty="0"/>
-          </a:p>
-        </p:txBody>
-      </p:sp>
-      <p:sp>
-        <p:nvSpPr>
-          <p:cNvPr id="10" name="Text 8"/>
-          <p:cNvSpPr txBox="1"/>
-          <p:nvPr/>
-        </p:nvSpPr>
-        <p:spPr>
-          <a:xfrm>
-            <a:off x="3547872" y="3154680"/>
-            <a:ext cx="2286000" cy="1463040"/>
-          </a:xfrm>
-          <a:prstGeom prst="rect">
-            <a:avLst/>
-          </a:prstGeom>
-          <a:noFill/>
-          <a:ln/>
-        </p:spPr>
-        <p:txBody>
-          <a:bodyPr wrap="square" lIns="0" tIns="0" rIns="0" bIns="0" rtlCol="0" anchor="t"/>
-          <a:lstStyle/>
-          <a:p>
-            <a:pPr indent="0" marL="0">
-              <a:buNone/>
-            </a:pPr>
-            <a:r>
-              <a:rPr lang="en-US" sz="1500" dirty="0">
-                <a:solidFill>
-                  <a:schemeClr val="tx1"/>
-                </a:solidFill>
-              </a:rPr>
-              <a:t>Serveur de fichiers</a:t>
-            </a:r>
-            <a:endParaRPr lang="en-US" sz="1500" dirty="0"/>
-          </a:p>
-          <a:p>
-            <a:pPr indent="0" marL="0">
-              <a:buNone/>
-            </a:pPr>
-            <a:r>
-              <a:rPr lang="en-US" sz="1500" dirty="0">
-                <a:solidFill>
-                  <a:schemeClr val="tx1"/>
-                </a:solidFill>
-              </a:rPr>
-              <a:t>Partages, droits, quotas, clichés</a:t>
-            </a:r>
-            <a:endParaRPr lang="en-US" sz="1500" dirty="0"/>
-          </a:p>
-        </p:txBody>
-      </p:sp>
-      <p:sp>
-        <p:nvSpPr>
-          <p:cNvPr id="11" name="Shape 9"/>
-          <p:cNvSpPr/>
-          <p:nvPr/>
-        </p:nvSpPr>
-        <p:spPr>
-          <a:xfrm>
-            <a:off x="6181344" y="2377440"/>
-            <a:ext cx="2651760" cy="2377440"/>
-          </a:xfrm>
-          <a:prstGeom prst="roundRect">
-            <a:avLst>
-              <a:gd name="adj" fmla="val 4615"/>
-            </a:avLst>
-          </a:prstGeom>
-          <a:solidFill>
-            <a:schemeClr val="bg2"/>
-          </a:solidFill>
-          <a:ln w="12700">
-            <a:solidFill>
-              <a:schemeClr val="bg2"/>
-            </a:solidFill>
-            <a:prstDash val="solid"/>
-          </a:ln>
-        </p:spPr>
-      </p:sp>
-      <p:sp>
-        <p:nvSpPr>
-          <p:cNvPr id="12" name="Text 10"/>
-          <p:cNvSpPr txBox="1"/>
-          <p:nvPr/>
-        </p:nvSpPr>
-        <p:spPr>
-          <a:xfrm>
-            <a:off x="6364224" y="2560320"/>
-            <a:ext cx="2286000" cy="548640"/>
-          </a:xfrm>
-          <a:prstGeom prst="rect">
-            <a:avLst/>
-          </a:prstGeom>
-          <a:noFill/>
-          <a:ln/>
-        </p:spPr>
-        <p:txBody>
-          <a:bodyPr wrap="square" lIns="0" tIns="0" rIns="0" bIns="0" rtlCol="0" anchor="ctr"/>
-          <a:lstStyle/>
-          <a:p>
-            <a:pPr indent="0" marL="0">
-              <a:buNone/>
-            </a:pPr>
-            <a:r>
-              <a:rPr lang="en-US" sz="1400" b="1" dirty="0">
-                <a:solidFill>
-                  <a:schemeClr val="accent1"/>
-                </a:solidFill>
-              </a:rPr>
-              <a:t>VM 3 · Windows Server</a:t>
-            </a:r>
-            <a:endParaRPr lang="en-US" sz="1400" dirty="0"/>
-          </a:p>
-        </p:txBody>
-      </p:sp>
-      <p:sp>
-        <p:nvSpPr>
-          <p:cNvPr id="13" name="Text 11"/>
-          <p:cNvSpPr txBox="1"/>
-          <p:nvPr/>
-        </p:nvSpPr>
-        <p:spPr>
-          <a:xfrm>
-            <a:off x="6364224" y="3154680"/>
-            <a:ext cx="2286000" cy="1463040"/>
-          </a:xfrm>
-          <a:prstGeom prst="rect">
-            <a:avLst/>
-          </a:prstGeom>
-          <a:noFill/>
-          <a:ln/>
-        </p:spPr>
-        <p:txBody>
-          <a:bodyPr wrap="square" lIns="0" tIns="0" rIns="0" bIns="0" rtlCol="0" anchor="t"/>
-          <a:lstStyle/>
-          <a:p>
-            <a:pPr indent="0" marL="0">
-              <a:buNone/>
-            </a:pPr>
-            <a:r>
-              <a:rPr lang="en-US" sz="1500" dirty="0">
-                <a:solidFill>
-                  <a:schemeClr val="tx1"/>
-                </a:solidFill>
-              </a:rPr>
-              <a:t>Bureau à distance (RDS)</a:t>
-            </a:r>
-            <a:endParaRPr lang="en-US" sz="1500" dirty="0"/>
-          </a:p>
-          <a:p>
-            <a:pPr indent="0" marL="0">
-              <a:buNone/>
-            </a:pPr>
-            <a:r>
-              <a:rPr lang="en-US" sz="1500" dirty="0">
-                <a:solidFill>
-                  <a:schemeClr val="tx1"/>
-                </a:solidFill>
-              </a:rPr>
-              <a:t>Applications métier, télétravail</a:t>
-            </a:r>
-            <a:endParaRPr lang="en-US" sz="1500" dirty="0"/>
-          </a:p>
-        </p:txBody>
-      </p:sp>
-      <p:sp>
-        <p:nvSpPr>
-          <p:cNvPr id="14" name="Shape 12"/>
-          <p:cNvSpPr/>
-          <p:nvPr/>
-        </p:nvSpPr>
-        <p:spPr>
-          <a:xfrm>
-            <a:off x="8997696" y="2377440"/>
-            <a:ext cx="2651760" cy="2377440"/>
-          </a:xfrm>
-          <a:prstGeom prst="roundRect">
-            <a:avLst>
-              <a:gd name="adj" fmla="val 4615"/>
-            </a:avLst>
-          </a:prstGeom>
-          <a:solidFill>
-            <a:schemeClr val="bg2"/>
-          </a:solidFill>
-          <a:ln w="12700">
-            <a:solidFill>
-              <a:schemeClr val="bg2"/>
-            </a:solidFill>
-            <a:prstDash val="solid"/>
-          </a:ln>
-        </p:spPr>
-      </p:sp>
-      <p:sp>
-        <p:nvSpPr>
-          <p:cNvPr id="15" name="Text 13"/>
-          <p:cNvSpPr txBox="1"/>
-          <p:nvPr/>
-        </p:nvSpPr>
-        <p:spPr>
-          <a:xfrm>
-            <a:off x="9180576" y="2560320"/>
-            <a:ext cx="2286000" cy="548640"/>
-          </a:xfrm>
-          <a:prstGeom prst="rect">
-            <a:avLst/>
-          </a:prstGeom>
-          <a:noFill/>
-          <a:ln/>
-        </p:spPr>
-        <p:txBody>
-          <a:bodyPr wrap="square" lIns="0" tIns="0" rIns="0" bIns="0" rtlCol="0" anchor="ctr"/>
-          <a:lstStyle/>
-          <a:p>
-            <a:pPr indent="0" marL="0">
-              <a:buNone/>
-            </a:pPr>
-            <a:r>
-              <a:rPr lang="en-US" sz="1400" b="1" dirty="0">
-                <a:solidFill>
-                  <a:schemeClr val="accent1"/>
-                </a:solidFill>
-              </a:rPr>
-              <a:t>Proxmox Backup Server</a:t>
-            </a:r>
-            <a:endParaRPr lang="en-US" sz="1400" dirty="0"/>
-          </a:p>
-        </p:txBody>
-      </p:sp>
-      <p:sp>
-        <p:nvSpPr>
-          <p:cNvPr id="16" name="Text 14"/>
-          <p:cNvSpPr txBox="1"/>
-          <p:nvPr/>
-        </p:nvSpPr>
-        <p:spPr>
-          <a:xfrm>
-            <a:off x="9180576" y="3154680"/>
-            <a:ext cx="2286000" cy="1463040"/>
-          </a:xfrm>
-          <a:prstGeom prst="rect">
-            <a:avLst/>
-          </a:prstGeom>
-          <a:noFill/>
-          <a:ln/>
-        </p:spPr>
-        <p:txBody>
-          <a:bodyPr wrap="square" lIns="0" tIns="0" rIns="0" bIns="0" rtlCol="0" anchor="t"/>
-          <a:lstStyle/>
-          <a:p>
-            <a:pPr indent="0" marL="0">
-              <a:buNone/>
-            </a:pPr>
-            <a:r>
-              <a:rPr lang="en-US" sz="1500" dirty="0">
-                <a:solidFill>
-                  <a:schemeClr val="tx1"/>
-                </a:solidFill>
-              </a:rPr>
-              <a:t>Sauvegarde</a:t>
-            </a:r>
-            <a:endParaRPr lang="en-US" sz="1500" dirty="0"/>
-          </a:p>
-          <a:p>
-            <a:pPr indent="0" marL="0">
-              <a:buNone/>
-            </a:pPr>
-            <a:r>
-              <a:rPr lang="en-US" sz="1500" dirty="0">
-                <a:solidFill>
-                  <a:schemeClr val="tx1"/>
-                </a:solidFill>
-              </a:rPr>
-              <a:t>Copies quotidiennes vers NAS</a:t>
-            </a:r>
-            <a:endParaRPr lang="en-US" sz="1500" dirty="0"/>
-          </a:p>
-        </p:txBody>
-      </p:sp>
-      <p:sp>
-        <p:nvSpPr>
-          <p:cNvPr id="17" name="Text 15"/>
-          <p:cNvSpPr txBox="1"/>
-          <p:nvPr/>
-        </p:nvSpPr>
-        <p:spPr>
-          <a:xfrm>
-            <a:off x="548640" y="5029200"/>
+            <a:off x="548640" y="5394960"/>
             <a:ext cx="11064240" cy="548640"/>
           </a:xfrm>
           <a:prstGeom prst="rect">
@@ -3813,7 +3903,7 @@
                   <a:schemeClr val="accent6"/>
                 </a:solidFill>
               </a:rPr>
-              <a:t>Postes clients (10–25) · NAS de sauvegarde · Onduleur · Switch réseau</a:t>
+              <a:t>Postes des employés joints au domaine (10–25)</a:t>
             </a:r>
             <a:endParaRPr lang="en-US" sz="1600" dirty="0"/>
           </a:p>
@@ -4095,7 +4185,7 @@
                             <a:schemeClr val="tx1"/>
                           </a:solidFill>
                         </a:rPr>
-                        <a:t>Serveur tour (Dell T360 / HPE ML110) – Xeon 8 cœurs, 64 Go RAM, 2×960 Go SSD RAID1 + 2×4 To</a:t>
+                        <a:t>Serveur tour (Dell T160 / HPE ML30) – Xeon, 32 Go RAM, 2×960 Go SSD en RAID1</a:t>
                       </a:r>
                       <a:endParaRPr lang="en-US" sz="1500" dirty="0"/>
                     </a:p>
@@ -4153,361 +4243,7 @@
                             <a:schemeClr val="tx1"/>
                           </a:solidFill>
                         </a:rPr>
-                        <a:t>3 500 000 FCFA</a:t>
-                      </a:r>
-                      <a:endParaRPr lang="en-US" sz="1500" dirty="0"/>
-                    </a:p>
-                  </a:txBody>
-                  <a:tcPr marL="91440" marR="91440" marT="45720" marB="45720" anchor="ctr">
-                    <a:lnL w="6350" cap="flat" cmpd="sng" algn="ctr">
-                      <a:solidFill>
-                        <a:srgbClr val="C9D6D3"/>
-                      </a:solidFill>
-                      <a:prstDash val="solid"/>
-                      <a:round/>
-                      <a:headEnd type="none" w="med" len="med"/>
-                      <a:tailEnd type="none" w="med" len="med"/>
-                    </a:lnL>
-                    <a:lnR w="6350" cap="flat" cmpd="sng" algn="ctr">
-                      <a:solidFill>
-                        <a:srgbClr val="C9D6D3"/>
-                      </a:solidFill>
-                      <a:prstDash val="solid"/>
-                      <a:round/>
-                      <a:headEnd type="none" w="med" len="med"/>
-                      <a:tailEnd type="none" w="med" len="med"/>
-                    </a:lnR>
-                    <a:lnT w="6350" cap="flat" cmpd="sng" algn="ctr">
-                      <a:solidFill>
-                        <a:srgbClr val="C9D6D3"/>
-                      </a:solidFill>
-                      <a:prstDash val="solid"/>
-                      <a:round/>
-                      <a:headEnd type="none" w="med" len="med"/>
-                      <a:tailEnd type="none" w="med" len="med"/>
-                    </a:lnT>
-                    <a:lnB w="6350" cap="flat" cmpd="sng" algn="ctr">
-                      <a:solidFill>
-                        <a:srgbClr val="C9D6D3"/>
-                      </a:solidFill>
-                      <a:prstDash val="solid"/>
-                      <a:round/>
-                      <a:headEnd type="none" w="med" len="med"/>
-                      <a:tailEnd type="none" w="med" len="med"/>
-                    </a:lnB>
-                  </a:tcPr>
-                </a:tc>
-              </a:tr>
-              <a:tr h="548640">
-                <a:tc>
-                  <a:txBody>
-                    <a:bodyPr/>
-                    <a:lstStyle/>
-                    <a:p>
-                      <a:pPr indent="0" marL="0">
-                        <a:buNone/>
-                      </a:pPr>
-                      <a:r>
-                        <a:rPr lang="en-US" sz="1500" dirty="0">
-                          <a:solidFill>
-                            <a:schemeClr val="tx1"/>
-                          </a:solidFill>
-                        </a:rPr>
-                        <a:t>NAS de sauvegarde 2 baies + 2×4 To</a:t>
-                      </a:r>
-                      <a:endParaRPr lang="en-US" sz="1500" dirty="0"/>
-                    </a:p>
-                  </a:txBody>
-                  <a:tcPr marL="91440" marR="91440" marT="45720" marB="45720" anchor="ctr">
-                    <a:lnL w="6350" cap="flat" cmpd="sng" algn="ctr">
-                      <a:solidFill>
-                        <a:srgbClr val="C9D6D3"/>
-                      </a:solidFill>
-                      <a:prstDash val="solid"/>
-                      <a:round/>
-                      <a:headEnd type="none" w="med" len="med"/>
-                      <a:tailEnd type="none" w="med" len="med"/>
-                    </a:lnL>
-                    <a:lnR w="6350" cap="flat" cmpd="sng" algn="ctr">
-                      <a:solidFill>
-                        <a:srgbClr val="C9D6D3"/>
-                      </a:solidFill>
-                      <a:prstDash val="solid"/>
-                      <a:round/>
-                      <a:headEnd type="none" w="med" len="med"/>
-                      <a:tailEnd type="none" w="med" len="med"/>
-                    </a:lnR>
-                    <a:lnT w="6350" cap="flat" cmpd="sng" algn="ctr">
-                      <a:solidFill>
-                        <a:srgbClr val="C9D6D3"/>
-                      </a:solidFill>
-                      <a:prstDash val="solid"/>
-                      <a:round/>
-                      <a:headEnd type="none" w="med" len="med"/>
-                      <a:tailEnd type="none" w="med" len="med"/>
-                    </a:lnT>
-                    <a:lnB w="6350" cap="flat" cmpd="sng" algn="ctr">
-                      <a:solidFill>
-                        <a:srgbClr val="C9D6D3"/>
-                      </a:solidFill>
-                      <a:prstDash val="solid"/>
-                      <a:round/>
-                      <a:headEnd type="none" w="med" len="med"/>
-                      <a:tailEnd type="none" w="med" len="med"/>
-                    </a:lnB>
-                  </a:tcPr>
-                </a:tc>
-                <a:tc>
-                  <a:txBody>
-                    <a:bodyPr/>
-                    <a:lstStyle/>
-                    <a:p>
-                      <a:pPr algn="r" indent="0" marL="0">
-                        <a:buNone/>
-                      </a:pPr>
-                      <a:r>
-                        <a:rPr lang="en-US" sz="1500" dirty="0">
-                          <a:solidFill>
-                            <a:schemeClr val="tx1"/>
-                          </a:solidFill>
-                        </a:rPr>
-                        <a:t>650 000 FCFA</a:t>
-                      </a:r>
-                      <a:endParaRPr lang="en-US" sz="1500" dirty="0"/>
-                    </a:p>
-                  </a:txBody>
-                  <a:tcPr marL="91440" marR="91440" marT="45720" marB="45720" anchor="ctr">
-                    <a:lnL w="6350" cap="flat" cmpd="sng" algn="ctr">
-                      <a:solidFill>
-                        <a:srgbClr val="C9D6D3"/>
-                      </a:solidFill>
-                      <a:prstDash val="solid"/>
-                      <a:round/>
-                      <a:headEnd type="none" w="med" len="med"/>
-                      <a:tailEnd type="none" w="med" len="med"/>
-                    </a:lnL>
-                    <a:lnR w="6350" cap="flat" cmpd="sng" algn="ctr">
-                      <a:solidFill>
-                        <a:srgbClr val="C9D6D3"/>
-                      </a:solidFill>
-                      <a:prstDash val="solid"/>
-                      <a:round/>
-                      <a:headEnd type="none" w="med" len="med"/>
-                      <a:tailEnd type="none" w="med" len="med"/>
-                    </a:lnR>
-                    <a:lnT w="6350" cap="flat" cmpd="sng" algn="ctr">
-                      <a:solidFill>
-                        <a:srgbClr val="C9D6D3"/>
-                      </a:solidFill>
-                      <a:prstDash val="solid"/>
-                      <a:round/>
-                      <a:headEnd type="none" w="med" len="med"/>
-                      <a:tailEnd type="none" w="med" len="med"/>
-                    </a:lnT>
-                    <a:lnB w="6350" cap="flat" cmpd="sng" algn="ctr">
-                      <a:solidFill>
-                        <a:srgbClr val="C9D6D3"/>
-                      </a:solidFill>
-                      <a:prstDash val="solid"/>
-                      <a:round/>
-                      <a:headEnd type="none" w="med" len="med"/>
-                      <a:tailEnd type="none" w="med" len="med"/>
-                    </a:lnB>
-                  </a:tcPr>
-                </a:tc>
-              </a:tr>
-              <a:tr h="548640">
-                <a:tc>
-                  <a:txBody>
-                    <a:bodyPr/>
-                    <a:lstStyle/>
-                    <a:p>
-                      <a:pPr indent="0" marL="0">
-                        <a:buNone/>
-                      </a:pPr>
-                      <a:r>
-                        <a:rPr lang="en-US" sz="1500" dirty="0">
-                          <a:solidFill>
-                            <a:schemeClr val="tx1"/>
-                          </a:solidFill>
-                        </a:rPr>
-                        <a:t>Onduleur 1500 VA</a:t>
-                      </a:r>
-                      <a:endParaRPr lang="en-US" sz="1500" dirty="0"/>
-                    </a:p>
-                  </a:txBody>
-                  <a:tcPr marL="91440" marR="91440" marT="45720" marB="45720" anchor="ctr">
-                    <a:lnL w="6350" cap="flat" cmpd="sng" algn="ctr">
-                      <a:solidFill>
-                        <a:srgbClr val="C9D6D3"/>
-                      </a:solidFill>
-                      <a:prstDash val="solid"/>
-                      <a:round/>
-                      <a:headEnd type="none" w="med" len="med"/>
-                      <a:tailEnd type="none" w="med" len="med"/>
-                    </a:lnL>
-                    <a:lnR w="6350" cap="flat" cmpd="sng" algn="ctr">
-                      <a:solidFill>
-                        <a:srgbClr val="C9D6D3"/>
-                      </a:solidFill>
-                      <a:prstDash val="solid"/>
-                      <a:round/>
-                      <a:headEnd type="none" w="med" len="med"/>
-                      <a:tailEnd type="none" w="med" len="med"/>
-                    </a:lnR>
-                    <a:lnT w="6350" cap="flat" cmpd="sng" algn="ctr">
-                      <a:solidFill>
-                        <a:srgbClr val="C9D6D3"/>
-                      </a:solidFill>
-                      <a:prstDash val="solid"/>
-                      <a:round/>
-                      <a:headEnd type="none" w="med" len="med"/>
-                      <a:tailEnd type="none" w="med" len="med"/>
-                    </a:lnT>
-                    <a:lnB w="6350" cap="flat" cmpd="sng" algn="ctr">
-                      <a:solidFill>
-                        <a:srgbClr val="C9D6D3"/>
-                      </a:solidFill>
-                      <a:prstDash val="solid"/>
-                      <a:round/>
-                      <a:headEnd type="none" w="med" len="med"/>
-                      <a:tailEnd type="none" w="med" len="med"/>
-                    </a:lnB>
-                  </a:tcPr>
-                </a:tc>
-                <a:tc>
-                  <a:txBody>
-                    <a:bodyPr/>
-                    <a:lstStyle/>
-                    <a:p>
-                      <a:pPr algn="r" indent="0" marL="0">
-                        <a:buNone/>
-                      </a:pPr>
-                      <a:r>
-                        <a:rPr lang="en-US" sz="1500" dirty="0">
-                          <a:solidFill>
-                            <a:schemeClr val="tx1"/>
-                          </a:solidFill>
-                        </a:rPr>
-                        <a:t>450 000 FCFA</a:t>
-                      </a:r>
-                      <a:endParaRPr lang="en-US" sz="1500" dirty="0"/>
-                    </a:p>
-                  </a:txBody>
-                  <a:tcPr marL="91440" marR="91440" marT="45720" marB="45720" anchor="ctr">
-                    <a:lnL w="6350" cap="flat" cmpd="sng" algn="ctr">
-                      <a:solidFill>
-                        <a:srgbClr val="C9D6D3"/>
-                      </a:solidFill>
-                      <a:prstDash val="solid"/>
-                      <a:round/>
-                      <a:headEnd type="none" w="med" len="med"/>
-                      <a:tailEnd type="none" w="med" len="med"/>
-                    </a:lnL>
-                    <a:lnR w="6350" cap="flat" cmpd="sng" algn="ctr">
-                      <a:solidFill>
-                        <a:srgbClr val="C9D6D3"/>
-                      </a:solidFill>
-                      <a:prstDash val="solid"/>
-                      <a:round/>
-                      <a:headEnd type="none" w="med" len="med"/>
-                      <a:tailEnd type="none" w="med" len="med"/>
-                    </a:lnR>
-                    <a:lnT w="6350" cap="flat" cmpd="sng" algn="ctr">
-                      <a:solidFill>
-                        <a:srgbClr val="C9D6D3"/>
-                      </a:solidFill>
-                      <a:prstDash val="solid"/>
-                      <a:round/>
-                      <a:headEnd type="none" w="med" len="med"/>
-                      <a:tailEnd type="none" w="med" len="med"/>
-                    </a:lnT>
-                    <a:lnB w="6350" cap="flat" cmpd="sng" algn="ctr">
-                      <a:solidFill>
-                        <a:srgbClr val="C9D6D3"/>
-                      </a:solidFill>
-                      <a:prstDash val="solid"/>
-                      <a:round/>
-                      <a:headEnd type="none" w="med" len="med"/>
-                      <a:tailEnd type="none" w="med" len="med"/>
-                    </a:lnB>
-                  </a:tcPr>
-                </a:tc>
-              </a:tr>
-              <a:tr h="548640">
-                <a:tc>
-                  <a:txBody>
-                    <a:bodyPr/>
-                    <a:lstStyle/>
-                    <a:p>
-                      <a:pPr indent="0" marL="0">
-                        <a:buNone/>
-                      </a:pPr>
-                      <a:r>
-                        <a:rPr lang="en-US" sz="1500" dirty="0">
-                          <a:solidFill>
-                            <a:schemeClr val="tx1"/>
-                          </a:solidFill>
-                        </a:rPr>
-                        <a:t>Switch 24 ports gigabit + câblage / petit rack</a:t>
-                      </a:r>
-                      <a:endParaRPr lang="en-US" sz="1500" dirty="0"/>
-                    </a:p>
-                  </a:txBody>
-                  <a:tcPr marL="91440" marR="91440" marT="45720" marB="45720" anchor="ctr">
-                    <a:lnL w="6350" cap="flat" cmpd="sng" algn="ctr">
-                      <a:solidFill>
-                        <a:srgbClr val="C9D6D3"/>
-                      </a:solidFill>
-                      <a:prstDash val="solid"/>
-                      <a:round/>
-                      <a:headEnd type="none" w="med" len="med"/>
-                      <a:tailEnd type="none" w="med" len="med"/>
-                    </a:lnL>
-                    <a:lnR w="6350" cap="flat" cmpd="sng" algn="ctr">
-                      <a:solidFill>
-                        <a:srgbClr val="C9D6D3"/>
-                      </a:solidFill>
-                      <a:prstDash val="solid"/>
-                      <a:round/>
-                      <a:headEnd type="none" w="med" len="med"/>
-                      <a:tailEnd type="none" w="med" len="med"/>
-                    </a:lnR>
-                    <a:lnT w="6350" cap="flat" cmpd="sng" algn="ctr">
-                      <a:solidFill>
-                        <a:srgbClr val="C9D6D3"/>
-                      </a:solidFill>
-                      <a:prstDash val="solid"/>
-                      <a:round/>
-                      <a:headEnd type="none" w="med" len="med"/>
-                      <a:tailEnd type="none" w="med" len="med"/>
-                    </a:lnT>
-                    <a:lnB w="6350" cap="flat" cmpd="sng" algn="ctr">
-                      <a:solidFill>
-                        <a:srgbClr val="C9D6D3"/>
-                      </a:solidFill>
-                      <a:prstDash val="solid"/>
-                      <a:round/>
-                      <a:headEnd type="none" w="med" len="med"/>
-                      <a:tailEnd type="none" w="med" len="med"/>
-                    </a:lnB>
-                  </a:tcPr>
-                </a:tc>
-                <a:tc>
-                  <a:txBody>
-                    <a:bodyPr/>
-                    <a:lstStyle/>
-                    <a:p>
-                      <a:pPr algn="r" indent="0" marL="0">
-                        <a:buNone/>
-                      </a:pPr>
-                      <a:r>
-                        <a:rPr lang="en-US" sz="1500" dirty="0">
-                          <a:solidFill>
-                            <a:schemeClr val="tx1"/>
-                          </a:solidFill>
-                        </a:rPr>
-                        <a:t>350 000 FCFA</a:t>
+                        <a:t>2 200 000 FCFA</a:t>
                       </a:r>
                       <a:endParaRPr lang="en-US" sz="1500" dirty="0"/>
                     </a:p>
@@ -4628,7 +4364,7 @@
                             <a:schemeClr val="bg1"/>
                           </a:solidFill>
                         </a:rPr>
-                        <a:t>4 950 000 FCFA</a:t>
+                        <a:t>2 200 000 FCFA</a:t>
                       </a:r>
                       <a:endParaRPr lang="en-US" sz="1600" dirty="0"/>
                     </a:p>
@@ -4680,6 +4416,42 @@
           </a:graphicData>
         </a:graphic>
       </p:graphicFrame>
+      <p:sp>
+        <p:nvSpPr>
+          <p:cNvPr id="4" name="Text 1"/>
+          <p:cNvSpPr txBox="1"/>
+          <p:nvPr/>
+        </p:nvSpPr>
+        <p:spPr>
+          <a:xfrm>
+            <a:off x="548640" y="3291840"/>
+            <a:ext cx="11064240" cy="548640"/>
+          </a:xfrm>
+          <a:prstGeom prst="rect">
+            <a:avLst/>
+          </a:prstGeom>
+          <a:noFill/>
+          <a:ln/>
+        </p:spPr>
+        <p:txBody>
+          <a:bodyPr wrap="square" rtlCol="0" anchor="ctr"/>
+          <a:lstStyle/>
+          <a:p>
+            <a:pPr indent="0" marL="0">
+              <a:buNone/>
+            </a:pPr>
+            <a:r>
+              <a:rPr lang="en-US" sz="1400" i="1" dirty="0">
+                <a:solidFill>
+                  <a:schemeClr val="accent6"/>
+                </a:solidFill>
+              </a:rPr>
+              <a:t>Onduleur fortement recommandé (≈ 300 000 FCFA). Sauvegarde et stockage : hors périmètre, à définir.</a:t>
+            </a:r>
+            <a:endParaRPr lang="en-US" sz="1400" dirty="0"/>
+          </a:p>
+        </p:txBody>
+      </p:sp>
       <p:sp>
         <p:nvSpPr>
           <p:cNvPr id="25" name="Slide Number Placeholder 0"/>
@@ -4956,7 +4728,7 @@
                             <a:schemeClr val="tx1"/>
                           </a:solidFill>
                         </a:rPr>
-                        <a:t>Proxmox VE – souscription Community (1 an, 1 socket)</a:t>
+                        <a:t>Proxmox VE – édition gratuite (sans abonnement)</a:t>
                       </a:r>
                       <a:endParaRPr lang="en-US" sz="1500" dirty="0"/>
                     </a:p>
@@ -5014,7 +4786,7 @@
                             <a:schemeClr val="tx1"/>
                           </a:solidFill>
                         </a:rPr>
-                        <a:t>75 000 FCFA</a:t>
+                        <a:t>0 FCFA</a:t>
                       </a:r>
                       <a:endParaRPr lang="en-US" sz="1500" dirty="0"/>
                     </a:p>
@@ -5074,7 +4846,7 @@
                             <a:schemeClr val="tx1"/>
                           </a:solidFill>
                         </a:rPr>
-                        <a:t>Windows Server 2025 Standard 16 cœurs ×2 (couvre 4 VM)</a:t>
+                        <a:t>Windows Server 2025 Standard 16 cœurs ×1</a:t>
                       </a:r>
                       <a:endParaRPr lang="en-US" sz="1500" dirty="0"/>
                     </a:p>
@@ -5132,7 +4904,7 @@
                             <a:schemeClr val="tx1"/>
                           </a:solidFill>
                         </a:rPr>
-                        <a:t>1 400 000 FCFA</a:t>
+                        <a:t>700 000 FCFA</a:t>
                       </a:r>
                       <a:endParaRPr lang="en-US" sz="1500" dirty="0"/>
                     </a:p>
@@ -5310,7 +5082,7 @@
                             <a:schemeClr val="tx1"/>
                           </a:solidFill>
                         </a:rPr>
-                        <a:t>CAL RDS utilisateur ×10 (≈85 000 l'unité)</a:t>
+                        <a:t>Tailscale – offre gratuite (Personal, jusqu'à 3 utilisateurs)</a:t>
                       </a:r>
                       <a:endParaRPr lang="en-US" sz="1500" dirty="0"/>
                     </a:p>
@@ -5368,7 +5140,7 @@
                             <a:schemeClr val="tx1"/>
                           </a:solidFill>
                         </a:rPr>
-                        <a:t>850 000 FCFA</a:t>
+                        <a:t>0 FCFA</a:t>
                       </a:r>
                       <a:endParaRPr lang="en-US" sz="1500" dirty="0"/>
                     </a:p>
@@ -5489,7 +5261,7 @@
                             <a:schemeClr val="bg1"/>
                           </a:solidFill>
                         </a:rPr>
-                        <a:t>2 925 000 FCFA</a:t>
+                        <a:t>1 300 000 FCFA</a:t>
                       </a:r>
                       <a:endParaRPr lang="en-US" sz="1600" dirty="0"/>
                     </a:p>
@@ -5571,7 +5343,7 @@
                   <a:schemeClr val="accent6"/>
                 </a:solidFill>
               </a:rPr>
-              <a:t>Windows Server Standard autorise 2 VM par licence 16 cœurs ; les CAL sont obligatoires pour chaque utilisateur accédant au domaine.</a:t>
+              <a:t>Les CAL sont obligatoires pour chaque utilisateur du domaine : leur nombre suit l'effectif réel.</a:t>
             </a:r>
             <a:endParaRPr lang="en-US" sz="1300" dirty="0"/>
           </a:p>
@@ -5853,7 +5625,125 @@
                             <a:schemeClr val="tx1"/>
                           </a:solidFill>
                         </a:rPr>
-                        <a:t>Installation Proxmox, RAID, réseau</a:t>
+                        <a:t>Installation Proxmox VE, RAID, réseau</a:t>
+                      </a:r>
+                      <a:endParaRPr lang="en-US" sz="1500" dirty="0"/>
+                    </a:p>
+                  </a:txBody>
+                  <a:tcPr marL="91440" marR="91440" marT="45720" marB="45720" anchor="ctr">
+                    <a:lnL w="6350" cap="flat" cmpd="sng" algn="ctr">
+                      <a:solidFill>
+                        <a:srgbClr val="C9D6D3"/>
+                      </a:solidFill>
+                      <a:prstDash val="solid"/>
+                      <a:round/>
+                      <a:headEnd type="none" w="med" len="med"/>
+                      <a:tailEnd type="none" w="med" len="med"/>
+                    </a:lnL>
+                    <a:lnR w="6350" cap="flat" cmpd="sng" algn="ctr">
+                      <a:solidFill>
+                        <a:srgbClr val="C9D6D3"/>
+                      </a:solidFill>
+                      <a:prstDash val="solid"/>
+                      <a:round/>
+                      <a:headEnd type="none" w="med" len="med"/>
+                      <a:tailEnd type="none" w="med" len="med"/>
+                    </a:lnR>
+                    <a:lnT w="6350" cap="flat" cmpd="sng" algn="ctr">
+                      <a:solidFill>
+                        <a:srgbClr val="C9D6D3"/>
+                      </a:solidFill>
+                      <a:prstDash val="solid"/>
+                      <a:round/>
+                      <a:headEnd type="none" w="med" len="med"/>
+                      <a:tailEnd type="none" w="med" len="med"/>
+                    </a:lnT>
+                    <a:lnB w="6350" cap="flat" cmpd="sng" algn="ctr">
+                      <a:solidFill>
+                        <a:srgbClr val="C9D6D3"/>
+                      </a:solidFill>
+                      <a:prstDash val="solid"/>
+                      <a:round/>
+                      <a:headEnd type="none" w="med" len="med"/>
+                      <a:tailEnd type="none" w="med" len="med"/>
+                    </a:lnB>
+                  </a:tcPr>
+                </a:tc>
+                <a:tc>
+                  <a:txBody>
+                    <a:bodyPr/>
+                    <a:lstStyle/>
+                    <a:p>
+                      <a:pPr algn="r" indent="0" marL="0">
+                        <a:buNone/>
+                      </a:pPr>
+                      <a:r>
+                        <a:rPr lang="en-US" sz="1500" dirty="0">
+                          <a:solidFill>
+                            <a:schemeClr val="tx1"/>
+                          </a:solidFill>
+                        </a:rPr>
+                        <a:t>150 000 FCFA</a:t>
+                      </a:r>
+                      <a:endParaRPr lang="en-US" sz="1500" dirty="0"/>
+                    </a:p>
+                  </a:txBody>
+                  <a:tcPr marL="91440" marR="91440" marT="45720" marB="45720" anchor="ctr">
+                    <a:lnL w="6350" cap="flat" cmpd="sng" algn="ctr">
+                      <a:solidFill>
+                        <a:srgbClr val="C9D6D3"/>
+                      </a:solidFill>
+                      <a:prstDash val="solid"/>
+                      <a:round/>
+                      <a:headEnd type="none" w="med" len="med"/>
+                      <a:tailEnd type="none" w="med" len="med"/>
+                    </a:lnL>
+                    <a:lnR w="6350" cap="flat" cmpd="sng" algn="ctr">
+                      <a:solidFill>
+                        <a:srgbClr val="C9D6D3"/>
+                      </a:solidFill>
+                      <a:prstDash val="solid"/>
+                      <a:round/>
+                      <a:headEnd type="none" w="med" len="med"/>
+                      <a:tailEnd type="none" w="med" len="med"/>
+                    </a:lnR>
+                    <a:lnT w="6350" cap="flat" cmpd="sng" algn="ctr">
+                      <a:solidFill>
+                        <a:srgbClr val="C9D6D3"/>
+                      </a:solidFill>
+                      <a:prstDash val="solid"/>
+                      <a:round/>
+                      <a:headEnd type="none" w="med" len="med"/>
+                      <a:tailEnd type="none" w="med" len="med"/>
+                    </a:lnT>
+                    <a:lnB w="6350" cap="flat" cmpd="sng" algn="ctr">
+                      <a:solidFill>
+                        <a:srgbClr val="C9D6D3"/>
+                      </a:solidFill>
+                      <a:prstDash val="solid"/>
+                      <a:round/>
+                      <a:headEnd type="none" w="med" len="med"/>
+                      <a:tailEnd type="none" w="med" len="med"/>
+                    </a:lnB>
+                  </a:tcPr>
+                </a:tc>
+              </a:tr>
+              <a:tr h="548640">
+                <a:tc>
+                  <a:txBody>
+                    <a:bodyPr/>
+                    <a:lstStyle/>
+                    <a:p>
+                      <a:pPr indent="0" marL="0">
+                        <a:buNone/>
+                      </a:pPr>
+                      <a:r>
+                        <a:rPr lang="en-US" sz="1500" dirty="0">
+                          <a:solidFill>
+                            <a:schemeClr val="tx1"/>
+                          </a:solidFill>
+                        </a:rPr>
+                        <a:t>Windows Server : Active Directory, DNS, DHCP</a:t>
                       </a:r>
                       <a:endParaRPr lang="en-US" sz="1500" dirty="0"/>
                     </a:p>
@@ -5971,7 +5861,7 @@
                             <a:schemeClr val="tx1"/>
                           </a:solidFill>
                         </a:rPr>
-                        <a:t>Déploiement AD/DNS/DHCP, GPO, intégration postes</a:t>
+                        <a:t>Stratégies de groupe (GPO) + intégration des postes au domaine</a:t>
                       </a:r>
                       <a:endParaRPr lang="en-US" sz="1500" dirty="0"/>
                     </a:p>
@@ -6029,7 +5919,7 @@
                             <a:schemeClr val="tx1"/>
                           </a:solidFill>
                         </a:rPr>
-                        <a:t>400 000 FCFA</a:t>
+                        <a:t>200 000 FCFA</a:t>
                       </a:r>
                       <a:endParaRPr lang="en-US" sz="1500" dirty="0"/>
                     </a:p>
@@ -6089,7 +5979,7 @@
                             <a:schemeClr val="tx1"/>
                           </a:solidFill>
                         </a:rPr>
-                        <a:t>Serveur de fichiers + RDS</a:t>
+                        <a:t>Accès distant administrateur via Tailscale</a:t>
                       </a:r>
                       <a:endParaRPr lang="en-US" sz="1500" dirty="0"/>
                     </a:p>
@@ -6147,7 +6037,7 @@
                             <a:schemeClr val="tx1"/>
                           </a:solidFill>
                         </a:rPr>
-                        <a:t>300 000 FCFA</a:t>
+                        <a:t>50 000 FCFA</a:t>
                       </a:r>
                       <a:endParaRPr lang="en-US" sz="1500" dirty="0"/>
                     </a:p>
@@ -6207,125 +6097,7 @@
                             <a:schemeClr val="tx1"/>
                           </a:solidFill>
                         </a:rPr>
-                        <a:t>Sauvegarde PBS + NAS, tests de restauration</a:t>
-                      </a:r>
-                      <a:endParaRPr lang="en-US" sz="1500" dirty="0"/>
-                    </a:p>
-                  </a:txBody>
-                  <a:tcPr marL="91440" marR="91440" marT="45720" marB="45720" anchor="ctr">
-                    <a:lnL w="6350" cap="flat" cmpd="sng" algn="ctr">
-                      <a:solidFill>
-                        <a:srgbClr val="C9D6D3"/>
-                      </a:solidFill>
-                      <a:prstDash val="solid"/>
-                      <a:round/>
-                      <a:headEnd type="none" w="med" len="med"/>
-                      <a:tailEnd type="none" w="med" len="med"/>
-                    </a:lnL>
-                    <a:lnR w="6350" cap="flat" cmpd="sng" algn="ctr">
-                      <a:solidFill>
-                        <a:srgbClr val="C9D6D3"/>
-                      </a:solidFill>
-                      <a:prstDash val="solid"/>
-                      <a:round/>
-                      <a:headEnd type="none" w="med" len="med"/>
-                      <a:tailEnd type="none" w="med" len="med"/>
-                    </a:lnR>
-                    <a:lnT w="6350" cap="flat" cmpd="sng" algn="ctr">
-                      <a:solidFill>
-                        <a:srgbClr val="C9D6D3"/>
-                      </a:solidFill>
-                      <a:prstDash val="solid"/>
-                      <a:round/>
-                      <a:headEnd type="none" w="med" len="med"/>
-                      <a:tailEnd type="none" w="med" len="med"/>
-                    </a:lnT>
-                    <a:lnB w="6350" cap="flat" cmpd="sng" algn="ctr">
-                      <a:solidFill>
-                        <a:srgbClr val="C9D6D3"/>
-                      </a:solidFill>
-                      <a:prstDash val="solid"/>
-                      <a:round/>
-                      <a:headEnd type="none" w="med" len="med"/>
-                      <a:tailEnd type="none" w="med" len="med"/>
-                    </a:lnB>
-                  </a:tcPr>
-                </a:tc>
-                <a:tc>
-                  <a:txBody>
-                    <a:bodyPr/>
-                    <a:lstStyle/>
-                    <a:p>
-                      <a:pPr algn="r" indent="0" marL="0">
-                        <a:buNone/>
-                      </a:pPr>
-                      <a:r>
-                        <a:rPr lang="en-US" sz="1500" dirty="0">
-                          <a:solidFill>
-                            <a:schemeClr val="tx1"/>
-                          </a:solidFill>
-                        </a:rPr>
-                        <a:t>150 000 FCFA</a:t>
-                      </a:r>
-                      <a:endParaRPr lang="en-US" sz="1500" dirty="0"/>
-                    </a:p>
-                  </a:txBody>
-                  <a:tcPr marL="91440" marR="91440" marT="45720" marB="45720" anchor="ctr">
-                    <a:lnL w="6350" cap="flat" cmpd="sng" algn="ctr">
-                      <a:solidFill>
-                        <a:srgbClr val="C9D6D3"/>
-                      </a:solidFill>
-                      <a:prstDash val="solid"/>
-                      <a:round/>
-                      <a:headEnd type="none" w="med" len="med"/>
-                      <a:tailEnd type="none" w="med" len="med"/>
-                    </a:lnL>
-                    <a:lnR w="6350" cap="flat" cmpd="sng" algn="ctr">
-                      <a:solidFill>
-                        <a:srgbClr val="C9D6D3"/>
-                      </a:solidFill>
-                      <a:prstDash val="solid"/>
-                      <a:round/>
-                      <a:headEnd type="none" w="med" len="med"/>
-                      <a:tailEnd type="none" w="med" len="med"/>
-                    </a:lnR>
-                    <a:lnT w="6350" cap="flat" cmpd="sng" algn="ctr">
-                      <a:solidFill>
-                        <a:srgbClr val="C9D6D3"/>
-                      </a:solidFill>
-                      <a:prstDash val="solid"/>
-                      <a:round/>
-                      <a:headEnd type="none" w="med" len="med"/>
-                      <a:tailEnd type="none" w="med" len="med"/>
-                    </a:lnT>
-                    <a:lnB w="6350" cap="flat" cmpd="sng" algn="ctr">
-                      <a:solidFill>
-                        <a:srgbClr val="C9D6D3"/>
-                      </a:solidFill>
-                      <a:prstDash val="solid"/>
-                      <a:round/>
-                      <a:headEnd type="none" w="med" len="med"/>
-                      <a:tailEnd type="none" w="med" len="med"/>
-                    </a:lnB>
-                  </a:tcPr>
-                </a:tc>
-              </a:tr>
-              <a:tr h="548640">
-                <a:tc>
-                  <a:txBody>
-                    <a:bodyPr/>
-                    <a:lstStyle/>
-                    <a:p>
-                      <a:pPr indent="0" marL="0">
-                        <a:buNone/>
-                      </a:pPr>
-                      <a:r>
-                        <a:rPr lang="en-US" sz="1500" dirty="0">
-                          <a:solidFill>
-                            <a:schemeClr val="tx1"/>
-                          </a:solidFill>
-                        </a:rPr>
-                        <a:t>Documentation + formation administrateur (1 jour)</a:t>
+                        <a:t>Documentation + prise en main administrateur</a:t>
                       </a:r>
                       <a:endParaRPr lang="en-US" sz="1500" dirty="0"/>
                     </a:p>
@@ -6504,7 +6276,7 @@
                             <a:schemeClr val="bg1"/>
                           </a:solidFill>
                         </a:rPr>
-                        <a:t>1 200 000 FCFA</a:t>
+                        <a:t>750 000 FCFA</a:t>
                       </a:r>
                       <a:endParaRPr lang="en-US" sz="1600" dirty="0"/>
                     </a:p>
@@ -6749,7 +6521,7 @@
                   <a:schemeClr val="tx1"/>
                 </a:solidFill>
               </a:rPr>
-              <a:t>4 950 000 FCFA</a:t>
+              <a:t>2 200 000 FCFA</a:t>
             </a:r>
             <a:endParaRPr lang="en-US" sz="1800" dirty="0"/>
           </a:p>
@@ -6821,7 +6593,7 @@
                   <a:schemeClr val="tx1"/>
                 </a:solidFill>
               </a:rPr>
-              <a:t>2 925 000 FCFA</a:t>
+              <a:t>1 300 000 FCFA</a:t>
             </a:r>
             <a:endParaRPr lang="en-US" sz="1800" dirty="0"/>
           </a:p>
@@ -6893,7 +6665,7 @@
                   <a:schemeClr val="tx1"/>
                 </a:solidFill>
               </a:rPr>
-              <a:t>1 200 000 FCFA</a:t>
+              <a:t>750 000 FCFA</a:t>
             </a:r>
             <a:endParaRPr lang="en-US" sz="1800" dirty="0"/>
           </a:p>
@@ -6992,7 +6764,7 @@
                   <a:schemeClr val="bg1"/>
                 </a:solidFill>
               </a:rPr>
-              <a:t>9 075 000 FCFA</a:t>
+              <a:t>4 250 000 FCFA</a:t>
             </a:r>
             <a:endParaRPr lang="en-US" sz="4000" dirty="0"/>
           </a:p>
@@ -7028,7 +6800,7 @@
                   <a:schemeClr val="accent4"/>
                 </a:solidFill>
               </a:rPr>
-              <a:t>TVA 18 % en sus : 10 708 500 FCFA TTC</a:t>
+              <a:t>TVA 18 % en sus : 5 015 000 FCFA TTC</a:t>
             </a:r>
             <a:endParaRPr lang="en-US" sz="1300" dirty="0"/>
           </a:p>
@@ -7202,7 +6974,7 @@
                   <a:schemeClr val="accent1"/>
                 </a:solidFill>
               </a:rPr>
-              <a:t>75 000</a:t>
+              <a:t>0</a:t>
             </a:r>
             <a:endParaRPr lang="en-US" sz="4400" dirty="0"/>
           </a:p>
@@ -7238,7 +7010,7 @@
                   <a:schemeClr val="accent2"/>
                 </a:solidFill>
               </a:rPr>
-              <a:t>FCFA / an</a:t>
+              <a:t>FCFA</a:t>
             </a:r>
             <a:endParaRPr lang="en-US" sz="1600" dirty="0"/>
           </a:p>
@@ -7274,7 +7046,7 @@
                   <a:schemeClr val="tx1"/>
                 </a:solidFill>
               </a:rPr>
-              <a:t>Souscription Proxmox (mises à jour stables)</a:t>
+              <a:t>Proxmox VE et Tailscale : aucune licence annuelle</a:t>
             </a:r>
             <a:endParaRPr lang="en-US" sz="1500" dirty="0"/>
           </a:p>

</xml_diff>

<commit_message>
Ajoute l'option sécurité Kaspersky Next EDR Foundations
Co-Authored-By: Claude Opus 5.5 <noreply@anthropic.com>
Claude-Session: https://claude.ai/code/session_01FnPw3bDfKWoxE5ktD8jdcy
</commit_message>
<xml_diff>
--- a/proposition-serveur/Proposition_Serveur_Proxmox_WindowsServer.pptx
+++ b/proposition-serveur/Proposition_Serveur_Proxmox_WindowsServer.pptx
@@ -17,9 +17,11 @@
     <p:sldId id="265" r:id="rId11"/>
     <p:sldId id="266" r:id="rId12"/>
     <p:sldId id="267" r:id="rId13"/>
+    <p:sldId id="268" r:id="rId14"/>
+    <p:sldId id="269" r:id="rId15"/>
   </p:sldIdLst>
   <p:notesMasterIdLst>
-    <p:notesMasterId r:id="rId14"/>
+    <p:notesMasterId r:id="rId16"/>
   </p:notesMasterIdLst>
   <p:sldSz cx="12192000" cy="6858000"/>
   <p:notesSz cx="6858000" cy="12192000"/>
@@ -118,18 +120,18 @@
   <p:extLst>
     <p:ext uri="{521415D9-36F7-43E2-AB2F-B90AF26B5E84}">
       <p14:sectionLst xmlns:p14="http://schemas.microsoft.com/office/powerpoint/2010/main">
-        <p14:section name="Ouverture" id="{5c5a761e-5385-6a5d-fd6c-f7d2391cf60a}">
+        <p14:section name="Ouverture" id="{9f4b07d6-0ad7-3d27-c45f-d0ffe6046954}">
           <p14:sldIdLst>
             <p14:sldId id="256"/>
           </p14:sldIdLst>
         </p14:section>
-        <p14:section name="Le constat" id="{4e3a1581-c34b-7f86-e811-a598aa4034e1}">
+        <p14:section name="Le constat" id="{f661f09c-2d5e-bd86-d646-41227c0d096a}">
           <p14:sldIdLst>
             <p14:sldId id="257"/>
             <p14:sldId id="258"/>
           </p14:sldIdLst>
         </p14:section>
-        <p14:section name="La solution" id="{25ba85df-67ea-6631-82b0-59d825e87f6e}">
+        <p14:section name="La solution" id="{cbc441fb-6e93-2305-fe00-15c615251632}">
           <p14:sldIdLst>
             <p14:sldId id="259"/>
             <p14:sldId id="260"/>
@@ -137,7 +139,7 @@
             <p14:sldId id="262"/>
           </p14:sldIdLst>
         </p14:section>
-        <p14:section name="Investissement" id="{8cf68f80-910e-6409-8aee-315bc4d57d30}">
+        <p14:section name="Investissement" id="{7e8f0b11-515c-d7a1-b39e-a268634f4fcf}">
           <p14:sldIdLst>
             <p14:sldId id="263"/>
             <p14:sldId id="264"/>
@@ -145,9 +147,15 @@
             <p14:sldId id="266"/>
           </p14:sldIdLst>
         </p14:section>
-        <p14:section name="Conclusion" id="{9c0a91da-ae94-41c3-3750-56c927fb9e5c}">
+        <p14:section name="Option sécurité" id="{5c039c55-9b7b-f558-2c83-6b6e7e155e1a}">
           <p14:sldIdLst>
             <p14:sldId id="267"/>
+            <p14:sldId id="268"/>
+          </p14:sldIdLst>
+        </p14:section>
+        <p14:section name="Conclusion" id="{6f368f04-928a-5a34-6371-b3bf0f034f7c}">
+          <p14:sldIdLst>
+            <p14:sldId id="269"/>
           </p14:sldIdLst>
         </p14:section>
       </p14:sectionLst>
@@ -818,7 +826,7 @@
           <a:p>
             <a:r>
               <a:rPr lang="en-US" dirty="0"/>
-              <a:t>Conclure par une question fermée : « On planifie l'installation pour quelle semaine ? »</a:t>
+              <a:t>Transition : l'infrastructure organise le parc, mais il faut aussi le protéger. Cette option est indépendante de la proposition principale : le client peut la prendre maintenant ou plus tard.</a:t>
             </a:r>
             <a:endParaRPr lang="en-US" dirty="0"/>
           </a:p>
@@ -842,6 +850,182 @@
             <a:fld id="{F7021451-1387-4CA6-816F-3879F97B5CBC}" type="slidenum">
               <a:rPr lang="en-US"/>
               <a:t>12</a:t>
+            </a:fld>
+            <a:endParaRPr lang="en-US"/>
+          </a:p>
+        </p:txBody>
+      </p:sp>
+    </p:spTree>
+    <p:extLst>
+      <p:ext uri="{BB962C8B-B14F-4D97-AF65-F5344CB8AC3E}">
+        <p14:creationId xmlns:p14="http://schemas.microsoft.com/office/powerpoint/2010/main" val="1024086991"/>
+      </p:ext>
+    </p:extLst>
+  </p:cSld>
+  <p:clrMapOvr>
+    <a:masterClrMapping/>
+  </p:clrMapOvr>
+</p:notes>
+</file>
+
+<file path=ppt/notesSlides/notesSlide13.xml><?xml version="1.0" encoding="utf-8"?>
+<p:notes xmlns:a="http://schemas.openxmlformats.org/drawingml/2006/main" xmlns:r="http://schemas.openxmlformats.org/officeDocument/2006/relationships" xmlns:p="http://schemas.openxmlformats.org/presentationml/2006/main">
+  <p:cSld>
+    <p:spTree>
+      <p:nvGrpSpPr>
+        <p:cNvPr id="1" name=""/>
+        <p:cNvGrpSpPr/>
+        <p:nvPr/>
+      </p:nvGrpSpPr>
+      <p:grpSpPr>
+        <a:xfrm>
+          <a:off x="0" y="0"/>
+          <a:ext cx="0" cy="0"/>
+          <a:chOff x="0" y="0"/>
+          <a:chExt cx="0" cy="0"/>
+        </a:xfrm>
+      </p:grpSpPr>
+      <p:sp>
+        <p:nvSpPr>
+          <p:cNvPr id="2" name="Slide Image Placeholder 1"/>
+          <p:cNvSpPr>
+            <a:spLocks noGrp="1" noRot="1" noChangeAspect="1"/>
+          </p:cNvSpPr>
+          <p:nvPr>
+            <p:ph type="sldImg"/>
+          </p:nvPr>
+        </p:nvSpPr>
+        <p:spPr/>
+      </p:sp>
+      <p:sp>
+        <p:nvSpPr>
+          <p:cNvPr id="3" name="Notes Placeholder 2"/>
+          <p:cNvSpPr>
+            <a:spLocks noGrp="1"/>
+          </p:cNvSpPr>
+          <p:nvPr>
+            <p:ph type="body" idx="1"/>
+          </p:nvPr>
+        </p:nvSpPr>
+        <p:spPr/>
+        <p:txBody>
+          <a:bodyPr/>
+          <a:lstStyle/>
+          <a:p>
+            <a:r>
+              <a:rPr lang="en-US" dirty="0"/>
+              <a:t>Présenter comme une assurance : environ 40 000 FCFA par mois pour protéger 15 postes contre les ransomwares. Le coût d'une seule attaque (données perdues, jours d'arrêt) dépasse largement ce montant.</a:t>
+            </a:r>
+            <a:endParaRPr lang="en-US" dirty="0"/>
+          </a:p>
+        </p:txBody>
+      </p:sp>
+      <p:sp>
+        <p:nvSpPr>
+          <p:cNvPr id="4" name="Slide Number Placeholder 3"/>
+          <p:cNvSpPr>
+            <a:spLocks noGrp="1"/>
+          </p:cNvSpPr>
+          <p:nvPr>
+            <p:ph type="sldNum" sz="quarter" idx="10"/>
+          </p:nvPr>
+        </p:nvSpPr>
+        <p:spPr/>
+        <p:txBody>
+          <a:bodyPr/>
+          <a:lstStyle/>
+          <a:p>
+            <a:fld id="{F7021451-1387-4CA6-816F-3879F97B5CBC}" type="slidenum">
+              <a:rPr lang="en-US"/>
+              <a:t>13</a:t>
+            </a:fld>
+            <a:endParaRPr lang="en-US"/>
+          </a:p>
+        </p:txBody>
+      </p:sp>
+    </p:spTree>
+    <p:extLst>
+      <p:ext uri="{BB962C8B-B14F-4D97-AF65-F5344CB8AC3E}">
+        <p14:creationId xmlns:p14="http://schemas.microsoft.com/office/powerpoint/2010/main" val="1024086991"/>
+      </p:ext>
+    </p:extLst>
+  </p:cSld>
+  <p:clrMapOvr>
+    <a:masterClrMapping/>
+  </p:clrMapOvr>
+</p:notes>
+</file>
+
+<file path=ppt/notesSlides/notesSlide14.xml><?xml version="1.0" encoding="utf-8"?>
+<p:notes xmlns:a="http://schemas.openxmlformats.org/drawingml/2006/main" xmlns:r="http://schemas.openxmlformats.org/officeDocument/2006/relationships" xmlns:p="http://schemas.openxmlformats.org/presentationml/2006/main">
+  <p:cSld>
+    <p:spTree>
+      <p:nvGrpSpPr>
+        <p:cNvPr id="1" name=""/>
+        <p:cNvGrpSpPr/>
+        <p:nvPr/>
+      </p:nvGrpSpPr>
+      <p:grpSpPr>
+        <a:xfrm>
+          <a:off x="0" y="0"/>
+          <a:ext cx="0" cy="0"/>
+          <a:chOff x="0" y="0"/>
+          <a:chExt cx="0" cy="0"/>
+        </a:xfrm>
+      </p:grpSpPr>
+      <p:sp>
+        <p:nvSpPr>
+          <p:cNvPr id="2" name="Slide Image Placeholder 1"/>
+          <p:cNvSpPr>
+            <a:spLocks noGrp="1" noRot="1" noChangeAspect="1"/>
+          </p:cNvSpPr>
+          <p:nvPr>
+            <p:ph type="sldImg"/>
+          </p:nvPr>
+        </p:nvSpPr>
+        <p:spPr/>
+      </p:sp>
+      <p:sp>
+        <p:nvSpPr>
+          <p:cNvPr id="3" name="Notes Placeholder 2"/>
+          <p:cNvSpPr>
+            <a:spLocks noGrp="1"/>
+          </p:cNvSpPr>
+          <p:nvPr>
+            <p:ph type="body" idx="1"/>
+          </p:nvPr>
+        </p:nvSpPr>
+        <p:spPr/>
+        <p:txBody>
+          <a:bodyPr/>
+          <a:lstStyle/>
+          <a:p>
+            <a:r>
+              <a:rPr lang="en-US" dirty="0"/>
+              <a:t>Conclure par une question fermée : « On planifie l'installation pour quelle semaine ? »</a:t>
+            </a:r>
+            <a:endParaRPr lang="en-US" dirty="0"/>
+          </a:p>
+        </p:txBody>
+      </p:sp>
+      <p:sp>
+        <p:nvSpPr>
+          <p:cNvPr id="4" name="Slide Number Placeholder 3"/>
+          <p:cNvSpPr>
+            <a:spLocks noGrp="1"/>
+          </p:cNvSpPr>
+          <p:nvPr>
+            <p:ph type="sldNum" sz="quarter" idx="10"/>
+          </p:nvPr>
+        </p:nvSpPr>
+        <p:spPr/>
+        <p:txBody>
+          <a:bodyPr/>
+          <a:lstStyle/>
+          <a:p>
+            <a:fld id="{F7021451-1387-4CA6-816F-3879F97B5CBC}" type="slidenum">
+              <a:rPr lang="en-US"/>
+              <a:t>14</a:t>
             </a:fld>
             <a:endParaRPr lang="en-US"/>
           </a:p>
@@ -8464,6 +8648,3143 @@
                   <a:schemeClr val="accent4"/>
                 </a:solidFill>
               </a:rPr>
+              <a:t>Option · proposition séparée</a:t>
+            </a:r>
+            <a:endParaRPr lang="en-US" sz="1800" dirty="0"/>
+          </a:p>
+        </p:txBody>
+      </p:sp>
+      <p:sp>
+        <p:nvSpPr>
+          <p:cNvPr id="3" name="Text 0"/>
+          <p:cNvSpPr/>
+          <p:nvPr>
+            <p:ph idx="101" type="title" hasCustomPrompt="1"/>
+          </p:nvPr>
+        </p:nvSpPr>
+        <p:spPr>
+          <a:xfrm>
+            <a:off x="731520" y="2468880"/>
+            <a:ext cx="6766560" cy="2011680"/>
+          </a:xfrm>
+          <a:prstGeom prst="rect">
+            <a:avLst/>
+          </a:prstGeom>
+          <a:noFill/>
+          <a:ln/>
+        </p:spPr>
+        <p:txBody>
+          <a:bodyPr wrap="square" rtlCol="0" anchor="t"/>
+          <a:lstStyle/>
+          <a:p>
+            <a:pPr algn="l" indent="0" marL="0">
+              <a:buNone/>
+            </a:pPr>
+            <a:r>
+              <a:rPr lang="en-US" sz="4000" b="1" dirty="0">
+                <a:solidFill>
+                  <a:schemeClr val="bg1"/>
+                </a:solidFill>
+              </a:rPr>
+              <a:t>Et si un ransomware frappait demain ?</a:t>
+            </a:r>
+            <a:endParaRPr lang="en-US" sz="4000" dirty="0"/>
+          </a:p>
+        </p:txBody>
+      </p:sp>
+      <p:sp>
+        <p:nvSpPr>
+          <p:cNvPr id="4" name="a1_238"/>
+          <p:cNvSpPr txBox="1"/>
+          <p:nvPr/>
+        </p:nvSpPr>
+        <p:spPr>
+          <a:xfrm>
+            <a:off x="731520" y="4023360"/>
+            <a:ext cx="6583680" cy="1097280"/>
+          </a:xfrm>
+          <a:prstGeom prst="rect">
+            <a:avLst/>
+          </a:prstGeom>
+          <a:noFill/>
+          <a:ln/>
+        </p:spPr>
+        <p:txBody>
+          <a:bodyPr wrap="square" lIns="0" tIns="0" rIns="0" bIns="0" rtlCol="0" anchor="t"/>
+          <a:lstStyle/>
+          <a:p>
+            <a:pPr indent="0" marL="0">
+              <a:buNone/>
+            </a:pPr>
+            <a:r>
+              <a:rPr lang="en-US" sz="2000" dirty="0">
+                <a:solidFill>
+                  <a:schemeClr val="accent4"/>
+                </a:solidFill>
+              </a:rPr>
+              <a:t>Un poste infecté peut chiffrer les fichiers partagés et paralyser toute l'activité. Ajoutons une protection professionnelle.</a:t>
+            </a:r>
+            <a:endParaRPr lang="en-US" sz="2000" dirty="0"/>
+          </a:p>
+        </p:txBody>
+      </p:sp>
+      <p:sp>
+        <p:nvSpPr>
+          <p:cNvPr id="5" name="a2_239"/>
+          <p:cNvSpPr/>
+          <p:nvPr/>
+        </p:nvSpPr>
+        <p:spPr>
+          <a:xfrm>
+            <a:off x="8778240" y="2103120"/>
+            <a:ext cx="2377440" cy="2377440"/>
+          </a:xfrm>
+          <a:prstGeom prst="ellipse">
+            <a:avLst/>
+          </a:prstGeom>
+          <a:solidFill>
+            <a:schemeClr val="bg1"/>
+          </a:solidFill>
+          <a:ln w="12700">
+            <a:solidFill>
+              <a:schemeClr val="bg1"/>
+            </a:solidFill>
+            <a:prstDash val="solid"/>
+          </a:ln>
+        </p:spPr>
+      </p:sp>
+      <p:pic>
+        <p:nvPicPr>
+          <p:cNvPr id="6" name="a2_240" descr="preencoded.png">    </p:cNvPr>
+          <p:cNvPicPr>
+            <a:picLocks noChangeAspect="1"/>
+          </p:cNvPicPr>
+          <p:nvPr/>
+        </p:nvPicPr>
+        <p:blipFill>
+          <a:blip r:embed="rId1"/>
+          <a:stretch>
+            <a:fillRect/>
+          </a:stretch>
+        </p:blipFill>
+        <p:spPr>
+          <a:xfrm>
+            <a:off x="9396374" y="2721254"/>
+            <a:ext cx="1141171" cy="1141171"/>
+          </a:xfrm>
+          <a:prstGeom prst="rect">
+            <a:avLst/>
+          </a:prstGeom>
+        </p:spPr>
+      </p:pic>
+    </p:spTree>
+  </p:cSld>
+  <p:clrMapOvr>
+    <a:masterClrMapping/>
+  </p:clrMapOvr>
+  <p:transition spd="slow">
+    <p:fade/>
+  </p:transition>
+  <p:timing>
+    <p:tnLst>
+      <p:par>
+        <p:cTn id="1" dur="indefinite" restart="never" nodeType="tmRoot">
+          <p:childTnLst>
+            <p:seq concurrent="1" nextAc="seek">
+              <p:cTn id="2" dur="indefinite" nodeType="mainSeq">
+                <p:childTnLst>
+                  <p:par>
+                    <p:cTn id="3" fill="hold">
+                      <p:stCondLst>
+                        <p:cond delay="indefinite"/>
+                        <p:cond evt="onBegin" delay="0">
+                          <p:tn val="2"/>
+                        </p:cond>
+                      </p:stCondLst>
+                      <p:childTnLst>
+                        <p:par>
+                          <p:cTn id="4" presetID="10" presetClass="entr" presetSubtype="0" fill="hold" nodeType="withEffect">
+                            <p:stCondLst>
+                              <p:cond delay="0"/>
+                            </p:stCondLst>
+                            <p:childTnLst>
+                              <p:set>
+                                <p:cBhvr>
+                                  <p:cTn id="5" dur="1" fill="hold">
+                                    <p:stCondLst>
+                                      <p:cond delay="0"/>
+                                    </p:stCondLst>
+                                  </p:cTn>
+                                  <p:tgtEl>
+                                    <p:spTgt spid="4"/>
+                                  </p:tgtEl>
+                                  <p:attrNameLst>
+                                    <p:attrName>style.visibility</p:attrName>
+                                  </p:attrNameLst>
+                                </p:cBhvr>
+                                <p:to>
+                                  <p:strVal val="visible"/>
+                                </p:to>
+                              </p:set>
+                              <p:animEffect transition="in" filter="fade">
+                                <p:cBhvr>
+                                  <p:cTn id="6" dur="600"/>
+                                  <p:tgtEl>
+                                    <p:spTgt spid="4"/>
+                                  </p:tgtEl>
+                                </p:cBhvr>
+                              </p:animEffect>
+                              <p:anim calcmode="lin" valueType="num">
+                                <p:cBhvr>
+                                  <p:cTn id="7" dur="600" decel="100000" fill="hold"/>
+                                  <p:tgtEl>
+                                    <p:spTgt spid="4"/>
+                                  </p:tgtEl>
+                                  <p:attrNameLst>
+                                    <p:attrName>ppt_y</p:attrName>
+                                  </p:attrNameLst>
+                                </p:cBhvr>
+                                <p:tavLst>
+                                  <p:tav tm="0">
+                                    <p:val>
+                                      <p:strVal val="#ppt_y+0.03"/>
+                                    </p:val>
+                                  </p:tav>
+                                  <p:tav tm="100000">
+                                    <p:val>
+                                      <p:strVal val="#ppt_y"/>
+                                    </p:val>
+                                  </p:tav>
+                                </p:tavLst>
+                              </p:anim>
+                            </p:childTnLst>
+                          </p:cTn>
+                        </p:par>
+                        <p:par>
+                          <p:cTn id="8" presetID="10" presetClass="entr" presetSubtype="0" fill="hold" nodeType="withEffect">
+                            <p:stCondLst>
+                              <p:cond delay="450"/>
+                            </p:stCondLst>
+                            <p:childTnLst>
+                              <p:set>
+                                <p:cBhvr>
+                                  <p:cTn id="9" dur="1" fill="hold">
+                                    <p:stCondLst>
+                                      <p:cond delay="0"/>
+                                    </p:stCondLst>
+                                  </p:cTn>
+                                  <p:tgtEl>
+                                    <p:spTgt spid="5"/>
+                                  </p:tgtEl>
+                                  <p:attrNameLst>
+                                    <p:attrName>style.visibility</p:attrName>
+                                  </p:attrNameLst>
+                                </p:cBhvr>
+                                <p:to>
+                                  <p:strVal val="visible"/>
+                                </p:to>
+                              </p:set>
+                              <p:animEffect transition="in" filter="fade">
+                                <p:cBhvr>
+                                  <p:cTn id="10" dur="600"/>
+                                  <p:tgtEl>
+                                    <p:spTgt spid="5"/>
+                                  </p:tgtEl>
+                                </p:cBhvr>
+                              </p:animEffect>
+                              <p:anim calcmode="lin" valueType="num">
+                                <p:cBhvr>
+                                  <p:cTn id="11" dur="600" decel="100000" fill="hold"/>
+                                  <p:tgtEl>
+                                    <p:spTgt spid="5"/>
+                                  </p:tgtEl>
+                                  <p:attrNameLst>
+                                    <p:attrName>ppt_y</p:attrName>
+                                  </p:attrNameLst>
+                                </p:cBhvr>
+                                <p:tavLst>
+                                  <p:tav tm="0">
+                                    <p:val>
+                                      <p:strVal val="#ppt_y+0.03"/>
+                                    </p:val>
+                                  </p:tav>
+                                  <p:tav tm="100000">
+                                    <p:val>
+                                      <p:strVal val="#ppt_y"/>
+                                    </p:val>
+                                  </p:tav>
+                                </p:tavLst>
+                              </p:anim>
+                            </p:childTnLst>
+                          </p:cTn>
+                        </p:par>
+                        <p:par>
+                          <p:cTn id="12" presetID="10" presetClass="entr" presetSubtype="0" fill="hold" nodeType="withEffect">
+                            <p:stCondLst>
+                              <p:cond delay="510"/>
+                            </p:stCondLst>
+                            <p:childTnLst>
+                              <p:set>
+                                <p:cBhvr>
+                                  <p:cTn id="13" dur="1" fill="hold">
+                                    <p:stCondLst>
+                                      <p:cond delay="0"/>
+                                    </p:stCondLst>
+                                  </p:cTn>
+                                  <p:tgtEl>
+                                    <p:spTgt spid="6"/>
+                                  </p:tgtEl>
+                                  <p:attrNameLst>
+                                    <p:attrName>style.visibility</p:attrName>
+                                  </p:attrNameLst>
+                                </p:cBhvr>
+                                <p:to>
+                                  <p:strVal val="visible"/>
+                                </p:to>
+                              </p:set>
+                              <p:animEffect transition="in" filter="fade">
+                                <p:cBhvr>
+                                  <p:cTn id="14" dur="600"/>
+                                  <p:tgtEl>
+                                    <p:spTgt spid="6"/>
+                                  </p:tgtEl>
+                                </p:cBhvr>
+                              </p:animEffect>
+                              <p:anim calcmode="lin" valueType="num">
+                                <p:cBhvr>
+                                  <p:cTn id="15" dur="600" decel="100000" fill="hold"/>
+                                  <p:tgtEl>
+                                    <p:spTgt spid="6"/>
+                                  </p:tgtEl>
+                                  <p:attrNameLst>
+                                    <p:attrName>ppt_y</p:attrName>
+                                  </p:attrNameLst>
+                                </p:cBhvr>
+                                <p:tavLst>
+                                  <p:tav tm="0">
+                                    <p:val>
+                                      <p:strVal val="#ppt_y+0.03"/>
+                                    </p:val>
+                                  </p:tav>
+                                  <p:tav tm="100000">
+                                    <p:val>
+                                      <p:strVal val="#ppt_y"/>
+                                    </p:val>
+                                  </p:tav>
+                                </p:tavLst>
+                              </p:anim>
+                            </p:childTnLst>
+                          </p:cTn>
+                        </p:par>
+                      </p:childTnLst>
+                    </p:cTn>
+                  </p:par>
+                </p:childTnLst>
+              </p:cTn>
+              <p:prevCondLst>
+                <p:cond evt="onPrev" delay="0">
+                  <p:tgtEl>
+                    <p:sldTgt/>
+                  </p:tgtEl>
+                </p:cond>
+              </p:prevCondLst>
+              <p:nextCondLst>
+                <p:cond evt="onNext" delay="0">
+                  <p:tgtEl>
+                    <p:sldTgt/>
+                  </p:tgtEl>
+                </p:cond>
+              </p:nextCondLst>
+            </p:seq>
+          </p:childTnLst>
+        </p:cTn>
+      </p:par>
+    </p:tnLst>
+  </p:timing>
+</p:sld>
+</file>
+
+<file path=ppt/slides/slide13.xml><?xml version="1.0" encoding="utf-8"?>
+<p:sld xmlns:a="http://schemas.openxmlformats.org/drawingml/2006/main" xmlns:r="http://schemas.openxmlformats.org/officeDocument/2006/relationships" xmlns:p="http://schemas.openxmlformats.org/presentationml/2006/main">
+  <p:cSld name="Slide 13">
+    <p:spTree>
+      <p:nvGrpSpPr>
+        <p:cNvPr id="1" name=""/>
+        <p:cNvGrpSpPr/>
+        <p:nvPr/>
+      </p:nvGrpSpPr>
+      <p:grpSpPr>
+        <a:xfrm>
+          <a:off x="0" y="0"/>
+          <a:ext cx="0" cy="0"/>
+          <a:chOff x="0" y="0"/>
+          <a:chExt cx="0" cy="0"/>
+        </a:xfrm>
+      </p:grpSpPr>
+      <p:sp>
+        <p:nvSpPr>
+          <p:cNvPr id="2" name="Text 0"/>
+          <p:cNvSpPr/>
+          <p:nvPr>
+            <p:ph idx="100" type="body" hasCustomPrompt="1"/>
+          </p:nvPr>
+        </p:nvSpPr>
+        <p:spPr>
+          <a:xfrm>
+            <a:off x="548640" y="365760"/>
+            <a:ext cx="8229600" cy="320040"/>
+          </a:xfrm>
+          <a:prstGeom prst="rect">
+            <a:avLst/>
+          </a:prstGeom>
+          <a:noFill/>
+          <a:ln/>
+        </p:spPr>
+        <p:txBody>
+          <a:bodyPr wrap="square" rtlCol="0"/>
+          <a:lstStyle/>
+          <a:p>
+            <a:pPr indent="0" marL="0">
+              <a:buNone/>
+            </a:pPr>
+            <a:r>
+              <a:rPr lang="en-US" sz="1400" b="1" dirty="0">
+                <a:solidFill>
+                  <a:schemeClr val="accent1"/>
+                </a:solidFill>
+              </a:rPr>
+              <a:t>Option sécurité</a:t>
+            </a:r>
+            <a:endParaRPr lang="en-US" sz="1400" dirty="0"/>
+          </a:p>
+        </p:txBody>
+      </p:sp>
+      <p:sp>
+        <p:nvSpPr>
+          <p:cNvPr id="3" name="Text 0"/>
+          <p:cNvSpPr/>
+          <p:nvPr>
+            <p:ph idx="101" type="title" hasCustomPrompt="1"/>
+          </p:nvPr>
+        </p:nvSpPr>
+        <p:spPr>
+          <a:xfrm>
+            <a:off x="548640" y="685800"/>
+            <a:ext cx="11064240" cy="731520"/>
+          </a:xfrm>
+          <a:prstGeom prst="rect">
+            <a:avLst/>
+          </a:prstGeom>
+          <a:noFill/>
+          <a:ln/>
+        </p:spPr>
+        <p:txBody>
+          <a:bodyPr wrap="square" rtlCol="0"/>
+          <a:lstStyle/>
+          <a:p>
+            <a:pPr algn="l" indent="0" marL="0">
+              <a:buNone/>
+            </a:pPr>
+            <a:r>
+              <a:rPr lang="en-US" sz="3200" b="1" dirty="0">
+                <a:solidFill>
+                  <a:schemeClr val="tx1"/>
+                </a:solidFill>
+              </a:rPr>
+              <a:t>Kaspersky Next </a:t>
+            </a:r>
+            <a:pPr algn="l" indent="0" marL="0">
+              <a:buNone/>
+            </a:pPr>
+            <a:r>
+              <a:rPr lang="en-US" sz="3200" b="1" dirty="0">
+                <a:solidFill>
+                  <a:schemeClr val="accent1"/>
+                </a:solidFill>
+              </a:rPr>
+              <a:t>EDR Foundations</a:t>
+            </a:r>
+            <a:endParaRPr lang="en-US" sz="3200" dirty="0"/>
+          </a:p>
+        </p:txBody>
+      </p:sp>
+      <p:sp>
+        <p:nvSpPr>
+          <p:cNvPr id="4" name="a1_241"/>
+          <p:cNvSpPr/>
+          <p:nvPr/>
+        </p:nvSpPr>
+        <p:spPr>
+          <a:xfrm>
+            <a:off x="548640" y="1645920"/>
+            <a:ext cx="3337560" cy="2011680"/>
+          </a:xfrm>
+          <a:prstGeom prst="roundRect">
+            <a:avLst>
+              <a:gd name="adj" fmla="val 6364"/>
+            </a:avLst>
+          </a:prstGeom>
+          <a:solidFill>
+            <a:schemeClr val="bg1"/>
+          </a:solidFill>
+          <a:ln w="12700">
+            <a:solidFill>
+              <a:srgbClr val="DCE5F7"/>
+            </a:solidFill>
+            <a:prstDash val="solid"/>
+          </a:ln>
+          <a:effectLst>
+            <a:outerShdw sx="100000" sy="100000" kx="0" ky="0" algn="bl" rotWithShape="0" blurRad="127000" dist="38100" dir="5400000">
+              <a:srgbClr val="0B2A6F">
+                <a:alpha val="12000"/>
+              </a:srgbClr>
+            </a:outerShdw>
+          </a:effectLst>
+        </p:spPr>
+      </p:sp>
+      <p:sp>
+        <p:nvSpPr>
+          <p:cNvPr id="5" name="a1_242"/>
+          <p:cNvSpPr/>
+          <p:nvPr/>
+        </p:nvSpPr>
+        <p:spPr>
+          <a:xfrm>
+            <a:off x="822960" y="1920240"/>
+            <a:ext cx="640080" cy="640080"/>
+          </a:xfrm>
+          <a:prstGeom prst="ellipse">
+            <a:avLst/>
+          </a:prstGeom>
+          <a:solidFill>
+            <a:schemeClr val="accent1"/>
+          </a:solidFill>
+          <a:ln w="12700">
+            <a:solidFill>
+              <a:schemeClr val="accent1"/>
+            </a:solidFill>
+            <a:prstDash val="solid"/>
+          </a:ln>
+        </p:spPr>
+      </p:sp>
+      <p:pic>
+        <p:nvPicPr>
+          <p:cNvPr id="6" name="a1_243" descr="preencoded.png">    </p:cNvPr>
+          <p:cNvPicPr>
+            <a:picLocks noChangeAspect="1"/>
+          </p:cNvPicPr>
+          <p:nvPr/>
+        </p:nvPicPr>
+        <p:blipFill>
+          <a:blip r:embed="rId1"/>
+          <a:stretch>
+            <a:fillRect/>
+          </a:stretch>
+        </p:blipFill>
+        <p:spPr>
+          <a:xfrm>
+            <a:off x="989381" y="2086661"/>
+            <a:ext cx="307238" cy="307238"/>
+          </a:xfrm>
+          <a:prstGeom prst="rect">
+            <a:avLst/>
+          </a:prstGeom>
+        </p:spPr>
+      </p:pic>
+      <p:sp>
+        <p:nvSpPr>
+          <p:cNvPr id="7" name="a1_244"/>
+          <p:cNvSpPr txBox="1"/>
+          <p:nvPr/>
+        </p:nvSpPr>
+        <p:spPr>
+          <a:xfrm>
+            <a:off x="822960" y="2651760"/>
+            <a:ext cx="2834640" cy="365760"/>
+          </a:xfrm>
+          <a:prstGeom prst="rect">
+            <a:avLst/>
+          </a:prstGeom>
+          <a:noFill/>
+          <a:ln/>
+        </p:spPr>
+        <p:txBody>
+          <a:bodyPr wrap="square" lIns="0" tIns="0" rIns="0" bIns="0" rtlCol="0" anchor="ctr"/>
+          <a:lstStyle/>
+          <a:p>
+            <a:pPr indent="0" marL="0">
+              <a:buNone/>
+            </a:pPr>
+            <a:r>
+              <a:rPr lang="en-US" sz="1700" b="1" dirty="0">
+                <a:solidFill>
+                  <a:schemeClr val="tx2"/>
+                </a:solidFill>
+              </a:rPr>
+              <a:t>Anti-ransomware</a:t>
+            </a:r>
+            <a:endParaRPr lang="en-US" sz="1700" dirty="0"/>
+          </a:p>
+        </p:txBody>
+      </p:sp>
+      <p:sp>
+        <p:nvSpPr>
+          <p:cNvPr id="8" name="a1_245"/>
+          <p:cNvSpPr txBox="1"/>
+          <p:nvPr/>
+        </p:nvSpPr>
+        <p:spPr>
+          <a:xfrm>
+            <a:off x="822960" y="3017520"/>
+            <a:ext cx="2834640" cy="594360"/>
+          </a:xfrm>
+          <a:prstGeom prst="rect">
+            <a:avLst/>
+          </a:prstGeom>
+          <a:noFill/>
+          <a:ln/>
+        </p:spPr>
+        <p:txBody>
+          <a:bodyPr wrap="square" lIns="0" tIns="0" rIns="0" bIns="0" rtlCol="0" anchor="t"/>
+          <a:lstStyle/>
+          <a:p>
+            <a:pPr indent="0" marL="0">
+              <a:buNone/>
+            </a:pPr>
+            <a:r>
+              <a:rPr lang="en-US" sz="1300" dirty="0">
+                <a:solidFill>
+                  <a:schemeClr val="accent6"/>
+                </a:solidFill>
+              </a:rPr>
+              <a:t>Bloque le chiffrement malveillant des fichiers</a:t>
+            </a:r>
+            <a:endParaRPr lang="en-US" sz="1300" dirty="0"/>
+          </a:p>
+        </p:txBody>
+      </p:sp>
+      <p:sp>
+        <p:nvSpPr>
+          <p:cNvPr id="9" name="a2_246"/>
+          <p:cNvSpPr/>
+          <p:nvPr/>
+        </p:nvSpPr>
+        <p:spPr>
+          <a:xfrm>
+            <a:off x="4069080" y="1645920"/>
+            <a:ext cx="3337560" cy="2011680"/>
+          </a:xfrm>
+          <a:prstGeom prst="roundRect">
+            <a:avLst>
+              <a:gd name="adj" fmla="val 6364"/>
+            </a:avLst>
+          </a:prstGeom>
+          <a:solidFill>
+            <a:schemeClr val="bg1"/>
+          </a:solidFill>
+          <a:ln w="12700">
+            <a:solidFill>
+              <a:srgbClr val="DCE5F7"/>
+            </a:solidFill>
+            <a:prstDash val="solid"/>
+          </a:ln>
+          <a:effectLst>
+            <a:outerShdw sx="100000" sy="100000" kx="0" ky="0" algn="bl" rotWithShape="0" blurRad="127000" dist="38100" dir="5400000">
+              <a:srgbClr val="0B2A6F">
+                <a:alpha val="12000"/>
+              </a:srgbClr>
+            </a:outerShdw>
+          </a:effectLst>
+        </p:spPr>
+      </p:sp>
+      <p:sp>
+        <p:nvSpPr>
+          <p:cNvPr id="10" name="a2_247"/>
+          <p:cNvSpPr/>
+          <p:nvPr/>
+        </p:nvSpPr>
+        <p:spPr>
+          <a:xfrm>
+            <a:off x="4343400" y="1920240"/>
+            <a:ext cx="640080" cy="640080"/>
+          </a:xfrm>
+          <a:prstGeom prst="ellipse">
+            <a:avLst/>
+          </a:prstGeom>
+          <a:solidFill>
+            <a:schemeClr val="accent1"/>
+          </a:solidFill>
+          <a:ln w="12700">
+            <a:solidFill>
+              <a:schemeClr val="accent1"/>
+            </a:solidFill>
+            <a:prstDash val="solid"/>
+          </a:ln>
+        </p:spPr>
+      </p:sp>
+      <p:pic>
+        <p:nvPicPr>
+          <p:cNvPr id="11" name="a2_248" descr="preencoded.png">    </p:cNvPr>
+          <p:cNvPicPr>
+            <a:picLocks noChangeAspect="1"/>
+          </p:cNvPicPr>
+          <p:nvPr/>
+        </p:nvPicPr>
+        <p:blipFill>
+          <a:blip r:embed="rId2"/>
+          <a:stretch>
+            <a:fillRect/>
+          </a:stretch>
+        </p:blipFill>
+        <p:spPr>
+          <a:xfrm>
+            <a:off x="4509821" y="2086661"/>
+            <a:ext cx="307238" cy="307238"/>
+          </a:xfrm>
+          <a:prstGeom prst="rect">
+            <a:avLst/>
+          </a:prstGeom>
+        </p:spPr>
+      </p:pic>
+      <p:sp>
+        <p:nvSpPr>
+          <p:cNvPr id="12" name="a2_249"/>
+          <p:cNvSpPr txBox="1"/>
+          <p:nvPr/>
+        </p:nvSpPr>
+        <p:spPr>
+          <a:xfrm>
+            <a:off x="4343400" y="2651760"/>
+            <a:ext cx="2834640" cy="365760"/>
+          </a:xfrm>
+          <a:prstGeom prst="rect">
+            <a:avLst/>
+          </a:prstGeom>
+          <a:noFill/>
+          <a:ln/>
+        </p:spPr>
+        <p:txBody>
+          <a:bodyPr wrap="square" lIns="0" tIns="0" rIns="0" bIns="0" rtlCol="0" anchor="ctr"/>
+          <a:lstStyle/>
+          <a:p>
+            <a:pPr indent="0" marL="0">
+              <a:buNone/>
+            </a:pPr>
+            <a:r>
+              <a:rPr lang="en-US" sz="1700" b="1" dirty="0">
+                <a:solidFill>
+                  <a:schemeClr val="tx2"/>
+                </a:solidFill>
+              </a:rPr>
+              <a:t>Menaces avancées</a:t>
+            </a:r>
+            <a:endParaRPr lang="en-US" sz="1700" dirty="0"/>
+          </a:p>
+        </p:txBody>
+      </p:sp>
+      <p:sp>
+        <p:nvSpPr>
+          <p:cNvPr id="13" name="a2_250"/>
+          <p:cNvSpPr txBox="1"/>
+          <p:nvPr/>
+        </p:nvSpPr>
+        <p:spPr>
+          <a:xfrm>
+            <a:off x="4343400" y="3017520"/>
+            <a:ext cx="2834640" cy="594360"/>
+          </a:xfrm>
+          <a:prstGeom prst="rect">
+            <a:avLst/>
+          </a:prstGeom>
+          <a:noFill/>
+          <a:ln/>
+        </p:spPr>
+        <p:txBody>
+          <a:bodyPr wrap="square" lIns="0" tIns="0" rIns="0" bIns="0" rtlCol="0" anchor="t"/>
+          <a:lstStyle/>
+          <a:p>
+            <a:pPr indent="0" marL="0">
+              <a:buNone/>
+            </a:pPr>
+            <a:r>
+              <a:rPr lang="en-US" sz="1300" dirty="0">
+                <a:solidFill>
+                  <a:schemeClr val="accent6"/>
+                </a:solidFill>
+              </a:rPr>
+              <a:t>Détecte les programmes malveillants sans fichier et les menaces émergentes</a:t>
+            </a:r>
+            <a:endParaRPr lang="en-US" sz="1300" dirty="0"/>
+          </a:p>
+        </p:txBody>
+      </p:sp>
+      <p:sp>
+        <p:nvSpPr>
+          <p:cNvPr id="14" name="a3_251"/>
+          <p:cNvSpPr/>
+          <p:nvPr/>
+        </p:nvSpPr>
+        <p:spPr>
+          <a:xfrm>
+            <a:off x="548640" y="3886200"/>
+            <a:ext cx="3337560" cy="2011680"/>
+          </a:xfrm>
+          <a:prstGeom prst="roundRect">
+            <a:avLst>
+              <a:gd name="adj" fmla="val 6364"/>
+            </a:avLst>
+          </a:prstGeom>
+          <a:solidFill>
+            <a:schemeClr val="bg1"/>
+          </a:solidFill>
+          <a:ln w="12700">
+            <a:solidFill>
+              <a:srgbClr val="DCE5F7"/>
+            </a:solidFill>
+            <a:prstDash val="solid"/>
+          </a:ln>
+          <a:effectLst>
+            <a:outerShdw sx="100000" sy="100000" kx="0" ky="0" algn="bl" rotWithShape="0" blurRad="127000" dist="38100" dir="5400000">
+              <a:srgbClr val="0B2A6F">
+                <a:alpha val="12000"/>
+              </a:srgbClr>
+            </a:outerShdw>
+          </a:effectLst>
+        </p:spPr>
+      </p:sp>
+      <p:sp>
+        <p:nvSpPr>
+          <p:cNvPr id="15" name="a3_252"/>
+          <p:cNvSpPr/>
+          <p:nvPr/>
+        </p:nvSpPr>
+        <p:spPr>
+          <a:xfrm>
+            <a:off x="822960" y="4160520"/>
+            <a:ext cx="640080" cy="640080"/>
+          </a:xfrm>
+          <a:prstGeom prst="ellipse">
+            <a:avLst/>
+          </a:prstGeom>
+          <a:solidFill>
+            <a:schemeClr val="accent1"/>
+          </a:solidFill>
+          <a:ln w="12700">
+            <a:solidFill>
+              <a:schemeClr val="accent1"/>
+            </a:solidFill>
+            <a:prstDash val="solid"/>
+          </a:ln>
+        </p:spPr>
+      </p:sp>
+      <p:pic>
+        <p:nvPicPr>
+          <p:cNvPr id="16" name="a3_253" descr="preencoded.png">    </p:cNvPr>
+          <p:cNvPicPr>
+            <a:picLocks noChangeAspect="1"/>
+          </p:cNvPicPr>
+          <p:nvPr/>
+        </p:nvPicPr>
+        <p:blipFill>
+          <a:blip r:embed="rId3"/>
+          <a:stretch>
+            <a:fillRect/>
+          </a:stretch>
+        </p:blipFill>
+        <p:spPr>
+          <a:xfrm>
+            <a:off x="989381" y="4326941"/>
+            <a:ext cx="307238" cy="307238"/>
+          </a:xfrm>
+          <a:prstGeom prst="rect">
+            <a:avLst/>
+          </a:prstGeom>
+        </p:spPr>
+      </p:pic>
+      <p:sp>
+        <p:nvSpPr>
+          <p:cNvPr id="17" name="a3_254"/>
+          <p:cNvSpPr txBox="1"/>
+          <p:nvPr/>
+        </p:nvSpPr>
+        <p:spPr>
+          <a:xfrm>
+            <a:off x="822960" y="4892040"/>
+            <a:ext cx="2834640" cy="365760"/>
+          </a:xfrm>
+          <a:prstGeom prst="rect">
+            <a:avLst/>
+          </a:prstGeom>
+          <a:noFill/>
+          <a:ln/>
+        </p:spPr>
+        <p:txBody>
+          <a:bodyPr wrap="square" lIns="0" tIns="0" rIns="0" bIns="0" rtlCol="0" anchor="ctr"/>
+          <a:lstStyle/>
+          <a:p>
+            <a:pPr indent="0" marL="0">
+              <a:buNone/>
+            </a:pPr>
+            <a:r>
+              <a:rPr lang="en-US" sz="1700" b="1" dirty="0">
+                <a:solidFill>
+                  <a:schemeClr val="tx2"/>
+                </a:solidFill>
+              </a:rPr>
+              <a:t>Analyse des causes (EDR)</a:t>
+            </a:r>
+            <a:endParaRPr lang="en-US" sz="1700" dirty="0"/>
+          </a:p>
+        </p:txBody>
+      </p:sp>
+      <p:sp>
+        <p:nvSpPr>
+          <p:cNvPr id="18" name="a3_255"/>
+          <p:cNvSpPr txBox="1"/>
+          <p:nvPr/>
+        </p:nvSpPr>
+        <p:spPr>
+          <a:xfrm>
+            <a:off x="822960" y="5257800"/>
+            <a:ext cx="2834640" cy="594360"/>
+          </a:xfrm>
+          <a:prstGeom prst="rect">
+            <a:avLst/>
+          </a:prstGeom>
+          <a:noFill/>
+          <a:ln/>
+        </p:spPr>
+        <p:txBody>
+          <a:bodyPr wrap="square" lIns="0" tIns="0" rIns="0" bIns="0" rtlCol="0" anchor="t"/>
+          <a:lstStyle/>
+          <a:p>
+            <a:pPr indent="0" marL="0">
+              <a:buNone/>
+            </a:pPr>
+            <a:r>
+              <a:rPr lang="en-US" sz="1300" dirty="0">
+                <a:solidFill>
+                  <a:schemeClr val="accent6"/>
+                </a:solidFill>
+              </a:rPr>
+              <a:t>Montre comment une attaque est arrivée pour la stopper</a:t>
+            </a:r>
+            <a:endParaRPr lang="en-US" sz="1300" dirty="0"/>
+          </a:p>
+        </p:txBody>
+      </p:sp>
+      <p:sp>
+        <p:nvSpPr>
+          <p:cNvPr id="19" name="a4_256"/>
+          <p:cNvSpPr/>
+          <p:nvPr/>
+        </p:nvSpPr>
+        <p:spPr>
+          <a:xfrm>
+            <a:off x="4069080" y="3886200"/>
+            <a:ext cx="3337560" cy="2011680"/>
+          </a:xfrm>
+          <a:prstGeom prst="roundRect">
+            <a:avLst>
+              <a:gd name="adj" fmla="val 6364"/>
+            </a:avLst>
+          </a:prstGeom>
+          <a:solidFill>
+            <a:schemeClr val="bg1"/>
+          </a:solidFill>
+          <a:ln w="12700">
+            <a:solidFill>
+              <a:srgbClr val="DCE5F7"/>
+            </a:solidFill>
+            <a:prstDash val="solid"/>
+          </a:ln>
+          <a:effectLst>
+            <a:outerShdw sx="100000" sy="100000" kx="0" ky="0" algn="bl" rotWithShape="0" blurRad="127000" dist="38100" dir="5400000">
+              <a:srgbClr val="0B2A6F">
+                <a:alpha val="12000"/>
+              </a:srgbClr>
+            </a:outerShdw>
+          </a:effectLst>
+        </p:spPr>
+      </p:sp>
+      <p:sp>
+        <p:nvSpPr>
+          <p:cNvPr id="20" name="a4_257"/>
+          <p:cNvSpPr/>
+          <p:nvPr/>
+        </p:nvSpPr>
+        <p:spPr>
+          <a:xfrm>
+            <a:off x="4343400" y="4160520"/>
+            <a:ext cx="640080" cy="640080"/>
+          </a:xfrm>
+          <a:prstGeom prst="ellipse">
+            <a:avLst/>
+          </a:prstGeom>
+          <a:solidFill>
+            <a:schemeClr val="accent1"/>
+          </a:solidFill>
+          <a:ln w="12700">
+            <a:solidFill>
+              <a:schemeClr val="accent1"/>
+            </a:solidFill>
+            <a:prstDash val="solid"/>
+          </a:ln>
+        </p:spPr>
+      </p:sp>
+      <p:pic>
+        <p:nvPicPr>
+          <p:cNvPr id="21" name="a4_258" descr="preencoded.png">    </p:cNvPr>
+          <p:cNvPicPr>
+            <a:picLocks noChangeAspect="1"/>
+          </p:cNvPicPr>
+          <p:nvPr/>
+        </p:nvPicPr>
+        <p:blipFill>
+          <a:blip r:embed="rId4"/>
+          <a:stretch>
+            <a:fillRect/>
+          </a:stretch>
+        </p:blipFill>
+        <p:spPr>
+          <a:xfrm>
+            <a:off x="4509821" y="4326941"/>
+            <a:ext cx="307238" cy="307238"/>
+          </a:xfrm>
+          <a:prstGeom prst="rect">
+            <a:avLst/>
+          </a:prstGeom>
+        </p:spPr>
+      </p:pic>
+      <p:sp>
+        <p:nvSpPr>
+          <p:cNvPr id="22" name="a4_259"/>
+          <p:cNvSpPr txBox="1"/>
+          <p:nvPr/>
+        </p:nvSpPr>
+        <p:spPr>
+          <a:xfrm>
+            <a:off x="4343400" y="4892040"/>
+            <a:ext cx="2834640" cy="365760"/>
+          </a:xfrm>
+          <a:prstGeom prst="rect">
+            <a:avLst/>
+          </a:prstGeom>
+          <a:noFill/>
+          <a:ln/>
+        </p:spPr>
+        <p:txBody>
+          <a:bodyPr wrap="square" lIns="0" tIns="0" rIns="0" bIns="0" rtlCol="0" anchor="ctr"/>
+          <a:lstStyle/>
+          <a:p>
+            <a:pPr indent="0" marL="0">
+              <a:buNone/>
+            </a:pPr>
+            <a:r>
+              <a:rPr lang="en-US" sz="1700" b="1" dirty="0">
+                <a:solidFill>
+                  <a:schemeClr val="tx2"/>
+                </a:solidFill>
+              </a:rPr>
+              <a:t>Console cloud</a:t>
+            </a:r>
+            <a:endParaRPr lang="en-US" sz="1700" dirty="0"/>
+          </a:p>
+        </p:txBody>
+      </p:sp>
+      <p:sp>
+        <p:nvSpPr>
+          <p:cNvPr id="23" name="a4_260"/>
+          <p:cNvSpPr txBox="1"/>
+          <p:nvPr/>
+        </p:nvSpPr>
+        <p:spPr>
+          <a:xfrm>
+            <a:off x="4343400" y="5257800"/>
+            <a:ext cx="2834640" cy="594360"/>
+          </a:xfrm>
+          <a:prstGeom prst="rect">
+            <a:avLst/>
+          </a:prstGeom>
+          <a:noFill/>
+          <a:ln/>
+        </p:spPr>
+        <p:txBody>
+          <a:bodyPr wrap="square" lIns="0" tIns="0" rIns="0" bIns="0" rtlCol="0" anchor="t"/>
+          <a:lstStyle/>
+          <a:p>
+            <a:pPr indent="0" marL="0">
+              <a:buNone/>
+            </a:pPr>
+            <a:r>
+              <a:rPr lang="en-US" sz="1300" dirty="0">
+                <a:solidFill>
+                  <a:schemeClr val="accent6"/>
+                </a:solidFill>
+              </a:rPr>
+              <a:t>Toute la sécurité pilotée à distance par l'administrateur</a:t>
+            </a:r>
+            <a:endParaRPr lang="en-US" sz="1300" dirty="0"/>
+          </a:p>
+        </p:txBody>
+      </p:sp>
+      <p:sp>
+        <p:nvSpPr>
+          <p:cNvPr id="24" name="a5_261"/>
+          <p:cNvSpPr/>
+          <p:nvPr/>
+        </p:nvSpPr>
+        <p:spPr>
+          <a:xfrm>
+            <a:off x="7772400" y="1645920"/>
+            <a:ext cx="3840480" cy="4251960"/>
+          </a:xfrm>
+          <a:prstGeom prst="roundRect">
+            <a:avLst>
+              <a:gd name="adj" fmla="val 3333"/>
+            </a:avLst>
+          </a:prstGeom>
+          <a:solidFill>
+            <a:schemeClr val="tx2"/>
+          </a:solidFill>
+          <a:ln w="12700">
+            <a:solidFill>
+              <a:schemeClr val="tx2"/>
+            </a:solidFill>
+            <a:prstDash val="solid"/>
+          </a:ln>
+          <a:effectLst>
+            <a:outerShdw sx="100000" sy="100000" kx="0" ky="0" algn="bl" rotWithShape="0" blurRad="127000" dist="38100" dir="5400000">
+              <a:srgbClr val="0B2A6F">
+                <a:alpha val="12000"/>
+              </a:srgbClr>
+            </a:outerShdw>
+          </a:effectLst>
+        </p:spPr>
+      </p:sp>
+      <p:sp>
+        <p:nvSpPr>
+          <p:cNvPr id="25" name="a5_262"/>
+          <p:cNvSpPr txBox="1"/>
+          <p:nvPr/>
+        </p:nvSpPr>
+        <p:spPr>
+          <a:xfrm>
+            <a:off x="8046720" y="1874520"/>
+            <a:ext cx="3291840" cy="365760"/>
+          </a:xfrm>
+          <a:prstGeom prst="rect">
+            <a:avLst/>
+          </a:prstGeom>
+          <a:noFill/>
+          <a:ln/>
+        </p:spPr>
+        <p:txBody>
+          <a:bodyPr wrap="square" lIns="0" tIns="0" rIns="0" bIns="0" rtlCol="0" anchor="ctr"/>
+          <a:lstStyle/>
+          <a:p>
+            <a:pPr indent="0" marL="0">
+              <a:buNone/>
+            </a:pPr>
+            <a:r>
+              <a:rPr lang="en-US" sz="1500" dirty="0">
+                <a:solidFill>
+                  <a:schemeClr val="accent4"/>
+                </a:solidFill>
+              </a:rPr>
+              <a:t>15 utilisateurs · 1 an</a:t>
+            </a:r>
+            <a:endParaRPr lang="en-US" sz="1500" dirty="0"/>
+          </a:p>
+        </p:txBody>
+      </p:sp>
+      <p:sp>
+        <p:nvSpPr>
+          <p:cNvPr id="26" name="a5_263"/>
+          <p:cNvSpPr txBox="1"/>
+          <p:nvPr/>
+        </p:nvSpPr>
+        <p:spPr>
+          <a:xfrm>
+            <a:off x="8046720" y="2240280"/>
+            <a:ext cx="3291840" cy="365760"/>
+          </a:xfrm>
+          <a:prstGeom prst="rect">
+            <a:avLst/>
+          </a:prstGeom>
+          <a:noFill/>
+          <a:ln/>
+        </p:spPr>
+        <p:txBody>
+          <a:bodyPr wrap="square" lIns="0" tIns="0" rIns="0" bIns="0" rtlCol="0" anchor="ctr"/>
+          <a:lstStyle/>
+          <a:p>
+            <a:pPr indent="0" marL="0">
+              <a:buNone/>
+            </a:pPr>
+            <a:r>
+              <a:rPr lang="en-US" sz="1300" dirty="0">
+                <a:solidFill>
+                  <a:schemeClr val="accent4"/>
+                </a:solidFill>
+              </a:rPr>
+              <a:t>Postes, serveur et jusqu'à 30 mobiles</a:t>
+            </a:r>
+            <a:endParaRPr lang="en-US" sz="1300" dirty="0"/>
+          </a:p>
+        </p:txBody>
+      </p:sp>
+      <p:sp>
+        <p:nvSpPr>
+          <p:cNvPr id="27" name="a6_264"/>
+          <p:cNvSpPr txBox="1"/>
+          <p:nvPr/>
+        </p:nvSpPr>
+        <p:spPr>
+          <a:xfrm>
+            <a:off x="8046720" y="2788920"/>
+            <a:ext cx="3291840" cy="365760"/>
+          </a:xfrm>
+          <a:prstGeom prst="rect">
+            <a:avLst/>
+          </a:prstGeom>
+          <a:noFill/>
+          <a:ln/>
+        </p:spPr>
+        <p:txBody>
+          <a:bodyPr wrap="square" lIns="0" tIns="0" rIns="0" bIns="0" rtlCol="0" anchor="ctr"/>
+          <a:lstStyle/>
+          <a:p>
+            <a:pPr indent="0" marL="0">
+              <a:buNone/>
+            </a:pPr>
+            <a:r>
+              <a:rPr lang="en-US" sz="1500" strike="sngStrike" dirty="0">
+                <a:solidFill>
+                  <a:schemeClr val="accent3"/>
+                </a:solidFill>
+              </a:rPr>
+              <a:t>≈ 566 000 FCFA</a:t>
+            </a:r>
+            <a:endParaRPr lang="en-US" sz="1500" dirty="0"/>
+          </a:p>
+        </p:txBody>
+      </p:sp>
+      <p:sp>
+        <p:nvSpPr>
+          <p:cNvPr id="28" name="a6_265"/>
+          <p:cNvSpPr txBox="1"/>
+          <p:nvPr/>
+        </p:nvSpPr>
+        <p:spPr>
+          <a:xfrm>
+            <a:off x="8046720" y="3108960"/>
+            <a:ext cx="3291840" cy="731520"/>
+          </a:xfrm>
+          <a:prstGeom prst="rect">
+            <a:avLst/>
+          </a:prstGeom>
+          <a:noFill/>
+          <a:ln/>
+        </p:spPr>
+        <p:txBody>
+          <a:bodyPr wrap="square" lIns="0" tIns="0" rIns="0" bIns="0" rtlCol="0" anchor="ctr"/>
+          <a:lstStyle/>
+          <a:p>
+            <a:pPr indent="0" marL="0">
+              <a:buNone/>
+            </a:pPr>
+            <a:r>
+              <a:rPr lang="en-US" sz="4000" b="1" dirty="0">
+                <a:solidFill>
+                  <a:schemeClr val="bg1"/>
+                </a:solidFill>
+              </a:rPr>
+              <a:t>≈ 477 000</a:t>
+            </a:r>
+            <a:endParaRPr lang="en-US" sz="4000" dirty="0"/>
+          </a:p>
+        </p:txBody>
+      </p:sp>
+      <p:sp>
+        <p:nvSpPr>
+          <p:cNvPr id="29" name="a6_266"/>
+          <p:cNvSpPr txBox="1"/>
+          <p:nvPr/>
+        </p:nvSpPr>
+        <p:spPr>
+          <a:xfrm>
+            <a:off x="8046720" y="3840480"/>
+            <a:ext cx="3291840" cy="548640"/>
+          </a:xfrm>
+          <a:prstGeom prst="rect">
+            <a:avLst/>
+          </a:prstGeom>
+          <a:noFill/>
+          <a:ln/>
+        </p:spPr>
+        <p:txBody>
+          <a:bodyPr wrap="square" lIns="0" tIns="0" rIns="0" bIns="0" rtlCol="0" anchor="t"/>
+          <a:lstStyle/>
+          <a:p>
+            <a:pPr indent="0" marL="0">
+              <a:buNone/>
+            </a:pPr>
+            <a:r>
+              <a:rPr lang="en-US" sz="1300" dirty="0">
+                <a:solidFill>
+                  <a:schemeClr val="accent4"/>
+                </a:solidFill>
+              </a:rPr>
+              <a:t>FCFA HT / an · tarif promotionnel nouveaux clients</a:t>
+            </a:r>
+            <a:endParaRPr lang="en-US" sz="1300" dirty="0"/>
+          </a:p>
+        </p:txBody>
+      </p:sp>
+      <p:sp>
+        <p:nvSpPr>
+          <p:cNvPr id="30" name="a7_267"/>
+          <p:cNvSpPr txBox="1"/>
+          <p:nvPr/>
+        </p:nvSpPr>
+        <p:spPr>
+          <a:xfrm>
+            <a:off x="8046720" y="4617720"/>
+            <a:ext cx="3291840" cy="822960"/>
+          </a:xfrm>
+          <a:prstGeom prst="rect">
+            <a:avLst/>
+          </a:prstGeom>
+          <a:noFill/>
+          <a:ln/>
+        </p:spPr>
+        <p:txBody>
+          <a:bodyPr wrap="square" lIns="0" tIns="0" rIns="0" bIns="0" rtlCol="0" anchor="t"/>
+          <a:lstStyle/>
+          <a:p>
+            <a:pPr indent="0" marL="0">
+              <a:buNone/>
+            </a:pPr>
+            <a:r>
+              <a:rPr lang="en-US" sz="1500" b="1" dirty="0">
+                <a:solidFill>
+                  <a:schemeClr val="bg1"/>
+                </a:solidFill>
+              </a:rPr>
+              <a:t>≈ 40 000 FCFA par mois pour protéger toute l'entreprise</a:t>
+            </a:r>
+            <a:endParaRPr lang="en-US" sz="1500" dirty="0"/>
+          </a:p>
+        </p:txBody>
+      </p:sp>
+      <p:sp>
+        <p:nvSpPr>
+          <p:cNvPr id="31" name="a7_268"/>
+          <p:cNvSpPr txBox="1"/>
+          <p:nvPr/>
+        </p:nvSpPr>
+        <p:spPr>
+          <a:xfrm>
+            <a:off x="548640" y="6035040"/>
+            <a:ext cx="11064240" cy="274320"/>
+          </a:xfrm>
+          <a:prstGeom prst="rect">
+            <a:avLst/>
+          </a:prstGeom>
+          <a:noFill/>
+          <a:ln/>
+        </p:spPr>
+        <p:txBody>
+          <a:bodyPr wrap="square" lIns="0" tIns="0" rIns="0" bIns="0" rtlCol="0" anchor="ctr"/>
+          <a:lstStyle/>
+          <a:p>
+            <a:pPr indent="0" marL="0">
+              <a:buNone/>
+            </a:pPr>
+            <a:r>
+              <a:rPr lang="en-US" sz="1100" i="1" dirty="0">
+                <a:solidFill>
+                  <a:schemeClr val="accent6"/>
+                </a:solidFill>
+              </a:rPr>
+              <a:t>Option indépendante de l'infrastructure · prix éditeur converti (1 € = 655,957 FCFA)</a:t>
+            </a:r>
+            <a:endParaRPr lang="en-US" sz="1100" dirty="0"/>
+          </a:p>
+        </p:txBody>
+      </p:sp>
+      <p:sp>
+        <p:nvSpPr>
+          <p:cNvPr id="25" name="Slide Number Placeholder 0"/>
+          <p:cNvSpPr>
+            <a:spLocks noGrp="1"/>
+          </p:cNvSpPr>
+          <p:nvPr>
+            <p:ph type="sldNum" sz="quarter" idx="4294967295"/>
+          </p:nvPr>
+        </p:nvSpPr>
+        <p:spPr>
+          <a:xfrm>
+            <a:off x="11247120" y="6400800"/>
+            <a:ext cx="457200" cy="274320"/>
+          </a:xfrm>
+          <a:prstGeom prst="rect">
+            <a:avLst/>
+          </a:prstGeom>
+          <a:extLst>
+            <a:ext uri="{C572A759-6A51-4108-AA02-DFA0A04FC94B}">
+              <ma14:wrappingTextBoxFlag xmlns:ma14="http://schemas.microsoft.com/office/mac/drawingml/2011/main" val="0"/>
+            </a:ext>
+          </a:extLst>
+        </p:spPr>
+        <p:txBody>
+          <a:bodyPr/>
+          <a:lstStyle>
+            <a:lvl1pPr>
+              <a:defRPr sz="1000">
+                <a:solidFill>
+                  <a:schemeClr val="accent6"/>
+                </a:solidFill>
+              </a:defRPr>
+            </a:lvl1pPr>
+          </a:lstStyle>
+          <a:p>
+            <a:pPr algn="l"/>
+            <a:fld id="{F7021451-1387-4CA6-816F-3879F97B5CBC}" type="slidenum">
+              <a:rPr b="0" lang="en-US"/>
+              <a:t>13</a:t>
+            </a:fld>
+            <a:endParaRPr lang="en-US"/>
+          </a:p>
+        </p:txBody>
+      </p:sp>
+    </p:spTree>
+  </p:cSld>
+  <p:clrMapOvr>
+    <a:masterClrMapping/>
+  </p:clrMapOvr>
+  <p:transition spd="slow">
+    <p:fade/>
+  </p:transition>
+  <p:timing>
+    <p:tnLst>
+      <p:par>
+        <p:cTn id="1" dur="indefinite" restart="never" nodeType="tmRoot">
+          <p:childTnLst>
+            <p:seq concurrent="1" nextAc="seek">
+              <p:cTn id="2" dur="indefinite" nodeType="mainSeq">
+                <p:childTnLst>
+                  <p:par>
+                    <p:cTn id="3" fill="hold">
+                      <p:stCondLst>
+                        <p:cond delay="indefinite"/>
+                        <p:cond evt="onBegin" delay="0">
+                          <p:tn val="2"/>
+                        </p:cond>
+                      </p:stCondLst>
+                      <p:childTnLst>
+                        <p:par>
+                          <p:cTn id="4" presetID="10" presetClass="entr" presetSubtype="0" fill="hold" nodeType="withEffect">
+                            <p:stCondLst>
+                              <p:cond delay="0"/>
+                            </p:stCondLst>
+                            <p:childTnLst>
+                              <p:set>
+                                <p:cBhvr>
+                                  <p:cTn id="5" dur="1" fill="hold">
+                                    <p:stCondLst>
+                                      <p:cond delay="0"/>
+                                    </p:stCondLst>
+                                  </p:cTn>
+                                  <p:tgtEl>
+                                    <p:spTgt spid="4"/>
+                                  </p:tgtEl>
+                                  <p:attrNameLst>
+                                    <p:attrName>style.visibility</p:attrName>
+                                  </p:attrNameLst>
+                                </p:cBhvr>
+                                <p:to>
+                                  <p:strVal val="visible"/>
+                                </p:to>
+                              </p:set>
+                              <p:animEffect transition="in" filter="fade">
+                                <p:cBhvr>
+                                  <p:cTn id="6" dur="600"/>
+                                  <p:tgtEl>
+                                    <p:spTgt spid="4"/>
+                                  </p:tgtEl>
+                                </p:cBhvr>
+                              </p:animEffect>
+                              <p:anim calcmode="lin" valueType="num">
+                                <p:cBhvr>
+                                  <p:cTn id="7" dur="600" decel="100000" fill="hold"/>
+                                  <p:tgtEl>
+                                    <p:spTgt spid="4"/>
+                                  </p:tgtEl>
+                                  <p:attrNameLst>
+                                    <p:attrName>ppt_y</p:attrName>
+                                  </p:attrNameLst>
+                                </p:cBhvr>
+                                <p:tavLst>
+                                  <p:tav tm="0">
+                                    <p:val>
+                                      <p:strVal val="#ppt_y+0.03"/>
+                                    </p:val>
+                                  </p:tav>
+                                  <p:tav tm="100000">
+                                    <p:val>
+                                      <p:strVal val="#ppt_y"/>
+                                    </p:val>
+                                  </p:tav>
+                                </p:tavLst>
+                              </p:anim>
+                            </p:childTnLst>
+                          </p:cTn>
+                        </p:par>
+                        <p:par>
+                          <p:cTn id="8" presetID="10" presetClass="entr" presetSubtype="0" fill="hold" nodeType="withEffect">
+                            <p:stCondLst>
+                              <p:cond delay="60"/>
+                            </p:stCondLst>
+                            <p:childTnLst>
+                              <p:set>
+                                <p:cBhvr>
+                                  <p:cTn id="9" dur="1" fill="hold">
+                                    <p:stCondLst>
+                                      <p:cond delay="0"/>
+                                    </p:stCondLst>
+                                  </p:cTn>
+                                  <p:tgtEl>
+                                    <p:spTgt spid="5"/>
+                                  </p:tgtEl>
+                                  <p:attrNameLst>
+                                    <p:attrName>style.visibility</p:attrName>
+                                  </p:attrNameLst>
+                                </p:cBhvr>
+                                <p:to>
+                                  <p:strVal val="visible"/>
+                                </p:to>
+                              </p:set>
+                              <p:animEffect transition="in" filter="fade">
+                                <p:cBhvr>
+                                  <p:cTn id="10" dur="600"/>
+                                  <p:tgtEl>
+                                    <p:spTgt spid="5"/>
+                                  </p:tgtEl>
+                                </p:cBhvr>
+                              </p:animEffect>
+                              <p:anim calcmode="lin" valueType="num">
+                                <p:cBhvr>
+                                  <p:cTn id="11" dur="600" decel="100000" fill="hold"/>
+                                  <p:tgtEl>
+                                    <p:spTgt spid="5"/>
+                                  </p:tgtEl>
+                                  <p:attrNameLst>
+                                    <p:attrName>ppt_y</p:attrName>
+                                  </p:attrNameLst>
+                                </p:cBhvr>
+                                <p:tavLst>
+                                  <p:tav tm="0">
+                                    <p:val>
+                                      <p:strVal val="#ppt_y+0.03"/>
+                                    </p:val>
+                                  </p:tav>
+                                  <p:tav tm="100000">
+                                    <p:val>
+                                      <p:strVal val="#ppt_y"/>
+                                    </p:val>
+                                  </p:tav>
+                                </p:tavLst>
+                              </p:anim>
+                            </p:childTnLst>
+                          </p:cTn>
+                        </p:par>
+                        <p:par>
+                          <p:cTn id="12" presetID="10" presetClass="entr" presetSubtype="0" fill="hold" nodeType="withEffect">
+                            <p:stCondLst>
+                              <p:cond delay="120"/>
+                            </p:stCondLst>
+                            <p:childTnLst>
+                              <p:set>
+                                <p:cBhvr>
+                                  <p:cTn id="13" dur="1" fill="hold">
+                                    <p:stCondLst>
+                                      <p:cond delay="0"/>
+                                    </p:stCondLst>
+                                  </p:cTn>
+                                  <p:tgtEl>
+                                    <p:spTgt spid="6"/>
+                                  </p:tgtEl>
+                                  <p:attrNameLst>
+                                    <p:attrName>style.visibility</p:attrName>
+                                  </p:attrNameLst>
+                                </p:cBhvr>
+                                <p:to>
+                                  <p:strVal val="visible"/>
+                                </p:to>
+                              </p:set>
+                              <p:animEffect transition="in" filter="fade">
+                                <p:cBhvr>
+                                  <p:cTn id="14" dur="600"/>
+                                  <p:tgtEl>
+                                    <p:spTgt spid="6"/>
+                                  </p:tgtEl>
+                                </p:cBhvr>
+                              </p:animEffect>
+                              <p:anim calcmode="lin" valueType="num">
+                                <p:cBhvr>
+                                  <p:cTn id="15" dur="600" decel="100000" fill="hold"/>
+                                  <p:tgtEl>
+                                    <p:spTgt spid="6"/>
+                                  </p:tgtEl>
+                                  <p:attrNameLst>
+                                    <p:attrName>ppt_y</p:attrName>
+                                  </p:attrNameLst>
+                                </p:cBhvr>
+                                <p:tavLst>
+                                  <p:tav tm="0">
+                                    <p:val>
+                                      <p:strVal val="#ppt_y+0.03"/>
+                                    </p:val>
+                                  </p:tav>
+                                  <p:tav tm="100000">
+                                    <p:val>
+                                      <p:strVal val="#ppt_y"/>
+                                    </p:val>
+                                  </p:tav>
+                                </p:tavLst>
+                              </p:anim>
+                            </p:childTnLst>
+                          </p:cTn>
+                        </p:par>
+                        <p:par>
+                          <p:cTn id="16" presetID="10" presetClass="entr" presetSubtype="0" fill="hold" nodeType="withEffect">
+                            <p:stCondLst>
+                              <p:cond delay="180"/>
+                            </p:stCondLst>
+                            <p:childTnLst>
+                              <p:set>
+                                <p:cBhvr>
+                                  <p:cTn id="17" dur="1" fill="hold">
+                                    <p:stCondLst>
+                                      <p:cond delay="0"/>
+                                    </p:stCondLst>
+                                  </p:cTn>
+                                  <p:tgtEl>
+                                    <p:spTgt spid="7"/>
+                                  </p:tgtEl>
+                                  <p:attrNameLst>
+                                    <p:attrName>style.visibility</p:attrName>
+                                  </p:attrNameLst>
+                                </p:cBhvr>
+                                <p:to>
+                                  <p:strVal val="visible"/>
+                                </p:to>
+                              </p:set>
+                              <p:animEffect transition="in" filter="fade">
+                                <p:cBhvr>
+                                  <p:cTn id="18" dur="600"/>
+                                  <p:tgtEl>
+                                    <p:spTgt spid="7"/>
+                                  </p:tgtEl>
+                                </p:cBhvr>
+                              </p:animEffect>
+                              <p:anim calcmode="lin" valueType="num">
+                                <p:cBhvr>
+                                  <p:cTn id="19" dur="600" decel="100000" fill="hold"/>
+                                  <p:tgtEl>
+                                    <p:spTgt spid="7"/>
+                                  </p:tgtEl>
+                                  <p:attrNameLst>
+                                    <p:attrName>ppt_y</p:attrName>
+                                  </p:attrNameLst>
+                                </p:cBhvr>
+                                <p:tavLst>
+                                  <p:tav tm="0">
+                                    <p:val>
+                                      <p:strVal val="#ppt_y+0.03"/>
+                                    </p:val>
+                                  </p:tav>
+                                  <p:tav tm="100000">
+                                    <p:val>
+                                      <p:strVal val="#ppt_y"/>
+                                    </p:val>
+                                  </p:tav>
+                                </p:tavLst>
+                              </p:anim>
+                            </p:childTnLst>
+                          </p:cTn>
+                        </p:par>
+                        <p:par>
+                          <p:cTn id="20" presetID="10" presetClass="entr" presetSubtype="0" fill="hold" nodeType="withEffect">
+                            <p:stCondLst>
+                              <p:cond delay="240"/>
+                            </p:stCondLst>
+                            <p:childTnLst>
+                              <p:set>
+                                <p:cBhvr>
+                                  <p:cTn id="21" dur="1" fill="hold">
+                                    <p:stCondLst>
+                                      <p:cond delay="0"/>
+                                    </p:stCondLst>
+                                  </p:cTn>
+                                  <p:tgtEl>
+                                    <p:spTgt spid="8"/>
+                                  </p:tgtEl>
+                                  <p:attrNameLst>
+                                    <p:attrName>style.visibility</p:attrName>
+                                  </p:attrNameLst>
+                                </p:cBhvr>
+                                <p:to>
+                                  <p:strVal val="visible"/>
+                                </p:to>
+                              </p:set>
+                              <p:animEffect transition="in" filter="fade">
+                                <p:cBhvr>
+                                  <p:cTn id="22" dur="600"/>
+                                  <p:tgtEl>
+                                    <p:spTgt spid="8"/>
+                                  </p:tgtEl>
+                                </p:cBhvr>
+                              </p:animEffect>
+                              <p:anim calcmode="lin" valueType="num">
+                                <p:cBhvr>
+                                  <p:cTn id="23" dur="600" decel="100000" fill="hold"/>
+                                  <p:tgtEl>
+                                    <p:spTgt spid="8"/>
+                                  </p:tgtEl>
+                                  <p:attrNameLst>
+                                    <p:attrName>ppt_y</p:attrName>
+                                  </p:attrNameLst>
+                                </p:cBhvr>
+                                <p:tavLst>
+                                  <p:tav tm="0">
+                                    <p:val>
+                                      <p:strVal val="#ppt_y+0.03"/>
+                                    </p:val>
+                                  </p:tav>
+                                  <p:tav tm="100000">
+                                    <p:val>
+                                      <p:strVal val="#ppt_y"/>
+                                    </p:val>
+                                  </p:tav>
+                                </p:tavLst>
+                              </p:anim>
+                            </p:childTnLst>
+                          </p:cTn>
+                        </p:par>
+                        <p:par>
+                          <p:cTn id="24" presetID="10" presetClass="entr" presetSubtype="0" fill="hold" nodeType="withEffect">
+                            <p:stCondLst>
+                              <p:cond delay="450"/>
+                            </p:stCondLst>
+                            <p:childTnLst>
+                              <p:set>
+                                <p:cBhvr>
+                                  <p:cTn id="25" dur="1" fill="hold">
+                                    <p:stCondLst>
+                                      <p:cond delay="0"/>
+                                    </p:stCondLst>
+                                  </p:cTn>
+                                  <p:tgtEl>
+                                    <p:spTgt spid="9"/>
+                                  </p:tgtEl>
+                                  <p:attrNameLst>
+                                    <p:attrName>style.visibility</p:attrName>
+                                  </p:attrNameLst>
+                                </p:cBhvr>
+                                <p:to>
+                                  <p:strVal val="visible"/>
+                                </p:to>
+                              </p:set>
+                              <p:animEffect transition="in" filter="fade">
+                                <p:cBhvr>
+                                  <p:cTn id="26" dur="600"/>
+                                  <p:tgtEl>
+                                    <p:spTgt spid="9"/>
+                                  </p:tgtEl>
+                                </p:cBhvr>
+                              </p:animEffect>
+                              <p:anim calcmode="lin" valueType="num">
+                                <p:cBhvr>
+                                  <p:cTn id="27" dur="600" decel="100000" fill="hold"/>
+                                  <p:tgtEl>
+                                    <p:spTgt spid="9"/>
+                                  </p:tgtEl>
+                                  <p:attrNameLst>
+                                    <p:attrName>ppt_y</p:attrName>
+                                  </p:attrNameLst>
+                                </p:cBhvr>
+                                <p:tavLst>
+                                  <p:tav tm="0">
+                                    <p:val>
+                                      <p:strVal val="#ppt_y+0.03"/>
+                                    </p:val>
+                                  </p:tav>
+                                  <p:tav tm="100000">
+                                    <p:val>
+                                      <p:strVal val="#ppt_y"/>
+                                    </p:val>
+                                  </p:tav>
+                                </p:tavLst>
+                              </p:anim>
+                            </p:childTnLst>
+                          </p:cTn>
+                        </p:par>
+                        <p:par>
+                          <p:cTn id="28" presetID="10" presetClass="entr" presetSubtype="0" fill="hold" nodeType="withEffect">
+                            <p:stCondLst>
+                              <p:cond delay="510"/>
+                            </p:stCondLst>
+                            <p:childTnLst>
+                              <p:set>
+                                <p:cBhvr>
+                                  <p:cTn id="29" dur="1" fill="hold">
+                                    <p:stCondLst>
+                                      <p:cond delay="0"/>
+                                    </p:stCondLst>
+                                  </p:cTn>
+                                  <p:tgtEl>
+                                    <p:spTgt spid="10"/>
+                                  </p:tgtEl>
+                                  <p:attrNameLst>
+                                    <p:attrName>style.visibility</p:attrName>
+                                  </p:attrNameLst>
+                                </p:cBhvr>
+                                <p:to>
+                                  <p:strVal val="visible"/>
+                                </p:to>
+                              </p:set>
+                              <p:animEffect transition="in" filter="fade">
+                                <p:cBhvr>
+                                  <p:cTn id="30" dur="600"/>
+                                  <p:tgtEl>
+                                    <p:spTgt spid="10"/>
+                                  </p:tgtEl>
+                                </p:cBhvr>
+                              </p:animEffect>
+                              <p:anim calcmode="lin" valueType="num">
+                                <p:cBhvr>
+                                  <p:cTn id="31" dur="600" decel="100000" fill="hold"/>
+                                  <p:tgtEl>
+                                    <p:spTgt spid="10"/>
+                                  </p:tgtEl>
+                                  <p:attrNameLst>
+                                    <p:attrName>ppt_y</p:attrName>
+                                  </p:attrNameLst>
+                                </p:cBhvr>
+                                <p:tavLst>
+                                  <p:tav tm="0">
+                                    <p:val>
+                                      <p:strVal val="#ppt_y+0.03"/>
+                                    </p:val>
+                                  </p:tav>
+                                  <p:tav tm="100000">
+                                    <p:val>
+                                      <p:strVal val="#ppt_y"/>
+                                    </p:val>
+                                  </p:tav>
+                                </p:tavLst>
+                              </p:anim>
+                            </p:childTnLst>
+                          </p:cTn>
+                        </p:par>
+                        <p:par>
+                          <p:cTn id="32" presetID="10" presetClass="entr" presetSubtype="0" fill="hold" nodeType="withEffect">
+                            <p:stCondLst>
+                              <p:cond delay="570"/>
+                            </p:stCondLst>
+                            <p:childTnLst>
+                              <p:set>
+                                <p:cBhvr>
+                                  <p:cTn id="33" dur="1" fill="hold">
+                                    <p:stCondLst>
+                                      <p:cond delay="0"/>
+                                    </p:stCondLst>
+                                  </p:cTn>
+                                  <p:tgtEl>
+                                    <p:spTgt spid="11"/>
+                                  </p:tgtEl>
+                                  <p:attrNameLst>
+                                    <p:attrName>style.visibility</p:attrName>
+                                  </p:attrNameLst>
+                                </p:cBhvr>
+                                <p:to>
+                                  <p:strVal val="visible"/>
+                                </p:to>
+                              </p:set>
+                              <p:animEffect transition="in" filter="fade">
+                                <p:cBhvr>
+                                  <p:cTn id="34" dur="600"/>
+                                  <p:tgtEl>
+                                    <p:spTgt spid="11"/>
+                                  </p:tgtEl>
+                                </p:cBhvr>
+                              </p:animEffect>
+                              <p:anim calcmode="lin" valueType="num">
+                                <p:cBhvr>
+                                  <p:cTn id="35" dur="600" decel="100000" fill="hold"/>
+                                  <p:tgtEl>
+                                    <p:spTgt spid="11"/>
+                                  </p:tgtEl>
+                                  <p:attrNameLst>
+                                    <p:attrName>ppt_y</p:attrName>
+                                  </p:attrNameLst>
+                                </p:cBhvr>
+                                <p:tavLst>
+                                  <p:tav tm="0">
+                                    <p:val>
+                                      <p:strVal val="#ppt_y+0.03"/>
+                                    </p:val>
+                                  </p:tav>
+                                  <p:tav tm="100000">
+                                    <p:val>
+                                      <p:strVal val="#ppt_y"/>
+                                    </p:val>
+                                  </p:tav>
+                                </p:tavLst>
+                              </p:anim>
+                            </p:childTnLst>
+                          </p:cTn>
+                        </p:par>
+                        <p:par>
+                          <p:cTn id="36" presetID="10" presetClass="entr" presetSubtype="0" fill="hold" nodeType="withEffect">
+                            <p:stCondLst>
+                              <p:cond delay="630"/>
+                            </p:stCondLst>
+                            <p:childTnLst>
+                              <p:set>
+                                <p:cBhvr>
+                                  <p:cTn id="37" dur="1" fill="hold">
+                                    <p:stCondLst>
+                                      <p:cond delay="0"/>
+                                    </p:stCondLst>
+                                  </p:cTn>
+                                  <p:tgtEl>
+                                    <p:spTgt spid="12"/>
+                                  </p:tgtEl>
+                                  <p:attrNameLst>
+                                    <p:attrName>style.visibility</p:attrName>
+                                  </p:attrNameLst>
+                                </p:cBhvr>
+                                <p:to>
+                                  <p:strVal val="visible"/>
+                                </p:to>
+                              </p:set>
+                              <p:animEffect transition="in" filter="fade">
+                                <p:cBhvr>
+                                  <p:cTn id="38" dur="600"/>
+                                  <p:tgtEl>
+                                    <p:spTgt spid="12"/>
+                                  </p:tgtEl>
+                                </p:cBhvr>
+                              </p:animEffect>
+                              <p:anim calcmode="lin" valueType="num">
+                                <p:cBhvr>
+                                  <p:cTn id="39" dur="600" decel="100000" fill="hold"/>
+                                  <p:tgtEl>
+                                    <p:spTgt spid="12"/>
+                                  </p:tgtEl>
+                                  <p:attrNameLst>
+                                    <p:attrName>ppt_y</p:attrName>
+                                  </p:attrNameLst>
+                                </p:cBhvr>
+                                <p:tavLst>
+                                  <p:tav tm="0">
+                                    <p:val>
+                                      <p:strVal val="#ppt_y+0.03"/>
+                                    </p:val>
+                                  </p:tav>
+                                  <p:tav tm="100000">
+                                    <p:val>
+                                      <p:strVal val="#ppt_y"/>
+                                    </p:val>
+                                  </p:tav>
+                                </p:tavLst>
+                              </p:anim>
+                            </p:childTnLst>
+                          </p:cTn>
+                        </p:par>
+                        <p:par>
+                          <p:cTn id="40" presetID="10" presetClass="entr" presetSubtype="0" fill="hold" nodeType="withEffect">
+                            <p:stCondLst>
+                              <p:cond delay="690"/>
+                            </p:stCondLst>
+                            <p:childTnLst>
+                              <p:set>
+                                <p:cBhvr>
+                                  <p:cTn id="41" dur="1" fill="hold">
+                                    <p:stCondLst>
+                                      <p:cond delay="0"/>
+                                    </p:stCondLst>
+                                  </p:cTn>
+                                  <p:tgtEl>
+                                    <p:spTgt spid="13"/>
+                                  </p:tgtEl>
+                                  <p:attrNameLst>
+                                    <p:attrName>style.visibility</p:attrName>
+                                  </p:attrNameLst>
+                                </p:cBhvr>
+                                <p:to>
+                                  <p:strVal val="visible"/>
+                                </p:to>
+                              </p:set>
+                              <p:animEffect transition="in" filter="fade">
+                                <p:cBhvr>
+                                  <p:cTn id="42" dur="600"/>
+                                  <p:tgtEl>
+                                    <p:spTgt spid="13"/>
+                                  </p:tgtEl>
+                                </p:cBhvr>
+                              </p:animEffect>
+                              <p:anim calcmode="lin" valueType="num">
+                                <p:cBhvr>
+                                  <p:cTn id="43" dur="600" decel="100000" fill="hold"/>
+                                  <p:tgtEl>
+                                    <p:spTgt spid="13"/>
+                                  </p:tgtEl>
+                                  <p:attrNameLst>
+                                    <p:attrName>ppt_y</p:attrName>
+                                  </p:attrNameLst>
+                                </p:cBhvr>
+                                <p:tavLst>
+                                  <p:tav tm="0">
+                                    <p:val>
+                                      <p:strVal val="#ppt_y+0.03"/>
+                                    </p:val>
+                                  </p:tav>
+                                  <p:tav tm="100000">
+                                    <p:val>
+                                      <p:strVal val="#ppt_y"/>
+                                    </p:val>
+                                  </p:tav>
+                                </p:tavLst>
+                              </p:anim>
+                            </p:childTnLst>
+                          </p:cTn>
+                        </p:par>
+                        <p:par>
+                          <p:cTn id="44" presetID="10" presetClass="entr" presetSubtype="0" fill="hold" nodeType="withEffect">
+                            <p:stCondLst>
+                              <p:cond delay="900"/>
+                            </p:stCondLst>
+                            <p:childTnLst>
+                              <p:set>
+                                <p:cBhvr>
+                                  <p:cTn id="45" dur="1" fill="hold">
+                                    <p:stCondLst>
+                                      <p:cond delay="0"/>
+                                    </p:stCondLst>
+                                  </p:cTn>
+                                  <p:tgtEl>
+                                    <p:spTgt spid="14"/>
+                                  </p:tgtEl>
+                                  <p:attrNameLst>
+                                    <p:attrName>style.visibility</p:attrName>
+                                  </p:attrNameLst>
+                                </p:cBhvr>
+                                <p:to>
+                                  <p:strVal val="visible"/>
+                                </p:to>
+                              </p:set>
+                              <p:animEffect transition="in" filter="fade">
+                                <p:cBhvr>
+                                  <p:cTn id="46" dur="600"/>
+                                  <p:tgtEl>
+                                    <p:spTgt spid="14"/>
+                                  </p:tgtEl>
+                                </p:cBhvr>
+                              </p:animEffect>
+                              <p:anim calcmode="lin" valueType="num">
+                                <p:cBhvr>
+                                  <p:cTn id="47" dur="600" decel="100000" fill="hold"/>
+                                  <p:tgtEl>
+                                    <p:spTgt spid="14"/>
+                                  </p:tgtEl>
+                                  <p:attrNameLst>
+                                    <p:attrName>ppt_y</p:attrName>
+                                  </p:attrNameLst>
+                                </p:cBhvr>
+                                <p:tavLst>
+                                  <p:tav tm="0">
+                                    <p:val>
+                                      <p:strVal val="#ppt_y+0.03"/>
+                                    </p:val>
+                                  </p:tav>
+                                  <p:tav tm="100000">
+                                    <p:val>
+                                      <p:strVal val="#ppt_y"/>
+                                    </p:val>
+                                  </p:tav>
+                                </p:tavLst>
+                              </p:anim>
+                            </p:childTnLst>
+                          </p:cTn>
+                        </p:par>
+                        <p:par>
+                          <p:cTn id="48" presetID="10" presetClass="entr" presetSubtype="0" fill="hold" nodeType="withEffect">
+                            <p:stCondLst>
+                              <p:cond delay="960"/>
+                            </p:stCondLst>
+                            <p:childTnLst>
+                              <p:set>
+                                <p:cBhvr>
+                                  <p:cTn id="49" dur="1" fill="hold">
+                                    <p:stCondLst>
+                                      <p:cond delay="0"/>
+                                    </p:stCondLst>
+                                  </p:cTn>
+                                  <p:tgtEl>
+                                    <p:spTgt spid="15"/>
+                                  </p:tgtEl>
+                                  <p:attrNameLst>
+                                    <p:attrName>style.visibility</p:attrName>
+                                  </p:attrNameLst>
+                                </p:cBhvr>
+                                <p:to>
+                                  <p:strVal val="visible"/>
+                                </p:to>
+                              </p:set>
+                              <p:animEffect transition="in" filter="fade">
+                                <p:cBhvr>
+                                  <p:cTn id="50" dur="600"/>
+                                  <p:tgtEl>
+                                    <p:spTgt spid="15"/>
+                                  </p:tgtEl>
+                                </p:cBhvr>
+                              </p:animEffect>
+                              <p:anim calcmode="lin" valueType="num">
+                                <p:cBhvr>
+                                  <p:cTn id="51" dur="600" decel="100000" fill="hold"/>
+                                  <p:tgtEl>
+                                    <p:spTgt spid="15"/>
+                                  </p:tgtEl>
+                                  <p:attrNameLst>
+                                    <p:attrName>ppt_y</p:attrName>
+                                  </p:attrNameLst>
+                                </p:cBhvr>
+                                <p:tavLst>
+                                  <p:tav tm="0">
+                                    <p:val>
+                                      <p:strVal val="#ppt_y+0.03"/>
+                                    </p:val>
+                                  </p:tav>
+                                  <p:tav tm="100000">
+                                    <p:val>
+                                      <p:strVal val="#ppt_y"/>
+                                    </p:val>
+                                  </p:tav>
+                                </p:tavLst>
+                              </p:anim>
+                            </p:childTnLst>
+                          </p:cTn>
+                        </p:par>
+                        <p:par>
+                          <p:cTn id="52" presetID="10" presetClass="entr" presetSubtype="0" fill="hold" nodeType="withEffect">
+                            <p:stCondLst>
+                              <p:cond delay="1020"/>
+                            </p:stCondLst>
+                            <p:childTnLst>
+                              <p:set>
+                                <p:cBhvr>
+                                  <p:cTn id="53" dur="1" fill="hold">
+                                    <p:stCondLst>
+                                      <p:cond delay="0"/>
+                                    </p:stCondLst>
+                                  </p:cTn>
+                                  <p:tgtEl>
+                                    <p:spTgt spid="16"/>
+                                  </p:tgtEl>
+                                  <p:attrNameLst>
+                                    <p:attrName>style.visibility</p:attrName>
+                                  </p:attrNameLst>
+                                </p:cBhvr>
+                                <p:to>
+                                  <p:strVal val="visible"/>
+                                </p:to>
+                              </p:set>
+                              <p:animEffect transition="in" filter="fade">
+                                <p:cBhvr>
+                                  <p:cTn id="54" dur="600"/>
+                                  <p:tgtEl>
+                                    <p:spTgt spid="16"/>
+                                  </p:tgtEl>
+                                </p:cBhvr>
+                              </p:animEffect>
+                              <p:anim calcmode="lin" valueType="num">
+                                <p:cBhvr>
+                                  <p:cTn id="55" dur="600" decel="100000" fill="hold"/>
+                                  <p:tgtEl>
+                                    <p:spTgt spid="16"/>
+                                  </p:tgtEl>
+                                  <p:attrNameLst>
+                                    <p:attrName>ppt_y</p:attrName>
+                                  </p:attrNameLst>
+                                </p:cBhvr>
+                                <p:tavLst>
+                                  <p:tav tm="0">
+                                    <p:val>
+                                      <p:strVal val="#ppt_y+0.03"/>
+                                    </p:val>
+                                  </p:tav>
+                                  <p:tav tm="100000">
+                                    <p:val>
+                                      <p:strVal val="#ppt_y"/>
+                                    </p:val>
+                                  </p:tav>
+                                </p:tavLst>
+                              </p:anim>
+                            </p:childTnLst>
+                          </p:cTn>
+                        </p:par>
+                        <p:par>
+                          <p:cTn id="56" presetID="10" presetClass="entr" presetSubtype="0" fill="hold" nodeType="withEffect">
+                            <p:stCondLst>
+                              <p:cond delay="1080"/>
+                            </p:stCondLst>
+                            <p:childTnLst>
+                              <p:set>
+                                <p:cBhvr>
+                                  <p:cTn id="57" dur="1" fill="hold">
+                                    <p:stCondLst>
+                                      <p:cond delay="0"/>
+                                    </p:stCondLst>
+                                  </p:cTn>
+                                  <p:tgtEl>
+                                    <p:spTgt spid="17"/>
+                                  </p:tgtEl>
+                                  <p:attrNameLst>
+                                    <p:attrName>style.visibility</p:attrName>
+                                  </p:attrNameLst>
+                                </p:cBhvr>
+                                <p:to>
+                                  <p:strVal val="visible"/>
+                                </p:to>
+                              </p:set>
+                              <p:animEffect transition="in" filter="fade">
+                                <p:cBhvr>
+                                  <p:cTn id="58" dur="600"/>
+                                  <p:tgtEl>
+                                    <p:spTgt spid="17"/>
+                                  </p:tgtEl>
+                                </p:cBhvr>
+                              </p:animEffect>
+                              <p:anim calcmode="lin" valueType="num">
+                                <p:cBhvr>
+                                  <p:cTn id="59" dur="600" decel="100000" fill="hold"/>
+                                  <p:tgtEl>
+                                    <p:spTgt spid="17"/>
+                                  </p:tgtEl>
+                                  <p:attrNameLst>
+                                    <p:attrName>ppt_y</p:attrName>
+                                  </p:attrNameLst>
+                                </p:cBhvr>
+                                <p:tavLst>
+                                  <p:tav tm="0">
+                                    <p:val>
+                                      <p:strVal val="#ppt_y+0.03"/>
+                                    </p:val>
+                                  </p:tav>
+                                  <p:tav tm="100000">
+                                    <p:val>
+                                      <p:strVal val="#ppt_y"/>
+                                    </p:val>
+                                  </p:tav>
+                                </p:tavLst>
+                              </p:anim>
+                            </p:childTnLst>
+                          </p:cTn>
+                        </p:par>
+                        <p:par>
+                          <p:cTn id="60" presetID="10" presetClass="entr" presetSubtype="0" fill="hold" nodeType="withEffect">
+                            <p:stCondLst>
+                              <p:cond delay="1140"/>
+                            </p:stCondLst>
+                            <p:childTnLst>
+                              <p:set>
+                                <p:cBhvr>
+                                  <p:cTn id="61" dur="1" fill="hold">
+                                    <p:stCondLst>
+                                      <p:cond delay="0"/>
+                                    </p:stCondLst>
+                                  </p:cTn>
+                                  <p:tgtEl>
+                                    <p:spTgt spid="18"/>
+                                  </p:tgtEl>
+                                  <p:attrNameLst>
+                                    <p:attrName>style.visibility</p:attrName>
+                                  </p:attrNameLst>
+                                </p:cBhvr>
+                                <p:to>
+                                  <p:strVal val="visible"/>
+                                </p:to>
+                              </p:set>
+                              <p:animEffect transition="in" filter="fade">
+                                <p:cBhvr>
+                                  <p:cTn id="62" dur="600"/>
+                                  <p:tgtEl>
+                                    <p:spTgt spid="18"/>
+                                  </p:tgtEl>
+                                </p:cBhvr>
+                              </p:animEffect>
+                              <p:anim calcmode="lin" valueType="num">
+                                <p:cBhvr>
+                                  <p:cTn id="63" dur="600" decel="100000" fill="hold"/>
+                                  <p:tgtEl>
+                                    <p:spTgt spid="18"/>
+                                  </p:tgtEl>
+                                  <p:attrNameLst>
+                                    <p:attrName>ppt_y</p:attrName>
+                                  </p:attrNameLst>
+                                </p:cBhvr>
+                                <p:tavLst>
+                                  <p:tav tm="0">
+                                    <p:val>
+                                      <p:strVal val="#ppt_y+0.03"/>
+                                    </p:val>
+                                  </p:tav>
+                                  <p:tav tm="100000">
+                                    <p:val>
+                                      <p:strVal val="#ppt_y"/>
+                                    </p:val>
+                                  </p:tav>
+                                </p:tavLst>
+                              </p:anim>
+                            </p:childTnLst>
+                          </p:cTn>
+                        </p:par>
+                        <p:par>
+                          <p:cTn id="64" presetID="10" presetClass="entr" presetSubtype="0" fill="hold" nodeType="withEffect">
+                            <p:stCondLst>
+                              <p:cond delay="1350"/>
+                            </p:stCondLst>
+                            <p:childTnLst>
+                              <p:set>
+                                <p:cBhvr>
+                                  <p:cTn id="65" dur="1" fill="hold">
+                                    <p:stCondLst>
+                                      <p:cond delay="0"/>
+                                    </p:stCondLst>
+                                  </p:cTn>
+                                  <p:tgtEl>
+                                    <p:spTgt spid="19"/>
+                                  </p:tgtEl>
+                                  <p:attrNameLst>
+                                    <p:attrName>style.visibility</p:attrName>
+                                  </p:attrNameLst>
+                                </p:cBhvr>
+                                <p:to>
+                                  <p:strVal val="visible"/>
+                                </p:to>
+                              </p:set>
+                              <p:animEffect transition="in" filter="fade">
+                                <p:cBhvr>
+                                  <p:cTn id="66" dur="600"/>
+                                  <p:tgtEl>
+                                    <p:spTgt spid="19"/>
+                                  </p:tgtEl>
+                                </p:cBhvr>
+                              </p:animEffect>
+                              <p:anim calcmode="lin" valueType="num">
+                                <p:cBhvr>
+                                  <p:cTn id="67" dur="600" decel="100000" fill="hold"/>
+                                  <p:tgtEl>
+                                    <p:spTgt spid="19"/>
+                                  </p:tgtEl>
+                                  <p:attrNameLst>
+                                    <p:attrName>ppt_y</p:attrName>
+                                  </p:attrNameLst>
+                                </p:cBhvr>
+                                <p:tavLst>
+                                  <p:tav tm="0">
+                                    <p:val>
+                                      <p:strVal val="#ppt_y+0.03"/>
+                                    </p:val>
+                                  </p:tav>
+                                  <p:tav tm="100000">
+                                    <p:val>
+                                      <p:strVal val="#ppt_y"/>
+                                    </p:val>
+                                  </p:tav>
+                                </p:tavLst>
+                              </p:anim>
+                            </p:childTnLst>
+                          </p:cTn>
+                        </p:par>
+                        <p:par>
+                          <p:cTn id="68" presetID="10" presetClass="entr" presetSubtype="0" fill="hold" nodeType="withEffect">
+                            <p:stCondLst>
+                              <p:cond delay="1410"/>
+                            </p:stCondLst>
+                            <p:childTnLst>
+                              <p:set>
+                                <p:cBhvr>
+                                  <p:cTn id="69" dur="1" fill="hold">
+                                    <p:stCondLst>
+                                      <p:cond delay="0"/>
+                                    </p:stCondLst>
+                                  </p:cTn>
+                                  <p:tgtEl>
+                                    <p:spTgt spid="20"/>
+                                  </p:tgtEl>
+                                  <p:attrNameLst>
+                                    <p:attrName>style.visibility</p:attrName>
+                                  </p:attrNameLst>
+                                </p:cBhvr>
+                                <p:to>
+                                  <p:strVal val="visible"/>
+                                </p:to>
+                              </p:set>
+                              <p:animEffect transition="in" filter="fade">
+                                <p:cBhvr>
+                                  <p:cTn id="70" dur="600"/>
+                                  <p:tgtEl>
+                                    <p:spTgt spid="20"/>
+                                  </p:tgtEl>
+                                </p:cBhvr>
+                              </p:animEffect>
+                              <p:anim calcmode="lin" valueType="num">
+                                <p:cBhvr>
+                                  <p:cTn id="71" dur="600" decel="100000" fill="hold"/>
+                                  <p:tgtEl>
+                                    <p:spTgt spid="20"/>
+                                  </p:tgtEl>
+                                  <p:attrNameLst>
+                                    <p:attrName>ppt_y</p:attrName>
+                                  </p:attrNameLst>
+                                </p:cBhvr>
+                                <p:tavLst>
+                                  <p:tav tm="0">
+                                    <p:val>
+                                      <p:strVal val="#ppt_y+0.03"/>
+                                    </p:val>
+                                  </p:tav>
+                                  <p:tav tm="100000">
+                                    <p:val>
+                                      <p:strVal val="#ppt_y"/>
+                                    </p:val>
+                                  </p:tav>
+                                </p:tavLst>
+                              </p:anim>
+                            </p:childTnLst>
+                          </p:cTn>
+                        </p:par>
+                        <p:par>
+                          <p:cTn id="72" presetID="10" presetClass="entr" presetSubtype="0" fill="hold" nodeType="withEffect">
+                            <p:stCondLst>
+                              <p:cond delay="1470"/>
+                            </p:stCondLst>
+                            <p:childTnLst>
+                              <p:set>
+                                <p:cBhvr>
+                                  <p:cTn id="73" dur="1" fill="hold">
+                                    <p:stCondLst>
+                                      <p:cond delay="0"/>
+                                    </p:stCondLst>
+                                  </p:cTn>
+                                  <p:tgtEl>
+                                    <p:spTgt spid="21"/>
+                                  </p:tgtEl>
+                                  <p:attrNameLst>
+                                    <p:attrName>style.visibility</p:attrName>
+                                  </p:attrNameLst>
+                                </p:cBhvr>
+                                <p:to>
+                                  <p:strVal val="visible"/>
+                                </p:to>
+                              </p:set>
+                              <p:animEffect transition="in" filter="fade">
+                                <p:cBhvr>
+                                  <p:cTn id="74" dur="600"/>
+                                  <p:tgtEl>
+                                    <p:spTgt spid="21"/>
+                                  </p:tgtEl>
+                                </p:cBhvr>
+                              </p:animEffect>
+                              <p:anim calcmode="lin" valueType="num">
+                                <p:cBhvr>
+                                  <p:cTn id="75" dur="600" decel="100000" fill="hold"/>
+                                  <p:tgtEl>
+                                    <p:spTgt spid="21"/>
+                                  </p:tgtEl>
+                                  <p:attrNameLst>
+                                    <p:attrName>ppt_y</p:attrName>
+                                  </p:attrNameLst>
+                                </p:cBhvr>
+                                <p:tavLst>
+                                  <p:tav tm="0">
+                                    <p:val>
+                                      <p:strVal val="#ppt_y+0.03"/>
+                                    </p:val>
+                                  </p:tav>
+                                  <p:tav tm="100000">
+                                    <p:val>
+                                      <p:strVal val="#ppt_y"/>
+                                    </p:val>
+                                  </p:tav>
+                                </p:tavLst>
+                              </p:anim>
+                            </p:childTnLst>
+                          </p:cTn>
+                        </p:par>
+                        <p:par>
+                          <p:cTn id="76" presetID="10" presetClass="entr" presetSubtype="0" fill="hold" nodeType="withEffect">
+                            <p:stCondLst>
+                              <p:cond delay="1530"/>
+                            </p:stCondLst>
+                            <p:childTnLst>
+                              <p:set>
+                                <p:cBhvr>
+                                  <p:cTn id="77" dur="1" fill="hold">
+                                    <p:stCondLst>
+                                      <p:cond delay="0"/>
+                                    </p:stCondLst>
+                                  </p:cTn>
+                                  <p:tgtEl>
+                                    <p:spTgt spid="22"/>
+                                  </p:tgtEl>
+                                  <p:attrNameLst>
+                                    <p:attrName>style.visibility</p:attrName>
+                                  </p:attrNameLst>
+                                </p:cBhvr>
+                                <p:to>
+                                  <p:strVal val="visible"/>
+                                </p:to>
+                              </p:set>
+                              <p:animEffect transition="in" filter="fade">
+                                <p:cBhvr>
+                                  <p:cTn id="78" dur="600"/>
+                                  <p:tgtEl>
+                                    <p:spTgt spid="22"/>
+                                  </p:tgtEl>
+                                </p:cBhvr>
+                              </p:animEffect>
+                              <p:anim calcmode="lin" valueType="num">
+                                <p:cBhvr>
+                                  <p:cTn id="79" dur="600" decel="100000" fill="hold"/>
+                                  <p:tgtEl>
+                                    <p:spTgt spid="22"/>
+                                  </p:tgtEl>
+                                  <p:attrNameLst>
+                                    <p:attrName>ppt_y</p:attrName>
+                                  </p:attrNameLst>
+                                </p:cBhvr>
+                                <p:tavLst>
+                                  <p:tav tm="0">
+                                    <p:val>
+                                      <p:strVal val="#ppt_y+0.03"/>
+                                    </p:val>
+                                  </p:tav>
+                                  <p:tav tm="100000">
+                                    <p:val>
+                                      <p:strVal val="#ppt_y"/>
+                                    </p:val>
+                                  </p:tav>
+                                </p:tavLst>
+                              </p:anim>
+                            </p:childTnLst>
+                          </p:cTn>
+                        </p:par>
+                        <p:par>
+                          <p:cTn id="80" presetID="10" presetClass="entr" presetSubtype="0" fill="hold" nodeType="withEffect">
+                            <p:stCondLst>
+                              <p:cond delay="1590"/>
+                            </p:stCondLst>
+                            <p:childTnLst>
+                              <p:set>
+                                <p:cBhvr>
+                                  <p:cTn id="81" dur="1" fill="hold">
+                                    <p:stCondLst>
+                                      <p:cond delay="0"/>
+                                    </p:stCondLst>
+                                  </p:cTn>
+                                  <p:tgtEl>
+                                    <p:spTgt spid="23"/>
+                                  </p:tgtEl>
+                                  <p:attrNameLst>
+                                    <p:attrName>style.visibility</p:attrName>
+                                  </p:attrNameLst>
+                                </p:cBhvr>
+                                <p:to>
+                                  <p:strVal val="visible"/>
+                                </p:to>
+                              </p:set>
+                              <p:animEffect transition="in" filter="fade">
+                                <p:cBhvr>
+                                  <p:cTn id="82" dur="600"/>
+                                  <p:tgtEl>
+                                    <p:spTgt spid="23"/>
+                                  </p:tgtEl>
+                                </p:cBhvr>
+                              </p:animEffect>
+                              <p:anim calcmode="lin" valueType="num">
+                                <p:cBhvr>
+                                  <p:cTn id="83" dur="600" decel="100000" fill="hold"/>
+                                  <p:tgtEl>
+                                    <p:spTgt spid="23"/>
+                                  </p:tgtEl>
+                                  <p:attrNameLst>
+                                    <p:attrName>ppt_y</p:attrName>
+                                  </p:attrNameLst>
+                                </p:cBhvr>
+                                <p:tavLst>
+                                  <p:tav tm="0">
+                                    <p:val>
+                                      <p:strVal val="#ppt_y+0.03"/>
+                                    </p:val>
+                                  </p:tav>
+                                  <p:tav tm="100000">
+                                    <p:val>
+                                      <p:strVal val="#ppt_y"/>
+                                    </p:val>
+                                  </p:tav>
+                                </p:tavLst>
+                              </p:anim>
+                            </p:childTnLst>
+                          </p:cTn>
+                        </p:par>
+                        <p:par>
+                          <p:cTn id="84" presetID="10" presetClass="entr" presetSubtype="0" fill="hold" nodeType="withEffect">
+                            <p:stCondLst>
+                              <p:cond delay="1800"/>
+                            </p:stCondLst>
+                            <p:childTnLst>
+                              <p:set>
+                                <p:cBhvr>
+                                  <p:cTn id="85" dur="1" fill="hold">
+                                    <p:stCondLst>
+                                      <p:cond delay="0"/>
+                                    </p:stCondLst>
+                                  </p:cTn>
+                                  <p:tgtEl>
+                                    <p:spTgt spid="24"/>
+                                  </p:tgtEl>
+                                  <p:attrNameLst>
+                                    <p:attrName>style.visibility</p:attrName>
+                                  </p:attrNameLst>
+                                </p:cBhvr>
+                                <p:to>
+                                  <p:strVal val="visible"/>
+                                </p:to>
+                              </p:set>
+                              <p:animEffect transition="in" filter="fade">
+                                <p:cBhvr>
+                                  <p:cTn id="86" dur="600"/>
+                                  <p:tgtEl>
+                                    <p:spTgt spid="24"/>
+                                  </p:tgtEl>
+                                </p:cBhvr>
+                              </p:animEffect>
+                              <p:anim calcmode="lin" valueType="num">
+                                <p:cBhvr>
+                                  <p:cTn id="87" dur="600" decel="100000" fill="hold"/>
+                                  <p:tgtEl>
+                                    <p:spTgt spid="24"/>
+                                  </p:tgtEl>
+                                  <p:attrNameLst>
+                                    <p:attrName>ppt_y</p:attrName>
+                                  </p:attrNameLst>
+                                </p:cBhvr>
+                                <p:tavLst>
+                                  <p:tav tm="0">
+                                    <p:val>
+                                      <p:strVal val="#ppt_y+0.03"/>
+                                    </p:val>
+                                  </p:tav>
+                                  <p:tav tm="100000">
+                                    <p:val>
+                                      <p:strVal val="#ppt_y"/>
+                                    </p:val>
+                                  </p:tav>
+                                </p:tavLst>
+                              </p:anim>
+                            </p:childTnLst>
+                          </p:cTn>
+                        </p:par>
+                        <p:par>
+                          <p:cTn id="88" presetID="10" presetClass="entr" presetSubtype="0" fill="hold" nodeType="withEffect">
+                            <p:stCondLst>
+                              <p:cond delay="1860"/>
+                            </p:stCondLst>
+                            <p:childTnLst>
+                              <p:set>
+                                <p:cBhvr>
+                                  <p:cTn id="89" dur="1" fill="hold">
+                                    <p:stCondLst>
+                                      <p:cond delay="0"/>
+                                    </p:stCondLst>
+                                  </p:cTn>
+                                  <p:tgtEl>
+                                    <p:spTgt spid="25"/>
+                                  </p:tgtEl>
+                                  <p:attrNameLst>
+                                    <p:attrName>style.visibility</p:attrName>
+                                  </p:attrNameLst>
+                                </p:cBhvr>
+                                <p:to>
+                                  <p:strVal val="visible"/>
+                                </p:to>
+                              </p:set>
+                              <p:animEffect transition="in" filter="fade">
+                                <p:cBhvr>
+                                  <p:cTn id="90" dur="600"/>
+                                  <p:tgtEl>
+                                    <p:spTgt spid="25"/>
+                                  </p:tgtEl>
+                                </p:cBhvr>
+                              </p:animEffect>
+                              <p:anim calcmode="lin" valueType="num">
+                                <p:cBhvr>
+                                  <p:cTn id="91" dur="600" decel="100000" fill="hold"/>
+                                  <p:tgtEl>
+                                    <p:spTgt spid="25"/>
+                                  </p:tgtEl>
+                                  <p:attrNameLst>
+                                    <p:attrName>ppt_y</p:attrName>
+                                  </p:attrNameLst>
+                                </p:cBhvr>
+                                <p:tavLst>
+                                  <p:tav tm="0">
+                                    <p:val>
+                                      <p:strVal val="#ppt_y+0.03"/>
+                                    </p:val>
+                                  </p:tav>
+                                  <p:tav tm="100000">
+                                    <p:val>
+                                      <p:strVal val="#ppt_y"/>
+                                    </p:val>
+                                  </p:tav>
+                                </p:tavLst>
+                              </p:anim>
+                            </p:childTnLst>
+                          </p:cTn>
+                        </p:par>
+                        <p:par>
+                          <p:cTn id="92" presetID="10" presetClass="entr" presetSubtype="0" fill="hold" nodeType="withEffect">
+                            <p:stCondLst>
+                              <p:cond delay="1920"/>
+                            </p:stCondLst>
+                            <p:childTnLst>
+                              <p:set>
+                                <p:cBhvr>
+                                  <p:cTn id="93" dur="1" fill="hold">
+                                    <p:stCondLst>
+                                      <p:cond delay="0"/>
+                                    </p:stCondLst>
+                                  </p:cTn>
+                                  <p:tgtEl>
+                                    <p:spTgt spid="26"/>
+                                  </p:tgtEl>
+                                  <p:attrNameLst>
+                                    <p:attrName>style.visibility</p:attrName>
+                                  </p:attrNameLst>
+                                </p:cBhvr>
+                                <p:to>
+                                  <p:strVal val="visible"/>
+                                </p:to>
+                              </p:set>
+                              <p:animEffect transition="in" filter="fade">
+                                <p:cBhvr>
+                                  <p:cTn id="94" dur="600"/>
+                                  <p:tgtEl>
+                                    <p:spTgt spid="26"/>
+                                  </p:tgtEl>
+                                </p:cBhvr>
+                              </p:animEffect>
+                              <p:anim calcmode="lin" valueType="num">
+                                <p:cBhvr>
+                                  <p:cTn id="95" dur="600" decel="100000" fill="hold"/>
+                                  <p:tgtEl>
+                                    <p:spTgt spid="26"/>
+                                  </p:tgtEl>
+                                  <p:attrNameLst>
+                                    <p:attrName>ppt_y</p:attrName>
+                                  </p:attrNameLst>
+                                </p:cBhvr>
+                                <p:tavLst>
+                                  <p:tav tm="0">
+                                    <p:val>
+                                      <p:strVal val="#ppt_y+0.03"/>
+                                    </p:val>
+                                  </p:tav>
+                                  <p:tav tm="100000">
+                                    <p:val>
+                                      <p:strVal val="#ppt_y"/>
+                                    </p:val>
+                                  </p:tav>
+                                </p:tavLst>
+                              </p:anim>
+                            </p:childTnLst>
+                          </p:cTn>
+                        </p:par>
+                        <p:par>
+                          <p:cTn id="96" presetID="10" presetClass="entr" presetSubtype="0" fill="hold" nodeType="withEffect">
+                            <p:stCondLst>
+                              <p:cond delay="2250"/>
+                            </p:stCondLst>
+                            <p:childTnLst>
+                              <p:set>
+                                <p:cBhvr>
+                                  <p:cTn id="97" dur="1" fill="hold">
+                                    <p:stCondLst>
+                                      <p:cond delay="0"/>
+                                    </p:stCondLst>
+                                  </p:cTn>
+                                  <p:tgtEl>
+                                    <p:spTgt spid="27"/>
+                                  </p:tgtEl>
+                                  <p:attrNameLst>
+                                    <p:attrName>style.visibility</p:attrName>
+                                  </p:attrNameLst>
+                                </p:cBhvr>
+                                <p:to>
+                                  <p:strVal val="visible"/>
+                                </p:to>
+                              </p:set>
+                              <p:animEffect transition="in" filter="fade">
+                                <p:cBhvr>
+                                  <p:cTn id="98" dur="600"/>
+                                  <p:tgtEl>
+                                    <p:spTgt spid="27"/>
+                                  </p:tgtEl>
+                                </p:cBhvr>
+                              </p:animEffect>
+                              <p:anim calcmode="lin" valueType="num">
+                                <p:cBhvr>
+                                  <p:cTn id="99" dur="600" decel="100000" fill="hold"/>
+                                  <p:tgtEl>
+                                    <p:spTgt spid="27"/>
+                                  </p:tgtEl>
+                                  <p:attrNameLst>
+                                    <p:attrName>ppt_y</p:attrName>
+                                  </p:attrNameLst>
+                                </p:cBhvr>
+                                <p:tavLst>
+                                  <p:tav tm="0">
+                                    <p:val>
+                                      <p:strVal val="#ppt_y+0.03"/>
+                                    </p:val>
+                                  </p:tav>
+                                  <p:tav tm="100000">
+                                    <p:val>
+                                      <p:strVal val="#ppt_y"/>
+                                    </p:val>
+                                  </p:tav>
+                                </p:tavLst>
+                              </p:anim>
+                            </p:childTnLst>
+                          </p:cTn>
+                        </p:par>
+                        <p:par>
+                          <p:cTn id="100" presetID="10" presetClass="entr" presetSubtype="0" fill="hold" nodeType="withEffect">
+                            <p:stCondLst>
+                              <p:cond delay="2310"/>
+                            </p:stCondLst>
+                            <p:childTnLst>
+                              <p:set>
+                                <p:cBhvr>
+                                  <p:cTn id="101" dur="1" fill="hold">
+                                    <p:stCondLst>
+                                      <p:cond delay="0"/>
+                                    </p:stCondLst>
+                                  </p:cTn>
+                                  <p:tgtEl>
+                                    <p:spTgt spid="28"/>
+                                  </p:tgtEl>
+                                  <p:attrNameLst>
+                                    <p:attrName>style.visibility</p:attrName>
+                                  </p:attrNameLst>
+                                </p:cBhvr>
+                                <p:to>
+                                  <p:strVal val="visible"/>
+                                </p:to>
+                              </p:set>
+                              <p:animEffect transition="in" filter="fade">
+                                <p:cBhvr>
+                                  <p:cTn id="102" dur="600"/>
+                                  <p:tgtEl>
+                                    <p:spTgt spid="28"/>
+                                  </p:tgtEl>
+                                </p:cBhvr>
+                              </p:animEffect>
+                              <p:anim calcmode="lin" valueType="num">
+                                <p:cBhvr>
+                                  <p:cTn id="103" dur="600" decel="100000" fill="hold"/>
+                                  <p:tgtEl>
+                                    <p:spTgt spid="28"/>
+                                  </p:tgtEl>
+                                  <p:attrNameLst>
+                                    <p:attrName>ppt_y</p:attrName>
+                                  </p:attrNameLst>
+                                </p:cBhvr>
+                                <p:tavLst>
+                                  <p:tav tm="0">
+                                    <p:val>
+                                      <p:strVal val="#ppt_y+0.03"/>
+                                    </p:val>
+                                  </p:tav>
+                                  <p:tav tm="100000">
+                                    <p:val>
+                                      <p:strVal val="#ppt_y"/>
+                                    </p:val>
+                                  </p:tav>
+                                </p:tavLst>
+                              </p:anim>
+                            </p:childTnLst>
+                          </p:cTn>
+                        </p:par>
+                        <p:par>
+                          <p:cTn id="104" presetID="10" presetClass="entr" presetSubtype="0" fill="hold" nodeType="withEffect">
+                            <p:stCondLst>
+                              <p:cond delay="2370"/>
+                            </p:stCondLst>
+                            <p:childTnLst>
+                              <p:set>
+                                <p:cBhvr>
+                                  <p:cTn id="105" dur="1" fill="hold">
+                                    <p:stCondLst>
+                                      <p:cond delay="0"/>
+                                    </p:stCondLst>
+                                  </p:cTn>
+                                  <p:tgtEl>
+                                    <p:spTgt spid="29"/>
+                                  </p:tgtEl>
+                                  <p:attrNameLst>
+                                    <p:attrName>style.visibility</p:attrName>
+                                  </p:attrNameLst>
+                                </p:cBhvr>
+                                <p:to>
+                                  <p:strVal val="visible"/>
+                                </p:to>
+                              </p:set>
+                              <p:animEffect transition="in" filter="fade">
+                                <p:cBhvr>
+                                  <p:cTn id="106" dur="600"/>
+                                  <p:tgtEl>
+                                    <p:spTgt spid="29"/>
+                                  </p:tgtEl>
+                                </p:cBhvr>
+                              </p:animEffect>
+                              <p:anim calcmode="lin" valueType="num">
+                                <p:cBhvr>
+                                  <p:cTn id="107" dur="600" decel="100000" fill="hold"/>
+                                  <p:tgtEl>
+                                    <p:spTgt spid="29"/>
+                                  </p:tgtEl>
+                                  <p:attrNameLst>
+                                    <p:attrName>ppt_y</p:attrName>
+                                  </p:attrNameLst>
+                                </p:cBhvr>
+                                <p:tavLst>
+                                  <p:tav tm="0">
+                                    <p:val>
+                                      <p:strVal val="#ppt_y+0.03"/>
+                                    </p:val>
+                                  </p:tav>
+                                  <p:tav tm="100000">
+                                    <p:val>
+                                      <p:strVal val="#ppt_y"/>
+                                    </p:val>
+                                  </p:tav>
+                                </p:tavLst>
+                              </p:anim>
+                            </p:childTnLst>
+                          </p:cTn>
+                        </p:par>
+                        <p:par>
+                          <p:cTn id="108" presetID="10" presetClass="entr" presetSubtype="0" fill="hold" nodeType="withEffect">
+                            <p:stCondLst>
+                              <p:cond delay="2700"/>
+                            </p:stCondLst>
+                            <p:childTnLst>
+                              <p:set>
+                                <p:cBhvr>
+                                  <p:cTn id="109" dur="1" fill="hold">
+                                    <p:stCondLst>
+                                      <p:cond delay="0"/>
+                                    </p:stCondLst>
+                                  </p:cTn>
+                                  <p:tgtEl>
+                                    <p:spTgt spid="30"/>
+                                  </p:tgtEl>
+                                  <p:attrNameLst>
+                                    <p:attrName>style.visibility</p:attrName>
+                                  </p:attrNameLst>
+                                </p:cBhvr>
+                                <p:to>
+                                  <p:strVal val="visible"/>
+                                </p:to>
+                              </p:set>
+                              <p:animEffect transition="in" filter="fade">
+                                <p:cBhvr>
+                                  <p:cTn id="110" dur="600"/>
+                                  <p:tgtEl>
+                                    <p:spTgt spid="30"/>
+                                  </p:tgtEl>
+                                </p:cBhvr>
+                              </p:animEffect>
+                              <p:anim calcmode="lin" valueType="num">
+                                <p:cBhvr>
+                                  <p:cTn id="111" dur="600" decel="100000" fill="hold"/>
+                                  <p:tgtEl>
+                                    <p:spTgt spid="30"/>
+                                  </p:tgtEl>
+                                  <p:attrNameLst>
+                                    <p:attrName>ppt_y</p:attrName>
+                                  </p:attrNameLst>
+                                </p:cBhvr>
+                                <p:tavLst>
+                                  <p:tav tm="0">
+                                    <p:val>
+                                      <p:strVal val="#ppt_y+0.03"/>
+                                    </p:val>
+                                  </p:tav>
+                                  <p:tav tm="100000">
+                                    <p:val>
+                                      <p:strVal val="#ppt_y"/>
+                                    </p:val>
+                                  </p:tav>
+                                </p:tavLst>
+                              </p:anim>
+                            </p:childTnLst>
+                          </p:cTn>
+                        </p:par>
+                        <p:par>
+                          <p:cTn id="112" presetID="10" presetClass="entr" presetSubtype="0" fill="hold" nodeType="withEffect">
+                            <p:stCondLst>
+                              <p:cond delay="2760"/>
+                            </p:stCondLst>
+                            <p:childTnLst>
+                              <p:set>
+                                <p:cBhvr>
+                                  <p:cTn id="113" dur="1" fill="hold">
+                                    <p:stCondLst>
+                                      <p:cond delay="0"/>
+                                    </p:stCondLst>
+                                  </p:cTn>
+                                  <p:tgtEl>
+                                    <p:spTgt spid="31"/>
+                                  </p:tgtEl>
+                                  <p:attrNameLst>
+                                    <p:attrName>style.visibility</p:attrName>
+                                  </p:attrNameLst>
+                                </p:cBhvr>
+                                <p:to>
+                                  <p:strVal val="visible"/>
+                                </p:to>
+                              </p:set>
+                              <p:animEffect transition="in" filter="fade">
+                                <p:cBhvr>
+                                  <p:cTn id="114" dur="600"/>
+                                  <p:tgtEl>
+                                    <p:spTgt spid="31"/>
+                                  </p:tgtEl>
+                                </p:cBhvr>
+                              </p:animEffect>
+                              <p:anim calcmode="lin" valueType="num">
+                                <p:cBhvr>
+                                  <p:cTn id="115" dur="600" decel="100000" fill="hold"/>
+                                  <p:tgtEl>
+                                    <p:spTgt spid="31"/>
+                                  </p:tgtEl>
+                                  <p:attrNameLst>
+                                    <p:attrName>ppt_y</p:attrName>
+                                  </p:attrNameLst>
+                                </p:cBhvr>
+                                <p:tavLst>
+                                  <p:tav tm="0">
+                                    <p:val>
+                                      <p:strVal val="#ppt_y+0.03"/>
+                                    </p:val>
+                                  </p:tav>
+                                  <p:tav tm="100000">
+                                    <p:val>
+                                      <p:strVal val="#ppt_y"/>
+                                    </p:val>
+                                  </p:tav>
+                                </p:tavLst>
+                              </p:anim>
+                            </p:childTnLst>
+                          </p:cTn>
+                        </p:par>
+                      </p:childTnLst>
+                    </p:cTn>
+                  </p:par>
+                </p:childTnLst>
+              </p:cTn>
+              <p:prevCondLst>
+                <p:cond evt="onPrev" delay="0">
+                  <p:tgtEl>
+                    <p:sldTgt/>
+                  </p:tgtEl>
+                </p:cond>
+              </p:prevCondLst>
+              <p:nextCondLst>
+                <p:cond evt="onNext" delay="0">
+                  <p:tgtEl>
+                    <p:sldTgt/>
+                  </p:tgtEl>
+                </p:cond>
+              </p:nextCondLst>
+            </p:seq>
+          </p:childTnLst>
+        </p:cTn>
+      </p:par>
+    </p:tnLst>
+  </p:timing>
+</p:sld>
+</file>
+
+<file path=ppt/slides/slide14.xml><?xml version="1.0" encoding="utf-8"?>
+<p:sld xmlns:a="http://schemas.openxmlformats.org/drawingml/2006/main" xmlns:r="http://schemas.openxmlformats.org/officeDocument/2006/relationships" xmlns:p="http://schemas.openxmlformats.org/presentationml/2006/main">
+  <p:cSld name="Slide 14">
+    <p:spTree>
+      <p:nvGrpSpPr>
+        <p:cNvPr id="1" name=""/>
+        <p:cNvGrpSpPr/>
+        <p:nvPr/>
+      </p:nvGrpSpPr>
+      <p:grpSpPr>
+        <a:xfrm>
+          <a:off x="0" y="0"/>
+          <a:ext cx="0" cy="0"/>
+          <a:chOff x="0" y="0"/>
+          <a:chExt cx="0" cy="0"/>
+        </a:xfrm>
+      </p:grpSpPr>
+      <p:sp>
+        <p:nvSpPr>
+          <p:cNvPr id="2" name="Text 0"/>
+          <p:cNvSpPr/>
+          <p:nvPr>
+            <p:ph idx="100" type="body" hasCustomPrompt="1"/>
+          </p:nvPr>
+        </p:nvSpPr>
+        <p:spPr>
+          <a:xfrm>
+            <a:off x="731520" y="2011680"/>
+            <a:ext cx="6400800" cy="411480"/>
+          </a:xfrm>
+          <a:prstGeom prst="rect">
+            <a:avLst/>
+          </a:prstGeom>
+          <a:noFill/>
+          <a:ln/>
+        </p:spPr>
+        <p:txBody>
+          <a:bodyPr wrap="square" rtlCol="0"/>
+          <a:lstStyle/>
+          <a:p>
+            <a:pPr indent="0" marL="0">
+              <a:buNone/>
+            </a:pPr>
+            <a:r>
+              <a:rPr lang="en-US" sz="1800" dirty="0">
+                <a:solidFill>
+                  <a:schemeClr val="accent4"/>
+                </a:solidFill>
+              </a:rPr>
               <a:t>Prochaine étape</a:t>
             </a:r>
             <a:endParaRPr lang="en-US" sz="1800" dirty="0"/>
@@ -8510,7 +11831,7 @@
       </p:sp>
       <p:sp>
         <p:nvSpPr>
-          <p:cNvPr id="4" name="a1_238"/>
+          <p:cNvPr id="4" name="a1_269"/>
           <p:cNvSpPr txBox="1"/>
           <p:nvPr/>
         </p:nvSpPr>
@@ -8546,7 +11867,7 @@
       </p:sp>
       <p:sp>
         <p:nvSpPr>
-          <p:cNvPr id="5" name="a2_239"/>
+          <p:cNvPr id="5" name="a2_270"/>
           <p:cNvSpPr/>
           <p:nvPr/>
         </p:nvSpPr>
@@ -8580,7 +11901,7 @@
       </p:sp>
       <p:sp>
         <p:nvSpPr>
-          <p:cNvPr id="6" name="a2_240"/>
+          <p:cNvPr id="6" name="a2_271"/>
           <p:cNvSpPr/>
           <p:nvPr/>
         </p:nvSpPr>
@@ -8605,7 +11926,7 @@
       </p:sp>
       <p:pic>
         <p:nvPicPr>
-          <p:cNvPr id="7" name="a2_241" descr="preencoded.png">    </p:cNvPr>
+          <p:cNvPr id="7" name="a2_272" descr="preencoded.png">    </p:cNvPr>
           <p:cNvPicPr>
             <a:picLocks noChangeAspect="1"/>
           </p:cNvPicPr>
@@ -8629,7 +11950,7 @@
       </p:pic>
       <p:sp>
         <p:nvSpPr>
-          <p:cNvPr id="8" name="a2_242"/>
+          <p:cNvPr id="8" name="a2_273"/>
           <p:cNvSpPr txBox="1"/>
           <p:nvPr/>
         </p:nvSpPr>
@@ -8665,7 +11986,7 @@
       </p:sp>
       <p:sp>
         <p:nvSpPr>
-          <p:cNvPr id="9" name="a3_243"/>
+          <p:cNvPr id="9" name="a3_274"/>
           <p:cNvSpPr/>
           <p:nvPr/>
         </p:nvSpPr>
@@ -8699,7 +12020,7 @@
       </p:sp>
       <p:sp>
         <p:nvSpPr>
-          <p:cNvPr id="10" name="a3_244"/>
+          <p:cNvPr id="10" name="a3_275"/>
           <p:cNvSpPr/>
           <p:nvPr/>
         </p:nvSpPr>
@@ -8724,7 +12045,7 @@
       </p:sp>
       <p:pic>
         <p:nvPicPr>
-          <p:cNvPr id="11" name="a3_245" descr="preencoded.png">    </p:cNvPr>
+          <p:cNvPr id="11" name="a3_276" descr="preencoded.png">    </p:cNvPr>
           <p:cNvPicPr>
             <a:picLocks noChangeAspect="1"/>
           </p:cNvPicPr>
@@ -8748,7 +12069,7 @@
       </p:pic>
       <p:sp>
         <p:nvSpPr>
-          <p:cNvPr id="12" name="a3_246"/>
+          <p:cNvPr id="12" name="a3_277"/>
           <p:cNvSpPr txBox="1"/>
           <p:nvPr/>
         </p:nvSpPr>
@@ -8784,7 +12105,7 @@
       </p:sp>
       <p:sp>
         <p:nvSpPr>
-          <p:cNvPr id="13" name="a4_247"/>
+          <p:cNvPr id="13" name="a4_278"/>
           <p:cNvSpPr/>
           <p:nvPr/>
         </p:nvSpPr>
@@ -8818,7 +12139,7 @@
       </p:sp>
       <p:sp>
         <p:nvSpPr>
-          <p:cNvPr id="14" name="a4_248"/>
+          <p:cNvPr id="14" name="a4_279"/>
           <p:cNvSpPr/>
           <p:nvPr/>
         </p:nvSpPr>
@@ -8843,7 +12164,7 @@
       </p:sp>
       <p:pic>
         <p:nvPicPr>
-          <p:cNvPr id="15" name="a4_249" descr="preencoded.png">    </p:cNvPr>
+          <p:cNvPr id="15" name="a4_280" descr="preencoded.png">    </p:cNvPr>
           <p:cNvPicPr>
             <a:picLocks noChangeAspect="1"/>
           </p:cNvPicPr>
@@ -8867,7 +12188,7 @@
       </p:pic>
       <p:sp>
         <p:nvSpPr>
-          <p:cNvPr id="16" name="a4_250"/>
+          <p:cNvPr id="16" name="a4_281"/>
           <p:cNvSpPr txBox="1"/>
           <p:nvPr/>
         </p:nvSpPr>

</xml_diff>

<commit_message>
Option sécurité sans prix : accroche sur le coût d'une attaque
Co-Authored-By: Claude Opus 5.5 <noreply@anthropic.com>
Claude-Session: https://claude.ai/code/session_01FnPw3bDfKWoxE5ktD8jdcy
</commit_message>
<xml_diff>
--- a/proposition-serveur/Proposition_Serveur_Proxmox_WindowsServer.pptx
+++ b/proposition-serveur/Proposition_Serveur_Proxmox_WindowsServer.pptx
@@ -121,18 +121,18 @@
   <p:extLst>
     <p:ext uri="{521415D9-36F7-43E2-AB2F-B90AF26B5E84}">
       <p14:sectionLst xmlns:p14="http://schemas.microsoft.com/office/powerpoint/2010/main">
-        <p14:section name="Ouverture" id="{6ea01f0f-fd15-cea6-2855-63fbfe0b900b}">
+        <p14:section name="Ouverture" id="{328e7e64-f39a-357e-02d1-9b364ef95873}">
           <p14:sldIdLst>
             <p14:sldId id="256"/>
           </p14:sldIdLst>
         </p14:section>
-        <p14:section name="Le constat" id="{4ee3d018-3193-0371-63ec-aa3962e6cf44}">
+        <p14:section name="Le constat" id="{9d72bd6c-2779-ff18-57b2-d54485be97ba}">
           <p14:sldIdLst>
             <p14:sldId id="257"/>
             <p14:sldId id="258"/>
           </p14:sldIdLst>
         </p14:section>
-        <p14:section name="La solution" id="{9406cd11-4fb1-d568-e8f8-8b2d1911f51c}">
+        <p14:section name="La solution" id="{5a65f2fd-306c-392e-cb84-ad3ff5011769}">
           <p14:sldIdLst>
             <p14:sldId id="259"/>
             <p14:sldId id="260"/>
@@ -140,7 +140,7 @@
             <p14:sldId id="262"/>
           </p14:sldIdLst>
         </p14:section>
-        <p14:section name="Investissement" id="{f2c9a59d-de72-3f24-90f5-5c5a06e5f500}">
+        <p14:section name="Investissement" id="{14093b41-e65f-58b1-ea85-bba93ebe4fb6}">
           <p14:sldIdLst>
             <p14:sldId id="263"/>
             <p14:sldId id="264"/>
@@ -148,14 +148,14 @@
             <p14:sldId id="266"/>
           </p14:sldIdLst>
         </p14:section>
-        <p14:section name="Option sécurité" id="{57dac7cb-0be2-7308-57dd-affef8e7e857}">
+        <p14:section name="Option sécurité" id="{94d072a4-a44a-29d6-7859-8081645992a0}">
           <p14:sldIdLst>
             <p14:sldId id="267"/>
             <p14:sldId id="268"/>
             <p14:sldId id="269"/>
           </p14:sldIdLst>
         </p14:section>
-        <p14:section name="Conclusion" id="{353f6f49-6cef-37c7-313d-e0e62f04e286}">
+        <p14:section name="Conclusion" id="{56098fbb-293a-40e0-4bc1-0a9c889f559f}">
           <p14:sldIdLst>
             <p14:sldId id="270"/>
           </p14:sldIdLst>
@@ -1004,7 +1004,7 @@
           <a:p>
             <a:r>
               <a:rPr lang="en-US" dirty="0"/>
-              <a:t>Présenter comme une assurance : environ 40 000 FCFA par mois pour protéger 15 postes contre les ransomwares. Le coût d'une seule attaque (données perdues, jours d'arrêt) dépasse largement ce montant.</a:t>
+              <a:t>Ne pas annoncer de prix : poser la question du coût d'une journée d'arrêt et laisser le client y réfléchir. Proposer une démonstration ou un devis séparé s'il montre de l'intérêt.</a:t>
             </a:r>
             <a:endParaRPr lang="en-US" dirty="0"/>
           </a:p>
@@ -13038,157 +13038,62 @@
       <p:sp>
         <p:nvSpPr>
           <p:cNvPr id="35" name="a5_303"/>
+          <p:cNvSpPr/>
+          <p:nvPr/>
+        </p:nvSpPr>
+        <p:spPr>
+          <a:xfrm>
+            <a:off x="8046720" y="1920240"/>
+            <a:ext cx="822960" cy="822960"/>
+          </a:xfrm>
+          <a:prstGeom prst="ellipse">
+            <a:avLst/>
+          </a:prstGeom>
+          <a:solidFill>
+            <a:schemeClr val="accent2"/>
+          </a:solidFill>
+          <a:ln w="12700">
+            <a:solidFill>
+              <a:schemeClr val="accent2"/>
+            </a:solidFill>
+            <a:prstDash val="solid"/>
+          </a:ln>
+        </p:spPr>
+      </p:sp>
+      <p:pic>
+        <p:nvPicPr>
+          <p:cNvPr id="36" name="a5_304" descr="preencoded.png">    </p:cNvPr>
+          <p:cNvPicPr>
+            <a:picLocks noChangeAspect="1"/>
+          </p:cNvPicPr>
+          <p:nvPr/>
+        </p:nvPicPr>
+        <p:blipFill>
+          <a:blip r:embed="rId7"/>
+          <a:stretch>
+            <a:fillRect/>
+          </a:stretch>
+        </p:blipFill>
+        <p:spPr>
+          <a:xfrm>
+            <a:off x="8260690" y="2134210"/>
+            <a:ext cx="395021" cy="395021"/>
+          </a:xfrm>
+          <a:prstGeom prst="rect">
+            <a:avLst/>
+          </a:prstGeom>
+        </p:spPr>
+      </p:pic>
+      <p:sp>
+        <p:nvSpPr>
+          <p:cNvPr id="37" name="a5_305"/>
           <p:cNvSpPr txBox="1"/>
           <p:nvPr/>
         </p:nvSpPr>
         <p:spPr>
           <a:xfrm>
-            <a:off x="8046720" y="1874520"/>
-            <a:ext cx="3291840" cy="365760"/>
-          </a:xfrm>
-          <a:prstGeom prst="rect">
-            <a:avLst/>
-          </a:prstGeom>
-          <a:noFill/>
-          <a:ln/>
-        </p:spPr>
-        <p:txBody>
-          <a:bodyPr wrap="square" lIns="0" tIns="0" rIns="0" bIns="0" rtlCol="0" anchor="ctr"/>
-          <a:lstStyle/>
-          <a:p>
-            <a:pPr indent="0" marL="0">
-              <a:buNone/>
-            </a:pPr>
-            <a:r>
-              <a:rPr lang="en-US" sz="1500" dirty="0">
-                <a:solidFill>
-                  <a:schemeClr val="accent4"/>
-                </a:solidFill>
-              </a:rPr>
-              <a:t>15 utilisateurs · 1 an</a:t>
-            </a:r>
-            <a:endParaRPr lang="en-US" sz="1500" dirty="0"/>
-          </a:p>
-        </p:txBody>
-      </p:sp>
-      <p:sp>
-        <p:nvSpPr>
-          <p:cNvPr id="36" name="a5_304"/>
-          <p:cNvSpPr txBox="1"/>
-          <p:nvPr/>
-        </p:nvSpPr>
-        <p:spPr>
-          <a:xfrm>
-            <a:off x="8046720" y="2240280"/>
-            <a:ext cx="3291840" cy="365760"/>
-          </a:xfrm>
-          <a:prstGeom prst="rect">
-            <a:avLst/>
-          </a:prstGeom>
-          <a:noFill/>
-          <a:ln/>
-        </p:spPr>
-        <p:txBody>
-          <a:bodyPr wrap="square" lIns="0" tIns="0" rIns="0" bIns="0" rtlCol="0" anchor="ctr"/>
-          <a:lstStyle/>
-          <a:p>
-            <a:pPr indent="0" marL="0">
-              <a:buNone/>
-            </a:pPr>
-            <a:r>
-              <a:rPr lang="en-US" sz="1300" dirty="0">
-                <a:solidFill>
-                  <a:schemeClr val="accent4"/>
-                </a:solidFill>
-              </a:rPr>
-              <a:t>15 postes/serveurs et jusqu'à 30 mobiles</a:t>
-            </a:r>
-            <a:endParaRPr lang="en-US" sz="1300" dirty="0"/>
-          </a:p>
-        </p:txBody>
-      </p:sp>
-      <p:sp>
-        <p:nvSpPr>
-          <p:cNvPr id="37" name="a6_305"/>
-          <p:cNvSpPr txBox="1"/>
-          <p:nvPr/>
-        </p:nvSpPr>
-        <p:spPr>
-          <a:xfrm>
-            <a:off x="8046720" y="2788920"/>
-            <a:ext cx="3291840" cy="365760"/>
-          </a:xfrm>
-          <a:prstGeom prst="rect">
-            <a:avLst/>
-          </a:prstGeom>
-          <a:noFill/>
-          <a:ln/>
-        </p:spPr>
-        <p:txBody>
-          <a:bodyPr wrap="square" lIns="0" tIns="0" rIns="0" bIns="0" rtlCol="0" anchor="ctr"/>
-          <a:lstStyle/>
-          <a:p>
-            <a:pPr indent="0" marL="0">
-              <a:buNone/>
-            </a:pPr>
-            <a:r>
-              <a:rPr lang="en-US" sz="1500" strike="sngStrike" dirty="0">
-                <a:solidFill>
-                  <a:schemeClr val="accent3"/>
-                </a:solidFill>
-              </a:rPr>
-              <a:t>≈ 566 000 FCFA</a:t>
-            </a:r>
-            <a:endParaRPr lang="en-US" sz="1500" dirty="0"/>
-          </a:p>
-        </p:txBody>
-      </p:sp>
-      <p:sp>
-        <p:nvSpPr>
-          <p:cNvPr id="38" name="a6_306"/>
-          <p:cNvSpPr txBox="1"/>
-          <p:nvPr/>
-        </p:nvSpPr>
-        <p:spPr>
-          <a:xfrm>
-            <a:off x="8046720" y="3108960"/>
-            <a:ext cx="3291840" cy="731520"/>
-          </a:xfrm>
-          <a:prstGeom prst="rect">
-            <a:avLst/>
-          </a:prstGeom>
-          <a:noFill/>
-          <a:ln/>
-        </p:spPr>
-        <p:txBody>
-          <a:bodyPr wrap="square" lIns="0" tIns="0" rIns="0" bIns="0" rtlCol="0" anchor="ctr"/>
-          <a:lstStyle/>
-          <a:p>
-            <a:pPr indent="0" marL="0">
-              <a:buNone/>
-            </a:pPr>
-            <a:r>
-              <a:rPr lang="en-US" sz="4000" b="1" dirty="0">
-                <a:solidFill>
-                  <a:schemeClr val="bg1"/>
-                </a:solidFill>
-              </a:rPr>
-              <a:t>≈ 477 000</a:t>
-            </a:r>
-            <a:endParaRPr lang="en-US" sz="4000" dirty="0"/>
-          </a:p>
-        </p:txBody>
-      </p:sp>
-      <p:sp>
-        <p:nvSpPr>
-          <p:cNvPr id="39" name="a6_307"/>
-          <p:cNvSpPr txBox="1"/>
-          <p:nvPr/>
-        </p:nvSpPr>
-        <p:spPr>
-          <a:xfrm>
-            <a:off x="8046720" y="3840480"/>
-            <a:ext cx="3291840" cy="548640"/>
+            <a:off x="8046720" y="2880360"/>
+            <a:ext cx="3291840" cy="914400"/>
           </a:xfrm>
           <a:prstGeom prst="rect">
             <a:avLst/>
@@ -13204,27 +13109,27 @@
               <a:buNone/>
             </a:pPr>
             <a:r>
-              <a:rPr lang="en-US" sz="1300" dirty="0">
+              <a:rPr lang="en-US" sz="2200" b="1" dirty="0">
                 <a:solidFill>
-                  <a:schemeClr val="accent4"/>
+                  <a:schemeClr val="bg1"/>
                 </a:solidFill>
               </a:rPr>
-              <a:t>FCFA HT / an · tarif promotionnel nouveaux clients</a:t>
+              <a:t>Combien vous coûterait une journée d'arrêt ?</a:t>
             </a:r>
-            <a:endParaRPr lang="en-US" sz="1300" dirty="0"/>
+            <a:endParaRPr lang="en-US" sz="2200" dirty="0"/>
           </a:p>
         </p:txBody>
       </p:sp>
       <p:sp>
         <p:nvSpPr>
-          <p:cNvPr id="40" name="a7_308"/>
+          <p:cNvPr id="38" name="a6_306"/>
           <p:cNvSpPr txBox="1"/>
           <p:nvPr/>
         </p:nvSpPr>
         <p:spPr>
           <a:xfrm>
-            <a:off x="8046720" y="4617720"/>
-            <a:ext cx="3291840" cy="822960"/>
+            <a:off x="8046720" y="3840480"/>
+            <a:ext cx="3291840" cy="1188720"/>
           </a:xfrm>
           <a:prstGeom prst="rect">
             <a:avLst/>
@@ -13240,14 +13145,77 @@
               <a:buNone/>
             </a:pPr>
             <a:r>
-              <a:rPr lang="en-US" sz="1500" b="1" dirty="0">
+              <a:rPr lang="en-US" sz="1400" dirty="0">
+                <a:solidFill>
+                  <a:schemeClr val="accent4"/>
+                </a:solidFill>
+              </a:rPr>
+              <a:t>Fichiers chiffrés, clients en attente, données perdues… La vraie question n'est pas le prix de la protection, mais celui d'une attaque.</a:t>
+            </a:r>
+            <a:endParaRPr lang="en-US" sz="1400" dirty="0"/>
+          </a:p>
+        </p:txBody>
+      </p:sp>
+      <p:sp>
+        <p:nvSpPr>
+          <p:cNvPr id="39" name="a7_307"/>
+          <p:cNvSpPr/>
+          <p:nvPr/>
+        </p:nvSpPr>
+        <p:spPr>
+          <a:xfrm>
+            <a:off x="8046720" y="5166360"/>
+            <a:ext cx="3291840" cy="457200"/>
+          </a:xfrm>
+          <a:prstGeom prst="roundRect">
+            <a:avLst>
+              <a:gd name="adj" fmla="val 50000"/>
+            </a:avLst>
+          </a:prstGeom>
+          <a:solidFill>
+            <a:schemeClr val="accent2"/>
+          </a:solidFill>
+          <a:ln w="12700">
+            <a:solidFill>
+              <a:schemeClr val="accent2"/>
+            </a:solidFill>
+            <a:prstDash val="solid"/>
+          </a:ln>
+        </p:spPr>
+      </p:sp>
+      <p:sp>
+        <p:nvSpPr>
+          <p:cNvPr id="40" name="a7_308"/>
+          <p:cNvSpPr txBox="1"/>
+          <p:nvPr/>
+        </p:nvSpPr>
+        <p:spPr>
+          <a:xfrm>
+            <a:off x="8046720" y="5166360"/>
+            <a:ext cx="3291840" cy="457200"/>
+          </a:xfrm>
+          <a:prstGeom prst="rect">
+            <a:avLst/>
+          </a:prstGeom>
+          <a:noFill/>
+          <a:ln/>
+        </p:spPr>
+        <p:txBody>
+          <a:bodyPr wrap="square" lIns="0" tIns="0" rIns="0" bIns="0" rtlCol="0" anchor="ctr"/>
+          <a:lstStyle/>
+          <a:p>
+            <a:pPr algn="ctr" indent="0" marL="0">
+              <a:buNone/>
+            </a:pPr>
+            <a:r>
+              <a:rPr lang="en-US" sz="1300" b="1" dirty="0">
                 <a:solidFill>
                   <a:schemeClr val="bg1"/>
                 </a:solidFill>
               </a:rPr>
-              <a:t>≈ 40 000 FCFA par mois pour protéger toute l'entreprise</a:t>
+              <a:t>Parlons-en · démonstration sur demande</a:t>
             </a:r>
-            <a:endParaRPr lang="en-US" sz="1500" dirty="0"/>
+            <a:endParaRPr lang="en-US" sz="1300" dirty="0"/>
           </a:p>
         </p:txBody>
       </p:sp>
@@ -13281,7 +13249,7 @@
                   <a:schemeClr val="accent6"/>
                 </a:solidFill>
               </a:rPr>
-              <a:t>Option indépendante de l'infrastructure · prix éditeur converti (1 € = 655,957 FCFA)</a:t>
+              <a:t>Option indépendante de l'infrastructure · offre adaptée à la taille de votre parc</a:t>
             </a:r>
             <a:endParaRPr lang="en-US" sz="1100" dirty="0"/>
           </a:p>
@@ -15274,7 +15242,7 @@
                         <p:par>
                           <p:cTn id="136" presetID="10" presetClass="entr" presetSubtype="0" fill="hold" nodeType="withEffect">
                             <p:stCondLst>
-                              <p:cond delay="2250"/>
+                              <p:cond delay="1980"/>
                             </p:stCondLst>
                             <p:childTnLst>
                               <p:set>
@@ -15332,7 +15300,7 @@
                         <p:par>
                           <p:cTn id="140" presetID="10" presetClass="entr" presetSubtype="0" fill="hold" nodeType="withEffect">
                             <p:stCondLst>
-                              <p:cond delay="2310"/>
+                              <p:cond delay="2250"/>
                             </p:stCondLst>
                             <p:childTnLst>
                               <p:set>
@@ -15390,7 +15358,7 @@
                         <p:par>
                           <p:cTn id="144" presetID="10" presetClass="entr" presetSubtype="0" fill="hold" nodeType="withEffect">
                             <p:stCondLst>
-                              <p:cond delay="2370"/>
+                              <p:cond delay="2700"/>
                             </p:stCondLst>
                             <p:childTnLst>
                               <p:set>
@@ -15448,7 +15416,7 @@
                         <p:par>
                           <p:cTn id="148" presetID="10" presetClass="entr" presetSubtype="0" fill="hold" nodeType="withEffect">
                             <p:stCondLst>
-                              <p:cond delay="2700"/>
+                              <p:cond delay="2760"/>
                             </p:stCondLst>
                             <p:childTnLst>
                               <p:set>
@@ -15506,7 +15474,7 @@
                         <p:par>
                           <p:cTn id="152" presetID="10" presetClass="entr" presetSubtype="0" fill="hold" nodeType="withEffect">
                             <p:stCondLst>
-                              <p:cond delay="2760"/>
+                              <p:cond delay="2820"/>
                             </p:stCondLst>
                             <p:childTnLst>
                               <p:set>

</xml_diff>

<commit_message>
Couverture : auteur, fonction et date
Co-Authored-By: Claude Opus 5.5 <noreply@anthropic.com>
Claude-Session: https://claude.ai/code/session_01FnPw3bDfKWoxE5ktD8jdcy
</commit_message>
<xml_diff>
--- a/proposition-serveur/Proposition_Serveur_Proxmox_WindowsServer.pptx
+++ b/proposition-serveur/Proposition_Serveur_Proxmox_WindowsServer.pptx
@@ -121,18 +121,18 @@
   <p:extLst>
     <p:ext uri="{521415D9-36F7-43E2-AB2F-B90AF26B5E84}">
       <p14:sectionLst xmlns:p14="http://schemas.microsoft.com/office/powerpoint/2010/main">
-        <p14:section name="Ouverture" id="{328e7e64-f39a-357e-02d1-9b364ef95873}">
+        <p14:section name="Ouverture" id="{c0411ba4-a59f-5c19-67eb-961194f77821}">
           <p14:sldIdLst>
             <p14:sldId id="256"/>
           </p14:sldIdLst>
         </p14:section>
-        <p14:section name="Le constat" id="{9d72bd6c-2779-ff18-57b2-d54485be97ba}">
+        <p14:section name="Le constat" id="{97f01592-b7d1-93a6-6f79-becaaa7f7dcd}">
           <p14:sldIdLst>
             <p14:sldId id="257"/>
             <p14:sldId id="258"/>
           </p14:sldIdLst>
         </p14:section>
-        <p14:section name="La solution" id="{5a65f2fd-306c-392e-cb84-ad3ff5011769}">
+        <p14:section name="La solution" id="{a48bca01-a9fb-3d39-a521-909f469f6027}">
           <p14:sldIdLst>
             <p14:sldId id="259"/>
             <p14:sldId id="260"/>
@@ -140,7 +140,7 @@
             <p14:sldId id="262"/>
           </p14:sldIdLst>
         </p14:section>
-        <p14:section name="Investissement" id="{14093b41-e65f-58b1-ea85-bba93ebe4fb6}">
+        <p14:section name="Investissement" id="{80e088b1-997c-564b-866d-853c29f92ad7}">
           <p14:sldIdLst>
             <p14:sldId id="263"/>
             <p14:sldId id="264"/>
@@ -148,14 +148,14 @@
             <p14:sldId id="266"/>
           </p14:sldIdLst>
         </p14:section>
-        <p14:section name="Option sécurité" id="{94d072a4-a44a-29d6-7859-8081645992a0}">
+        <p14:section name="Option sécurité" id="{8b60bd97-10f8-d5ae-eecf-bbdd0b67b003}">
           <p14:sldIdLst>
             <p14:sldId id="267"/>
             <p14:sldId id="268"/>
             <p14:sldId id="269"/>
           </p14:sldIdLst>
         </p14:section>
-        <p14:section name="Conclusion" id="{56098fbb-293a-40e0-4bc1-0a9c889f559f}">
+        <p14:section name="Conclusion" id="{19e36175-e8c1-fceb-7fa5-6af27e6fd2b0}">
           <p14:sldIdLst>
             <p14:sldId id="270"/>
           </p14:sldIdLst>
@@ -2833,7 +2833,7 @@
         </p:nvSpPr>
         <p:spPr>
           <a:xfrm>
-            <a:off x="548640" y="5257800"/>
+            <a:off x="548640" y="5074920"/>
             <a:ext cx="1463040" cy="384048"/>
           </a:xfrm>
           <a:prstGeom prst="roundRect">
@@ -2860,7 +2860,7 @@
         </p:nvSpPr>
         <p:spPr>
           <a:xfrm>
-            <a:off x="548640" y="5257800"/>
+            <a:off x="548640" y="5074920"/>
             <a:ext cx="1463040" cy="384048"/>
           </a:xfrm>
           <a:prstGeom prst="rect">
@@ -2896,7 +2896,7 @@
         </p:nvSpPr>
         <p:spPr>
           <a:xfrm>
-            <a:off x="2148840" y="5257800"/>
+            <a:off x="2148840" y="5074920"/>
             <a:ext cx="1828800" cy="384048"/>
           </a:xfrm>
           <a:prstGeom prst="roundRect">
@@ -2923,7 +2923,7 @@
         </p:nvSpPr>
         <p:spPr>
           <a:xfrm>
-            <a:off x="2148840" y="5257800"/>
+            <a:off x="2148840" y="5074920"/>
             <a:ext cx="1828800" cy="384048"/>
           </a:xfrm>
           <a:prstGeom prst="rect">
@@ -2959,7 +2959,7 @@
         </p:nvSpPr>
         <p:spPr>
           <a:xfrm>
-            <a:off x="4114800" y="5257800"/>
+            <a:off x="4114800" y="5074920"/>
             <a:ext cx="2194560" cy="384048"/>
           </a:xfrm>
           <a:prstGeom prst="roundRect">
@@ -2986,7 +2986,7 @@
         </p:nvSpPr>
         <p:spPr>
           <a:xfrm>
-            <a:off x="4114800" y="5257800"/>
+            <a:off x="4114800" y="5074920"/>
             <a:ext cx="2194560" cy="384048"/>
           </a:xfrm>
           <a:prstGeom prst="rect">
@@ -3014,9 +3014,95 @@
           </a:p>
         </p:txBody>
       </p:sp>
+      <p:sp>
+        <p:nvSpPr>
+          <p:cNvPr id="13" name="a3_9"/>
+          <p:cNvSpPr txBox="1"/>
+          <p:nvPr/>
+        </p:nvSpPr>
+        <p:spPr>
+          <a:xfrm>
+            <a:off x="548640" y="5806440"/>
+            <a:ext cx="5943600" cy="594360"/>
+          </a:xfrm>
+          <a:prstGeom prst="rect">
+            <a:avLst/>
+          </a:prstGeom>
+          <a:noFill/>
+          <a:ln/>
+        </p:spPr>
+        <p:txBody>
+          <a:bodyPr wrap="square" lIns="0" tIns="0" rIns="0" bIns="0" rtlCol="0" anchor="t"/>
+          <a:lstStyle/>
+          <a:p>
+            <a:pPr indent="0" marL="0">
+              <a:buNone/>
+            </a:pPr>
+            <a:r>
+              <a:rPr lang="en-US" sz="1400" b="1" dirty="0">
+                <a:solidFill>
+                  <a:schemeClr val="tx1"/>
+                </a:solidFill>
+              </a:rPr>
+              <a:t>Armel Meledje</a:t>
+            </a:r>
+            <a:endParaRPr lang="en-US" sz="1400" dirty="0"/>
+          </a:p>
+          <a:p>
+            <a:pPr indent="0" marL="0">
+              <a:buNone/>
+            </a:pPr>
+            <a:r>
+              <a:rPr lang="en-US" sz="1400" dirty="0">
+                <a:solidFill>
+                  <a:schemeClr val="accent6"/>
+                </a:solidFill>
+              </a:rPr>
+              <a:t>Développeur Senior · Ingénieur de conception</a:t>
+            </a:r>
+            <a:endParaRPr lang="en-US" sz="1400" dirty="0"/>
+          </a:p>
+        </p:txBody>
+      </p:sp>
+      <p:sp>
+        <p:nvSpPr>
+          <p:cNvPr id="14" name="a3_10"/>
+          <p:cNvSpPr txBox="1"/>
+          <p:nvPr/>
+        </p:nvSpPr>
+        <p:spPr>
+          <a:xfrm>
+            <a:off x="8412480" y="6035040"/>
+            <a:ext cx="3200400" cy="365760"/>
+          </a:xfrm>
+          <a:prstGeom prst="rect">
+            <a:avLst/>
+          </a:prstGeom>
+          <a:noFill/>
+          <a:ln/>
+        </p:spPr>
+        <p:txBody>
+          <a:bodyPr wrap="square" lIns="0" tIns="0" rIns="0" bIns="0" rtlCol="0" anchor="ctr"/>
+          <a:lstStyle/>
+          <a:p>
+            <a:pPr algn="r" indent="0" marL="0">
+              <a:buNone/>
+            </a:pPr>
+            <a:r>
+              <a:rPr lang="en-US" sz="1400" dirty="0">
+                <a:solidFill>
+                  <a:schemeClr val="accent6"/>
+                </a:solidFill>
+              </a:rPr>
+              <a:t>Vendredi 30 octobre 2026</a:t>
+            </a:r>
+            <a:endParaRPr lang="en-US" sz="1400" dirty="0"/>
+          </a:p>
+        </p:txBody>
+      </p:sp>
       <p:pic>
         <p:nvPicPr>
-          <p:cNvPr id="13" name="a1_9" descr="preencoded.png">    </p:cNvPr>
+          <p:cNvPr id="15" name="a1_11" descr="preencoded.png">    </p:cNvPr>
           <p:cNvPicPr>
             <a:picLocks noChangeAspect="1"/>
           </p:cNvPicPr>
@@ -3251,7 +3337,7 @@
                                     </p:stCondLst>
                                   </p:cTn>
                                   <p:tgtEl>
-                                    <p:spTgt spid="13"/>
+                                    <p:spTgt spid="15"/>
                                   </p:tgtEl>
                                   <p:attrNameLst>
                                     <p:attrName>style.visibility</p:attrName>
@@ -3265,7 +3351,7 @@
                                 <p:cBhvr>
                                   <p:cTn id="18" dur="600"/>
                                   <p:tgtEl>
-                                    <p:spTgt spid="13"/>
+                                    <p:spTgt spid="15"/>
                                   </p:tgtEl>
                                 </p:cBhvr>
                               </p:animEffect>
@@ -3273,7 +3359,7 @@
                                 <p:cBhvr>
                                   <p:cTn id="19" dur="600" decel="100000" fill="hold"/>
                                   <p:tgtEl>
-                                    <p:spTgt spid="13"/>
+                                    <p:spTgt spid="15"/>
                                   </p:tgtEl>
                                   <p:attrNameLst>
                                     <p:attrName>ppt_y</p:attrName>
@@ -3622,6 +3708,122 @@
                                   <p:cTn id="43" dur="600" decel="100000" fill="hold"/>
                                   <p:tgtEl>
                                     <p:spTgt spid="12"/>
+                                  </p:tgtEl>
+                                  <p:attrNameLst>
+                                    <p:attrName>ppt_y</p:attrName>
+                                  </p:attrNameLst>
+                                </p:cBhvr>
+                                <p:tavLst>
+                                  <p:tav tm="0">
+                                    <p:val>
+                                      <p:strVal val="#ppt_y+0.03"/>
+                                    </p:val>
+                                  </p:tav>
+                                  <p:tav tm="100000">
+                                    <p:val>
+                                      <p:strVal val="#ppt_y"/>
+                                    </p:val>
+                                  </p:tav>
+                                </p:tavLst>
+                              </p:anim>
+                            </p:childTnLst>
+                          </p:cTn>
+                        </p:par>
+                        <p:par>
+                          <p:cTn id="44" presetID="10" presetClass="entr" presetSubtype="0" fill="hold" nodeType="withEffect">
+                            <p:stCondLst>
+                              <p:cond delay="900"/>
+                            </p:stCondLst>
+                            <p:childTnLst>
+                              <p:set>
+                                <p:cBhvr>
+                                  <p:cTn id="45" dur="1" fill="hold">
+                                    <p:stCondLst>
+                                      <p:cond delay="0"/>
+                                    </p:stCondLst>
+                                  </p:cTn>
+                                  <p:tgtEl>
+                                    <p:spTgt spid="13"/>
+                                  </p:tgtEl>
+                                  <p:attrNameLst>
+                                    <p:attrName>style.visibility</p:attrName>
+                                  </p:attrNameLst>
+                                </p:cBhvr>
+                                <p:to>
+                                  <p:strVal val="visible"/>
+                                </p:to>
+                              </p:set>
+                              <p:animEffect transition="in" filter="fade">
+                                <p:cBhvr>
+                                  <p:cTn id="46" dur="600"/>
+                                  <p:tgtEl>
+                                    <p:spTgt spid="13"/>
+                                  </p:tgtEl>
+                                </p:cBhvr>
+                              </p:animEffect>
+                              <p:anim calcmode="lin" valueType="num">
+                                <p:cBhvr>
+                                  <p:cTn id="47" dur="600" decel="100000" fill="hold"/>
+                                  <p:tgtEl>
+                                    <p:spTgt spid="13"/>
+                                  </p:tgtEl>
+                                  <p:attrNameLst>
+                                    <p:attrName>ppt_y</p:attrName>
+                                  </p:attrNameLst>
+                                </p:cBhvr>
+                                <p:tavLst>
+                                  <p:tav tm="0">
+                                    <p:val>
+                                      <p:strVal val="#ppt_y+0.03"/>
+                                    </p:val>
+                                  </p:tav>
+                                  <p:tav tm="100000">
+                                    <p:val>
+                                      <p:strVal val="#ppt_y"/>
+                                    </p:val>
+                                  </p:tav>
+                                </p:tavLst>
+                              </p:anim>
+                            </p:childTnLst>
+                          </p:cTn>
+                        </p:par>
+                        <p:par>
+                          <p:cTn id="48" presetID="10" presetClass="entr" presetSubtype="0" fill="hold" nodeType="withEffect">
+                            <p:stCondLst>
+                              <p:cond delay="960"/>
+                            </p:stCondLst>
+                            <p:childTnLst>
+                              <p:set>
+                                <p:cBhvr>
+                                  <p:cTn id="49" dur="1" fill="hold">
+                                    <p:stCondLst>
+                                      <p:cond delay="0"/>
+                                    </p:stCondLst>
+                                  </p:cTn>
+                                  <p:tgtEl>
+                                    <p:spTgt spid="14"/>
+                                  </p:tgtEl>
+                                  <p:attrNameLst>
+                                    <p:attrName>style.visibility</p:attrName>
+                                  </p:attrNameLst>
+                                </p:cBhvr>
+                                <p:to>
+                                  <p:strVal val="visible"/>
+                                </p:to>
+                              </p:set>
+                              <p:animEffect transition="in" filter="fade">
+                                <p:cBhvr>
+                                  <p:cTn id="50" dur="600"/>
+                                  <p:tgtEl>
+                                    <p:spTgt spid="14"/>
+                                  </p:tgtEl>
+                                </p:cBhvr>
+                              </p:animEffect>
+                              <p:anim calcmode="lin" valueType="num">
+                                <p:cBhvr>
+                                  <p:cTn id="51" dur="600" decel="100000" fill="hold"/>
+                                  <p:tgtEl>
+                                    <p:spTgt spid="14"/>
                                   </p:tgtEl>
                                   <p:attrNameLst>
                                     <p:attrName>ppt_y</p:attrName>
@@ -3777,7 +3979,7 @@
       </p:sp>
       <p:sp>
         <p:nvSpPr>
-          <p:cNvPr id="4" name="a1_186"/>
+          <p:cNvPr id="4" name="a1_188"/>
           <p:cNvSpPr/>
           <p:nvPr/>
         </p:nvSpPr>
@@ -3811,7 +4013,7 @@
       </p:sp>
       <p:sp>
         <p:nvSpPr>
-          <p:cNvPr id="5" name="a1_187"/>
+          <p:cNvPr id="5" name="a1_189"/>
           <p:cNvSpPr/>
           <p:nvPr/>
         </p:nvSpPr>
@@ -3836,7 +4038,7 @@
       </p:sp>
       <p:pic>
         <p:nvPicPr>
-          <p:cNvPr id="6" name="a1_188" descr="preencoded.png">    </p:cNvPr>
+          <p:cNvPr id="6" name="a1_190" descr="preencoded.png">    </p:cNvPr>
           <p:cNvPicPr>
             <a:picLocks noChangeAspect="1"/>
           </p:cNvPicPr>
@@ -3860,7 +4062,7 @@
       </p:pic>
       <p:sp>
         <p:nvSpPr>
-          <p:cNvPr id="7" name="a1_189"/>
+          <p:cNvPr id="7" name="a1_191"/>
           <p:cNvSpPr txBox="1"/>
           <p:nvPr/>
         </p:nvSpPr>
@@ -3896,7 +4098,7 @@
       </p:sp>
       <p:sp>
         <p:nvSpPr>
-          <p:cNvPr id="8" name="a1_190"/>
+          <p:cNvPr id="8" name="a1_192"/>
           <p:cNvSpPr txBox="1"/>
           <p:nvPr/>
         </p:nvSpPr>
@@ -3932,7 +4134,7 @@
       </p:sp>
       <p:sp>
         <p:nvSpPr>
-          <p:cNvPr id="9" name="a1_191"/>
+          <p:cNvPr id="9" name="a1_193"/>
           <p:cNvSpPr txBox="1"/>
           <p:nvPr/>
         </p:nvSpPr>
@@ -3968,7 +4170,7 @@
       </p:sp>
       <p:sp>
         <p:nvSpPr>
-          <p:cNvPr id="10" name="a2_192"/>
+          <p:cNvPr id="10" name="a2_194"/>
           <p:cNvSpPr/>
           <p:nvPr/>
         </p:nvSpPr>
@@ -3992,7 +4194,7 @@
       </p:sp>
       <p:sp>
         <p:nvSpPr>
-          <p:cNvPr id="11" name="a2_193"/>
+          <p:cNvPr id="11" name="a2_195"/>
           <p:cNvSpPr/>
           <p:nvPr/>
         </p:nvSpPr>
@@ -4026,7 +4228,7 @@
       </p:sp>
       <p:sp>
         <p:nvSpPr>
-          <p:cNvPr id="12" name="a2_194"/>
+          <p:cNvPr id="12" name="a2_196"/>
           <p:cNvSpPr/>
           <p:nvPr/>
         </p:nvSpPr>
@@ -4051,7 +4253,7 @@
       </p:sp>
       <p:pic>
         <p:nvPicPr>
-          <p:cNvPr id="13" name="a2_195" descr="preencoded.png">    </p:cNvPr>
+          <p:cNvPr id="13" name="a2_197" descr="preencoded.png">    </p:cNvPr>
           <p:cNvPicPr>
             <a:picLocks noChangeAspect="1"/>
           </p:cNvPicPr>
@@ -4075,7 +4277,7 @@
       </p:pic>
       <p:sp>
         <p:nvSpPr>
-          <p:cNvPr id="14" name="a2_196"/>
+          <p:cNvPr id="14" name="a2_198"/>
           <p:cNvSpPr txBox="1"/>
           <p:nvPr/>
         </p:nvSpPr>
@@ -4111,7 +4313,7 @@
       </p:sp>
       <p:sp>
         <p:nvSpPr>
-          <p:cNvPr id="15" name="a2_197"/>
+          <p:cNvPr id="15" name="a2_199"/>
           <p:cNvSpPr txBox="1"/>
           <p:nvPr/>
         </p:nvSpPr>
@@ -4147,7 +4349,7 @@
       </p:sp>
       <p:sp>
         <p:nvSpPr>
-          <p:cNvPr id="16" name="a2_198"/>
+          <p:cNvPr id="16" name="a2_200"/>
           <p:cNvSpPr txBox="1"/>
           <p:nvPr/>
         </p:nvSpPr>
@@ -4183,7 +4385,7 @@
       </p:sp>
       <p:sp>
         <p:nvSpPr>
-          <p:cNvPr id="17" name="a3_199"/>
+          <p:cNvPr id="17" name="a3_201"/>
           <p:cNvSpPr txBox="1"/>
           <p:nvPr/>
         </p:nvSpPr>
@@ -5273,7 +5475,7 @@
       </p:sp>
       <p:sp>
         <p:nvSpPr>
-          <p:cNvPr id="4" name="a1_200"/>
+          <p:cNvPr id="4" name="a1_202"/>
           <p:cNvSpPr/>
           <p:nvPr/>
         </p:nvSpPr>
@@ -5307,7 +5509,7 @@
       </p:sp>
       <p:sp>
         <p:nvSpPr>
-          <p:cNvPr id="5" name="a1_201"/>
+          <p:cNvPr id="5" name="a1_203"/>
           <p:cNvSpPr/>
           <p:nvPr/>
         </p:nvSpPr>
@@ -5332,7 +5534,7 @@
       </p:sp>
       <p:sp>
         <p:nvSpPr>
-          <p:cNvPr id="6" name="a1_202"/>
+          <p:cNvPr id="6" name="a1_204"/>
           <p:cNvSpPr/>
           <p:nvPr/>
         </p:nvSpPr>
@@ -5357,7 +5559,7 @@
       </p:sp>
       <p:sp>
         <p:nvSpPr>
-          <p:cNvPr id="7" name="a1_203"/>
+          <p:cNvPr id="7" name="a1_205"/>
           <p:cNvSpPr/>
           <p:nvPr/>
         </p:nvSpPr>
@@ -5382,7 +5584,7 @@
       </p:sp>
       <p:sp>
         <p:nvSpPr>
-          <p:cNvPr id="8" name="a1_204"/>
+          <p:cNvPr id="8" name="a1_206"/>
           <p:cNvSpPr/>
           <p:nvPr/>
         </p:nvSpPr>
@@ -5407,7 +5609,7 @@
       </p:sp>
       <p:sp>
         <p:nvSpPr>
-          <p:cNvPr id="9" name="a1_205"/>
+          <p:cNvPr id="9" name="a1_207"/>
           <p:cNvSpPr/>
           <p:nvPr/>
         </p:nvSpPr>
@@ -5432,7 +5634,7 @@
       </p:sp>
       <p:sp>
         <p:nvSpPr>
-          <p:cNvPr id="10" name="a1_206"/>
+          <p:cNvPr id="10" name="a1_208"/>
           <p:cNvSpPr txBox="1"/>
           <p:nvPr/>
         </p:nvSpPr>
@@ -5468,7 +5670,7 @@
       </p:sp>
       <p:sp>
         <p:nvSpPr>
-          <p:cNvPr id="11" name="a1_207"/>
+          <p:cNvPr id="11" name="a1_209"/>
           <p:cNvSpPr txBox="1"/>
           <p:nvPr/>
         </p:nvSpPr>
@@ -5504,7 +5706,7 @@
       </p:sp>
       <p:sp>
         <p:nvSpPr>
-          <p:cNvPr id="12" name="a1_208"/>
+          <p:cNvPr id="12" name="a1_210"/>
           <p:cNvSpPr/>
           <p:nvPr/>
         </p:nvSpPr>
@@ -5531,7 +5733,7 @@
       </p:sp>
       <p:sp>
         <p:nvSpPr>
-          <p:cNvPr id="13" name="a1_209"/>
+          <p:cNvPr id="13" name="a1_211"/>
           <p:cNvSpPr txBox="1"/>
           <p:nvPr/>
         </p:nvSpPr>
@@ -5567,7 +5769,7 @@
       </p:sp>
       <p:sp>
         <p:nvSpPr>
-          <p:cNvPr id="14" name="a1_210"/>
+          <p:cNvPr id="14" name="a1_212"/>
           <p:cNvSpPr/>
           <p:nvPr/>
         </p:nvSpPr>
@@ -5594,7 +5796,7 @@
       </p:sp>
       <p:sp>
         <p:nvSpPr>
-          <p:cNvPr id="15" name="a1_211"/>
+          <p:cNvPr id="15" name="a1_213"/>
           <p:cNvSpPr/>
           <p:nvPr/>
         </p:nvSpPr>
@@ -5619,7 +5821,7 @@
       </p:sp>
       <p:pic>
         <p:nvPicPr>
-          <p:cNvPr id="16" name="a1_212" descr="preencoded.png">    </p:cNvPr>
+          <p:cNvPr id="16" name="a1_214" descr="preencoded.png">    </p:cNvPr>
           <p:cNvPicPr>
             <a:picLocks noChangeAspect="1"/>
           </p:cNvPicPr>
@@ -5643,7 +5845,7 @@
       </p:pic>
       <p:sp>
         <p:nvSpPr>
-          <p:cNvPr id="17" name="a1_213"/>
+          <p:cNvPr id="17" name="a1_215"/>
           <p:cNvSpPr txBox="1"/>
           <p:nvPr/>
         </p:nvSpPr>
@@ -5679,7 +5881,7 @@
       </p:sp>
       <p:sp>
         <p:nvSpPr>
-          <p:cNvPr id="18" name="a1_214"/>
+          <p:cNvPr id="18" name="a1_216"/>
           <p:cNvSpPr/>
           <p:nvPr/>
         </p:nvSpPr>
@@ -5706,7 +5908,7 @@
       </p:sp>
       <p:sp>
         <p:nvSpPr>
-          <p:cNvPr id="19" name="a1_215"/>
+          <p:cNvPr id="19" name="a1_217"/>
           <p:cNvSpPr/>
           <p:nvPr/>
         </p:nvSpPr>
@@ -5731,7 +5933,7 @@
       </p:sp>
       <p:pic>
         <p:nvPicPr>
-          <p:cNvPr id="20" name="a1_216" descr="preencoded.png">    </p:cNvPr>
+          <p:cNvPr id="20" name="a1_218" descr="preencoded.png">    </p:cNvPr>
           <p:cNvPicPr>
             <a:picLocks noChangeAspect="1"/>
           </p:cNvPicPr>
@@ -5755,7 +5957,7 @@
       </p:pic>
       <p:sp>
         <p:nvSpPr>
-          <p:cNvPr id="21" name="a1_217"/>
+          <p:cNvPr id="21" name="a1_219"/>
           <p:cNvSpPr txBox="1"/>
           <p:nvPr/>
         </p:nvSpPr>
@@ -5791,7 +5993,7 @@
       </p:sp>
       <p:sp>
         <p:nvSpPr>
-          <p:cNvPr id="22" name="a1_218"/>
+          <p:cNvPr id="22" name="a1_220"/>
           <p:cNvSpPr/>
           <p:nvPr/>
         </p:nvSpPr>
@@ -5818,7 +6020,7 @@
       </p:sp>
       <p:sp>
         <p:nvSpPr>
-          <p:cNvPr id="23" name="a1_219"/>
+          <p:cNvPr id="23" name="a1_221"/>
           <p:cNvSpPr/>
           <p:nvPr/>
         </p:nvSpPr>
@@ -5843,7 +6045,7 @@
       </p:sp>
       <p:pic>
         <p:nvPicPr>
-          <p:cNvPr id="24" name="a1_220" descr="preencoded.png">    </p:cNvPr>
+          <p:cNvPr id="24" name="a1_222" descr="preencoded.png">    </p:cNvPr>
           <p:cNvPicPr>
             <a:picLocks noChangeAspect="1"/>
           </p:cNvPicPr>
@@ -5867,7 +6069,7 @@
       </p:pic>
       <p:sp>
         <p:nvSpPr>
-          <p:cNvPr id="25" name="a1_221"/>
+          <p:cNvPr id="25" name="a1_223"/>
           <p:cNvSpPr txBox="1"/>
           <p:nvPr/>
         </p:nvSpPr>
@@ -5903,7 +6105,7 @@
       </p:sp>
       <p:sp>
         <p:nvSpPr>
-          <p:cNvPr id="26" name="a2_222"/>
+          <p:cNvPr id="26" name="a2_224"/>
           <p:cNvSpPr txBox="1"/>
           <p:nvPr/>
         </p:nvSpPr>
@@ -5939,7 +6141,7 @@
       </p:sp>
       <p:sp>
         <p:nvSpPr>
-          <p:cNvPr id="27" name="a2_223"/>
+          <p:cNvPr id="27" name="a2_225"/>
           <p:cNvSpPr txBox="1"/>
           <p:nvPr/>
         </p:nvSpPr>
@@ -5975,7 +6177,7 @@
       </p:sp>
       <p:sp>
         <p:nvSpPr>
-          <p:cNvPr id="28" name="a3_224"/>
+          <p:cNvPr id="28" name="a3_226"/>
           <p:cNvSpPr/>
           <p:nvPr/>
         </p:nvSpPr>
@@ -6000,7 +6202,7 @@
       </p:sp>
       <p:pic>
         <p:nvPicPr>
-          <p:cNvPr id="29" name="a3_225" descr="preencoded.png">    </p:cNvPr>
+          <p:cNvPr id="29" name="a3_227" descr="preencoded.png">    </p:cNvPr>
           <p:cNvPicPr>
             <a:picLocks noChangeAspect="1"/>
           </p:cNvPicPr>
@@ -6024,7 +6226,7 @@
       </p:pic>
       <p:sp>
         <p:nvSpPr>
-          <p:cNvPr id="30" name="a3_226"/>
+          <p:cNvPr id="30" name="a3_228"/>
           <p:cNvSpPr txBox="1"/>
           <p:nvPr/>
         </p:nvSpPr>
@@ -6060,7 +6262,7 @@
       </p:sp>
       <p:sp>
         <p:nvSpPr>
-          <p:cNvPr id="31" name="a4_227"/>
+          <p:cNvPr id="31" name="a4_229"/>
           <p:cNvSpPr/>
           <p:nvPr/>
         </p:nvSpPr>
@@ -6085,7 +6287,7 @@
       </p:sp>
       <p:pic>
         <p:nvPicPr>
-          <p:cNvPr id="32" name="a4_228" descr="preencoded.png">    </p:cNvPr>
+          <p:cNvPr id="32" name="a4_230" descr="preencoded.png">    </p:cNvPr>
           <p:cNvPicPr>
             <a:picLocks noChangeAspect="1"/>
           </p:cNvPicPr>
@@ -6109,7 +6311,7 @@
       </p:pic>
       <p:sp>
         <p:nvSpPr>
-          <p:cNvPr id="33" name="a4_229"/>
+          <p:cNvPr id="33" name="a4_231"/>
           <p:cNvSpPr txBox="1"/>
           <p:nvPr/>
         </p:nvSpPr>
@@ -6145,7 +6347,7 @@
       </p:sp>
       <p:sp>
         <p:nvSpPr>
-          <p:cNvPr id="34" name="a5_230"/>
+          <p:cNvPr id="34" name="a5_232"/>
           <p:cNvSpPr/>
           <p:nvPr/>
         </p:nvSpPr>
@@ -6170,7 +6372,7 @@
       </p:sp>
       <p:pic>
         <p:nvPicPr>
-          <p:cNvPr id="35" name="a5_231" descr="preencoded.png">    </p:cNvPr>
+          <p:cNvPr id="35" name="a5_233" descr="preencoded.png">    </p:cNvPr>
           <p:cNvPicPr>
             <a:picLocks noChangeAspect="1"/>
           </p:cNvPicPr>
@@ -6194,7 +6396,7 @@
       </p:pic>
       <p:sp>
         <p:nvSpPr>
-          <p:cNvPr id="36" name="a5_232"/>
+          <p:cNvPr id="36" name="a5_234"/>
           <p:cNvSpPr txBox="1"/>
           <p:nvPr/>
         </p:nvSpPr>
@@ -6230,7 +6432,7 @@
       </p:sp>
       <p:sp>
         <p:nvSpPr>
-          <p:cNvPr id="37" name="a6_233"/>
+          <p:cNvPr id="37" name="a6_235"/>
           <p:cNvSpPr/>
           <p:nvPr/>
         </p:nvSpPr>
@@ -6255,7 +6457,7 @@
       </p:sp>
       <p:pic>
         <p:nvPicPr>
-          <p:cNvPr id="38" name="a6_234" descr="preencoded.png">    </p:cNvPr>
+          <p:cNvPr id="38" name="a6_236" descr="preencoded.png">    </p:cNvPr>
           <p:cNvPicPr>
             <a:picLocks noChangeAspect="1"/>
           </p:cNvPicPr>
@@ -6279,7 +6481,7 @@
       </p:pic>
       <p:sp>
         <p:nvSpPr>
-          <p:cNvPr id="39" name="a6_235"/>
+          <p:cNvPr id="39" name="a6_237"/>
           <p:cNvSpPr txBox="1"/>
           <p:nvPr/>
         </p:nvSpPr>
@@ -6315,7 +6517,7 @@
       </p:sp>
       <p:sp>
         <p:nvSpPr>
-          <p:cNvPr id="40" name="a7_236"/>
+          <p:cNvPr id="40" name="a7_238"/>
           <p:cNvSpPr/>
           <p:nvPr/>
         </p:nvSpPr>
@@ -6342,7 +6544,7 @@
       </p:sp>
       <p:sp>
         <p:nvSpPr>
-          <p:cNvPr id="41" name="a7_237"/>
+          <p:cNvPr id="41" name="a7_239"/>
           <p:cNvSpPr txBox="1"/>
           <p:nvPr/>
         </p:nvSpPr>
@@ -8784,7 +8986,7 @@
       </p:sp>
       <p:sp>
         <p:nvSpPr>
-          <p:cNvPr id="4" name="a1_238"/>
+          <p:cNvPr id="4" name="a1_240"/>
           <p:cNvSpPr txBox="1"/>
           <p:nvPr/>
         </p:nvSpPr>
@@ -8820,7 +9022,7 @@
       </p:sp>
       <p:sp>
         <p:nvSpPr>
-          <p:cNvPr id="5" name="a2_239"/>
+          <p:cNvPr id="5" name="a2_241"/>
           <p:cNvSpPr/>
           <p:nvPr/>
         </p:nvSpPr>
@@ -8845,7 +9047,7 @@
       </p:sp>
       <p:pic>
         <p:nvPicPr>
-          <p:cNvPr id="6" name="a2_240" descr="preencoded.png">    </p:cNvPr>
+          <p:cNvPr id="6" name="a2_242" descr="preencoded.png">    </p:cNvPr>
           <p:cNvPicPr>
             <a:picLocks noChangeAspect="1"/>
           </p:cNvPicPr>
@@ -9200,7 +9402,7 @@
       </p:sp>
       <p:sp>
         <p:nvSpPr>
-          <p:cNvPr id="4" name="a1_241"/>
+          <p:cNvPr id="4" name="a1_243"/>
           <p:cNvSpPr/>
           <p:nvPr/>
         </p:nvSpPr>
@@ -9225,7 +9427,7 @@
       </p:sp>
       <p:pic>
         <p:nvPicPr>
-          <p:cNvPr id="5" name="a1_242" descr="preencoded.png">    </p:cNvPr>
+          <p:cNvPr id="5" name="a1_244" descr="preencoded.png">    </p:cNvPr>
           <p:cNvPicPr>
             <a:picLocks noChangeAspect="1"/>
           </p:cNvPicPr>
@@ -9249,7 +9451,7 @@
       </p:pic>
       <p:sp>
         <p:nvSpPr>
-          <p:cNvPr id="6" name="a1_243"/>
+          <p:cNvPr id="6" name="a1_245"/>
           <p:cNvSpPr txBox="1"/>
           <p:nvPr/>
         </p:nvSpPr>
@@ -9285,7 +9487,7 @@
       </p:sp>
       <p:sp>
         <p:nvSpPr>
-          <p:cNvPr id="7" name="a2_244"/>
+          <p:cNvPr id="7" name="a2_246"/>
           <p:cNvSpPr/>
           <p:nvPr/>
         </p:nvSpPr>
@@ -9308,7 +9510,7 @@
       </p:sp>
       <p:sp>
         <p:nvSpPr>
-          <p:cNvPr id="8" name="a2_245"/>
+          <p:cNvPr id="8" name="a2_247"/>
           <p:cNvSpPr/>
           <p:nvPr/>
         </p:nvSpPr>
@@ -9342,7 +9544,7 @@
       </p:sp>
       <p:sp>
         <p:nvSpPr>
-          <p:cNvPr id="9" name="a2_246"/>
+          <p:cNvPr id="9" name="a2_248"/>
           <p:cNvSpPr txBox="1"/>
           <p:nvPr/>
         </p:nvSpPr>
@@ -9392,7 +9594,7 @@
       </p:sp>
       <p:sp>
         <p:nvSpPr>
-          <p:cNvPr id="10" name="a3_247"/>
+          <p:cNvPr id="10" name="a3_249"/>
           <p:cNvSpPr/>
           <p:nvPr/>
         </p:nvSpPr>
@@ -9417,7 +9619,7 @@
       </p:sp>
       <p:sp>
         <p:nvSpPr>
-          <p:cNvPr id="11" name="a3_248"/>
+          <p:cNvPr id="11" name="a3_250"/>
           <p:cNvSpPr/>
           <p:nvPr/>
         </p:nvSpPr>
@@ -9442,7 +9644,7 @@
       </p:sp>
       <p:sp>
         <p:nvSpPr>
-          <p:cNvPr id="12" name="a3_249"/>
+          <p:cNvPr id="12" name="a3_251"/>
           <p:cNvSpPr/>
           <p:nvPr/>
         </p:nvSpPr>
@@ -9467,7 +9669,7 @@
       </p:sp>
       <p:pic>
         <p:nvPicPr>
-          <p:cNvPr id="13" name="a3_250" descr="preencoded.png">    </p:cNvPr>
+          <p:cNvPr id="13" name="a3_252" descr="preencoded.png">    </p:cNvPr>
           <p:cNvPicPr>
             <a:picLocks noChangeAspect="1"/>
           </p:cNvPicPr>
@@ -9491,7 +9693,7 @@
       </p:pic>
       <p:sp>
         <p:nvSpPr>
-          <p:cNvPr id="14" name="a4_251"/>
+          <p:cNvPr id="14" name="a4_253"/>
           <p:cNvSpPr/>
           <p:nvPr/>
         </p:nvSpPr>
@@ -9516,7 +9718,7 @@
       </p:sp>
       <p:pic>
         <p:nvPicPr>
-          <p:cNvPr id="15" name="a4_252" descr="preencoded.png">    </p:cNvPr>
+          <p:cNvPr id="15" name="a4_254" descr="preencoded.png">    </p:cNvPr>
           <p:cNvPicPr>
             <a:picLocks noChangeAspect="1"/>
           </p:cNvPicPr>
@@ -9540,7 +9742,7 @@
       </p:pic>
       <p:sp>
         <p:nvSpPr>
-          <p:cNvPr id="16" name="a4_253"/>
+          <p:cNvPr id="16" name="a4_255"/>
           <p:cNvSpPr/>
           <p:nvPr/>
         </p:nvSpPr>
@@ -9565,7 +9767,7 @@
       </p:sp>
       <p:pic>
         <p:nvPicPr>
-          <p:cNvPr id="17" name="a4_254" descr="preencoded.png">    </p:cNvPr>
+          <p:cNvPr id="17" name="a4_256" descr="preencoded.png">    </p:cNvPr>
           <p:cNvPicPr>
             <a:picLocks noChangeAspect="1"/>
           </p:cNvPicPr>
@@ -9589,7 +9791,7 @@
       </p:pic>
       <p:sp>
         <p:nvSpPr>
-          <p:cNvPr id="18" name="a4_255"/>
+          <p:cNvPr id="18" name="a4_257"/>
           <p:cNvSpPr/>
           <p:nvPr/>
         </p:nvSpPr>
@@ -9614,7 +9816,7 @@
       </p:sp>
       <p:pic>
         <p:nvPicPr>
-          <p:cNvPr id="19" name="a4_256" descr="preencoded.png">    </p:cNvPr>
+          <p:cNvPr id="19" name="a4_258" descr="preencoded.png">    </p:cNvPr>
           <p:cNvPicPr>
             <a:picLocks noChangeAspect="1"/>
           </p:cNvPicPr>
@@ -9638,7 +9840,7 @@
       </p:pic>
       <p:sp>
         <p:nvSpPr>
-          <p:cNvPr id="20" name="a4_257"/>
+          <p:cNvPr id="20" name="a4_259"/>
           <p:cNvSpPr/>
           <p:nvPr/>
         </p:nvSpPr>
@@ -9663,7 +9865,7 @@
       </p:sp>
       <p:pic>
         <p:nvPicPr>
-          <p:cNvPr id="21" name="a4_258" descr="preencoded.png">    </p:cNvPr>
+          <p:cNvPr id="21" name="a4_260" descr="preencoded.png">    </p:cNvPr>
           <p:cNvPicPr>
             <a:picLocks noChangeAspect="1"/>
           </p:cNvPicPr>
@@ -9687,7 +9889,7 @@
       </p:pic>
       <p:sp>
         <p:nvSpPr>
-          <p:cNvPr id="22" name="a4_259"/>
+          <p:cNvPr id="22" name="a4_261"/>
           <p:cNvSpPr/>
           <p:nvPr/>
         </p:nvSpPr>
@@ -9712,7 +9914,7 @@
       </p:sp>
       <p:pic>
         <p:nvPicPr>
-          <p:cNvPr id="23" name="a4_260" descr="preencoded.png">    </p:cNvPr>
+          <p:cNvPr id="23" name="a4_262" descr="preencoded.png">    </p:cNvPr>
           <p:cNvPicPr>
             <a:picLocks noChangeAspect="1"/>
           </p:cNvPicPr>
@@ -9736,7 +9938,7 @@
       </p:pic>
       <p:sp>
         <p:nvSpPr>
-          <p:cNvPr id="24" name="a4_261"/>
+          <p:cNvPr id="24" name="a4_263"/>
           <p:cNvSpPr/>
           <p:nvPr/>
         </p:nvSpPr>
@@ -9761,7 +9963,7 @@
       </p:sp>
       <p:pic>
         <p:nvPicPr>
-          <p:cNvPr id="25" name="a4_262" descr="preencoded.png">    </p:cNvPr>
+          <p:cNvPr id="25" name="a4_264" descr="preencoded.png">    </p:cNvPr>
           <p:cNvPicPr>
             <a:picLocks noChangeAspect="1"/>
           </p:cNvPicPr>
@@ -9785,7 +9987,7 @@
       </p:pic>
       <p:sp>
         <p:nvSpPr>
-          <p:cNvPr id="26" name="a4_263"/>
+          <p:cNvPr id="26" name="a4_265"/>
           <p:cNvSpPr txBox="1"/>
           <p:nvPr/>
         </p:nvSpPr>
@@ -9821,7 +10023,7 @@
       </p:sp>
       <p:sp>
         <p:nvSpPr>
-          <p:cNvPr id="27" name="a5_264"/>
+          <p:cNvPr id="27" name="a5_266"/>
           <p:cNvSpPr/>
           <p:nvPr/>
         </p:nvSpPr>
@@ -9848,7 +10050,7 @@
       </p:sp>
       <p:sp>
         <p:nvSpPr>
-          <p:cNvPr id="28" name="a5_265"/>
+          <p:cNvPr id="28" name="a5_267"/>
           <p:cNvSpPr txBox="1"/>
           <p:nvPr/>
         </p:nvSpPr>
@@ -9884,7 +10086,7 @@
       </p:sp>
       <p:sp>
         <p:nvSpPr>
-          <p:cNvPr id="29" name="a6_266"/>
+          <p:cNvPr id="29" name="a6_268"/>
           <p:cNvSpPr/>
           <p:nvPr/>
         </p:nvSpPr>
@@ -9911,7 +10113,7 @@
       </p:sp>
       <p:sp>
         <p:nvSpPr>
-          <p:cNvPr id="30" name="a6_267"/>
+          <p:cNvPr id="30" name="a6_269"/>
           <p:cNvSpPr txBox="1"/>
           <p:nvPr/>
         </p:nvSpPr>
@@ -9947,7 +10149,7 @@
       </p:sp>
       <p:sp>
         <p:nvSpPr>
-          <p:cNvPr id="31" name="a7_268"/>
+          <p:cNvPr id="31" name="a7_270"/>
           <p:cNvSpPr/>
           <p:nvPr/>
         </p:nvSpPr>
@@ -9974,7 +10176,7 @@
       </p:sp>
       <p:sp>
         <p:nvSpPr>
-          <p:cNvPr id="32" name="a7_269"/>
+          <p:cNvPr id="32" name="a7_271"/>
           <p:cNvSpPr txBox="1"/>
           <p:nvPr/>
         </p:nvSpPr>
@@ -10010,7 +10212,7 @@
       </p:sp>
       <p:sp>
         <p:nvSpPr>
-          <p:cNvPr id="33" name="a8_270"/>
+          <p:cNvPr id="33" name="a8_272"/>
           <p:cNvSpPr/>
           <p:nvPr/>
         </p:nvSpPr>
@@ -10037,7 +10239,7 @@
       </p:sp>
       <p:sp>
         <p:nvSpPr>
-          <p:cNvPr id="34" name="a8_271"/>
+          <p:cNvPr id="34" name="a8_273"/>
           <p:cNvSpPr txBox="1"/>
           <p:nvPr/>
         </p:nvSpPr>
@@ -12073,7 +12275,7 @@
       </p:sp>
       <p:sp>
         <p:nvSpPr>
-          <p:cNvPr id="4" name="a1_272"/>
+          <p:cNvPr id="4" name="a1_274"/>
           <p:cNvSpPr/>
           <p:nvPr/>
         </p:nvSpPr>
@@ -12107,7 +12309,7 @@
       </p:sp>
       <p:sp>
         <p:nvSpPr>
-          <p:cNvPr id="5" name="a1_273"/>
+          <p:cNvPr id="5" name="a1_275"/>
           <p:cNvSpPr/>
           <p:nvPr/>
         </p:nvSpPr>
@@ -12132,7 +12334,7 @@
       </p:sp>
       <p:pic>
         <p:nvPicPr>
-          <p:cNvPr id="6" name="a1_274" descr="preencoded.png">    </p:cNvPr>
+          <p:cNvPr id="6" name="a1_276" descr="preencoded.png">    </p:cNvPr>
           <p:cNvPicPr>
             <a:picLocks noChangeAspect="1"/>
           </p:cNvPicPr>
@@ -12156,7 +12358,7 @@
       </p:pic>
       <p:sp>
         <p:nvSpPr>
-          <p:cNvPr id="7" name="a1_275"/>
+          <p:cNvPr id="7" name="a1_277"/>
           <p:cNvSpPr txBox="1"/>
           <p:nvPr/>
         </p:nvSpPr>
@@ -12192,7 +12394,7 @@
       </p:sp>
       <p:sp>
         <p:nvSpPr>
-          <p:cNvPr id="8" name="a1_276"/>
+          <p:cNvPr id="8" name="a1_278"/>
           <p:cNvSpPr txBox="1"/>
           <p:nvPr/>
         </p:nvSpPr>
@@ -12228,7 +12430,7 @@
       </p:sp>
       <p:sp>
         <p:nvSpPr>
-          <p:cNvPr id="9" name="a1_277"/>
+          <p:cNvPr id="9" name="a1_279"/>
           <p:cNvSpPr/>
           <p:nvPr/>
         </p:nvSpPr>
@@ -12262,7 +12464,7 @@
       </p:sp>
       <p:sp>
         <p:nvSpPr>
-          <p:cNvPr id="10" name="a1_278"/>
+          <p:cNvPr id="10" name="a1_280"/>
           <p:cNvSpPr/>
           <p:nvPr/>
         </p:nvSpPr>
@@ -12287,7 +12489,7 @@
       </p:sp>
       <p:pic>
         <p:nvPicPr>
-          <p:cNvPr id="11" name="a1_279" descr="preencoded.png">    </p:cNvPr>
+          <p:cNvPr id="11" name="a1_281" descr="preencoded.png">    </p:cNvPr>
           <p:cNvPicPr>
             <a:picLocks noChangeAspect="1"/>
           </p:cNvPicPr>
@@ -12311,7 +12513,7 @@
       </p:pic>
       <p:sp>
         <p:nvSpPr>
-          <p:cNvPr id="12" name="a1_280"/>
+          <p:cNvPr id="12" name="a1_282"/>
           <p:cNvSpPr txBox="1"/>
           <p:nvPr/>
         </p:nvSpPr>
@@ -12347,7 +12549,7 @@
       </p:sp>
       <p:sp>
         <p:nvSpPr>
-          <p:cNvPr id="13" name="a1_281"/>
+          <p:cNvPr id="13" name="a1_283"/>
           <p:cNvSpPr txBox="1"/>
           <p:nvPr/>
         </p:nvSpPr>
@@ -12383,7 +12585,7 @@
       </p:sp>
       <p:sp>
         <p:nvSpPr>
-          <p:cNvPr id="14" name="a2_282"/>
+          <p:cNvPr id="14" name="a2_284"/>
           <p:cNvSpPr/>
           <p:nvPr/>
         </p:nvSpPr>
@@ -12417,7 +12619,7 @@
       </p:sp>
       <p:sp>
         <p:nvSpPr>
-          <p:cNvPr id="15" name="a2_283"/>
+          <p:cNvPr id="15" name="a2_285"/>
           <p:cNvSpPr/>
           <p:nvPr/>
         </p:nvSpPr>
@@ -12442,7 +12644,7 @@
       </p:sp>
       <p:pic>
         <p:nvPicPr>
-          <p:cNvPr id="16" name="a2_284" descr="preencoded.png">    </p:cNvPr>
+          <p:cNvPr id="16" name="a2_286" descr="preencoded.png">    </p:cNvPr>
           <p:cNvPicPr>
             <a:picLocks noChangeAspect="1"/>
           </p:cNvPicPr>
@@ -12466,7 +12668,7 @@
       </p:pic>
       <p:sp>
         <p:nvSpPr>
-          <p:cNvPr id="17" name="a2_285"/>
+          <p:cNvPr id="17" name="a2_287"/>
           <p:cNvSpPr txBox="1"/>
           <p:nvPr/>
         </p:nvSpPr>
@@ -12502,7 +12704,7 @@
       </p:sp>
       <p:sp>
         <p:nvSpPr>
-          <p:cNvPr id="18" name="a2_286"/>
+          <p:cNvPr id="18" name="a2_288"/>
           <p:cNvSpPr txBox="1"/>
           <p:nvPr/>
         </p:nvSpPr>
@@ -12538,7 +12740,7 @@
       </p:sp>
       <p:sp>
         <p:nvSpPr>
-          <p:cNvPr id="19" name="a2_287"/>
+          <p:cNvPr id="19" name="a2_289"/>
           <p:cNvSpPr/>
           <p:nvPr/>
         </p:nvSpPr>
@@ -12572,7 +12774,7 @@
       </p:sp>
       <p:sp>
         <p:nvSpPr>
-          <p:cNvPr id="20" name="a2_288"/>
+          <p:cNvPr id="20" name="a2_290"/>
           <p:cNvSpPr/>
           <p:nvPr/>
         </p:nvSpPr>
@@ -12597,7 +12799,7 @@
       </p:sp>
       <p:pic>
         <p:nvPicPr>
-          <p:cNvPr id="21" name="a2_289" descr="preencoded.png">    </p:cNvPr>
+          <p:cNvPr id="21" name="a2_291" descr="preencoded.png">    </p:cNvPr>
           <p:cNvPicPr>
             <a:picLocks noChangeAspect="1"/>
           </p:cNvPicPr>
@@ -12621,7 +12823,7 @@
       </p:pic>
       <p:sp>
         <p:nvSpPr>
-          <p:cNvPr id="22" name="a2_290"/>
+          <p:cNvPr id="22" name="a2_292"/>
           <p:cNvSpPr txBox="1"/>
           <p:nvPr/>
         </p:nvSpPr>
@@ -12657,7 +12859,7 @@
       </p:sp>
       <p:sp>
         <p:nvSpPr>
-          <p:cNvPr id="23" name="a2_291"/>
+          <p:cNvPr id="23" name="a2_293"/>
           <p:cNvSpPr txBox="1"/>
           <p:nvPr/>
         </p:nvSpPr>
@@ -12693,7 +12895,7 @@
       </p:sp>
       <p:sp>
         <p:nvSpPr>
-          <p:cNvPr id="24" name="a3_292"/>
+          <p:cNvPr id="24" name="a3_294"/>
           <p:cNvSpPr/>
           <p:nvPr/>
         </p:nvSpPr>
@@ -12727,7 +12929,7 @@
       </p:sp>
       <p:sp>
         <p:nvSpPr>
-          <p:cNvPr id="25" name="a3_293"/>
+          <p:cNvPr id="25" name="a3_295"/>
           <p:cNvSpPr/>
           <p:nvPr/>
         </p:nvSpPr>
@@ -12752,7 +12954,7 @@
       </p:sp>
       <p:pic>
         <p:nvPicPr>
-          <p:cNvPr id="26" name="a3_294" descr="preencoded.png">    </p:cNvPr>
+          <p:cNvPr id="26" name="a3_296" descr="preencoded.png">    </p:cNvPr>
           <p:cNvPicPr>
             <a:picLocks noChangeAspect="1"/>
           </p:cNvPicPr>
@@ -12776,7 +12978,7 @@
       </p:pic>
       <p:sp>
         <p:nvSpPr>
-          <p:cNvPr id="27" name="a3_295"/>
+          <p:cNvPr id="27" name="a3_297"/>
           <p:cNvSpPr txBox="1"/>
           <p:nvPr/>
         </p:nvSpPr>
@@ -12812,7 +13014,7 @@
       </p:sp>
       <p:sp>
         <p:nvSpPr>
-          <p:cNvPr id="28" name="a3_296"/>
+          <p:cNvPr id="28" name="a3_298"/>
           <p:cNvSpPr txBox="1"/>
           <p:nvPr/>
         </p:nvSpPr>
@@ -12848,7 +13050,7 @@
       </p:sp>
       <p:sp>
         <p:nvSpPr>
-          <p:cNvPr id="29" name="a3_297"/>
+          <p:cNvPr id="29" name="a3_299"/>
           <p:cNvSpPr/>
           <p:nvPr/>
         </p:nvSpPr>
@@ -12882,7 +13084,7 @@
       </p:sp>
       <p:sp>
         <p:nvSpPr>
-          <p:cNvPr id="30" name="a3_298"/>
+          <p:cNvPr id="30" name="a3_300"/>
           <p:cNvSpPr/>
           <p:nvPr/>
         </p:nvSpPr>
@@ -12907,7 +13109,7 @@
       </p:sp>
       <p:pic>
         <p:nvPicPr>
-          <p:cNvPr id="31" name="a3_299" descr="preencoded.png">    </p:cNvPr>
+          <p:cNvPr id="31" name="a3_301" descr="preencoded.png">    </p:cNvPr>
           <p:cNvPicPr>
             <a:picLocks noChangeAspect="1"/>
           </p:cNvPicPr>
@@ -12931,7 +13133,7 @@
       </p:pic>
       <p:sp>
         <p:nvSpPr>
-          <p:cNvPr id="32" name="a3_300"/>
+          <p:cNvPr id="32" name="a3_302"/>
           <p:cNvSpPr txBox="1"/>
           <p:nvPr/>
         </p:nvSpPr>
@@ -12967,7 +13169,7 @@
       </p:sp>
       <p:sp>
         <p:nvSpPr>
-          <p:cNvPr id="33" name="a3_301"/>
+          <p:cNvPr id="33" name="a3_303"/>
           <p:cNvSpPr txBox="1"/>
           <p:nvPr/>
         </p:nvSpPr>
@@ -13003,7 +13205,7 @@
       </p:sp>
       <p:sp>
         <p:nvSpPr>
-          <p:cNvPr id="34" name="a5_302"/>
+          <p:cNvPr id="34" name="a5_304"/>
           <p:cNvSpPr/>
           <p:nvPr/>
         </p:nvSpPr>
@@ -13037,7 +13239,7 @@
       </p:sp>
       <p:sp>
         <p:nvSpPr>
-          <p:cNvPr id="35" name="a5_303"/>
+          <p:cNvPr id="35" name="a5_305"/>
           <p:cNvSpPr/>
           <p:nvPr/>
         </p:nvSpPr>
@@ -13062,7 +13264,7 @@
       </p:sp>
       <p:pic>
         <p:nvPicPr>
-          <p:cNvPr id="36" name="a5_304" descr="preencoded.png">    </p:cNvPr>
+          <p:cNvPr id="36" name="a5_306" descr="preencoded.png">    </p:cNvPr>
           <p:cNvPicPr>
             <a:picLocks noChangeAspect="1"/>
           </p:cNvPicPr>
@@ -13086,7 +13288,7 @@
       </p:pic>
       <p:sp>
         <p:nvSpPr>
-          <p:cNvPr id="37" name="a5_305"/>
+          <p:cNvPr id="37" name="a5_307"/>
           <p:cNvSpPr txBox="1"/>
           <p:nvPr/>
         </p:nvSpPr>
@@ -13122,7 +13324,7 @@
       </p:sp>
       <p:sp>
         <p:nvSpPr>
-          <p:cNvPr id="38" name="a6_306"/>
+          <p:cNvPr id="38" name="a6_308"/>
           <p:cNvSpPr txBox="1"/>
           <p:nvPr/>
         </p:nvSpPr>
@@ -13158,7 +13360,7 @@
       </p:sp>
       <p:sp>
         <p:nvSpPr>
-          <p:cNvPr id="39" name="a7_307"/>
+          <p:cNvPr id="39" name="a7_309"/>
           <p:cNvSpPr/>
           <p:nvPr/>
         </p:nvSpPr>
@@ -13185,7 +13387,7 @@
       </p:sp>
       <p:sp>
         <p:nvSpPr>
-          <p:cNvPr id="40" name="a7_308"/>
+          <p:cNvPr id="40" name="a7_310"/>
           <p:cNvSpPr txBox="1"/>
           <p:nvPr/>
         </p:nvSpPr>
@@ -13221,7 +13423,7 @@
       </p:sp>
       <p:sp>
         <p:nvSpPr>
-          <p:cNvPr id="41" name="a7_309"/>
+          <p:cNvPr id="41" name="a7_311"/>
           <p:cNvSpPr txBox="1"/>
           <p:nvPr/>
         </p:nvSpPr>
@@ -15652,7 +15854,7 @@
       </p:sp>
       <p:sp>
         <p:nvSpPr>
-          <p:cNvPr id="4" name="a1_310"/>
+          <p:cNvPr id="4" name="a1_312"/>
           <p:cNvSpPr txBox="1"/>
           <p:nvPr/>
         </p:nvSpPr>
@@ -15688,7 +15890,7 @@
       </p:sp>
       <p:sp>
         <p:nvSpPr>
-          <p:cNvPr id="5" name="a2_311"/>
+          <p:cNvPr id="5" name="a2_313"/>
           <p:cNvSpPr/>
           <p:nvPr/>
         </p:nvSpPr>
@@ -15722,7 +15924,7 @@
       </p:sp>
       <p:sp>
         <p:nvSpPr>
-          <p:cNvPr id="6" name="a2_312"/>
+          <p:cNvPr id="6" name="a2_314"/>
           <p:cNvSpPr/>
           <p:nvPr/>
         </p:nvSpPr>
@@ -15747,7 +15949,7 @@
       </p:sp>
       <p:pic>
         <p:nvPicPr>
-          <p:cNvPr id="7" name="a2_313" descr="preencoded.png">    </p:cNvPr>
+          <p:cNvPr id="7" name="a2_315" descr="preencoded.png">    </p:cNvPr>
           <p:cNvPicPr>
             <a:picLocks noChangeAspect="1"/>
           </p:cNvPicPr>
@@ -15771,7 +15973,7 @@
       </p:pic>
       <p:sp>
         <p:nvSpPr>
-          <p:cNvPr id="8" name="a2_314"/>
+          <p:cNvPr id="8" name="a2_316"/>
           <p:cNvSpPr txBox="1"/>
           <p:nvPr/>
         </p:nvSpPr>
@@ -15807,7 +16009,7 @@
       </p:sp>
       <p:sp>
         <p:nvSpPr>
-          <p:cNvPr id="9" name="a3_315"/>
+          <p:cNvPr id="9" name="a3_317"/>
           <p:cNvSpPr/>
           <p:nvPr/>
         </p:nvSpPr>
@@ -15841,7 +16043,7 @@
       </p:sp>
       <p:sp>
         <p:nvSpPr>
-          <p:cNvPr id="10" name="a3_316"/>
+          <p:cNvPr id="10" name="a3_318"/>
           <p:cNvSpPr/>
           <p:nvPr/>
         </p:nvSpPr>
@@ -15866,7 +16068,7 @@
       </p:sp>
       <p:pic>
         <p:nvPicPr>
-          <p:cNvPr id="11" name="a3_317" descr="preencoded.png">    </p:cNvPr>
+          <p:cNvPr id="11" name="a3_319" descr="preencoded.png">    </p:cNvPr>
           <p:cNvPicPr>
             <a:picLocks noChangeAspect="1"/>
           </p:cNvPicPr>
@@ -15890,7 +16092,7 @@
       </p:pic>
       <p:sp>
         <p:nvSpPr>
-          <p:cNvPr id="12" name="a3_318"/>
+          <p:cNvPr id="12" name="a3_320"/>
           <p:cNvSpPr txBox="1"/>
           <p:nvPr/>
         </p:nvSpPr>
@@ -15926,7 +16128,7 @@
       </p:sp>
       <p:sp>
         <p:nvSpPr>
-          <p:cNvPr id="13" name="a4_319"/>
+          <p:cNvPr id="13" name="a4_321"/>
           <p:cNvSpPr/>
           <p:nvPr/>
         </p:nvSpPr>
@@ -15960,7 +16162,7 @@
       </p:sp>
       <p:sp>
         <p:nvSpPr>
-          <p:cNvPr id="14" name="a4_320"/>
+          <p:cNvPr id="14" name="a4_322"/>
           <p:cNvSpPr/>
           <p:nvPr/>
         </p:nvSpPr>
@@ -15985,7 +16187,7 @@
       </p:sp>
       <p:pic>
         <p:nvPicPr>
-          <p:cNvPr id="15" name="a4_321" descr="preencoded.png">    </p:cNvPr>
+          <p:cNvPr id="15" name="a4_323" descr="preencoded.png">    </p:cNvPr>
           <p:cNvPicPr>
             <a:picLocks noChangeAspect="1"/>
           </p:cNvPicPr>
@@ -16009,7 +16211,7 @@
       </p:pic>
       <p:sp>
         <p:nvSpPr>
-          <p:cNvPr id="16" name="a4_322"/>
+          <p:cNvPr id="16" name="a4_324"/>
           <p:cNvSpPr txBox="1"/>
           <p:nvPr/>
         </p:nvSpPr>
@@ -16956,7 +17158,7 @@
       </p:sp>
       <p:pic>
         <p:nvPicPr>
-          <p:cNvPr id="4" name="a1_10" descr="preencoded.png">    </p:cNvPr>
+          <p:cNvPr id="4" name="a1_12" descr="preencoded.png">    </p:cNvPr>
           <p:cNvPicPr>
             <a:picLocks noChangeAspect="1"/>
           </p:cNvPicPr>
@@ -16980,7 +17182,7 @@
       </p:pic>
       <p:sp>
         <p:nvSpPr>
-          <p:cNvPr id="5" name="a2_11"/>
+          <p:cNvPr id="5" name="a2_13"/>
           <p:cNvSpPr/>
           <p:nvPr/>
         </p:nvSpPr>
@@ -17005,7 +17207,7 @@
       </p:sp>
       <p:sp>
         <p:nvSpPr>
-          <p:cNvPr id="6" name="a2_12"/>
+          <p:cNvPr id="6" name="a2_14"/>
           <p:cNvSpPr txBox="1"/>
           <p:nvPr/>
         </p:nvSpPr>
@@ -17041,7 +17243,7 @@
       </p:sp>
       <p:sp>
         <p:nvSpPr>
-          <p:cNvPr id="7" name="a3_13"/>
+          <p:cNvPr id="7" name="a3_15"/>
           <p:cNvSpPr/>
           <p:nvPr/>
         </p:nvSpPr>
@@ -17066,7 +17268,7 @@
       </p:sp>
       <p:sp>
         <p:nvSpPr>
-          <p:cNvPr id="8" name="a3_14"/>
+          <p:cNvPr id="8" name="a3_16"/>
           <p:cNvSpPr txBox="1"/>
           <p:nvPr/>
         </p:nvSpPr>
@@ -17102,7 +17304,7 @@
       </p:sp>
       <p:sp>
         <p:nvSpPr>
-          <p:cNvPr id="9" name="a4_15"/>
+          <p:cNvPr id="9" name="a4_17"/>
           <p:cNvSpPr/>
           <p:nvPr/>
         </p:nvSpPr>
@@ -17127,7 +17329,7 @@
       </p:sp>
       <p:sp>
         <p:nvSpPr>
-          <p:cNvPr id="10" name="a4_16"/>
+          <p:cNvPr id="10" name="a4_18"/>
           <p:cNvSpPr txBox="1"/>
           <p:nvPr/>
         </p:nvSpPr>
@@ -17163,7 +17365,7 @@
       </p:sp>
       <p:sp>
         <p:nvSpPr>
-          <p:cNvPr id="11" name="a5_17"/>
+          <p:cNvPr id="11" name="a5_19"/>
           <p:cNvSpPr/>
           <p:nvPr/>
         </p:nvSpPr>
@@ -17188,7 +17390,7 @@
       </p:sp>
       <p:sp>
         <p:nvSpPr>
-          <p:cNvPr id="12" name="a5_18"/>
+          <p:cNvPr id="12" name="a5_20"/>
           <p:cNvSpPr txBox="1"/>
           <p:nvPr/>
         </p:nvSpPr>
@@ -17937,7 +18139,7 @@
       </p:sp>
       <p:sp>
         <p:nvSpPr>
-          <p:cNvPr id="4" name="a1_19"/>
+          <p:cNvPr id="4" name="a1_21"/>
           <p:cNvSpPr txBox="1"/>
           <p:nvPr/>
         </p:nvSpPr>
@@ -18199,7 +18401,7 @@
       </p:sp>
       <p:pic>
         <p:nvPicPr>
-          <p:cNvPr id="4" name="a1_20" descr="preencoded.png">    </p:cNvPr>
+          <p:cNvPr id="4" name="a1_22" descr="preencoded.png">    </p:cNvPr>
           <p:cNvPicPr>
             <a:picLocks noChangeAspect="1"/>
           </p:cNvPicPr>
@@ -18223,7 +18425,7 @@
       </p:pic>
       <p:sp>
         <p:nvSpPr>
-          <p:cNvPr id="5" name="a7_21"/>
+          <p:cNvPr id="5" name="a7_23"/>
           <p:cNvSpPr txBox="1"/>
           <p:nvPr/>
         </p:nvSpPr>
@@ -18259,7 +18461,7 @@
       </p:sp>
       <p:sp>
         <p:nvSpPr>
-          <p:cNvPr id="6" name="a7_22"/>
+          <p:cNvPr id="6" name="a7_24"/>
           <p:cNvSpPr/>
           <p:nvPr/>
         </p:nvSpPr>
@@ -18282,7 +18484,7 @@
       </p:sp>
       <p:sp>
         <p:nvSpPr>
-          <p:cNvPr id="7" name="a7_23"/>
+          <p:cNvPr id="7" name="a7_25"/>
           <p:cNvSpPr txBox="1"/>
           <p:nvPr/>
         </p:nvSpPr>
@@ -18318,7 +18520,7 @@
       </p:sp>
       <p:sp>
         <p:nvSpPr>
-          <p:cNvPr id="8" name="a6_24"/>
+          <p:cNvPr id="8" name="a6_26"/>
           <p:cNvSpPr txBox="1"/>
           <p:nvPr/>
         </p:nvSpPr>
@@ -18354,7 +18556,7 @@
       </p:sp>
       <p:sp>
         <p:nvSpPr>
-          <p:cNvPr id="9" name="a6_25"/>
+          <p:cNvPr id="9" name="a6_27"/>
           <p:cNvSpPr/>
           <p:nvPr/>
         </p:nvSpPr>
@@ -18377,7 +18579,7 @@
       </p:sp>
       <p:sp>
         <p:nvSpPr>
-          <p:cNvPr id="10" name="a6_26"/>
+          <p:cNvPr id="10" name="a6_28"/>
           <p:cNvSpPr txBox="1"/>
           <p:nvPr/>
         </p:nvSpPr>
@@ -18413,7 +18615,7 @@
       </p:sp>
       <p:sp>
         <p:nvSpPr>
-          <p:cNvPr id="11" name="a5_27"/>
+          <p:cNvPr id="11" name="a5_29"/>
           <p:cNvSpPr txBox="1"/>
           <p:nvPr/>
         </p:nvSpPr>
@@ -18449,7 +18651,7 @@
       </p:sp>
       <p:sp>
         <p:nvSpPr>
-          <p:cNvPr id="12" name="a5_28"/>
+          <p:cNvPr id="12" name="a5_30"/>
           <p:cNvSpPr/>
           <p:nvPr/>
         </p:nvSpPr>
@@ -18472,7 +18674,7 @@
       </p:sp>
       <p:sp>
         <p:nvSpPr>
-          <p:cNvPr id="13" name="a5_29"/>
+          <p:cNvPr id="13" name="a5_31"/>
           <p:cNvSpPr txBox="1"/>
           <p:nvPr/>
         </p:nvSpPr>
@@ -18508,7 +18710,7 @@
       </p:sp>
       <p:sp>
         <p:nvSpPr>
-          <p:cNvPr id="14" name="a4_30"/>
+          <p:cNvPr id="14" name="a4_32"/>
           <p:cNvSpPr txBox="1"/>
           <p:nvPr/>
         </p:nvSpPr>
@@ -18544,7 +18746,7 @@
       </p:sp>
       <p:sp>
         <p:nvSpPr>
-          <p:cNvPr id="15" name="a4_31"/>
+          <p:cNvPr id="15" name="a4_33"/>
           <p:cNvSpPr/>
           <p:nvPr/>
         </p:nvSpPr>
@@ -18567,7 +18769,7 @@
       </p:sp>
       <p:sp>
         <p:nvSpPr>
-          <p:cNvPr id="16" name="a4_32"/>
+          <p:cNvPr id="16" name="a4_34"/>
           <p:cNvSpPr txBox="1"/>
           <p:nvPr/>
         </p:nvSpPr>
@@ -18603,7 +18805,7 @@
       </p:sp>
       <p:sp>
         <p:nvSpPr>
-          <p:cNvPr id="17" name="a3_33"/>
+          <p:cNvPr id="17" name="a3_35"/>
           <p:cNvSpPr txBox="1"/>
           <p:nvPr/>
         </p:nvSpPr>
@@ -18639,7 +18841,7 @@
       </p:sp>
       <p:sp>
         <p:nvSpPr>
-          <p:cNvPr id="18" name="a3_34"/>
+          <p:cNvPr id="18" name="a3_36"/>
           <p:cNvSpPr/>
           <p:nvPr/>
         </p:nvSpPr>
@@ -18662,7 +18864,7 @@
       </p:sp>
       <p:sp>
         <p:nvSpPr>
-          <p:cNvPr id="19" name="a3_35"/>
+          <p:cNvPr id="19" name="a3_37"/>
           <p:cNvSpPr txBox="1"/>
           <p:nvPr/>
         </p:nvSpPr>
@@ -18698,7 +18900,7 @@
       </p:sp>
       <p:sp>
         <p:nvSpPr>
-          <p:cNvPr id="20" name="a2_36"/>
+          <p:cNvPr id="20" name="a2_38"/>
           <p:cNvSpPr txBox="1"/>
           <p:nvPr/>
         </p:nvSpPr>
@@ -18734,7 +18936,7 @@
       </p:sp>
       <p:sp>
         <p:nvSpPr>
-          <p:cNvPr id="21" name="a2_37"/>
+          <p:cNvPr id="21" name="a2_39"/>
           <p:cNvSpPr/>
           <p:nvPr/>
         </p:nvSpPr>
@@ -18757,7 +18959,7 @@
       </p:sp>
       <p:sp>
         <p:nvSpPr>
-          <p:cNvPr id="22" name="a2_38"/>
+          <p:cNvPr id="22" name="a2_40"/>
           <p:cNvSpPr txBox="1"/>
           <p:nvPr/>
         </p:nvSpPr>
@@ -20097,7 +20299,7 @@
       </p:sp>
       <p:sp>
         <p:nvSpPr>
-          <p:cNvPr id="4" name="a1_39"/>
+          <p:cNvPr id="4" name="a1_41"/>
           <p:cNvSpPr/>
           <p:nvPr/>
         </p:nvSpPr>
@@ -20124,7 +20326,7 @@
       </p:sp>
       <p:sp>
         <p:nvSpPr>
-          <p:cNvPr id="5" name="a1_40"/>
+          <p:cNvPr id="5" name="a1_42"/>
           <p:cNvSpPr txBox="1"/>
           <p:nvPr/>
         </p:nvSpPr>
@@ -20160,7 +20362,7 @@
       </p:sp>
       <p:sp>
         <p:nvSpPr>
-          <p:cNvPr id="6" name="a1_41"/>
+          <p:cNvPr id="6" name="a1_43"/>
           <p:cNvSpPr/>
           <p:nvPr/>
         </p:nvSpPr>
@@ -20187,7 +20389,7 @@
       </p:sp>
       <p:sp>
         <p:nvSpPr>
-          <p:cNvPr id="7" name="a1_42"/>
+          <p:cNvPr id="7" name="a1_44"/>
           <p:cNvSpPr txBox="1"/>
           <p:nvPr/>
         </p:nvSpPr>
@@ -20223,7 +20425,7 @@
       </p:sp>
       <p:sp>
         <p:nvSpPr>
-          <p:cNvPr id="8" name="a2_43"/>
+          <p:cNvPr id="8" name="a2_45"/>
           <p:cNvSpPr txBox="1"/>
           <p:nvPr/>
         </p:nvSpPr>
@@ -20259,7 +20461,7 @@
       </p:sp>
       <p:sp>
         <p:nvSpPr>
-          <p:cNvPr id="9" name="a2_44"/>
+          <p:cNvPr id="9" name="a2_46"/>
           <p:cNvSpPr/>
           <p:nvPr/>
         </p:nvSpPr>
@@ -20286,7 +20488,7 @@
       </p:sp>
       <p:pic>
         <p:nvPicPr>
-          <p:cNvPr id="10" name="a2_45" descr="preencoded.png">    </p:cNvPr>
+          <p:cNvPr id="10" name="a2_47" descr="preencoded.png">    </p:cNvPr>
           <p:cNvPicPr>
             <a:picLocks noChangeAspect="1"/>
           </p:cNvPicPr>
@@ -20310,7 +20512,7 @@
       </p:pic>
       <p:sp>
         <p:nvSpPr>
-          <p:cNvPr id="11" name="a2_46"/>
+          <p:cNvPr id="11" name="a2_48"/>
           <p:cNvSpPr txBox="1"/>
           <p:nvPr/>
         </p:nvSpPr>
@@ -20346,7 +20548,7 @@
       </p:sp>
       <p:sp>
         <p:nvSpPr>
-          <p:cNvPr id="12" name="a2_47"/>
+          <p:cNvPr id="12" name="a2_49"/>
           <p:cNvSpPr/>
           <p:nvPr/>
         </p:nvSpPr>
@@ -20380,7 +20582,7 @@
       </p:sp>
       <p:pic>
         <p:nvPicPr>
-          <p:cNvPr id="13" name="a2_48" descr="preencoded.png">    </p:cNvPr>
+          <p:cNvPr id="13" name="a2_50" descr="preencoded.png">    </p:cNvPr>
           <p:cNvPicPr>
             <a:picLocks noChangeAspect="1"/>
           </p:cNvPicPr>
@@ -20404,7 +20606,7 @@
       </p:pic>
       <p:sp>
         <p:nvSpPr>
-          <p:cNvPr id="14" name="a2_49"/>
+          <p:cNvPr id="14" name="a2_51"/>
           <p:cNvSpPr txBox="1"/>
           <p:nvPr/>
         </p:nvSpPr>
@@ -20440,7 +20642,7 @@
       </p:sp>
       <p:sp>
         <p:nvSpPr>
-          <p:cNvPr id="15" name="a3_50"/>
+          <p:cNvPr id="15" name="a3_52"/>
           <p:cNvSpPr txBox="1"/>
           <p:nvPr/>
         </p:nvSpPr>
@@ -20476,7 +20678,7 @@
       </p:sp>
       <p:sp>
         <p:nvSpPr>
-          <p:cNvPr id="16" name="a3_51"/>
+          <p:cNvPr id="16" name="a3_53"/>
           <p:cNvSpPr/>
           <p:nvPr/>
         </p:nvSpPr>
@@ -20503,7 +20705,7 @@
       </p:sp>
       <p:pic>
         <p:nvPicPr>
-          <p:cNvPr id="17" name="a3_52" descr="preencoded.png">    </p:cNvPr>
+          <p:cNvPr id="17" name="a3_54" descr="preencoded.png">    </p:cNvPr>
           <p:cNvPicPr>
             <a:picLocks noChangeAspect="1"/>
           </p:cNvPicPr>
@@ -20527,7 +20729,7 @@
       </p:pic>
       <p:sp>
         <p:nvSpPr>
-          <p:cNvPr id="18" name="a3_53"/>
+          <p:cNvPr id="18" name="a3_55"/>
           <p:cNvSpPr txBox="1"/>
           <p:nvPr/>
         </p:nvSpPr>
@@ -20563,7 +20765,7 @@
       </p:sp>
       <p:sp>
         <p:nvSpPr>
-          <p:cNvPr id="19" name="a3_54"/>
+          <p:cNvPr id="19" name="a3_56"/>
           <p:cNvSpPr/>
           <p:nvPr/>
         </p:nvSpPr>
@@ -20597,7 +20799,7 @@
       </p:sp>
       <p:pic>
         <p:nvPicPr>
-          <p:cNvPr id="20" name="a3_55" descr="preencoded.png">    </p:cNvPr>
+          <p:cNvPr id="20" name="a3_57" descr="preencoded.png">    </p:cNvPr>
           <p:cNvPicPr>
             <a:picLocks noChangeAspect="1"/>
           </p:cNvPicPr>
@@ -20621,7 +20823,7 @@
       </p:pic>
       <p:sp>
         <p:nvSpPr>
-          <p:cNvPr id="21" name="a3_56"/>
+          <p:cNvPr id="21" name="a3_58"/>
           <p:cNvSpPr txBox="1"/>
           <p:nvPr/>
         </p:nvSpPr>
@@ -20657,7 +20859,7 @@
       </p:sp>
       <p:sp>
         <p:nvSpPr>
-          <p:cNvPr id="22" name="a4_57"/>
+          <p:cNvPr id="22" name="a4_59"/>
           <p:cNvSpPr txBox="1"/>
           <p:nvPr/>
         </p:nvSpPr>
@@ -20693,7 +20895,7 @@
       </p:sp>
       <p:sp>
         <p:nvSpPr>
-          <p:cNvPr id="23" name="a4_58"/>
+          <p:cNvPr id="23" name="a4_60"/>
           <p:cNvSpPr/>
           <p:nvPr/>
         </p:nvSpPr>
@@ -20720,7 +20922,7 @@
       </p:sp>
       <p:pic>
         <p:nvPicPr>
-          <p:cNvPr id="24" name="a4_59" descr="preencoded.png">    </p:cNvPr>
+          <p:cNvPr id="24" name="a4_61" descr="preencoded.png">    </p:cNvPr>
           <p:cNvPicPr>
             <a:picLocks noChangeAspect="1"/>
           </p:cNvPicPr>
@@ -20744,7 +20946,7 @@
       </p:pic>
       <p:sp>
         <p:nvSpPr>
-          <p:cNvPr id="25" name="a4_60"/>
+          <p:cNvPr id="25" name="a4_62"/>
           <p:cNvSpPr txBox="1"/>
           <p:nvPr/>
         </p:nvSpPr>
@@ -20780,7 +20982,7 @@
       </p:sp>
       <p:sp>
         <p:nvSpPr>
-          <p:cNvPr id="26" name="a4_61"/>
+          <p:cNvPr id="26" name="a4_63"/>
           <p:cNvSpPr/>
           <p:nvPr/>
         </p:nvSpPr>
@@ -20814,7 +21016,7 @@
       </p:sp>
       <p:pic>
         <p:nvPicPr>
-          <p:cNvPr id="27" name="a4_62" descr="preencoded.png">    </p:cNvPr>
+          <p:cNvPr id="27" name="a4_64" descr="preencoded.png">    </p:cNvPr>
           <p:cNvPicPr>
             <a:picLocks noChangeAspect="1"/>
           </p:cNvPicPr>
@@ -20838,7 +21040,7 @@
       </p:pic>
       <p:sp>
         <p:nvSpPr>
-          <p:cNvPr id="28" name="a4_63"/>
+          <p:cNvPr id="28" name="a4_65"/>
           <p:cNvSpPr txBox="1"/>
           <p:nvPr/>
         </p:nvSpPr>
@@ -20874,7 +21076,7 @@
       </p:sp>
       <p:sp>
         <p:nvSpPr>
-          <p:cNvPr id="29" name="a5_64"/>
+          <p:cNvPr id="29" name="a5_66"/>
           <p:cNvSpPr txBox="1"/>
           <p:nvPr/>
         </p:nvSpPr>
@@ -20910,7 +21112,7 @@
       </p:sp>
       <p:sp>
         <p:nvSpPr>
-          <p:cNvPr id="30" name="a5_65"/>
+          <p:cNvPr id="30" name="a5_67"/>
           <p:cNvSpPr/>
           <p:nvPr/>
         </p:nvSpPr>
@@ -20937,7 +21139,7 @@
       </p:sp>
       <p:pic>
         <p:nvPicPr>
-          <p:cNvPr id="31" name="a5_66" descr="preencoded.png">    </p:cNvPr>
+          <p:cNvPr id="31" name="a5_68" descr="preencoded.png">    </p:cNvPr>
           <p:cNvPicPr>
             <a:picLocks noChangeAspect="1"/>
           </p:cNvPicPr>
@@ -20961,7 +21163,7 @@
       </p:pic>
       <p:sp>
         <p:nvSpPr>
-          <p:cNvPr id="32" name="a5_67"/>
+          <p:cNvPr id="32" name="a5_69"/>
           <p:cNvSpPr txBox="1"/>
           <p:nvPr/>
         </p:nvSpPr>
@@ -20997,7 +21199,7 @@
       </p:sp>
       <p:sp>
         <p:nvSpPr>
-          <p:cNvPr id="33" name="a5_68"/>
+          <p:cNvPr id="33" name="a5_70"/>
           <p:cNvSpPr/>
           <p:nvPr/>
         </p:nvSpPr>
@@ -21031,7 +21233,7 @@
       </p:sp>
       <p:pic>
         <p:nvPicPr>
-          <p:cNvPr id="34" name="a5_69" descr="preencoded.png">    </p:cNvPr>
+          <p:cNvPr id="34" name="a5_71" descr="preencoded.png">    </p:cNvPr>
           <p:cNvPicPr>
             <a:picLocks noChangeAspect="1"/>
           </p:cNvPicPr>
@@ -21055,7 +21257,7 @@
       </p:pic>
       <p:sp>
         <p:nvSpPr>
-          <p:cNvPr id="35" name="a5_70"/>
+          <p:cNvPr id="35" name="a5_72"/>
           <p:cNvSpPr txBox="1"/>
           <p:nvPr/>
         </p:nvSpPr>
@@ -21091,7 +21293,7 @@
       </p:sp>
       <p:sp>
         <p:nvSpPr>
-          <p:cNvPr id="36" name="a6_71"/>
+          <p:cNvPr id="36" name="a6_73"/>
           <p:cNvSpPr txBox="1"/>
           <p:nvPr/>
         </p:nvSpPr>
@@ -21127,7 +21329,7 @@
       </p:sp>
       <p:sp>
         <p:nvSpPr>
-          <p:cNvPr id="37" name="a6_72"/>
+          <p:cNvPr id="37" name="a6_74"/>
           <p:cNvSpPr/>
           <p:nvPr/>
         </p:nvSpPr>
@@ -21154,7 +21356,7 @@
       </p:sp>
       <p:pic>
         <p:nvPicPr>
-          <p:cNvPr id="38" name="a6_73" descr="preencoded.png">    </p:cNvPr>
+          <p:cNvPr id="38" name="a6_75" descr="preencoded.png">    </p:cNvPr>
           <p:cNvPicPr>
             <a:picLocks noChangeAspect="1"/>
           </p:cNvPicPr>
@@ -21178,7 +21380,7 @@
       </p:pic>
       <p:sp>
         <p:nvSpPr>
-          <p:cNvPr id="39" name="a6_74"/>
+          <p:cNvPr id="39" name="a6_76"/>
           <p:cNvSpPr txBox="1"/>
           <p:nvPr/>
         </p:nvSpPr>
@@ -21214,7 +21416,7 @@
       </p:sp>
       <p:sp>
         <p:nvSpPr>
-          <p:cNvPr id="40" name="a6_75"/>
+          <p:cNvPr id="40" name="a6_77"/>
           <p:cNvSpPr/>
           <p:nvPr/>
         </p:nvSpPr>
@@ -21248,7 +21450,7 @@
       </p:sp>
       <p:pic>
         <p:nvPicPr>
-          <p:cNvPr id="41" name="a6_76" descr="preencoded.png">    </p:cNvPr>
+          <p:cNvPr id="41" name="a6_78" descr="preencoded.png">    </p:cNvPr>
           <p:cNvPicPr>
             <a:picLocks noChangeAspect="1"/>
           </p:cNvPicPr>
@@ -21272,7 +21474,7 @@
       </p:pic>
       <p:sp>
         <p:nvSpPr>
-          <p:cNvPr id="42" name="a6_77"/>
+          <p:cNvPr id="42" name="a6_79"/>
           <p:cNvSpPr txBox="1"/>
           <p:nvPr/>
         </p:nvSpPr>
@@ -23772,7 +23974,7 @@
       </p:sp>
       <p:sp>
         <p:nvSpPr>
-          <p:cNvPr id="4" name="a1_78"/>
+          <p:cNvPr id="4" name="a1_80"/>
           <p:cNvSpPr/>
           <p:nvPr/>
         </p:nvSpPr>
@@ -23797,7 +23999,7 @@
       </p:sp>
       <p:pic>
         <p:nvPicPr>
-          <p:cNvPr id="5" name="a1_79" descr="preencoded.png">    </p:cNvPr>
+          <p:cNvPr id="5" name="a1_81" descr="preencoded.png">    </p:cNvPr>
           <p:cNvPicPr>
             <a:picLocks noChangeAspect="1"/>
           </p:cNvPicPr>
@@ -23821,7 +24023,7 @@
       </p:pic>
       <p:sp>
         <p:nvSpPr>
-          <p:cNvPr id="6" name="a1_80"/>
+          <p:cNvPr id="6" name="a1_82"/>
           <p:cNvSpPr txBox="1"/>
           <p:nvPr/>
         </p:nvSpPr>
@@ -23857,7 +24059,7 @@
       </p:sp>
       <p:sp>
         <p:nvSpPr>
-          <p:cNvPr id="7" name="a1_81"/>
+          <p:cNvPr id="7" name="a1_83"/>
           <p:cNvSpPr txBox="1"/>
           <p:nvPr/>
         </p:nvSpPr>
@@ -23893,7 +24095,7 @@
       </p:sp>
       <p:sp>
         <p:nvSpPr>
-          <p:cNvPr id="8" name="a2_82"/>
+          <p:cNvPr id="8" name="a2_84"/>
           <p:cNvSpPr/>
           <p:nvPr/>
         </p:nvSpPr>
@@ -23916,7 +24118,7 @@
       </p:sp>
       <p:sp>
         <p:nvSpPr>
-          <p:cNvPr id="9" name="a2_83"/>
+          <p:cNvPr id="9" name="a2_85"/>
           <p:cNvSpPr/>
           <p:nvPr/>
         </p:nvSpPr>
@@ -23941,7 +24143,7 @@
       </p:sp>
       <p:pic>
         <p:nvPicPr>
-          <p:cNvPr id="10" name="a2_84" descr="preencoded.png">    </p:cNvPr>
+          <p:cNvPr id="10" name="a2_86" descr="preencoded.png">    </p:cNvPr>
           <p:cNvPicPr>
             <a:picLocks noChangeAspect="1"/>
           </p:cNvPicPr>
@@ -23965,7 +24167,7 @@
       </p:pic>
       <p:sp>
         <p:nvSpPr>
-          <p:cNvPr id="11" name="a2_85"/>
+          <p:cNvPr id="11" name="a2_87"/>
           <p:cNvSpPr txBox="1"/>
           <p:nvPr/>
         </p:nvSpPr>
@@ -24001,7 +24203,7 @@
       </p:sp>
       <p:pic>
         <p:nvPicPr>
-          <p:cNvPr id="12" name="a3_86" descr="preencoded.png">    </p:cNvPr>
+          <p:cNvPr id="12" name="a3_88" descr="preencoded.png">    </p:cNvPr>
           <p:cNvPicPr>
             <a:picLocks noChangeAspect="1"/>
           </p:cNvPicPr>
@@ -24025,7 +24227,7 @@
       </p:pic>
       <p:sp>
         <p:nvSpPr>
-          <p:cNvPr id="13" name="a3_87"/>
+          <p:cNvPr id="13" name="a3_89"/>
           <p:cNvSpPr txBox="1"/>
           <p:nvPr/>
         </p:nvSpPr>
@@ -24061,7 +24263,7 @@
       </p:sp>
       <p:sp>
         <p:nvSpPr>
-          <p:cNvPr id="14" name="a4_88"/>
+          <p:cNvPr id="14" name="a4_90"/>
           <p:cNvSpPr/>
           <p:nvPr/>
         </p:nvSpPr>
@@ -24085,7 +24287,7 @@
       </p:sp>
       <p:sp>
         <p:nvSpPr>
-          <p:cNvPr id="15" name="a4_89"/>
+          <p:cNvPr id="15" name="a4_91"/>
           <p:cNvSpPr/>
           <p:nvPr/>
         </p:nvSpPr>
@@ -24112,7 +24314,7 @@
       </p:sp>
       <p:pic>
         <p:nvPicPr>
-          <p:cNvPr id="16" name="a4_90" descr="preencoded.png">    </p:cNvPr>
+          <p:cNvPr id="16" name="a4_92" descr="preencoded.png">    </p:cNvPr>
           <p:cNvPicPr>
             <a:picLocks noChangeAspect="1"/>
           </p:cNvPicPr>
@@ -24136,7 +24338,7 @@
       </p:pic>
       <p:sp>
         <p:nvSpPr>
-          <p:cNvPr id="17" name="a4_91"/>
+          <p:cNvPr id="17" name="a4_93"/>
           <p:cNvSpPr/>
           <p:nvPr/>
         </p:nvSpPr>
@@ -24163,7 +24365,7 @@
       </p:sp>
       <p:pic>
         <p:nvPicPr>
-          <p:cNvPr id="18" name="a4_92" descr="preencoded.png">    </p:cNvPr>
+          <p:cNvPr id="18" name="a4_94" descr="preencoded.png">    </p:cNvPr>
           <p:cNvPicPr>
             <a:picLocks noChangeAspect="1"/>
           </p:cNvPicPr>
@@ -24187,7 +24389,7 @@
       </p:pic>
       <p:sp>
         <p:nvSpPr>
-          <p:cNvPr id="19" name="a4_93"/>
+          <p:cNvPr id="19" name="a4_95"/>
           <p:cNvSpPr/>
           <p:nvPr/>
         </p:nvSpPr>
@@ -24214,7 +24416,7 @@
       </p:sp>
       <p:pic>
         <p:nvPicPr>
-          <p:cNvPr id="20" name="a4_94" descr="preencoded.png">    </p:cNvPr>
+          <p:cNvPr id="20" name="a4_96" descr="preencoded.png">    </p:cNvPr>
           <p:cNvPicPr>
             <a:picLocks noChangeAspect="1"/>
           </p:cNvPicPr>
@@ -24238,7 +24440,7 @@
       </p:pic>
       <p:sp>
         <p:nvSpPr>
-          <p:cNvPr id="21" name="a4_95"/>
+          <p:cNvPr id="21" name="a4_97"/>
           <p:cNvSpPr/>
           <p:nvPr/>
         </p:nvSpPr>
@@ -24265,7 +24467,7 @@
       </p:sp>
       <p:pic>
         <p:nvPicPr>
-          <p:cNvPr id="22" name="a4_96" descr="preencoded.png">    </p:cNvPr>
+          <p:cNvPr id="22" name="a4_98" descr="preencoded.png">    </p:cNvPr>
           <p:cNvPicPr>
             <a:picLocks noChangeAspect="1"/>
           </p:cNvPicPr>
@@ -24289,7 +24491,7 @@
       </p:pic>
       <p:sp>
         <p:nvSpPr>
-          <p:cNvPr id="23" name="a4_97"/>
+          <p:cNvPr id="23" name="a4_99"/>
           <p:cNvSpPr/>
           <p:nvPr/>
         </p:nvSpPr>
@@ -24316,7 +24518,7 @@
       </p:sp>
       <p:pic>
         <p:nvPicPr>
-          <p:cNvPr id="24" name="a4_98" descr="preencoded.png">    </p:cNvPr>
+          <p:cNvPr id="24" name="a4_100" descr="preencoded.png">    </p:cNvPr>
           <p:cNvPicPr>
             <a:picLocks noChangeAspect="1"/>
           </p:cNvPicPr>
@@ -24340,7 +24542,7 @@
       </p:pic>
       <p:sp>
         <p:nvSpPr>
-          <p:cNvPr id="25" name="a4_99"/>
+          <p:cNvPr id="25" name="a4_101"/>
           <p:cNvSpPr/>
           <p:nvPr/>
         </p:nvSpPr>
@@ -24367,7 +24569,7 @@
       </p:sp>
       <p:pic>
         <p:nvPicPr>
-          <p:cNvPr id="26" name="a4_100" descr="preencoded.png">    </p:cNvPr>
+          <p:cNvPr id="26" name="a4_102" descr="preencoded.png">    </p:cNvPr>
           <p:cNvPicPr>
             <a:picLocks noChangeAspect="1"/>
           </p:cNvPicPr>
@@ -24391,7 +24593,7 @@
       </p:pic>
       <p:sp>
         <p:nvSpPr>
-          <p:cNvPr id="27" name="a4_101"/>
+          <p:cNvPr id="27" name="a4_103"/>
           <p:cNvSpPr/>
           <p:nvPr/>
         </p:nvSpPr>
@@ -24418,7 +24620,7 @@
       </p:sp>
       <p:pic>
         <p:nvPicPr>
-          <p:cNvPr id="28" name="a4_102" descr="preencoded.png">    </p:cNvPr>
+          <p:cNvPr id="28" name="a4_104" descr="preencoded.png">    </p:cNvPr>
           <p:cNvPicPr>
             <a:picLocks noChangeAspect="1"/>
           </p:cNvPicPr>
@@ -24442,7 +24644,7 @@
       </p:pic>
       <p:sp>
         <p:nvSpPr>
-          <p:cNvPr id="29" name="a4_103"/>
+          <p:cNvPr id="29" name="a4_105"/>
           <p:cNvSpPr/>
           <p:nvPr/>
         </p:nvSpPr>
@@ -24469,7 +24671,7 @@
       </p:sp>
       <p:pic>
         <p:nvPicPr>
-          <p:cNvPr id="30" name="a4_104" descr="preencoded.png">    </p:cNvPr>
+          <p:cNvPr id="30" name="a4_106" descr="preencoded.png">    </p:cNvPr>
           <p:cNvPicPr>
             <a:picLocks noChangeAspect="1"/>
           </p:cNvPicPr>
@@ -24493,7 +24695,7 @@
       </p:pic>
       <p:sp>
         <p:nvSpPr>
-          <p:cNvPr id="31" name="a4_105"/>
+          <p:cNvPr id="31" name="a4_107"/>
           <p:cNvSpPr/>
           <p:nvPr/>
         </p:nvSpPr>
@@ -24520,7 +24722,7 @@
       </p:sp>
       <p:pic>
         <p:nvPicPr>
-          <p:cNvPr id="32" name="a4_106" descr="preencoded.png">    </p:cNvPr>
+          <p:cNvPr id="32" name="a4_108" descr="preencoded.png">    </p:cNvPr>
           <p:cNvPicPr>
             <a:picLocks noChangeAspect="1"/>
           </p:cNvPicPr>
@@ -24544,7 +24746,7 @@
       </p:pic>
       <p:sp>
         <p:nvSpPr>
-          <p:cNvPr id="33" name="a4_107"/>
+          <p:cNvPr id="33" name="a4_109"/>
           <p:cNvSpPr/>
           <p:nvPr/>
         </p:nvSpPr>
@@ -24571,7 +24773,7 @@
       </p:sp>
       <p:pic>
         <p:nvPicPr>
-          <p:cNvPr id="34" name="a4_108" descr="preencoded.png">    </p:cNvPr>
+          <p:cNvPr id="34" name="a4_110" descr="preencoded.png">    </p:cNvPr>
           <p:cNvPicPr>
             <a:picLocks noChangeAspect="1"/>
           </p:cNvPicPr>
@@ -24595,7 +24797,7 @@
       </p:pic>
       <p:sp>
         <p:nvSpPr>
-          <p:cNvPr id="35" name="a4_109"/>
+          <p:cNvPr id="35" name="a4_111"/>
           <p:cNvSpPr/>
           <p:nvPr/>
         </p:nvSpPr>
@@ -24622,7 +24824,7 @@
       </p:sp>
       <p:pic>
         <p:nvPicPr>
-          <p:cNvPr id="36" name="a4_110" descr="preencoded.png">    </p:cNvPr>
+          <p:cNvPr id="36" name="a4_112" descr="preencoded.png">    </p:cNvPr>
           <p:cNvPicPr>
             <a:picLocks noChangeAspect="1"/>
           </p:cNvPicPr>
@@ -24646,7 +24848,7 @@
       </p:pic>
       <p:sp>
         <p:nvSpPr>
-          <p:cNvPr id="37" name="a4_111"/>
+          <p:cNvPr id="37" name="a4_113"/>
           <p:cNvSpPr/>
           <p:nvPr/>
         </p:nvSpPr>
@@ -24673,7 +24875,7 @@
       </p:sp>
       <p:pic>
         <p:nvPicPr>
-          <p:cNvPr id="38" name="a4_112" descr="preencoded.png">    </p:cNvPr>
+          <p:cNvPr id="38" name="a4_114" descr="preencoded.png">    </p:cNvPr>
           <p:cNvPicPr>
             <a:picLocks noChangeAspect="1"/>
           </p:cNvPicPr>
@@ -24697,7 +24899,7 @@
       </p:pic>
       <p:sp>
         <p:nvSpPr>
-          <p:cNvPr id="39" name="a4_113"/>
+          <p:cNvPr id="39" name="a4_115"/>
           <p:cNvSpPr/>
           <p:nvPr/>
         </p:nvSpPr>
@@ -24724,7 +24926,7 @@
       </p:sp>
       <p:pic>
         <p:nvPicPr>
-          <p:cNvPr id="40" name="a4_114" descr="preencoded.png">    </p:cNvPr>
+          <p:cNvPr id="40" name="a4_116" descr="preencoded.png">    </p:cNvPr>
           <p:cNvPicPr>
             <a:picLocks noChangeAspect="1"/>
           </p:cNvPicPr>
@@ -24748,7 +24950,7 @@
       </p:pic>
       <p:sp>
         <p:nvSpPr>
-          <p:cNvPr id="41" name="a4_115"/>
+          <p:cNvPr id="41" name="a4_117"/>
           <p:cNvSpPr/>
           <p:nvPr/>
         </p:nvSpPr>
@@ -24775,7 +24977,7 @@
       </p:sp>
       <p:pic>
         <p:nvPicPr>
-          <p:cNvPr id="42" name="a4_116" descr="preencoded.png">    </p:cNvPr>
+          <p:cNvPr id="42" name="a4_118" descr="preencoded.png">    </p:cNvPr>
           <p:cNvPicPr>
             <a:picLocks noChangeAspect="1"/>
           </p:cNvPicPr>
@@ -24799,7 +25001,7 @@
       </p:pic>
       <p:sp>
         <p:nvSpPr>
-          <p:cNvPr id="43" name="a4_117"/>
+          <p:cNvPr id="43" name="a4_119"/>
           <p:cNvSpPr/>
           <p:nvPr/>
         </p:nvSpPr>
@@ -24826,7 +25028,7 @@
       </p:sp>
       <p:pic>
         <p:nvPicPr>
-          <p:cNvPr id="44" name="a4_118" descr="preencoded.png">    </p:cNvPr>
+          <p:cNvPr id="44" name="a4_120" descr="preencoded.png">    </p:cNvPr>
           <p:cNvPicPr>
             <a:picLocks noChangeAspect="1"/>
           </p:cNvPicPr>
@@ -24850,7 +25052,7 @@
       </p:pic>
       <p:sp>
         <p:nvSpPr>
-          <p:cNvPr id="45" name="a4_119"/>
+          <p:cNvPr id="45" name="a4_121"/>
           <p:cNvSpPr txBox="1"/>
           <p:nvPr/>
         </p:nvSpPr>
@@ -24886,7 +25088,7 @@
       </p:sp>
       <p:sp>
         <p:nvSpPr>
-          <p:cNvPr id="46" name="a5_120"/>
+          <p:cNvPr id="46" name="a5_122"/>
           <p:cNvSpPr/>
           <p:nvPr/>
         </p:nvSpPr>
@@ -24920,7 +25122,7 @@
       </p:sp>
       <p:sp>
         <p:nvSpPr>
-          <p:cNvPr id="47" name="a5_121"/>
+          <p:cNvPr id="47" name="a5_123"/>
           <p:cNvSpPr txBox="1"/>
           <p:nvPr/>
         </p:nvSpPr>
@@ -24956,7 +25158,7 @@
       </p:sp>
       <p:sp>
         <p:nvSpPr>
-          <p:cNvPr id="48" name="a5_122"/>
+          <p:cNvPr id="48" name="a5_124"/>
           <p:cNvSpPr txBox="1"/>
           <p:nvPr/>
         </p:nvSpPr>
@@ -24992,7 +25194,7 @@
       </p:sp>
       <p:sp>
         <p:nvSpPr>
-          <p:cNvPr id="49" name="a5_123"/>
+          <p:cNvPr id="49" name="a5_125"/>
           <p:cNvSpPr/>
           <p:nvPr/>
         </p:nvSpPr>
@@ -25026,7 +25228,7 @@
       </p:sp>
       <p:sp>
         <p:nvSpPr>
-          <p:cNvPr id="50" name="a5_124"/>
+          <p:cNvPr id="50" name="a5_126"/>
           <p:cNvSpPr txBox="1"/>
           <p:nvPr/>
         </p:nvSpPr>
@@ -25062,7 +25264,7 @@
       </p:sp>
       <p:sp>
         <p:nvSpPr>
-          <p:cNvPr id="51" name="a5_125"/>
+          <p:cNvPr id="51" name="a5_127"/>
           <p:cNvSpPr txBox="1"/>
           <p:nvPr/>
         </p:nvSpPr>
@@ -25098,7 +25300,7 @@
       </p:sp>
       <p:sp>
         <p:nvSpPr>
-          <p:cNvPr id="52" name="a5_126"/>
+          <p:cNvPr id="52" name="a5_128"/>
           <p:cNvSpPr/>
           <p:nvPr/>
         </p:nvSpPr>
@@ -25132,7 +25334,7 @@
       </p:sp>
       <p:sp>
         <p:nvSpPr>
-          <p:cNvPr id="53" name="a5_127"/>
+          <p:cNvPr id="53" name="a5_129"/>
           <p:cNvSpPr txBox="1"/>
           <p:nvPr/>
         </p:nvSpPr>
@@ -25168,7 +25370,7 @@
       </p:sp>
       <p:sp>
         <p:nvSpPr>
-          <p:cNvPr id="54" name="a5_128"/>
+          <p:cNvPr id="54" name="a5_130"/>
           <p:cNvSpPr txBox="1"/>
           <p:nvPr/>
         </p:nvSpPr>
@@ -28375,7 +28577,7 @@
       </p:sp>
       <p:sp>
         <p:nvSpPr>
-          <p:cNvPr id="4" name="a1_129"/>
+          <p:cNvPr id="4" name="a1_131"/>
           <p:cNvSpPr/>
           <p:nvPr/>
         </p:nvSpPr>
@@ -28400,7 +28602,7 @@
       </p:sp>
       <p:pic>
         <p:nvPicPr>
-          <p:cNvPr id="5" name="a1_130" descr="preencoded.png">    </p:cNvPr>
+          <p:cNvPr id="5" name="a1_132" descr="preencoded.png">    </p:cNvPr>
           <p:cNvPicPr>
             <a:picLocks noChangeAspect="1"/>
           </p:cNvPicPr>
@@ -28424,7 +28626,7 @@
       </p:pic>
       <p:sp>
         <p:nvSpPr>
-          <p:cNvPr id="6" name="a2_131"/>
+          <p:cNvPr id="6" name="a2_133"/>
           <p:cNvSpPr/>
           <p:nvPr/>
         </p:nvSpPr>
@@ -28449,7 +28651,7 @@
       </p:sp>
       <p:pic>
         <p:nvPicPr>
-          <p:cNvPr id="7" name="a2_132" descr="preencoded.png">    </p:cNvPr>
+          <p:cNvPr id="7" name="a2_134" descr="preencoded.png">    </p:cNvPr>
           <p:cNvPicPr>
             <a:picLocks noChangeAspect="1"/>
           </p:cNvPicPr>
@@ -28473,7 +28675,7 @@
       </p:pic>
       <p:sp>
         <p:nvSpPr>
-          <p:cNvPr id="8" name="a2_133"/>
+          <p:cNvPr id="8" name="a2_135"/>
           <p:cNvSpPr txBox="1"/>
           <p:nvPr/>
         </p:nvSpPr>
@@ -28509,7 +28711,7 @@
       </p:sp>
       <p:sp>
         <p:nvSpPr>
-          <p:cNvPr id="9" name="a2_134"/>
+          <p:cNvPr id="9" name="a2_136"/>
           <p:cNvSpPr txBox="1"/>
           <p:nvPr/>
         </p:nvSpPr>
@@ -28545,7 +28747,7 @@
       </p:sp>
       <p:sp>
         <p:nvSpPr>
-          <p:cNvPr id="10" name="a3_135"/>
+          <p:cNvPr id="10" name="a3_137"/>
           <p:cNvSpPr/>
           <p:nvPr/>
         </p:nvSpPr>
@@ -28570,7 +28772,7 @@
       </p:sp>
       <p:pic>
         <p:nvPicPr>
-          <p:cNvPr id="11" name="a3_136" descr="preencoded.png">    </p:cNvPr>
+          <p:cNvPr id="11" name="a3_138" descr="preencoded.png">    </p:cNvPr>
           <p:cNvPicPr>
             <a:picLocks noChangeAspect="1"/>
           </p:cNvPicPr>
@@ -28594,7 +28796,7 @@
       </p:pic>
       <p:sp>
         <p:nvSpPr>
-          <p:cNvPr id="12" name="a3_137"/>
+          <p:cNvPr id="12" name="a3_139"/>
           <p:cNvSpPr txBox="1"/>
           <p:nvPr/>
         </p:nvSpPr>
@@ -28630,7 +28832,7 @@
       </p:sp>
       <p:sp>
         <p:nvSpPr>
-          <p:cNvPr id="13" name="a3_138"/>
+          <p:cNvPr id="13" name="a3_140"/>
           <p:cNvSpPr txBox="1"/>
           <p:nvPr/>
         </p:nvSpPr>
@@ -28666,7 +28868,7 @@
       </p:sp>
       <p:sp>
         <p:nvSpPr>
-          <p:cNvPr id="14" name="a4_139"/>
+          <p:cNvPr id="14" name="a4_141"/>
           <p:cNvSpPr/>
           <p:nvPr/>
         </p:nvSpPr>
@@ -28691,7 +28893,7 @@
       </p:sp>
       <p:pic>
         <p:nvPicPr>
-          <p:cNvPr id="15" name="a4_140" descr="preencoded.png">    </p:cNvPr>
+          <p:cNvPr id="15" name="a4_142" descr="preencoded.png">    </p:cNvPr>
           <p:cNvPicPr>
             <a:picLocks noChangeAspect="1"/>
           </p:cNvPicPr>
@@ -28715,7 +28917,7 @@
       </p:pic>
       <p:sp>
         <p:nvSpPr>
-          <p:cNvPr id="16" name="a4_141"/>
+          <p:cNvPr id="16" name="a4_143"/>
           <p:cNvSpPr txBox="1"/>
           <p:nvPr/>
         </p:nvSpPr>
@@ -28751,7 +28953,7 @@
       </p:sp>
       <p:sp>
         <p:nvSpPr>
-          <p:cNvPr id="17" name="a4_142"/>
+          <p:cNvPr id="17" name="a4_144"/>
           <p:cNvSpPr txBox="1"/>
           <p:nvPr/>
         </p:nvSpPr>
@@ -29801,7 +30003,7 @@
       </p:sp>
       <p:sp>
         <p:nvSpPr>
-          <p:cNvPr id="4" name="a1_143"/>
+          <p:cNvPr id="4" name="a1_145"/>
           <p:cNvSpPr/>
           <p:nvPr/>
         </p:nvSpPr>
@@ -29824,7 +30026,7 @@
       </p:sp>
       <p:sp>
         <p:nvSpPr>
-          <p:cNvPr id="5" name="a2_144"/>
+          <p:cNvPr id="5" name="a2_146"/>
           <p:cNvSpPr/>
           <p:nvPr/>
         </p:nvSpPr>
@@ -29849,7 +30051,7 @@
       </p:sp>
       <p:pic>
         <p:nvPicPr>
-          <p:cNvPr id="6" name="a2_145" descr="preencoded.png">    </p:cNvPr>
+          <p:cNvPr id="6" name="a2_147" descr="preencoded.png">    </p:cNvPr>
           <p:cNvPicPr>
             <a:picLocks noChangeAspect="1"/>
           </p:cNvPicPr>
@@ -29873,7 +30075,7 @@
       </p:pic>
       <p:sp>
         <p:nvSpPr>
-          <p:cNvPr id="7" name="a2_146"/>
+          <p:cNvPr id="7" name="a2_148"/>
           <p:cNvSpPr/>
           <p:nvPr/>
         </p:nvSpPr>
@@ -29907,7 +30109,7 @@
       </p:sp>
       <p:sp>
         <p:nvSpPr>
-          <p:cNvPr id="8" name="a2_147"/>
+          <p:cNvPr id="8" name="a2_149"/>
           <p:cNvSpPr txBox="1"/>
           <p:nvPr/>
         </p:nvSpPr>
@@ -29943,7 +30145,7 @@
       </p:sp>
       <p:sp>
         <p:nvSpPr>
-          <p:cNvPr id="9" name="a2_148"/>
+          <p:cNvPr id="9" name="a2_150"/>
           <p:cNvSpPr txBox="1"/>
           <p:nvPr/>
         </p:nvSpPr>
@@ -29979,7 +30181,7 @@
       </p:sp>
       <p:sp>
         <p:nvSpPr>
-          <p:cNvPr id="10" name="a2_149"/>
+          <p:cNvPr id="10" name="a2_151"/>
           <p:cNvSpPr txBox="1"/>
           <p:nvPr/>
         </p:nvSpPr>
@@ -30015,7 +30217,7 @@
       </p:sp>
       <p:sp>
         <p:nvSpPr>
-          <p:cNvPr id="11" name="a3_150"/>
+          <p:cNvPr id="11" name="a3_152"/>
           <p:cNvSpPr/>
           <p:nvPr/>
         </p:nvSpPr>
@@ -30040,7 +30242,7 @@
       </p:sp>
       <p:pic>
         <p:nvPicPr>
-          <p:cNvPr id="12" name="a3_151" descr="preencoded.png">    </p:cNvPr>
+          <p:cNvPr id="12" name="a3_153" descr="preencoded.png">    </p:cNvPr>
           <p:cNvPicPr>
             <a:picLocks noChangeAspect="1"/>
           </p:cNvPicPr>
@@ -30064,7 +30266,7 @@
       </p:pic>
       <p:sp>
         <p:nvSpPr>
-          <p:cNvPr id="13" name="a3_152"/>
+          <p:cNvPr id="13" name="a3_154"/>
           <p:cNvSpPr/>
           <p:nvPr/>
         </p:nvSpPr>
@@ -30098,7 +30300,7 @@
       </p:sp>
       <p:sp>
         <p:nvSpPr>
-          <p:cNvPr id="14" name="a3_153"/>
+          <p:cNvPr id="14" name="a3_155"/>
           <p:cNvSpPr txBox="1"/>
           <p:nvPr/>
         </p:nvSpPr>
@@ -30134,7 +30336,7 @@
       </p:sp>
       <p:sp>
         <p:nvSpPr>
-          <p:cNvPr id="15" name="a3_154"/>
+          <p:cNvPr id="15" name="a3_156"/>
           <p:cNvSpPr txBox="1"/>
           <p:nvPr/>
         </p:nvSpPr>
@@ -30170,7 +30372,7 @@
       </p:sp>
       <p:sp>
         <p:nvSpPr>
-          <p:cNvPr id="16" name="a3_155"/>
+          <p:cNvPr id="16" name="a3_157"/>
           <p:cNvSpPr txBox="1"/>
           <p:nvPr/>
         </p:nvSpPr>
@@ -30206,7 +30408,7 @@
       </p:sp>
       <p:sp>
         <p:nvSpPr>
-          <p:cNvPr id="17" name="a4_156"/>
+          <p:cNvPr id="17" name="a4_158"/>
           <p:cNvSpPr/>
           <p:nvPr/>
         </p:nvSpPr>
@@ -30231,7 +30433,7 @@
       </p:sp>
       <p:pic>
         <p:nvPicPr>
-          <p:cNvPr id="18" name="a4_157" descr="preencoded.png">    </p:cNvPr>
+          <p:cNvPr id="18" name="a4_159" descr="preencoded.png">    </p:cNvPr>
           <p:cNvPicPr>
             <a:picLocks noChangeAspect="1"/>
           </p:cNvPicPr>
@@ -30255,7 +30457,7 @@
       </p:pic>
       <p:sp>
         <p:nvSpPr>
-          <p:cNvPr id="19" name="a4_158"/>
+          <p:cNvPr id="19" name="a4_160"/>
           <p:cNvSpPr/>
           <p:nvPr/>
         </p:nvSpPr>
@@ -30289,7 +30491,7 @@
       </p:sp>
       <p:sp>
         <p:nvSpPr>
-          <p:cNvPr id="20" name="a4_159"/>
+          <p:cNvPr id="20" name="a4_161"/>
           <p:cNvSpPr txBox="1"/>
           <p:nvPr/>
         </p:nvSpPr>
@@ -30325,7 +30527,7 @@
       </p:sp>
       <p:sp>
         <p:nvSpPr>
-          <p:cNvPr id="21" name="a4_160"/>
+          <p:cNvPr id="21" name="a4_162"/>
           <p:cNvSpPr txBox="1"/>
           <p:nvPr/>
         </p:nvSpPr>
@@ -30361,7 +30563,7 @@
       </p:sp>
       <p:sp>
         <p:nvSpPr>
-          <p:cNvPr id="22" name="a4_161"/>
+          <p:cNvPr id="22" name="a4_163"/>
           <p:cNvSpPr txBox="1"/>
           <p:nvPr/>
         </p:nvSpPr>
@@ -30397,7 +30599,7 @@
       </p:sp>
       <p:sp>
         <p:nvSpPr>
-          <p:cNvPr id="23" name="a5_162"/>
+          <p:cNvPr id="23" name="a5_164"/>
           <p:cNvSpPr/>
           <p:nvPr/>
         </p:nvSpPr>
@@ -30422,7 +30624,7 @@
       </p:sp>
       <p:pic>
         <p:nvPicPr>
-          <p:cNvPr id="24" name="a5_163" descr="preencoded.png">    </p:cNvPr>
+          <p:cNvPr id="24" name="a5_165" descr="preencoded.png">    </p:cNvPr>
           <p:cNvPicPr>
             <a:picLocks noChangeAspect="1"/>
           </p:cNvPicPr>
@@ -30446,7 +30648,7 @@
       </p:pic>
       <p:sp>
         <p:nvSpPr>
-          <p:cNvPr id="25" name="a5_164"/>
+          <p:cNvPr id="25" name="a5_166"/>
           <p:cNvSpPr/>
           <p:nvPr/>
         </p:nvSpPr>
@@ -30480,7 +30682,7 @@
       </p:sp>
       <p:sp>
         <p:nvSpPr>
-          <p:cNvPr id="26" name="a5_165"/>
+          <p:cNvPr id="26" name="a5_167"/>
           <p:cNvSpPr txBox="1"/>
           <p:nvPr/>
         </p:nvSpPr>
@@ -30516,7 +30718,7 @@
       </p:sp>
       <p:sp>
         <p:nvSpPr>
-          <p:cNvPr id="27" name="a5_166"/>
+          <p:cNvPr id="27" name="a5_168"/>
           <p:cNvSpPr txBox="1"/>
           <p:nvPr/>
         </p:nvSpPr>
@@ -30552,7 +30754,7 @@
       </p:sp>
       <p:sp>
         <p:nvSpPr>
-          <p:cNvPr id="28" name="a5_167"/>
+          <p:cNvPr id="28" name="a5_169"/>
           <p:cNvSpPr txBox="1"/>
           <p:nvPr/>
         </p:nvSpPr>
@@ -30588,7 +30790,7 @@
       </p:sp>
       <p:sp>
         <p:nvSpPr>
-          <p:cNvPr id="29" name="a6_168"/>
+          <p:cNvPr id="29" name="a6_170"/>
           <p:cNvSpPr/>
           <p:nvPr/>
         </p:nvSpPr>
@@ -30613,7 +30815,7 @@
       </p:sp>
       <p:pic>
         <p:nvPicPr>
-          <p:cNvPr id="30" name="a6_169" descr="preencoded.png">    </p:cNvPr>
+          <p:cNvPr id="30" name="a6_171" descr="preencoded.png">    </p:cNvPr>
           <p:cNvPicPr>
             <a:picLocks noChangeAspect="1"/>
           </p:cNvPicPr>
@@ -30637,7 +30839,7 @@
       </p:pic>
       <p:sp>
         <p:nvSpPr>
-          <p:cNvPr id="31" name="a6_170"/>
+          <p:cNvPr id="31" name="a6_172"/>
           <p:cNvSpPr/>
           <p:nvPr/>
         </p:nvSpPr>
@@ -30671,7 +30873,7 @@
       </p:sp>
       <p:sp>
         <p:nvSpPr>
-          <p:cNvPr id="32" name="a6_171"/>
+          <p:cNvPr id="32" name="a6_173"/>
           <p:cNvSpPr txBox="1"/>
           <p:nvPr/>
         </p:nvSpPr>
@@ -30707,7 +30909,7 @@
       </p:sp>
       <p:sp>
         <p:nvSpPr>
-          <p:cNvPr id="33" name="a6_172"/>
+          <p:cNvPr id="33" name="a6_174"/>
           <p:cNvSpPr txBox="1"/>
           <p:nvPr/>
         </p:nvSpPr>
@@ -30743,7 +30945,7 @@
       </p:sp>
       <p:sp>
         <p:nvSpPr>
-          <p:cNvPr id="34" name="a6_173"/>
+          <p:cNvPr id="34" name="a6_175"/>
           <p:cNvSpPr txBox="1"/>
           <p:nvPr/>
         </p:nvSpPr>
@@ -30779,7 +30981,7 @@
       </p:sp>
       <p:sp>
         <p:nvSpPr>
-          <p:cNvPr id="35" name="a7_174"/>
+          <p:cNvPr id="35" name="a7_176"/>
           <p:cNvSpPr/>
           <p:nvPr/>
         </p:nvSpPr>
@@ -30806,7 +31008,7 @@
       </p:sp>
       <p:sp>
         <p:nvSpPr>
-          <p:cNvPr id="36" name="a7_175"/>
+          <p:cNvPr id="36" name="a7_177"/>
           <p:cNvSpPr txBox="1"/>
           <p:nvPr/>
         </p:nvSpPr>
@@ -32958,7 +33160,7 @@
       </p:sp>
       <p:sp>
         <p:nvSpPr>
-          <p:cNvPr id="4" name="a1_176"/>
+          <p:cNvPr id="4" name="a1_178"/>
           <p:cNvSpPr txBox="1"/>
           <p:nvPr/>
         </p:nvSpPr>
@@ -33005,7 +33207,7 @@
       </p:sp>
       <p:sp>
         <p:nvSpPr>
-          <p:cNvPr id="5" name="a1_177"/>
+          <p:cNvPr id="5" name="a1_179"/>
           <p:cNvSpPr txBox="1"/>
           <p:nvPr/>
         </p:nvSpPr>
@@ -33041,7 +33243,7 @@
       </p:sp>
       <p:sp>
         <p:nvSpPr>
-          <p:cNvPr id="6" name="a2_178"/>
+          <p:cNvPr id="6" name="a2_180"/>
           <p:cNvSpPr/>
           <p:nvPr/>
         </p:nvSpPr>
@@ -33066,7 +33268,7 @@
       </p:sp>
       <p:sp>
         <p:nvSpPr>
-          <p:cNvPr id="7" name="a2_179"/>
+          <p:cNvPr id="7" name="a2_181"/>
           <p:cNvSpPr txBox="1"/>
           <p:nvPr/>
         </p:nvSpPr>
@@ -33116,7 +33318,7 @@
       </p:sp>
       <p:sp>
         <p:nvSpPr>
-          <p:cNvPr id="8" name="a3_180"/>
+          <p:cNvPr id="8" name="a3_182"/>
           <p:cNvSpPr/>
           <p:nvPr/>
         </p:nvSpPr>
@@ -33141,7 +33343,7 @@
       </p:sp>
       <p:sp>
         <p:nvSpPr>
-          <p:cNvPr id="9" name="a3_181"/>
+          <p:cNvPr id="9" name="a3_183"/>
           <p:cNvSpPr txBox="1"/>
           <p:nvPr/>
         </p:nvSpPr>
@@ -33191,7 +33393,7 @@
       </p:sp>
       <p:sp>
         <p:nvSpPr>
-          <p:cNvPr id="10" name="a4_182"/>
+          <p:cNvPr id="10" name="a4_184"/>
           <p:cNvSpPr/>
           <p:nvPr/>
         </p:nvSpPr>
@@ -33216,7 +33418,7 @@
       </p:sp>
       <p:sp>
         <p:nvSpPr>
-          <p:cNvPr id="11" name="a4_183"/>
+          <p:cNvPr id="11" name="a4_185"/>
           <p:cNvSpPr txBox="1"/>
           <p:nvPr/>
         </p:nvSpPr>
@@ -33266,7 +33468,7 @@
       </p:sp>
       <p:sp>
         <p:nvSpPr>
-          <p:cNvPr id="12" name="a5_184"/>
+          <p:cNvPr id="12" name="a5_186"/>
           <p:cNvSpPr/>
           <p:nvPr/>
         </p:nvSpPr>
@@ -33291,7 +33493,7 @@
       </p:sp>
       <p:sp>
         <p:nvSpPr>
-          <p:cNvPr id="13" name="a5_185"/>
+          <p:cNvPr id="13" name="a5_187"/>
           <p:cNvSpPr txBox="1"/>
           <p:nvPr/>
         </p:nvSpPr>

</xml_diff>

<commit_message>
Vocabulaire simplifié, notes orales en français facile et lexique
Co-Authored-By: Claude Opus 5.5 <noreply@anthropic.com>
Claude-Session: https://claude.ai/code/session_01FnPw3bDfKWoxE5ktD8jdcy
</commit_message>
<xml_diff>
--- a/proposition-serveur/Proposition_Serveur_Proxmox_WindowsServer.pptx
+++ b/proposition-serveur/Proposition_Serveur_Proxmox_WindowsServer.pptx
@@ -20,9 +20,10 @@
     <p:sldId id="268" r:id="rId14"/>
     <p:sldId id="269" r:id="rId15"/>
     <p:sldId id="270" r:id="rId16"/>
+    <p:sldId id="271" r:id="rId17"/>
   </p:sldIdLst>
   <p:notesMasterIdLst>
-    <p:notesMasterId r:id="rId17"/>
+    <p:notesMasterId r:id="rId18"/>
   </p:notesMasterIdLst>
   <p:sldSz cx="12192000" cy="6858000"/>
   <p:notesSz cx="6858000" cy="12192000"/>
@@ -121,18 +122,18 @@
   <p:extLst>
     <p:ext uri="{521415D9-36F7-43E2-AB2F-B90AF26B5E84}">
       <p14:sectionLst xmlns:p14="http://schemas.microsoft.com/office/powerpoint/2010/main">
-        <p14:section name="Ouverture" id="{c0411ba4-a59f-5c19-67eb-961194f77821}">
+        <p14:section name="Ouverture" id="{378fa788-620f-d113-e2f6-27b5c0aefe19}">
           <p14:sldIdLst>
             <p14:sldId id="256"/>
           </p14:sldIdLst>
         </p14:section>
-        <p14:section name="Le constat" id="{97f01592-b7d1-93a6-6f79-becaaa7f7dcd}">
+        <p14:section name="Le constat" id="{aab7c0ec-7080-9838-a30e-f1e952b5ad93}">
           <p14:sldIdLst>
             <p14:sldId id="257"/>
             <p14:sldId id="258"/>
           </p14:sldIdLst>
         </p14:section>
-        <p14:section name="La solution" id="{a48bca01-a9fb-3d39-a521-909f469f6027}">
+        <p14:section name="La solution" id="{ed561382-a84a-f0d1-a383-6ca209c1974d}">
           <p14:sldIdLst>
             <p14:sldId id="259"/>
             <p14:sldId id="260"/>
@@ -140,7 +141,7 @@
             <p14:sldId id="262"/>
           </p14:sldIdLst>
         </p14:section>
-        <p14:section name="Investissement" id="{80e088b1-997c-564b-866d-853c29f92ad7}">
+        <p14:section name="Investissement" id="{1ec9e9c8-3687-caa9-d9a1-edb5aae6dbcd}">
           <p14:sldIdLst>
             <p14:sldId id="263"/>
             <p14:sldId id="264"/>
@@ -148,16 +149,21 @@
             <p14:sldId id="266"/>
           </p14:sldIdLst>
         </p14:section>
-        <p14:section name="Option sécurité" id="{8b60bd97-10f8-d5ae-eecf-bbdd0b67b003}">
+        <p14:section name="Option sécurité" id="{d0b2e7f0-ab01-ea36-de6d-339caa2173cc}">
           <p14:sldIdLst>
             <p14:sldId id="267"/>
             <p14:sldId id="268"/>
             <p14:sldId id="269"/>
           </p14:sldIdLst>
         </p14:section>
-        <p14:section name="Conclusion" id="{19e36175-e8c1-fceb-7fa5-6af27e6fd2b0}">
+        <p14:section name="Conclusion" id="{9a758952-758d-a95b-df93-031b521bab07}">
           <p14:sldIdLst>
             <p14:sldId id="270"/>
+          </p14:sldIdLst>
+        </p14:section>
+        <p14:section name="Annexe" id="{b8bba9e3-2ffd-1eef-a866-a91b11f4747a}">
+          <p14:sldIdLst>
+            <p14:sldId id="271"/>
           </p14:sldIdLst>
         </p14:section>
       </p14:sectionLst>
@@ -564,7 +570,7 @@
           <a:p>
             <a:r>
               <a:rPr lang="en-US" dirty="0"/>
-              <a:t>Accroche : aujourd'hui, l'informatique de l'entreprise fonctionne… jusqu'au jour où elle ne fonctionne plus. Cette proposition montre comment, avec un seul serveur, on passe d'un parc de postes isolés à un système géré, sécurisé et administré à distance — comme dans une grande entreprise, au budget d'une PME.</a:t>
+              <a:t>À dire : « Aujourd'hui, chaque ordinateur de l'entreprise vit sa vie de son côté. On vous propose de tout relier à un ordinateur central, le serveur, pour que tout soit organisé, protégé et facile à gérer. Et en cadeau, on vous fait votre site internet. »</a:t>
             </a:r>
             <a:endParaRPr lang="en-US" dirty="0"/>
           </a:p>
@@ -652,7 +658,7 @@
           <a:p>
             <a:r>
               <a:rPr lang="en-US" dirty="0"/>
-              <a:t>Rassurer : le client n'est pas laissé seul. Trois mois offerts pour qu'il constate la valeur, puis une maintenance trimestrielle à partir de 100 000 FCFA, à discuter selon ses besoins.</a:t>
+              <a:t>À dire : « On ne vous laisse pas seul. Les 3 premiers mois, on surveille et on corrige gratuitement. Ensuite, si vous voulez, on continue avec un suivi à partir de 100 000 FCFA tous les 3 mois, à discuter ensemble. »</a:t>
             </a:r>
             <a:endParaRPr lang="en-US" dirty="0"/>
           </a:p>
@@ -740,7 +746,7 @@
           <a:p>
             <a:r>
               <a:rPr lang="en-US" dirty="0"/>
-              <a:t>Le geste commercial : le site vitrine, d'une valeur de 365 000 FCFA, est offert. L'entreprise gagne à la fois un outil interne solide et une vitrine pour attirer de nouveaux clients.</a:t>
+              <a:t>À dire : « Et pour vous remercier de votre confiance, on vous offre votre site internet, d'une valeur de 365 000 FCFA. Vos clients pourront vous trouver sur Google et vous contacter facilement. »</a:t>
             </a:r>
             <a:endParaRPr lang="en-US" dirty="0"/>
           </a:p>
@@ -828,7 +834,7 @@
           <a:p>
             <a:r>
               <a:rPr lang="en-US" dirty="0"/>
-              <a:t>Transition : l'infrastructure organise le parc, mais il faut aussi le protéger. Cette option est indépendante de la proposition principale : le client peut la prendre maintenant ou plus tard.</a:t>
+              <a:t>À dire : « Organiser vos ordinateurs, c'est bien. Les protéger, c'est indispensable. Il existe des virus qui verrouillent tous vos fichiers et demandent de l'argent pour les débloquer. » C'est une option à part : le client peut la prendre maintenant ou plus tard.</a:t>
             </a:r>
             <a:endParaRPr lang="en-US" dirty="0"/>
           </a:p>
@@ -916,7 +922,7 @@
           <a:p>
             <a:r>
               <a:rPr lang="en-US" dirty="0"/>
-              <a:t>L'administrateur pilote la sécurité de tous les appareils depuis une seule console, à distance, comme pour le reste de l'infrastructure. Les postes, le serveur et les téléphones sont couverts.</a:t>
+              <a:t>À dire : « L'administrateur surveille la sécurité de tous vos appareils, ordinateurs et téléphones, depuis un seul écran. S'il y a un danger, il est prévenu tout de suite. »</a:t>
             </a:r>
             <a:endParaRPr lang="en-US" dirty="0"/>
           </a:p>
@@ -1004,7 +1010,7 @@
           <a:p>
             <a:r>
               <a:rPr lang="en-US" dirty="0"/>
-              <a:t>Ne pas annoncer de prix : poser la question du coût d'une journée d'arrêt et laisser le client y réfléchir. Proposer une démonstration ou un devis séparé s'il montre de l'intérêt.</a:t>
+              <a:t>À dire : « Je ne vous donne pas de prix aujourd'hui. Posez-vous juste cette question : combien vous coûterait une journée où plus personne ne peut travailler ? » Proposer ensuite une démonstration.</a:t>
             </a:r>
             <a:endParaRPr lang="en-US" dirty="0"/>
           </a:p>
@@ -1092,7 +1098,7 @@
           <a:p>
             <a:r>
               <a:rPr lang="en-US" dirty="0"/>
-              <a:t>Conclure par une question fermée : « On planifie l'installation pour quelle semaine ? »</a:t>
+              <a:t>À dire : « Si cela vous convient, on peut commencer tout de suite. Quelle semaine vous arrange pour l'installation ? »</a:t>
             </a:r>
             <a:endParaRPr lang="en-US" dirty="0"/>
           </a:p>
@@ -1116,6 +1122,94 @@
             <a:fld id="{F7021451-1387-4CA6-816F-3879F97B5CBC}" type="slidenum">
               <a:rPr lang="en-US"/>
               <a:t>15</a:t>
+            </a:fld>
+            <a:endParaRPr lang="en-US"/>
+          </a:p>
+        </p:txBody>
+      </p:sp>
+    </p:spTree>
+    <p:extLst>
+      <p:ext uri="{BB962C8B-B14F-4D97-AF65-F5344CB8AC3E}">
+        <p14:creationId xmlns:p14="http://schemas.microsoft.com/office/powerpoint/2010/main" val="1024086991"/>
+      </p:ext>
+    </p:extLst>
+  </p:cSld>
+  <p:clrMapOvr>
+    <a:masterClrMapping/>
+  </p:clrMapOvr>
+</p:notes>
+</file>
+
+<file path=ppt/notesSlides/notesSlide16.xml><?xml version="1.0" encoding="utf-8"?>
+<p:notes xmlns:a="http://schemas.openxmlformats.org/drawingml/2006/main" xmlns:r="http://schemas.openxmlformats.org/officeDocument/2006/relationships" xmlns:p="http://schemas.openxmlformats.org/presentationml/2006/main">
+  <p:cSld>
+    <p:spTree>
+      <p:nvGrpSpPr>
+        <p:cNvPr id="1" name=""/>
+        <p:cNvGrpSpPr/>
+        <p:nvPr/>
+      </p:nvGrpSpPr>
+      <p:grpSpPr>
+        <a:xfrm>
+          <a:off x="0" y="0"/>
+          <a:ext cx="0" cy="0"/>
+          <a:chOff x="0" y="0"/>
+          <a:chExt cx="0" cy="0"/>
+        </a:xfrm>
+      </p:grpSpPr>
+      <p:sp>
+        <p:nvSpPr>
+          <p:cNvPr id="2" name="Slide Image Placeholder 1"/>
+          <p:cNvSpPr>
+            <a:spLocks noGrp="1" noRot="1" noChangeAspect="1"/>
+          </p:cNvSpPr>
+          <p:nvPr>
+            <p:ph type="sldImg"/>
+          </p:nvPr>
+        </p:nvSpPr>
+        <p:spPr/>
+      </p:sp>
+      <p:sp>
+        <p:nvSpPr>
+          <p:cNvPr id="3" name="Notes Placeholder 2"/>
+          <p:cNvSpPr>
+            <a:spLocks noGrp="1"/>
+          </p:cNvSpPr>
+          <p:nvPr>
+            <p:ph type="body" idx="1"/>
+          </p:nvPr>
+        </p:nvSpPr>
+        <p:spPr/>
+        <p:txBody>
+          <a:bodyPr/>
+          <a:lstStyle/>
+          <a:p>
+            <a:r>
+              <a:rPr lang="en-US" dirty="0"/>
+              <a:t>Diapositive de secours : à montrer si quelqu'un demande ce que veut dire un mot. Lire simplement la définition.</a:t>
+            </a:r>
+            <a:endParaRPr lang="en-US" dirty="0"/>
+          </a:p>
+        </p:txBody>
+      </p:sp>
+      <p:sp>
+        <p:nvSpPr>
+          <p:cNvPr id="4" name="Slide Number Placeholder 3"/>
+          <p:cNvSpPr>
+            <a:spLocks noGrp="1"/>
+          </p:cNvSpPr>
+          <p:nvPr>
+            <p:ph type="sldNum" sz="quarter" idx="10"/>
+          </p:nvPr>
+        </p:nvSpPr>
+        <p:spPr/>
+        <p:txBody>
+          <a:bodyPr/>
+          <a:lstStyle/>
+          <a:p>
+            <a:fld id="{F7021451-1387-4CA6-816F-3879F97B5CBC}" type="slidenum">
+              <a:rPr lang="en-US"/>
+              <a:t>16</a:t>
             </a:fld>
             <a:endParaRPr lang="en-US"/>
           </a:p>
@@ -1180,7 +1274,7 @@
           <a:p>
             <a:r>
               <a:rPr lang="en-US" dirty="0"/>
-              <a:t>Faire réagir le client : « Vous reconnaissez-vous à l'une de ces étapes ? » Avec 15 postes, l'entreprise est exactement au moment où le bricolage devient un risque. Chaque départ d'employé, chaque virus, chaque panne coûte du temps et de l'argent.</a:t>
+              <a:t>À dire : « Plus il y a d'ordinateurs et d'employés, plus c'est difficile de savoir qui fait quoi. Les mots de passe circulent, chacun installe ce qu'il veut, et le jour où un virus arrive ou qu'un ordinateur tombe en panne, tout s'arrête. Vous vous reconnaissez dans une de ces étapes ? »</a:t>
             </a:r>
             <a:endParaRPr lang="en-US" dirty="0"/>
           </a:p>
@@ -1268,7 +1362,7 @@
           <a:p>
             <a:r>
               <a:rPr lang="en-US" dirty="0"/>
-              <a:t>Pause. Laisser la phrase s'installer. Le message : on ne vend pas du matériel, on vend de la tranquillité et du contrôle.</a:t>
+              <a:t>À dire : « Notre idée est simple : que vos ordinateurs soient bien rangés, protégés, et qu'on puisse vous aider à distance, sans se déplacer. » Faire une petite pause.</a:t>
             </a:r>
             <a:endParaRPr lang="en-US" dirty="0"/>
           </a:p>
@@ -1356,7 +1450,7 @@
           <a:p>
             <a:r>
               <a:rPr lang="en-US" dirty="0"/>
-              <a:t>Expliquer couche par couche, de bas en haut : un serveur, Proxmox qui le rend évolutif, Windows Server qui est le standard mondial pour gérer un réseau d'entreprise, puis Active Directory et les GPO qui donnent le contrôle sur les 15 postes.</a:t>
+              <a:t>À dire, de bas en haut : « En bas, le serveur : c'est un ordinateur central qui reste allumé. Dessus, Proxmox, un logiciel gratuit qui nous laisse de la place pour ajouter d'autres outils plus tard. Ensuite Windows Server : c'est le chef d'orchestre. Il crée un compte pour chaque employé et applique automatiquement les mêmes règles sur tous les ordinateurs. Tout en haut : vos 15 postes, bien réglés. » Image utile : le serveur est comme le gardien d'un immeuble qui a toutes les clés.</a:t>
             </a:r>
             <a:endParaRPr lang="en-US" dirty="0"/>
           </a:p>
@@ -1444,7 +1538,7 @@
           <a:p>
             <a:r>
               <a:rPr lang="en-US" dirty="0"/>
-              <a:t>C'est la slide qui vend. Insister sur le départ d'un employé : aujourd'hui, un ancien salarié peut encore accéder aux données. Demain : un clic et c'est fini.</a:t>
+              <a:t>À dire : « Voici ce qui change pour vous au quotidien. » Insister sur le départ d'un employé : « Aujourd'hui, un ancien employé peut encore ouvrir vos fichiers. Demain, on désactive son compte en un clic et c'est terminé. »</a:t>
             </a:r>
             <a:endParaRPr lang="en-US" dirty="0"/>
           </a:p>
@@ -1532,7 +1626,7 @@
           <a:p>
             <a:r>
               <a:rPr lang="en-US" dirty="0"/>
-              <a:t>Tailscale crée un tunnel chiffré : l'administrateur gère tout le parc à distance, sans exposer le serveur sur Internet. Résultat : un problème réglé en quelques minutes, sans attendre un déplacement.</a:t>
+              <a:t>À dire : « L'administrateur peut s'occuper de vos ordinateurs depuis chez lui ou en déplacement, grâce à une connexion privée et protégée qui s'appelle Tailscale. C'est comme un couloir secret que lui seul peut emprunter. Un problème ? Il le règle en quelques minutes, sans venir sur place. »</a:t>
             </a:r>
             <a:endParaRPr lang="en-US" dirty="0"/>
           </a:p>
@@ -1620,7 +1714,7 @@
           <a:p>
             <a:r>
               <a:rPr lang="en-US" dirty="0"/>
-              <a:t>Rassurer : ce ne sont pas des solutions exotiques. Et surtout, pas d'abonnement : une fois installé, le système appartient à l'entreprise.</a:t>
+              <a:t>À dire : « On a choisi des outils connus et fiables. Et surtout, pas d'abonnement : une fois installé, tout vous appartient. »</a:t>
             </a:r>
             <a:endParaRPr lang="en-US" dirty="0"/>
           </a:p>
@@ -1708,7 +1802,7 @@
           <a:p>
             <a:r>
               <a:rPr lang="en-US" dirty="0"/>
-              <a:t>Le client n'a rien à gérer : du serveur jusqu'au dernier poste, tout est installé, configuré et testé. Le forfait couvre les 15 postes.</a:t>
+              <a:t>À dire : « Vous n'avez rien à faire : on installe le serveur, on crée les comptes, on règle la sécurité, on relie les 15 ordinateurs et on prépare l'accès à distance. Tout est compris dans ce prix. »</a:t>
             </a:r>
             <a:endParaRPr lang="en-US" dirty="0"/>
           </a:p>
@@ -1796,7 +1890,7 @@
           <a:p>
             <a:r>
               <a:rPr lang="en-US" dirty="0"/>
-              <a:t>Annoncer le total puis ramener au coût par poste : environ 77 000 FCFA par poste, une seule fois. À comparer au coût d'une seule journée d'arrêt ou d'une perte de données.</a:t>
+              <a:t>À dire : « Le total est de 1 150 000 FCFA, payé une seule fois. Ramené à vos 15 ordinateurs, c'est environ 77 000 FCFA par poste. C'est souvent moins cher qu'une seule journée de travail perdue à cause d'une panne. »</a:t>
             </a:r>
             <a:endParaRPr lang="en-US" dirty="0"/>
           </a:p>
@@ -3008,7 +3102,7 @@
                   <a:schemeClr val="tx2"/>
                 </a:solidFill>
               </a:rPr>
-              <a:t>Administration à distance</a:t>
+              <a:t>Gestion à distance</a:t>
             </a:r>
             <a:endParaRPr lang="en-US" sz="1300" dirty="0"/>
           </a:p>
@@ -4162,7 +4256,7 @@
                   <a:schemeClr val="accent6"/>
                 </a:solidFill>
               </a:rPr>
-              <a:t>Dès la mise en service : surveillance, corrections et ajustements des GPO, sans frais.</a:t>
+              <a:t>Dès le démarrage : on surveille, on corrige et on ajuste les réglages, sans frais.</a:t>
             </a:r>
             <a:endParaRPr lang="en-US" sz="1500" dirty="0"/>
           </a:p>
@@ -4417,7 +4511,7 @@
                   <a:schemeClr val="bg1"/>
                 </a:solidFill>
               </a:rPr>
-              <a:t>Mises à jour et supervision du serveur</a:t>
+              <a:t>Mises à jour et surveillance du serveur</a:t>
             </a:r>
             <a:endParaRPr lang="en-US" sz="1500" dirty="0"/>
           </a:p>
@@ -4435,7 +4529,7 @@
                   <a:schemeClr val="bg1"/>
                 </a:solidFill>
               </a:rPr>
-              <a:t>Gestion des comptes et des GPO</a:t>
+              <a:t>Ajout ou retrait d'employés, réglages</a:t>
             </a:r>
             <a:endParaRPr lang="en-US" sz="1500" dirty="0"/>
           </a:p>
@@ -6509,7 +6603,7 @@
                   <a:schemeClr val="tx1"/>
                 </a:solidFill>
               </a:rPr>
-              <a:t>Visible sur Google, sécurisé en HTTPS</a:t>
+              <a:t>Visible sur Google et sécurisé (cadenas)</a:t>
             </a:r>
             <a:endParaRPr lang="en-US" sz="1500" dirty="0"/>
           </a:p>
@@ -8978,7 +9072,7 @@
                   <a:schemeClr val="bg1"/>
                 </a:solidFill>
               </a:rPr>
-              <a:t>Et si un ransomware frappait demain ?</a:t>
+              <a:t>Et si un virus bloquait tout demain ?</a:t>
             </a:r>
             <a:endParaRPr lang="en-US" sz="4000" dirty="0"/>
           </a:p>
@@ -9014,7 +9108,7 @@
                   <a:schemeClr val="accent4"/>
                 </a:solidFill>
               </a:rPr>
-              <a:t>Un poste infecté peut chiffrer les fichiers partagés et paralyser toute l'activité. Ajoutons une protection professionnelle.</a:t>
+              <a:t>Un seul ordinateur infecté peut verrouiller tous les fichiers et demander une rançon. Un bon antivirus d'entreprise l'empêche.</a:t>
             </a:r>
             <a:endParaRPr lang="en-US" sz="2000" dirty="0"/>
           </a:p>
@@ -9586,7 +9680,7 @@
                   <a:schemeClr val="bg1"/>
                 </a:solidFill>
               </a:rPr>
-              <a:t>dans le cloud (ou sur site)</a:t>
+              <a:t>accessible par Internet</a:t>
             </a:r>
             <a:endParaRPr lang="en-US" sz="1600" dirty="0"/>
           </a:p>
@@ -10078,7 +10172,7 @@
                   <a:schemeClr val="bg1"/>
                 </a:solidFill>
               </a:rPr>
-              <a:t>Protection des terminaux</a:t>
+              <a:t>Antivirus sur chaque appareil</a:t>
             </a:r>
             <a:endParaRPr lang="en-US" sz="1200" dirty="0"/>
           </a:p>
@@ -10141,7 +10235,7 @@
                   <a:schemeClr val="bg1"/>
                 </a:solidFill>
               </a:rPr>
-              <a:t>Contrôles Web, appareils, applications</a:t>
+              <a:t>Sites et clés USB surveillés</a:t>
             </a:r>
             <a:endParaRPr lang="en-US" sz="1200" dirty="0"/>
           </a:p>
@@ -10204,7 +10298,7 @@
                   <a:schemeClr val="bg1"/>
                 </a:solidFill>
               </a:rPr>
-              <a:t>Analyse des causes</a:t>
+              <a:t>Comprendre d'où vient une attaque</a:t>
             </a:r>
             <a:endParaRPr lang="en-US" sz="1200" dirty="0"/>
           </a:p>
@@ -10267,7 +10361,7 @@
                   <a:schemeClr val="bg1"/>
                 </a:solidFill>
               </a:rPr>
-              <a:t>Campagnes de phishing simulées</a:t>
+              <a:t>Entraînement contre les faux e-mails</a:t>
             </a:r>
             <a:endParaRPr lang="en-US" sz="1200" dirty="0"/>
           </a:p>
@@ -12256,7 +12350,7 @@
                   <a:schemeClr val="tx1"/>
                 </a:solidFill>
               </a:rPr>
-              <a:t>Kaspersky Next </a:t>
+              <a:t>Kaspersky : </a:t>
             </a:r>
             <a:pPr algn="l" indent="0" marL="0">
               <a:buNone/>
@@ -12267,7 +12361,7 @@
                   <a:schemeClr val="accent1"/>
                 </a:solidFill>
               </a:rPr>
-              <a:t>EDR Foundations</a:t>
+              <a:t>l'antivirus des entreprises</a:t>
             </a:r>
             <a:endParaRPr lang="en-US" sz="3200" dirty="0"/>
           </a:p>
@@ -12422,7 +12516,7 @@
                   <a:schemeClr val="accent6"/>
                 </a:solidFill>
               </a:rPr>
-              <a:t>Anti-ransomware et anti-malware éprouvés</a:t>
+              <a:t>Contre les virus et les demandes de rançon</a:t>
             </a:r>
             <a:endParaRPr lang="en-US" sz="1300" dirty="0"/>
           </a:p>
@@ -12541,7 +12635,7 @@
                   <a:schemeClr val="tx2"/>
                 </a:solidFill>
               </a:rPr>
-              <a:t>Bloque les malwares</a:t>
+              <a:t>Bloque les virus</a:t>
             </a:r>
             <a:endParaRPr lang="en-US" sz="1500" dirty="0"/>
           </a:p>
@@ -12577,7 +12671,7 @@
                   <a:schemeClr val="accent6"/>
                 </a:solidFill>
               </a:rPr>
-              <a:t>Connus et inconnus : fichiers, Web et e-mails</a:t>
+              <a:t>Dans les fichiers, sur Internet et dans les e-mails</a:t>
             </a:r>
             <a:endParaRPr lang="en-US" sz="1300" dirty="0"/>
           </a:p>
@@ -12732,7 +12826,7 @@
                   <a:schemeClr val="accent6"/>
                 </a:solidFill>
               </a:rPr>
-              <a:t>Détection automatique des logiciels obsolètes</a:t>
+              <a:t>Signale les logiciels trop vieux, donc risqués</a:t>
             </a:r>
             <a:endParaRPr lang="en-US" sz="1300" dirty="0"/>
           </a:p>
@@ -12887,7 +12981,7 @@
                   <a:schemeClr val="accent6"/>
                 </a:solidFill>
               </a:rPr>
-              <a:t>Applications, Web et périphériques encadrés</a:t>
+              <a:t>Sites dangereux et clés USB sous contrôle</a:t>
             </a:r>
             <a:endParaRPr lang="en-US" sz="1300" dirty="0"/>
           </a:p>
@@ -13006,7 +13100,7 @@
                   <a:schemeClr val="tx2"/>
                 </a:solidFill>
               </a:rPr>
-              <a:t>Attaques avancées</a:t>
+              <a:t>Attaques stoppées</a:t>
             </a:r>
             <a:endParaRPr lang="en-US" sz="1500" dirty="0"/>
           </a:p>
@@ -13042,7 +13136,7 @@
                   <a:schemeClr val="accent6"/>
                 </a:solidFill>
               </a:rPr>
-              <a:t>Détectées, éliminées, avec analyse des causes</a:t>
+              <a:t>Et on comprend comment elles sont arrivées</a:t>
             </a:r>
             <a:endParaRPr lang="en-US" sz="1300" dirty="0"/>
           </a:p>
@@ -13197,7 +13291,7 @@
                   <a:schemeClr val="accent6"/>
                 </a:solidFill>
               </a:rPr>
-              <a:t>Activités suspectes et failles signalées</a:t>
+              <a:t>L'administrateur est prévenu en cas de danger</a:t>
             </a:r>
             <a:endParaRPr lang="en-US" sz="1300" dirty="0"/>
           </a:p>
@@ -13451,7 +13545,7 @@
                   <a:schemeClr val="accent6"/>
                 </a:solidFill>
               </a:rPr>
-              <a:t>Option indépendante de l'infrastructure · offre adaptée à la taille de votre parc</a:t>
+              <a:t>Option séparée du reste · offre adaptée au nombre d'ordinateurs</a:t>
             </a:r>
             <a:endParaRPr lang="en-US" sz="1100" dirty="0"/>
           </a:p>
@@ -15882,7 +15976,7 @@
                   <a:schemeClr val="accent4"/>
                 </a:solidFill>
               </a:rPr>
-              <a:t>Votre infrastructure opérationnelle en 1 à 2 semaines.</a:t>
+              <a:t>Tout est prêt en 1 à 2 semaines.</a:t>
             </a:r>
             <a:endParaRPr lang="en-US" sz="2000" dirty="0"/>
           </a:p>
@@ -17003,6 +17097,3768 @@
                                   <p:cTn id="55" dur="600" decel="100000" fill="hold"/>
                                   <p:tgtEl>
                                     <p:spTgt spid="16"/>
+                                  </p:tgtEl>
+                                  <p:attrNameLst>
+                                    <p:attrName>ppt_y</p:attrName>
+                                  </p:attrNameLst>
+                                </p:cBhvr>
+                                <p:tavLst>
+                                  <p:tav tm="0">
+                                    <p:val>
+                                      <p:strVal val="#ppt_y+0.03"/>
+                                    </p:val>
+                                  </p:tav>
+                                  <p:tav tm="100000">
+                                    <p:val>
+                                      <p:strVal val="#ppt_y"/>
+                                    </p:val>
+                                  </p:tav>
+                                </p:tavLst>
+                              </p:anim>
+                            </p:childTnLst>
+                          </p:cTn>
+                        </p:par>
+                      </p:childTnLst>
+                    </p:cTn>
+                  </p:par>
+                </p:childTnLst>
+              </p:cTn>
+              <p:prevCondLst>
+                <p:cond evt="onPrev" delay="0">
+                  <p:tgtEl>
+                    <p:sldTgt/>
+                  </p:tgtEl>
+                </p:cond>
+              </p:prevCondLst>
+              <p:nextCondLst>
+                <p:cond evt="onNext" delay="0">
+                  <p:tgtEl>
+                    <p:sldTgt/>
+                  </p:tgtEl>
+                </p:cond>
+              </p:nextCondLst>
+            </p:seq>
+          </p:childTnLst>
+        </p:cTn>
+      </p:par>
+    </p:tnLst>
+  </p:timing>
+</p:sld>
+</file>
+
+<file path=ppt/slides/slide16.xml><?xml version="1.0" encoding="utf-8"?>
+<p:sld xmlns:a="http://schemas.openxmlformats.org/drawingml/2006/main" xmlns:r="http://schemas.openxmlformats.org/officeDocument/2006/relationships" xmlns:p="http://schemas.openxmlformats.org/presentationml/2006/main">
+  <p:cSld name="Slide 16">
+    <p:spTree>
+      <p:nvGrpSpPr>
+        <p:cNvPr id="1" name=""/>
+        <p:cNvGrpSpPr/>
+        <p:nvPr/>
+      </p:nvGrpSpPr>
+      <p:grpSpPr>
+        <a:xfrm>
+          <a:off x="0" y="0"/>
+          <a:ext cx="0" cy="0"/>
+          <a:chOff x="0" y="0"/>
+          <a:chExt cx="0" cy="0"/>
+        </a:xfrm>
+      </p:grpSpPr>
+      <p:sp>
+        <p:nvSpPr>
+          <p:cNvPr id="2" name="Text 0"/>
+          <p:cNvSpPr/>
+          <p:nvPr>
+            <p:ph idx="100" type="body" hasCustomPrompt="1"/>
+          </p:nvPr>
+        </p:nvSpPr>
+        <p:spPr>
+          <a:xfrm>
+            <a:off x="548640" y="365760"/>
+            <a:ext cx="8229600" cy="320040"/>
+          </a:xfrm>
+          <a:prstGeom prst="rect">
+            <a:avLst/>
+          </a:prstGeom>
+          <a:noFill/>
+          <a:ln/>
+        </p:spPr>
+        <p:txBody>
+          <a:bodyPr wrap="square" rtlCol="0"/>
+          <a:lstStyle/>
+          <a:p>
+            <a:pPr indent="0" marL="0">
+              <a:buNone/>
+            </a:pPr>
+            <a:r>
+              <a:rPr lang="en-US" sz="1400" b="1" dirty="0">
+                <a:solidFill>
+                  <a:schemeClr val="accent1"/>
+                </a:solidFill>
+              </a:rPr>
+              <a:t>Annexe</a:t>
+            </a:r>
+            <a:endParaRPr lang="en-US" sz="1400" dirty="0"/>
+          </a:p>
+        </p:txBody>
+      </p:sp>
+      <p:sp>
+        <p:nvSpPr>
+          <p:cNvPr id="3" name="Text 0"/>
+          <p:cNvSpPr/>
+          <p:nvPr>
+            <p:ph idx="101" type="title" hasCustomPrompt="1"/>
+          </p:nvPr>
+        </p:nvSpPr>
+        <p:spPr>
+          <a:xfrm>
+            <a:off x="548640" y="685800"/>
+            <a:ext cx="11064240" cy="731520"/>
+          </a:xfrm>
+          <a:prstGeom prst="rect">
+            <a:avLst/>
+          </a:prstGeom>
+          <a:noFill/>
+          <a:ln/>
+        </p:spPr>
+        <p:txBody>
+          <a:bodyPr wrap="square" rtlCol="0"/>
+          <a:lstStyle/>
+          <a:p>
+            <a:pPr algn="l" indent="0" marL="0">
+              <a:buNone/>
+            </a:pPr>
+            <a:r>
+              <a:rPr lang="en-US" sz="3200" b="1" dirty="0">
+                <a:solidFill>
+                  <a:schemeClr val="tx1"/>
+                </a:solidFill>
+              </a:rPr>
+              <a:t>Les mots </a:t>
+            </a:r>
+            <a:pPr algn="l" indent="0" marL="0">
+              <a:buNone/>
+            </a:pPr>
+            <a:r>
+              <a:rPr lang="en-US" sz="3200" b="1" dirty="0">
+                <a:solidFill>
+                  <a:schemeClr val="accent1"/>
+                </a:solidFill>
+              </a:rPr>
+              <a:t>expliqués simplement</a:t>
+            </a:r>
+            <a:endParaRPr lang="en-US" sz="3200" dirty="0"/>
+          </a:p>
+        </p:txBody>
+      </p:sp>
+      <p:sp>
+        <p:nvSpPr>
+          <p:cNvPr id="4" name="a1_325"/>
+          <p:cNvSpPr/>
+          <p:nvPr/>
+        </p:nvSpPr>
+        <p:spPr>
+          <a:xfrm>
+            <a:off x="548640" y="1600200"/>
+            <a:ext cx="5440680" cy="1005840"/>
+          </a:xfrm>
+          <a:prstGeom prst="roundRect">
+            <a:avLst>
+              <a:gd name="adj" fmla="val 12727"/>
+            </a:avLst>
+          </a:prstGeom>
+          <a:solidFill>
+            <a:schemeClr val="bg1"/>
+          </a:solidFill>
+          <a:ln w="12700">
+            <a:solidFill>
+              <a:srgbClr val="DCE5F7"/>
+            </a:solidFill>
+            <a:prstDash val="solid"/>
+          </a:ln>
+          <a:effectLst>
+            <a:outerShdw sx="100000" sy="100000" kx="0" ky="0" algn="bl" rotWithShape="0" blurRad="127000" dist="38100" dir="5400000">
+              <a:srgbClr val="0B2A6F">
+                <a:alpha val="12000"/>
+              </a:srgbClr>
+            </a:outerShdw>
+          </a:effectLst>
+        </p:spPr>
+      </p:sp>
+      <p:sp>
+        <p:nvSpPr>
+          <p:cNvPr id="5" name="a1_326"/>
+          <p:cNvSpPr/>
+          <p:nvPr/>
+        </p:nvSpPr>
+        <p:spPr>
+          <a:xfrm>
+            <a:off x="731520" y="1801368"/>
+            <a:ext cx="603504" cy="603504"/>
+          </a:xfrm>
+          <a:prstGeom prst="ellipse">
+            <a:avLst/>
+          </a:prstGeom>
+          <a:solidFill>
+            <a:schemeClr val="accent1"/>
+          </a:solidFill>
+          <a:ln w="12700">
+            <a:solidFill>
+              <a:schemeClr val="accent1"/>
+            </a:solidFill>
+            <a:prstDash val="solid"/>
+          </a:ln>
+        </p:spPr>
+      </p:sp>
+      <p:pic>
+        <p:nvPicPr>
+          <p:cNvPr id="6" name="a1_327" descr="preencoded.png">    </p:cNvPr>
+          <p:cNvPicPr>
+            <a:picLocks noChangeAspect="1"/>
+          </p:cNvPicPr>
+          <p:nvPr/>
+        </p:nvPicPr>
+        <p:blipFill>
+          <a:blip r:embed="rId1"/>
+          <a:stretch>
+            <a:fillRect/>
+          </a:stretch>
+        </p:blipFill>
+        <p:spPr>
+          <a:xfrm>
+            <a:off x="888431" y="1958279"/>
+            <a:ext cx="289682" cy="289682"/>
+          </a:xfrm>
+          <a:prstGeom prst="rect">
+            <a:avLst/>
+          </a:prstGeom>
+        </p:spPr>
+      </p:pic>
+      <p:sp>
+        <p:nvSpPr>
+          <p:cNvPr id="7" name="a1_328"/>
+          <p:cNvSpPr txBox="1"/>
+          <p:nvPr/>
+        </p:nvSpPr>
+        <p:spPr>
+          <a:xfrm>
+            <a:off x="1508760" y="1691640"/>
+            <a:ext cx="4297680" cy="365760"/>
+          </a:xfrm>
+          <a:prstGeom prst="rect">
+            <a:avLst/>
+          </a:prstGeom>
+          <a:noFill/>
+          <a:ln/>
+        </p:spPr>
+        <p:txBody>
+          <a:bodyPr wrap="square" lIns="0" tIns="0" rIns="0" bIns="0" rtlCol="0" anchor="ctr"/>
+          <a:lstStyle/>
+          <a:p>
+            <a:pPr indent="0" marL="0">
+              <a:buNone/>
+            </a:pPr>
+            <a:r>
+              <a:rPr lang="en-US" sz="1500" b="1" dirty="0">
+                <a:solidFill>
+                  <a:schemeClr val="tx2"/>
+                </a:solidFill>
+              </a:rPr>
+              <a:t>Serveur</a:t>
+            </a:r>
+            <a:endParaRPr lang="en-US" sz="1500" dirty="0"/>
+          </a:p>
+        </p:txBody>
+      </p:sp>
+      <p:sp>
+        <p:nvSpPr>
+          <p:cNvPr id="8" name="a1_329"/>
+          <p:cNvSpPr txBox="1"/>
+          <p:nvPr/>
+        </p:nvSpPr>
+        <p:spPr>
+          <a:xfrm>
+            <a:off x="1508760" y="2039112"/>
+            <a:ext cx="4343400" cy="502920"/>
+          </a:xfrm>
+          <a:prstGeom prst="rect">
+            <a:avLst/>
+          </a:prstGeom>
+          <a:noFill/>
+          <a:ln/>
+        </p:spPr>
+        <p:txBody>
+          <a:bodyPr wrap="square" lIns="0" tIns="0" rIns="0" bIns="0" rtlCol="0" anchor="t"/>
+          <a:lstStyle/>
+          <a:p>
+            <a:pPr indent="0" marL="0">
+              <a:buNone/>
+            </a:pPr>
+            <a:r>
+              <a:rPr lang="en-US" sz="1300" dirty="0">
+                <a:solidFill>
+                  <a:schemeClr val="accent6"/>
+                </a:solidFill>
+              </a:rPr>
+              <a:t>Un ordinateur central, toujours allumé, qui organise tous les autres.</a:t>
+            </a:r>
+            <a:endParaRPr lang="en-US" sz="1300" dirty="0"/>
+          </a:p>
+        </p:txBody>
+      </p:sp>
+      <p:sp>
+        <p:nvSpPr>
+          <p:cNvPr id="9" name="a1_330"/>
+          <p:cNvSpPr/>
+          <p:nvPr/>
+        </p:nvSpPr>
+        <p:spPr>
+          <a:xfrm>
+            <a:off x="6172200" y="1600200"/>
+            <a:ext cx="5440680" cy="1005840"/>
+          </a:xfrm>
+          <a:prstGeom prst="roundRect">
+            <a:avLst>
+              <a:gd name="adj" fmla="val 12727"/>
+            </a:avLst>
+          </a:prstGeom>
+          <a:solidFill>
+            <a:schemeClr val="bg1"/>
+          </a:solidFill>
+          <a:ln w="12700">
+            <a:solidFill>
+              <a:srgbClr val="DCE5F7"/>
+            </a:solidFill>
+            <a:prstDash val="solid"/>
+          </a:ln>
+          <a:effectLst>
+            <a:outerShdw sx="100000" sy="100000" kx="0" ky="0" algn="bl" rotWithShape="0" blurRad="127000" dist="38100" dir="5400000">
+              <a:srgbClr val="0B2A6F">
+                <a:alpha val="12000"/>
+              </a:srgbClr>
+            </a:outerShdw>
+          </a:effectLst>
+        </p:spPr>
+      </p:sp>
+      <p:sp>
+        <p:nvSpPr>
+          <p:cNvPr id="10" name="a1_331"/>
+          <p:cNvSpPr/>
+          <p:nvPr/>
+        </p:nvSpPr>
+        <p:spPr>
+          <a:xfrm>
+            <a:off x="6355080" y="1801368"/>
+            <a:ext cx="603504" cy="603504"/>
+          </a:xfrm>
+          <a:prstGeom prst="ellipse">
+            <a:avLst/>
+          </a:prstGeom>
+          <a:solidFill>
+            <a:schemeClr val="accent1"/>
+          </a:solidFill>
+          <a:ln w="12700">
+            <a:solidFill>
+              <a:schemeClr val="accent1"/>
+            </a:solidFill>
+            <a:prstDash val="solid"/>
+          </a:ln>
+        </p:spPr>
+      </p:sp>
+      <p:pic>
+        <p:nvPicPr>
+          <p:cNvPr id="11" name="a1_332" descr="preencoded.png">    </p:cNvPr>
+          <p:cNvPicPr>
+            <a:picLocks noChangeAspect="1"/>
+          </p:cNvPicPr>
+          <p:nvPr/>
+        </p:nvPicPr>
+        <p:blipFill>
+          <a:blip r:embed="rId2"/>
+          <a:stretch>
+            <a:fillRect/>
+          </a:stretch>
+        </p:blipFill>
+        <p:spPr>
+          <a:xfrm>
+            <a:off x="6511991" y="1958279"/>
+            <a:ext cx="289682" cy="289682"/>
+          </a:xfrm>
+          <a:prstGeom prst="rect">
+            <a:avLst/>
+          </a:prstGeom>
+        </p:spPr>
+      </p:pic>
+      <p:sp>
+        <p:nvSpPr>
+          <p:cNvPr id="12" name="a1_333"/>
+          <p:cNvSpPr txBox="1"/>
+          <p:nvPr/>
+        </p:nvSpPr>
+        <p:spPr>
+          <a:xfrm>
+            <a:off x="7132320" y="1691640"/>
+            <a:ext cx="4297680" cy="365760"/>
+          </a:xfrm>
+          <a:prstGeom prst="rect">
+            <a:avLst/>
+          </a:prstGeom>
+          <a:noFill/>
+          <a:ln/>
+        </p:spPr>
+        <p:txBody>
+          <a:bodyPr wrap="square" lIns="0" tIns="0" rIns="0" bIns="0" rtlCol="0" anchor="ctr"/>
+          <a:lstStyle/>
+          <a:p>
+            <a:pPr indent="0" marL="0">
+              <a:buNone/>
+            </a:pPr>
+            <a:r>
+              <a:rPr lang="en-US" sz="1500" b="1" dirty="0">
+                <a:solidFill>
+                  <a:schemeClr val="tx2"/>
+                </a:solidFill>
+              </a:rPr>
+              <a:t>Proxmox</a:t>
+            </a:r>
+            <a:endParaRPr lang="en-US" sz="1500" dirty="0"/>
+          </a:p>
+        </p:txBody>
+      </p:sp>
+      <p:sp>
+        <p:nvSpPr>
+          <p:cNvPr id="13" name="a1_334"/>
+          <p:cNvSpPr txBox="1"/>
+          <p:nvPr/>
+        </p:nvSpPr>
+        <p:spPr>
+          <a:xfrm>
+            <a:off x="7132320" y="2039112"/>
+            <a:ext cx="4343400" cy="502920"/>
+          </a:xfrm>
+          <a:prstGeom prst="rect">
+            <a:avLst/>
+          </a:prstGeom>
+          <a:noFill/>
+          <a:ln/>
+        </p:spPr>
+        <p:txBody>
+          <a:bodyPr wrap="square" lIns="0" tIns="0" rIns="0" bIns="0" rtlCol="0" anchor="t"/>
+          <a:lstStyle/>
+          <a:p>
+            <a:pPr indent="0" marL="0">
+              <a:buNone/>
+            </a:pPr>
+            <a:r>
+              <a:rPr lang="en-US" sz="1300" dirty="0">
+                <a:solidFill>
+                  <a:schemeClr val="accent6"/>
+                </a:solidFill>
+              </a:rPr>
+              <a:t>Un logiciel gratuit installé sur le serveur, qui permet d'y ajouter des outils plus tard.</a:t>
+            </a:r>
+            <a:endParaRPr lang="en-US" sz="1300" dirty="0"/>
+          </a:p>
+        </p:txBody>
+      </p:sp>
+      <p:sp>
+        <p:nvSpPr>
+          <p:cNvPr id="14" name="a2_335"/>
+          <p:cNvSpPr/>
+          <p:nvPr/>
+        </p:nvSpPr>
+        <p:spPr>
+          <a:xfrm>
+            <a:off x="548640" y="2743200"/>
+            <a:ext cx="5440680" cy="1005840"/>
+          </a:xfrm>
+          <a:prstGeom prst="roundRect">
+            <a:avLst>
+              <a:gd name="adj" fmla="val 12727"/>
+            </a:avLst>
+          </a:prstGeom>
+          <a:solidFill>
+            <a:schemeClr val="bg1"/>
+          </a:solidFill>
+          <a:ln w="12700">
+            <a:solidFill>
+              <a:srgbClr val="DCE5F7"/>
+            </a:solidFill>
+            <a:prstDash val="solid"/>
+          </a:ln>
+          <a:effectLst>
+            <a:outerShdw sx="100000" sy="100000" kx="0" ky="0" algn="bl" rotWithShape="0" blurRad="127000" dist="38100" dir="5400000">
+              <a:srgbClr val="0B2A6F">
+                <a:alpha val="12000"/>
+              </a:srgbClr>
+            </a:outerShdw>
+          </a:effectLst>
+        </p:spPr>
+      </p:sp>
+      <p:sp>
+        <p:nvSpPr>
+          <p:cNvPr id="15" name="a2_336"/>
+          <p:cNvSpPr/>
+          <p:nvPr/>
+        </p:nvSpPr>
+        <p:spPr>
+          <a:xfrm>
+            <a:off x="731520" y="2944368"/>
+            <a:ext cx="603504" cy="603504"/>
+          </a:xfrm>
+          <a:prstGeom prst="ellipse">
+            <a:avLst/>
+          </a:prstGeom>
+          <a:solidFill>
+            <a:schemeClr val="accent1"/>
+          </a:solidFill>
+          <a:ln w="12700">
+            <a:solidFill>
+              <a:schemeClr val="accent1"/>
+            </a:solidFill>
+            <a:prstDash val="solid"/>
+          </a:ln>
+        </p:spPr>
+      </p:sp>
+      <p:pic>
+        <p:nvPicPr>
+          <p:cNvPr id="16" name="a2_337" descr="preencoded.png">    </p:cNvPr>
+          <p:cNvPicPr>
+            <a:picLocks noChangeAspect="1"/>
+          </p:cNvPicPr>
+          <p:nvPr/>
+        </p:nvPicPr>
+        <p:blipFill>
+          <a:blip r:embed="rId3"/>
+          <a:stretch>
+            <a:fillRect/>
+          </a:stretch>
+        </p:blipFill>
+        <p:spPr>
+          <a:xfrm>
+            <a:off x="888431" y="3101279"/>
+            <a:ext cx="289682" cy="289682"/>
+          </a:xfrm>
+          <a:prstGeom prst="rect">
+            <a:avLst/>
+          </a:prstGeom>
+        </p:spPr>
+      </p:pic>
+      <p:sp>
+        <p:nvSpPr>
+          <p:cNvPr id="17" name="a2_338"/>
+          <p:cNvSpPr txBox="1"/>
+          <p:nvPr/>
+        </p:nvSpPr>
+        <p:spPr>
+          <a:xfrm>
+            <a:off x="1508760" y="2834640"/>
+            <a:ext cx="4297680" cy="365760"/>
+          </a:xfrm>
+          <a:prstGeom prst="rect">
+            <a:avLst/>
+          </a:prstGeom>
+          <a:noFill/>
+          <a:ln/>
+        </p:spPr>
+        <p:txBody>
+          <a:bodyPr wrap="square" lIns="0" tIns="0" rIns="0" bIns="0" rtlCol="0" anchor="ctr"/>
+          <a:lstStyle/>
+          <a:p>
+            <a:pPr indent="0" marL="0">
+              <a:buNone/>
+            </a:pPr>
+            <a:r>
+              <a:rPr lang="en-US" sz="1500" b="1" dirty="0">
+                <a:solidFill>
+                  <a:schemeClr val="tx2"/>
+                </a:solidFill>
+              </a:rPr>
+              <a:t>Windows Server</a:t>
+            </a:r>
+            <a:endParaRPr lang="en-US" sz="1500" dirty="0"/>
+          </a:p>
+        </p:txBody>
+      </p:sp>
+      <p:sp>
+        <p:nvSpPr>
+          <p:cNvPr id="18" name="a2_339"/>
+          <p:cNvSpPr txBox="1"/>
+          <p:nvPr/>
+        </p:nvSpPr>
+        <p:spPr>
+          <a:xfrm>
+            <a:off x="1508760" y="3182112"/>
+            <a:ext cx="4343400" cy="502920"/>
+          </a:xfrm>
+          <a:prstGeom prst="rect">
+            <a:avLst/>
+          </a:prstGeom>
+          <a:noFill/>
+          <a:ln/>
+        </p:spPr>
+        <p:txBody>
+          <a:bodyPr wrap="square" lIns="0" tIns="0" rIns="0" bIns="0" rtlCol="0" anchor="t"/>
+          <a:lstStyle/>
+          <a:p>
+            <a:pPr indent="0" marL="0">
+              <a:buNone/>
+            </a:pPr>
+            <a:r>
+              <a:rPr lang="en-US" sz="1300" dirty="0">
+                <a:solidFill>
+                  <a:schemeClr val="accent6"/>
+                </a:solidFill>
+              </a:rPr>
+              <a:t>Le « chef d'orchestre » : il gère les comptes et les règles de tous les ordinateurs.</a:t>
+            </a:r>
+            <a:endParaRPr lang="en-US" sz="1300" dirty="0"/>
+          </a:p>
+        </p:txBody>
+      </p:sp>
+      <p:sp>
+        <p:nvSpPr>
+          <p:cNvPr id="19" name="a2_340"/>
+          <p:cNvSpPr/>
+          <p:nvPr/>
+        </p:nvSpPr>
+        <p:spPr>
+          <a:xfrm>
+            <a:off x="6172200" y="2743200"/>
+            <a:ext cx="5440680" cy="1005840"/>
+          </a:xfrm>
+          <a:prstGeom prst="roundRect">
+            <a:avLst>
+              <a:gd name="adj" fmla="val 12727"/>
+            </a:avLst>
+          </a:prstGeom>
+          <a:solidFill>
+            <a:schemeClr val="bg1"/>
+          </a:solidFill>
+          <a:ln w="12700">
+            <a:solidFill>
+              <a:srgbClr val="DCE5F7"/>
+            </a:solidFill>
+            <a:prstDash val="solid"/>
+          </a:ln>
+          <a:effectLst>
+            <a:outerShdw sx="100000" sy="100000" kx="0" ky="0" algn="bl" rotWithShape="0" blurRad="127000" dist="38100" dir="5400000">
+              <a:srgbClr val="0B2A6F">
+                <a:alpha val="12000"/>
+              </a:srgbClr>
+            </a:outerShdw>
+          </a:effectLst>
+        </p:spPr>
+      </p:sp>
+      <p:sp>
+        <p:nvSpPr>
+          <p:cNvPr id="20" name="a2_341"/>
+          <p:cNvSpPr/>
+          <p:nvPr/>
+        </p:nvSpPr>
+        <p:spPr>
+          <a:xfrm>
+            <a:off x="6355080" y="2944368"/>
+            <a:ext cx="603504" cy="603504"/>
+          </a:xfrm>
+          <a:prstGeom prst="ellipse">
+            <a:avLst/>
+          </a:prstGeom>
+          <a:solidFill>
+            <a:schemeClr val="accent1"/>
+          </a:solidFill>
+          <a:ln w="12700">
+            <a:solidFill>
+              <a:schemeClr val="accent1"/>
+            </a:solidFill>
+            <a:prstDash val="solid"/>
+          </a:ln>
+        </p:spPr>
+      </p:sp>
+      <p:pic>
+        <p:nvPicPr>
+          <p:cNvPr id="21" name="a2_342" descr="preencoded.png">    </p:cNvPr>
+          <p:cNvPicPr>
+            <a:picLocks noChangeAspect="1"/>
+          </p:cNvPicPr>
+          <p:nvPr/>
+        </p:nvPicPr>
+        <p:blipFill>
+          <a:blip r:embed="rId4"/>
+          <a:stretch>
+            <a:fillRect/>
+          </a:stretch>
+        </p:blipFill>
+        <p:spPr>
+          <a:xfrm>
+            <a:off x="6511991" y="3101279"/>
+            <a:ext cx="289682" cy="289682"/>
+          </a:xfrm>
+          <a:prstGeom prst="rect">
+            <a:avLst/>
+          </a:prstGeom>
+        </p:spPr>
+      </p:pic>
+      <p:sp>
+        <p:nvSpPr>
+          <p:cNvPr id="22" name="a2_343"/>
+          <p:cNvSpPr txBox="1"/>
+          <p:nvPr/>
+        </p:nvSpPr>
+        <p:spPr>
+          <a:xfrm>
+            <a:off x="7132320" y="2834640"/>
+            <a:ext cx="4297680" cy="365760"/>
+          </a:xfrm>
+          <a:prstGeom prst="rect">
+            <a:avLst/>
+          </a:prstGeom>
+          <a:noFill/>
+          <a:ln/>
+        </p:spPr>
+        <p:txBody>
+          <a:bodyPr wrap="square" lIns="0" tIns="0" rIns="0" bIns="0" rtlCol="0" anchor="ctr"/>
+          <a:lstStyle/>
+          <a:p>
+            <a:pPr indent="0" marL="0">
+              <a:buNone/>
+            </a:pPr>
+            <a:r>
+              <a:rPr lang="en-US" sz="1500" b="1" dirty="0">
+                <a:solidFill>
+                  <a:schemeClr val="tx2"/>
+                </a:solidFill>
+              </a:rPr>
+              <a:t>Compte employé</a:t>
+            </a:r>
+            <a:endParaRPr lang="en-US" sz="1500" dirty="0"/>
+          </a:p>
+        </p:txBody>
+      </p:sp>
+      <p:sp>
+        <p:nvSpPr>
+          <p:cNvPr id="23" name="a2_344"/>
+          <p:cNvSpPr txBox="1"/>
+          <p:nvPr/>
+        </p:nvSpPr>
+        <p:spPr>
+          <a:xfrm>
+            <a:off x="7132320" y="3182112"/>
+            <a:ext cx="4343400" cy="502920"/>
+          </a:xfrm>
+          <a:prstGeom prst="rect">
+            <a:avLst/>
+          </a:prstGeom>
+          <a:noFill/>
+          <a:ln/>
+        </p:spPr>
+        <p:txBody>
+          <a:bodyPr wrap="square" lIns="0" tIns="0" rIns="0" bIns="0" rtlCol="0" anchor="t"/>
+          <a:lstStyle/>
+          <a:p>
+            <a:pPr indent="0" marL="0">
+              <a:buNone/>
+            </a:pPr>
+            <a:r>
+              <a:rPr lang="en-US" sz="1300" dirty="0">
+                <a:solidFill>
+                  <a:schemeClr val="accent6"/>
+                </a:solidFill>
+              </a:rPr>
+              <a:t>Un identifiant et un mot de passe personnels, valables sur tous les postes.</a:t>
+            </a:r>
+            <a:endParaRPr lang="en-US" sz="1300" dirty="0"/>
+          </a:p>
+        </p:txBody>
+      </p:sp>
+      <p:sp>
+        <p:nvSpPr>
+          <p:cNvPr id="24" name="a3_345"/>
+          <p:cNvSpPr/>
+          <p:nvPr/>
+        </p:nvSpPr>
+        <p:spPr>
+          <a:xfrm>
+            <a:off x="548640" y="3886200"/>
+            <a:ext cx="5440680" cy="1005840"/>
+          </a:xfrm>
+          <a:prstGeom prst="roundRect">
+            <a:avLst>
+              <a:gd name="adj" fmla="val 12727"/>
+            </a:avLst>
+          </a:prstGeom>
+          <a:solidFill>
+            <a:schemeClr val="bg1"/>
+          </a:solidFill>
+          <a:ln w="12700">
+            <a:solidFill>
+              <a:srgbClr val="DCE5F7"/>
+            </a:solidFill>
+            <a:prstDash val="solid"/>
+          </a:ln>
+          <a:effectLst>
+            <a:outerShdw sx="100000" sy="100000" kx="0" ky="0" algn="bl" rotWithShape="0" blurRad="127000" dist="38100" dir="5400000">
+              <a:srgbClr val="0B2A6F">
+                <a:alpha val="12000"/>
+              </a:srgbClr>
+            </a:outerShdw>
+          </a:effectLst>
+        </p:spPr>
+      </p:sp>
+      <p:sp>
+        <p:nvSpPr>
+          <p:cNvPr id="25" name="a3_346"/>
+          <p:cNvSpPr/>
+          <p:nvPr/>
+        </p:nvSpPr>
+        <p:spPr>
+          <a:xfrm>
+            <a:off x="731520" y="4087368"/>
+            <a:ext cx="603504" cy="603504"/>
+          </a:xfrm>
+          <a:prstGeom prst="ellipse">
+            <a:avLst/>
+          </a:prstGeom>
+          <a:solidFill>
+            <a:schemeClr val="accent1"/>
+          </a:solidFill>
+          <a:ln w="12700">
+            <a:solidFill>
+              <a:schemeClr val="accent1"/>
+            </a:solidFill>
+            <a:prstDash val="solid"/>
+          </a:ln>
+        </p:spPr>
+      </p:sp>
+      <p:pic>
+        <p:nvPicPr>
+          <p:cNvPr id="26" name="a3_347" descr="preencoded.png">    </p:cNvPr>
+          <p:cNvPicPr>
+            <a:picLocks noChangeAspect="1"/>
+          </p:cNvPicPr>
+          <p:nvPr/>
+        </p:nvPicPr>
+        <p:blipFill>
+          <a:blip r:embed="rId5"/>
+          <a:stretch>
+            <a:fillRect/>
+          </a:stretch>
+        </p:blipFill>
+        <p:spPr>
+          <a:xfrm>
+            <a:off x="888431" y="4244279"/>
+            <a:ext cx="289682" cy="289682"/>
+          </a:xfrm>
+          <a:prstGeom prst="rect">
+            <a:avLst/>
+          </a:prstGeom>
+        </p:spPr>
+      </p:pic>
+      <p:sp>
+        <p:nvSpPr>
+          <p:cNvPr id="27" name="a3_348"/>
+          <p:cNvSpPr txBox="1"/>
+          <p:nvPr/>
+        </p:nvSpPr>
+        <p:spPr>
+          <a:xfrm>
+            <a:off x="1508760" y="3977640"/>
+            <a:ext cx="4297680" cy="365760"/>
+          </a:xfrm>
+          <a:prstGeom prst="rect">
+            <a:avLst/>
+          </a:prstGeom>
+          <a:noFill/>
+          <a:ln/>
+        </p:spPr>
+        <p:txBody>
+          <a:bodyPr wrap="square" lIns="0" tIns="0" rIns="0" bIns="0" rtlCol="0" anchor="ctr"/>
+          <a:lstStyle/>
+          <a:p>
+            <a:pPr indent="0" marL="0">
+              <a:buNone/>
+            </a:pPr>
+            <a:r>
+              <a:rPr lang="en-US" sz="1500" b="1" dirty="0">
+                <a:solidFill>
+                  <a:schemeClr val="tx2"/>
+                </a:solidFill>
+              </a:rPr>
+              <a:t>Règles automatiques (GPO)</a:t>
+            </a:r>
+            <a:endParaRPr lang="en-US" sz="1500" dirty="0"/>
+          </a:p>
+        </p:txBody>
+      </p:sp>
+      <p:sp>
+        <p:nvSpPr>
+          <p:cNvPr id="28" name="a3_349"/>
+          <p:cNvSpPr txBox="1"/>
+          <p:nvPr/>
+        </p:nvSpPr>
+        <p:spPr>
+          <a:xfrm>
+            <a:off x="1508760" y="4325112"/>
+            <a:ext cx="4343400" cy="502920"/>
+          </a:xfrm>
+          <a:prstGeom prst="rect">
+            <a:avLst/>
+          </a:prstGeom>
+          <a:noFill/>
+          <a:ln/>
+        </p:spPr>
+        <p:txBody>
+          <a:bodyPr wrap="square" lIns="0" tIns="0" rIns="0" bIns="0" rtlCol="0" anchor="t"/>
+          <a:lstStyle/>
+          <a:p>
+            <a:pPr indent="0" marL="0">
+              <a:buNone/>
+            </a:pPr>
+            <a:r>
+              <a:rPr lang="en-US" sz="1300" dirty="0">
+                <a:solidFill>
+                  <a:schemeClr val="accent6"/>
+                </a:solidFill>
+              </a:rPr>
+              <a:t>Des réglages imposés à tous les postes : mots de passe, mises à jour, interdictions.</a:t>
+            </a:r>
+            <a:endParaRPr lang="en-US" sz="1300" dirty="0"/>
+          </a:p>
+        </p:txBody>
+      </p:sp>
+      <p:sp>
+        <p:nvSpPr>
+          <p:cNvPr id="29" name="a3_350"/>
+          <p:cNvSpPr/>
+          <p:nvPr/>
+        </p:nvSpPr>
+        <p:spPr>
+          <a:xfrm>
+            <a:off x="6172200" y="3886200"/>
+            <a:ext cx="5440680" cy="1005840"/>
+          </a:xfrm>
+          <a:prstGeom prst="roundRect">
+            <a:avLst>
+              <a:gd name="adj" fmla="val 12727"/>
+            </a:avLst>
+          </a:prstGeom>
+          <a:solidFill>
+            <a:schemeClr val="bg1"/>
+          </a:solidFill>
+          <a:ln w="12700">
+            <a:solidFill>
+              <a:srgbClr val="DCE5F7"/>
+            </a:solidFill>
+            <a:prstDash val="solid"/>
+          </a:ln>
+          <a:effectLst>
+            <a:outerShdw sx="100000" sy="100000" kx="0" ky="0" algn="bl" rotWithShape="0" blurRad="127000" dist="38100" dir="5400000">
+              <a:srgbClr val="0B2A6F">
+                <a:alpha val="12000"/>
+              </a:srgbClr>
+            </a:outerShdw>
+          </a:effectLst>
+        </p:spPr>
+      </p:sp>
+      <p:sp>
+        <p:nvSpPr>
+          <p:cNvPr id="30" name="a3_351"/>
+          <p:cNvSpPr/>
+          <p:nvPr/>
+        </p:nvSpPr>
+        <p:spPr>
+          <a:xfrm>
+            <a:off x="6355080" y="4087368"/>
+            <a:ext cx="603504" cy="603504"/>
+          </a:xfrm>
+          <a:prstGeom prst="ellipse">
+            <a:avLst/>
+          </a:prstGeom>
+          <a:solidFill>
+            <a:schemeClr val="accent1"/>
+          </a:solidFill>
+          <a:ln w="12700">
+            <a:solidFill>
+              <a:schemeClr val="accent1"/>
+            </a:solidFill>
+            <a:prstDash val="solid"/>
+          </a:ln>
+        </p:spPr>
+      </p:sp>
+      <p:pic>
+        <p:nvPicPr>
+          <p:cNvPr id="31" name="a3_352" descr="preencoded.png">    </p:cNvPr>
+          <p:cNvPicPr>
+            <a:picLocks noChangeAspect="1"/>
+          </p:cNvPicPr>
+          <p:nvPr/>
+        </p:nvPicPr>
+        <p:blipFill>
+          <a:blip r:embed="rId6"/>
+          <a:stretch>
+            <a:fillRect/>
+          </a:stretch>
+        </p:blipFill>
+        <p:spPr>
+          <a:xfrm>
+            <a:off x="6511991" y="4244279"/>
+            <a:ext cx="289682" cy="289682"/>
+          </a:xfrm>
+          <a:prstGeom prst="rect">
+            <a:avLst/>
+          </a:prstGeom>
+        </p:spPr>
+      </p:pic>
+      <p:sp>
+        <p:nvSpPr>
+          <p:cNvPr id="32" name="a3_353"/>
+          <p:cNvSpPr txBox="1"/>
+          <p:nvPr/>
+        </p:nvSpPr>
+        <p:spPr>
+          <a:xfrm>
+            <a:off x="7132320" y="3977640"/>
+            <a:ext cx="4297680" cy="365760"/>
+          </a:xfrm>
+          <a:prstGeom prst="rect">
+            <a:avLst/>
+          </a:prstGeom>
+          <a:noFill/>
+          <a:ln/>
+        </p:spPr>
+        <p:txBody>
+          <a:bodyPr wrap="square" lIns="0" tIns="0" rIns="0" bIns="0" rtlCol="0" anchor="ctr"/>
+          <a:lstStyle/>
+          <a:p>
+            <a:pPr indent="0" marL="0">
+              <a:buNone/>
+            </a:pPr>
+            <a:r>
+              <a:rPr lang="en-US" sz="1500" b="1" dirty="0">
+                <a:solidFill>
+                  <a:schemeClr val="tx2"/>
+                </a:solidFill>
+              </a:rPr>
+              <a:t>Tailscale</a:t>
+            </a:r>
+            <a:endParaRPr lang="en-US" sz="1500" dirty="0"/>
+          </a:p>
+        </p:txBody>
+      </p:sp>
+      <p:sp>
+        <p:nvSpPr>
+          <p:cNvPr id="33" name="a3_354"/>
+          <p:cNvSpPr txBox="1"/>
+          <p:nvPr/>
+        </p:nvSpPr>
+        <p:spPr>
+          <a:xfrm>
+            <a:off x="7132320" y="4325112"/>
+            <a:ext cx="4343400" cy="502920"/>
+          </a:xfrm>
+          <a:prstGeom prst="rect">
+            <a:avLst/>
+          </a:prstGeom>
+          <a:noFill/>
+          <a:ln/>
+        </p:spPr>
+        <p:txBody>
+          <a:bodyPr wrap="square" lIns="0" tIns="0" rIns="0" bIns="0" rtlCol="0" anchor="t"/>
+          <a:lstStyle/>
+          <a:p>
+            <a:pPr indent="0" marL="0">
+              <a:buNone/>
+            </a:pPr>
+            <a:r>
+              <a:rPr lang="en-US" sz="1300" dirty="0">
+                <a:solidFill>
+                  <a:schemeClr val="accent6"/>
+                </a:solidFill>
+              </a:rPr>
+              <a:t>Une connexion privée et protégée pour que l'administrateur aide à distance.</a:t>
+            </a:r>
+            <a:endParaRPr lang="en-US" sz="1300" dirty="0"/>
+          </a:p>
+        </p:txBody>
+      </p:sp>
+      <p:sp>
+        <p:nvSpPr>
+          <p:cNvPr id="34" name="a4_355"/>
+          <p:cNvSpPr/>
+          <p:nvPr/>
+        </p:nvSpPr>
+        <p:spPr>
+          <a:xfrm>
+            <a:off x="548640" y="5029200"/>
+            <a:ext cx="5440680" cy="1005840"/>
+          </a:xfrm>
+          <a:prstGeom prst="roundRect">
+            <a:avLst>
+              <a:gd name="adj" fmla="val 12727"/>
+            </a:avLst>
+          </a:prstGeom>
+          <a:solidFill>
+            <a:schemeClr val="bg1"/>
+          </a:solidFill>
+          <a:ln w="12700">
+            <a:solidFill>
+              <a:srgbClr val="DCE5F7"/>
+            </a:solidFill>
+            <a:prstDash val="solid"/>
+          </a:ln>
+          <a:effectLst>
+            <a:outerShdw sx="100000" sy="100000" kx="0" ky="0" algn="bl" rotWithShape="0" blurRad="127000" dist="38100" dir="5400000">
+              <a:srgbClr val="0B2A6F">
+                <a:alpha val="12000"/>
+              </a:srgbClr>
+            </a:outerShdw>
+          </a:effectLst>
+        </p:spPr>
+      </p:sp>
+      <p:sp>
+        <p:nvSpPr>
+          <p:cNvPr id="35" name="a4_356"/>
+          <p:cNvSpPr/>
+          <p:nvPr/>
+        </p:nvSpPr>
+        <p:spPr>
+          <a:xfrm>
+            <a:off x="731520" y="5230368"/>
+            <a:ext cx="603504" cy="603504"/>
+          </a:xfrm>
+          <a:prstGeom prst="ellipse">
+            <a:avLst/>
+          </a:prstGeom>
+          <a:solidFill>
+            <a:schemeClr val="accent1"/>
+          </a:solidFill>
+          <a:ln w="12700">
+            <a:solidFill>
+              <a:schemeClr val="accent1"/>
+            </a:solidFill>
+            <a:prstDash val="solid"/>
+          </a:ln>
+        </p:spPr>
+      </p:sp>
+      <p:pic>
+        <p:nvPicPr>
+          <p:cNvPr id="36" name="a4_357" descr="preencoded.png">    </p:cNvPr>
+          <p:cNvPicPr>
+            <a:picLocks noChangeAspect="1"/>
+          </p:cNvPicPr>
+          <p:nvPr/>
+        </p:nvPicPr>
+        <p:blipFill>
+          <a:blip r:embed="rId7"/>
+          <a:stretch>
+            <a:fillRect/>
+          </a:stretch>
+        </p:blipFill>
+        <p:spPr>
+          <a:xfrm>
+            <a:off x="888431" y="5387279"/>
+            <a:ext cx="289682" cy="289682"/>
+          </a:xfrm>
+          <a:prstGeom prst="rect">
+            <a:avLst/>
+          </a:prstGeom>
+        </p:spPr>
+      </p:pic>
+      <p:sp>
+        <p:nvSpPr>
+          <p:cNvPr id="37" name="a4_358"/>
+          <p:cNvSpPr txBox="1"/>
+          <p:nvPr/>
+        </p:nvSpPr>
+        <p:spPr>
+          <a:xfrm>
+            <a:off x="1508760" y="5120640"/>
+            <a:ext cx="4297680" cy="365760"/>
+          </a:xfrm>
+          <a:prstGeom prst="rect">
+            <a:avLst/>
+          </a:prstGeom>
+          <a:noFill/>
+          <a:ln/>
+        </p:spPr>
+        <p:txBody>
+          <a:bodyPr wrap="square" lIns="0" tIns="0" rIns="0" bIns="0" rtlCol="0" anchor="ctr"/>
+          <a:lstStyle/>
+          <a:p>
+            <a:pPr indent="0" marL="0">
+              <a:buNone/>
+            </a:pPr>
+            <a:r>
+              <a:rPr lang="en-US" sz="1500" b="1" dirty="0">
+                <a:solidFill>
+                  <a:schemeClr val="tx2"/>
+                </a:solidFill>
+              </a:rPr>
+              <a:t>Rançongiciel</a:t>
+            </a:r>
+            <a:endParaRPr lang="en-US" sz="1500" dirty="0"/>
+          </a:p>
+        </p:txBody>
+      </p:sp>
+      <p:sp>
+        <p:nvSpPr>
+          <p:cNvPr id="38" name="a4_359"/>
+          <p:cNvSpPr txBox="1"/>
+          <p:nvPr/>
+        </p:nvSpPr>
+        <p:spPr>
+          <a:xfrm>
+            <a:off x="1508760" y="5468112"/>
+            <a:ext cx="4343400" cy="502920"/>
+          </a:xfrm>
+          <a:prstGeom prst="rect">
+            <a:avLst/>
+          </a:prstGeom>
+          <a:noFill/>
+          <a:ln/>
+        </p:spPr>
+        <p:txBody>
+          <a:bodyPr wrap="square" lIns="0" tIns="0" rIns="0" bIns="0" rtlCol="0" anchor="t"/>
+          <a:lstStyle/>
+          <a:p>
+            <a:pPr indent="0" marL="0">
+              <a:buNone/>
+            </a:pPr>
+            <a:r>
+              <a:rPr lang="en-US" sz="1300" dirty="0">
+                <a:solidFill>
+                  <a:schemeClr val="accent6"/>
+                </a:solidFill>
+              </a:rPr>
+              <a:t>Un virus qui verrouille vos fichiers et demande de l'argent pour les rendre.</a:t>
+            </a:r>
+            <a:endParaRPr lang="en-US" sz="1300" dirty="0"/>
+          </a:p>
+        </p:txBody>
+      </p:sp>
+      <p:sp>
+        <p:nvSpPr>
+          <p:cNvPr id="39" name="a4_360"/>
+          <p:cNvSpPr/>
+          <p:nvPr/>
+        </p:nvSpPr>
+        <p:spPr>
+          <a:xfrm>
+            <a:off x="6172200" y="5029200"/>
+            <a:ext cx="5440680" cy="1005840"/>
+          </a:xfrm>
+          <a:prstGeom prst="roundRect">
+            <a:avLst>
+              <a:gd name="adj" fmla="val 12727"/>
+            </a:avLst>
+          </a:prstGeom>
+          <a:solidFill>
+            <a:schemeClr val="bg1"/>
+          </a:solidFill>
+          <a:ln w="12700">
+            <a:solidFill>
+              <a:srgbClr val="DCE5F7"/>
+            </a:solidFill>
+            <a:prstDash val="solid"/>
+          </a:ln>
+          <a:effectLst>
+            <a:outerShdw sx="100000" sy="100000" kx="0" ky="0" algn="bl" rotWithShape="0" blurRad="127000" dist="38100" dir="5400000">
+              <a:srgbClr val="0B2A6F">
+                <a:alpha val="12000"/>
+              </a:srgbClr>
+            </a:outerShdw>
+          </a:effectLst>
+        </p:spPr>
+      </p:sp>
+      <p:sp>
+        <p:nvSpPr>
+          <p:cNvPr id="40" name="a4_361"/>
+          <p:cNvSpPr/>
+          <p:nvPr/>
+        </p:nvSpPr>
+        <p:spPr>
+          <a:xfrm>
+            <a:off x="6355080" y="5230368"/>
+            <a:ext cx="603504" cy="603504"/>
+          </a:xfrm>
+          <a:prstGeom prst="ellipse">
+            <a:avLst/>
+          </a:prstGeom>
+          <a:solidFill>
+            <a:schemeClr val="accent1"/>
+          </a:solidFill>
+          <a:ln w="12700">
+            <a:solidFill>
+              <a:schemeClr val="accent1"/>
+            </a:solidFill>
+            <a:prstDash val="solid"/>
+          </a:ln>
+        </p:spPr>
+      </p:sp>
+      <p:pic>
+        <p:nvPicPr>
+          <p:cNvPr id="41" name="a4_362" descr="preencoded.png">    </p:cNvPr>
+          <p:cNvPicPr>
+            <a:picLocks noChangeAspect="1"/>
+          </p:cNvPicPr>
+          <p:nvPr/>
+        </p:nvPicPr>
+        <p:blipFill>
+          <a:blip r:embed="rId8"/>
+          <a:stretch>
+            <a:fillRect/>
+          </a:stretch>
+        </p:blipFill>
+        <p:spPr>
+          <a:xfrm>
+            <a:off x="6511991" y="5387279"/>
+            <a:ext cx="289682" cy="289682"/>
+          </a:xfrm>
+          <a:prstGeom prst="rect">
+            <a:avLst/>
+          </a:prstGeom>
+        </p:spPr>
+      </p:pic>
+      <p:sp>
+        <p:nvSpPr>
+          <p:cNvPr id="42" name="a4_363"/>
+          <p:cNvSpPr txBox="1"/>
+          <p:nvPr/>
+        </p:nvSpPr>
+        <p:spPr>
+          <a:xfrm>
+            <a:off x="7132320" y="5120640"/>
+            <a:ext cx="4297680" cy="365760"/>
+          </a:xfrm>
+          <a:prstGeom prst="rect">
+            <a:avLst/>
+          </a:prstGeom>
+          <a:noFill/>
+          <a:ln/>
+        </p:spPr>
+        <p:txBody>
+          <a:bodyPr wrap="square" lIns="0" tIns="0" rIns="0" bIns="0" rtlCol="0" anchor="ctr"/>
+          <a:lstStyle/>
+          <a:p>
+            <a:pPr indent="0" marL="0">
+              <a:buNone/>
+            </a:pPr>
+            <a:r>
+              <a:rPr lang="en-US" sz="1500" b="1" dirty="0">
+                <a:solidFill>
+                  <a:schemeClr val="tx2"/>
+                </a:solidFill>
+              </a:rPr>
+              <a:t>Site vitrine</a:t>
+            </a:r>
+            <a:endParaRPr lang="en-US" sz="1500" dirty="0"/>
+          </a:p>
+        </p:txBody>
+      </p:sp>
+      <p:sp>
+        <p:nvSpPr>
+          <p:cNvPr id="43" name="a4_364"/>
+          <p:cNvSpPr txBox="1"/>
+          <p:nvPr/>
+        </p:nvSpPr>
+        <p:spPr>
+          <a:xfrm>
+            <a:off x="7132320" y="5468112"/>
+            <a:ext cx="4343400" cy="502920"/>
+          </a:xfrm>
+          <a:prstGeom prst="rect">
+            <a:avLst/>
+          </a:prstGeom>
+          <a:noFill/>
+          <a:ln/>
+        </p:spPr>
+        <p:txBody>
+          <a:bodyPr wrap="square" lIns="0" tIns="0" rIns="0" bIns="0" rtlCol="0" anchor="t"/>
+          <a:lstStyle/>
+          <a:p>
+            <a:pPr indent="0" marL="0">
+              <a:buNone/>
+            </a:pPr>
+            <a:r>
+              <a:rPr lang="en-US" sz="1300" dirty="0">
+                <a:solidFill>
+                  <a:schemeClr val="accent6"/>
+                </a:solidFill>
+              </a:rPr>
+              <a:t>Votre site internet qui présente l'entreprise et permet de vous contacter.</a:t>
+            </a:r>
+            <a:endParaRPr lang="en-US" sz="1300" dirty="0"/>
+          </a:p>
+        </p:txBody>
+      </p:sp>
+      <p:sp>
+        <p:nvSpPr>
+          <p:cNvPr id="25" name="Slide Number Placeholder 0"/>
+          <p:cNvSpPr>
+            <a:spLocks noGrp="1"/>
+          </p:cNvSpPr>
+          <p:nvPr>
+            <p:ph type="sldNum" sz="quarter" idx="4294967295"/>
+          </p:nvPr>
+        </p:nvSpPr>
+        <p:spPr>
+          <a:xfrm>
+            <a:off x="11247120" y="6400800"/>
+            <a:ext cx="457200" cy="274320"/>
+          </a:xfrm>
+          <a:prstGeom prst="rect">
+            <a:avLst/>
+          </a:prstGeom>
+          <a:extLst>
+            <a:ext uri="{C572A759-6A51-4108-AA02-DFA0A04FC94B}">
+              <ma14:wrappingTextBoxFlag xmlns:ma14="http://schemas.microsoft.com/office/mac/drawingml/2011/main" val="0"/>
+            </a:ext>
+          </a:extLst>
+        </p:spPr>
+        <p:txBody>
+          <a:bodyPr/>
+          <a:lstStyle>
+            <a:lvl1pPr>
+              <a:defRPr sz="1000">
+                <a:solidFill>
+                  <a:schemeClr val="accent6"/>
+                </a:solidFill>
+              </a:defRPr>
+            </a:lvl1pPr>
+          </a:lstStyle>
+          <a:p>
+            <a:pPr algn="l"/>
+            <a:fld id="{F7021451-1387-4CA6-816F-3879F97B5CBC}" type="slidenum">
+              <a:rPr b="0" lang="en-US"/>
+              <a:t>16</a:t>
+            </a:fld>
+            <a:endParaRPr lang="en-US"/>
+          </a:p>
+        </p:txBody>
+      </p:sp>
+    </p:spTree>
+  </p:cSld>
+  <p:clrMapOvr>
+    <a:masterClrMapping/>
+  </p:clrMapOvr>
+  <p:transition spd="slow">
+    <p:fade/>
+  </p:transition>
+  <p:timing>
+    <p:tnLst>
+      <p:par>
+        <p:cTn id="1" dur="indefinite" restart="never" nodeType="tmRoot">
+          <p:childTnLst>
+            <p:seq concurrent="1" nextAc="seek">
+              <p:cTn id="2" dur="indefinite" nodeType="mainSeq">
+                <p:childTnLst>
+                  <p:par>
+                    <p:cTn id="3" fill="hold">
+                      <p:stCondLst>
+                        <p:cond delay="indefinite"/>
+                        <p:cond evt="onBegin" delay="0">
+                          <p:tn val="2"/>
+                        </p:cond>
+                      </p:stCondLst>
+                      <p:childTnLst>
+                        <p:par>
+                          <p:cTn id="4" presetID="10" presetClass="entr" presetSubtype="0" fill="hold" nodeType="withEffect">
+                            <p:stCondLst>
+                              <p:cond delay="0"/>
+                            </p:stCondLst>
+                            <p:childTnLst>
+                              <p:set>
+                                <p:cBhvr>
+                                  <p:cTn id="5" dur="1" fill="hold">
+                                    <p:stCondLst>
+                                      <p:cond delay="0"/>
+                                    </p:stCondLst>
+                                  </p:cTn>
+                                  <p:tgtEl>
+                                    <p:spTgt spid="4"/>
+                                  </p:tgtEl>
+                                  <p:attrNameLst>
+                                    <p:attrName>style.visibility</p:attrName>
+                                  </p:attrNameLst>
+                                </p:cBhvr>
+                                <p:to>
+                                  <p:strVal val="visible"/>
+                                </p:to>
+                              </p:set>
+                              <p:animEffect transition="in" filter="fade">
+                                <p:cBhvr>
+                                  <p:cTn id="6" dur="600"/>
+                                  <p:tgtEl>
+                                    <p:spTgt spid="4"/>
+                                  </p:tgtEl>
+                                </p:cBhvr>
+                              </p:animEffect>
+                              <p:anim calcmode="lin" valueType="num">
+                                <p:cBhvr>
+                                  <p:cTn id="7" dur="600" decel="100000" fill="hold"/>
+                                  <p:tgtEl>
+                                    <p:spTgt spid="4"/>
+                                  </p:tgtEl>
+                                  <p:attrNameLst>
+                                    <p:attrName>ppt_y</p:attrName>
+                                  </p:attrNameLst>
+                                </p:cBhvr>
+                                <p:tavLst>
+                                  <p:tav tm="0">
+                                    <p:val>
+                                      <p:strVal val="#ppt_y+0.03"/>
+                                    </p:val>
+                                  </p:tav>
+                                  <p:tav tm="100000">
+                                    <p:val>
+                                      <p:strVal val="#ppt_y"/>
+                                    </p:val>
+                                  </p:tav>
+                                </p:tavLst>
+                              </p:anim>
+                            </p:childTnLst>
+                          </p:cTn>
+                        </p:par>
+                        <p:par>
+                          <p:cTn id="8" presetID="10" presetClass="entr" presetSubtype="0" fill="hold" nodeType="withEffect">
+                            <p:stCondLst>
+                              <p:cond delay="60"/>
+                            </p:stCondLst>
+                            <p:childTnLst>
+                              <p:set>
+                                <p:cBhvr>
+                                  <p:cTn id="9" dur="1" fill="hold">
+                                    <p:stCondLst>
+                                      <p:cond delay="0"/>
+                                    </p:stCondLst>
+                                  </p:cTn>
+                                  <p:tgtEl>
+                                    <p:spTgt spid="5"/>
+                                  </p:tgtEl>
+                                  <p:attrNameLst>
+                                    <p:attrName>style.visibility</p:attrName>
+                                  </p:attrNameLst>
+                                </p:cBhvr>
+                                <p:to>
+                                  <p:strVal val="visible"/>
+                                </p:to>
+                              </p:set>
+                              <p:animEffect transition="in" filter="fade">
+                                <p:cBhvr>
+                                  <p:cTn id="10" dur="600"/>
+                                  <p:tgtEl>
+                                    <p:spTgt spid="5"/>
+                                  </p:tgtEl>
+                                </p:cBhvr>
+                              </p:animEffect>
+                              <p:anim calcmode="lin" valueType="num">
+                                <p:cBhvr>
+                                  <p:cTn id="11" dur="600" decel="100000" fill="hold"/>
+                                  <p:tgtEl>
+                                    <p:spTgt spid="5"/>
+                                  </p:tgtEl>
+                                  <p:attrNameLst>
+                                    <p:attrName>ppt_y</p:attrName>
+                                  </p:attrNameLst>
+                                </p:cBhvr>
+                                <p:tavLst>
+                                  <p:tav tm="0">
+                                    <p:val>
+                                      <p:strVal val="#ppt_y+0.03"/>
+                                    </p:val>
+                                  </p:tav>
+                                  <p:tav tm="100000">
+                                    <p:val>
+                                      <p:strVal val="#ppt_y"/>
+                                    </p:val>
+                                  </p:tav>
+                                </p:tavLst>
+                              </p:anim>
+                            </p:childTnLst>
+                          </p:cTn>
+                        </p:par>
+                        <p:par>
+                          <p:cTn id="12" presetID="10" presetClass="entr" presetSubtype="0" fill="hold" nodeType="withEffect">
+                            <p:stCondLst>
+                              <p:cond delay="120"/>
+                            </p:stCondLst>
+                            <p:childTnLst>
+                              <p:set>
+                                <p:cBhvr>
+                                  <p:cTn id="13" dur="1" fill="hold">
+                                    <p:stCondLst>
+                                      <p:cond delay="0"/>
+                                    </p:stCondLst>
+                                  </p:cTn>
+                                  <p:tgtEl>
+                                    <p:spTgt spid="6"/>
+                                  </p:tgtEl>
+                                  <p:attrNameLst>
+                                    <p:attrName>style.visibility</p:attrName>
+                                  </p:attrNameLst>
+                                </p:cBhvr>
+                                <p:to>
+                                  <p:strVal val="visible"/>
+                                </p:to>
+                              </p:set>
+                              <p:animEffect transition="in" filter="fade">
+                                <p:cBhvr>
+                                  <p:cTn id="14" dur="600"/>
+                                  <p:tgtEl>
+                                    <p:spTgt spid="6"/>
+                                  </p:tgtEl>
+                                </p:cBhvr>
+                              </p:animEffect>
+                              <p:anim calcmode="lin" valueType="num">
+                                <p:cBhvr>
+                                  <p:cTn id="15" dur="600" decel="100000" fill="hold"/>
+                                  <p:tgtEl>
+                                    <p:spTgt spid="6"/>
+                                  </p:tgtEl>
+                                  <p:attrNameLst>
+                                    <p:attrName>ppt_y</p:attrName>
+                                  </p:attrNameLst>
+                                </p:cBhvr>
+                                <p:tavLst>
+                                  <p:tav tm="0">
+                                    <p:val>
+                                      <p:strVal val="#ppt_y+0.03"/>
+                                    </p:val>
+                                  </p:tav>
+                                  <p:tav tm="100000">
+                                    <p:val>
+                                      <p:strVal val="#ppt_y"/>
+                                    </p:val>
+                                  </p:tav>
+                                </p:tavLst>
+                              </p:anim>
+                            </p:childTnLst>
+                          </p:cTn>
+                        </p:par>
+                        <p:par>
+                          <p:cTn id="16" presetID="10" presetClass="entr" presetSubtype="0" fill="hold" nodeType="withEffect">
+                            <p:stCondLst>
+                              <p:cond delay="180"/>
+                            </p:stCondLst>
+                            <p:childTnLst>
+                              <p:set>
+                                <p:cBhvr>
+                                  <p:cTn id="17" dur="1" fill="hold">
+                                    <p:stCondLst>
+                                      <p:cond delay="0"/>
+                                    </p:stCondLst>
+                                  </p:cTn>
+                                  <p:tgtEl>
+                                    <p:spTgt spid="7"/>
+                                  </p:tgtEl>
+                                  <p:attrNameLst>
+                                    <p:attrName>style.visibility</p:attrName>
+                                  </p:attrNameLst>
+                                </p:cBhvr>
+                                <p:to>
+                                  <p:strVal val="visible"/>
+                                </p:to>
+                              </p:set>
+                              <p:animEffect transition="in" filter="fade">
+                                <p:cBhvr>
+                                  <p:cTn id="18" dur="600"/>
+                                  <p:tgtEl>
+                                    <p:spTgt spid="7"/>
+                                  </p:tgtEl>
+                                </p:cBhvr>
+                              </p:animEffect>
+                              <p:anim calcmode="lin" valueType="num">
+                                <p:cBhvr>
+                                  <p:cTn id="19" dur="600" decel="100000" fill="hold"/>
+                                  <p:tgtEl>
+                                    <p:spTgt spid="7"/>
+                                  </p:tgtEl>
+                                  <p:attrNameLst>
+                                    <p:attrName>ppt_y</p:attrName>
+                                  </p:attrNameLst>
+                                </p:cBhvr>
+                                <p:tavLst>
+                                  <p:tav tm="0">
+                                    <p:val>
+                                      <p:strVal val="#ppt_y+0.03"/>
+                                    </p:val>
+                                  </p:tav>
+                                  <p:tav tm="100000">
+                                    <p:val>
+                                      <p:strVal val="#ppt_y"/>
+                                    </p:val>
+                                  </p:tav>
+                                </p:tavLst>
+                              </p:anim>
+                            </p:childTnLst>
+                          </p:cTn>
+                        </p:par>
+                        <p:par>
+                          <p:cTn id="20" presetID="10" presetClass="entr" presetSubtype="0" fill="hold" nodeType="withEffect">
+                            <p:stCondLst>
+                              <p:cond delay="240"/>
+                            </p:stCondLst>
+                            <p:childTnLst>
+                              <p:set>
+                                <p:cBhvr>
+                                  <p:cTn id="21" dur="1" fill="hold">
+                                    <p:stCondLst>
+                                      <p:cond delay="0"/>
+                                    </p:stCondLst>
+                                  </p:cTn>
+                                  <p:tgtEl>
+                                    <p:spTgt spid="8"/>
+                                  </p:tgtEl>
+                                  <p:attrNameLst>
+                                    <p:attrName>style.visibility</p:attrName>
+                                  </p:attrNameLst>
+                                </p:cBhvr>
+                                <p:to>
+                                  <p:strVal val="visible"/>
+                                </p:to>
+                              </p:set>
+                              <p:animEffect transition="in" filter="fade">
+                                <p:cBhvr>
+                                  <p:cTn id="22" dur="600"/>
+                                  <p:tgtEl>
+                                    <p:spTgt spid="8"/>
+                                  </p:tgtEl>
+                                </p:cBhvr>
+                              </p:animEffect>
+                              <p:anim calcmode="lin" valueType="num">
+                                <p:cBhvr>
+                                  <p:cTn id="23" dur="600" decel="100000" fill="hold"/>
+                                  <p:tgtEl>
+                                    <p:spTgt spid="8"/>
+                                  </p:tgtEl>
+                                  <p:attrNameLst>
+                                    <p:attrName>ppt_y</p:attrName>
+                                  </p:attrNameLst>
+                                </p:cBhvr>
+                                <p:tavLst>
+                                  <p:tav tm="0">
+                                    <p:val>
+                                      <p:strVal val="#ppt_y+0.03"/>
+                                    </p:val>
+                                  </p:tav>
+                                  <p:tav tm="100000">
+                                    <p:val>
+                                      <p:strVal val="#ppt_y"/>
+                                    </p:val>
+                                  </p:tav>
+                                </p:tavLst>
+                              </p:anim>
+                            </p:childTnLst>
+                          </p:cTn>
+                        </p:par>
+                        <p:par>
+                          <p:cTn id="24" presetID="10" presetClass="entr" presetSubtype="0" fill="hold" nodeType="withEffect">
+                            <p:stCondLst>
+                              <p:cond delay="300"/>
+                            </p:stCondLst>
+                            <p:childTnLst>
+                              <p:set>
+                                <p:cBhvr>
+                                  <p:cTn id="25" dur="1" fill="hold">
+                                    <p:stCondLst>
+                                      <p:cond delay="0"/>
+                                    </p:stCondLst>
+                                  </p:cTn>
+                                  <p:tgtEl>
+                                    <p:spTgt spid="9"/>
+                                  </p:tgtEl>
+                                  <p:attrNameLst>
+                                    <p:attrName>style.visibility</p:attrName>
+                                  </p:attrNameLst>
+                                </p:cBhvr>
+                                <p:to>
+                                  <p:strVal val="visible"/>
+                                </p:to>
+                              </p:set>
+                              <p:animEffect transition="in" filter="fade">
+                                <p:cBhvr>
+                                  <p:cTn id="26" dur="600"/>
+                                  <p:tgtEl>
+                                    <p:spTgt spid="9"/>
+                                  </p:tgtEl>
+                                </p:cBhvr>
+                              </p:animEffect>
+                              <p:anim calcmode="lin" valueType="num">
+                                <p:cBhvr>
+                                  <p:cTn id="27" dur="600" decel="100000" fill="hold"/>
+                                  <p:tgtEl>
+                                    <p:spTgt spid="9"/>
+                                  </p:tgtEl>
+                                  <p:attrNameLst>
+                                    <p:attrName>ppt_y</p:attrName>
+                                  </p:attrNameLst>
+                                </p:cBhvr>
+                                <p:tavLst>
+                                  <p:tav tm="0">
+                                    <p:val>
+                                      <p:strVal val="#ppt_y+0.03"/>
+                                    </p:val>
+                                  </p:tav>
+                                  <p:tav tm="100000">
+                                    <p:val>
+                                      <p:strVal val="#ppt_y"/>
+                                    </p:val>
+                                  </p:tav>
+                                </p:tavLst>
+                              </p:anim>
+                            </p:childTnLst>
+                          </p:cTn>
+                        </p:par>
+                        <p:par>
+                          <p:cTn id="28" presetID="10" presetClass="entr" presetSubtype="0" fill="hold" nodeType="withEffect">
+                            <p:stCondLst>
+                              <p:cond delay="360"/>
+                            </p:stCondLst>
+                            <p:childTnLst>
+                              <p:set>
+                                <p:cBhvr>
+                                  <p:cTn id="29" dur="1" fill="hold">
+                                    <p:stCondLst>
+                                      <p:cond delay="0"/>
+                                    </p:stCondLst>
+                                  </p:cTn>
+                                  <p:tgtEl>
+                                    <p:spTgt spid="10"/>
+                                  </p:tgtEl>
+                                  <p:attrNameLst>
+                                    <p:attrName>style.visibility</p:attrName>
+                                  </p:attrNameLst>
+                                </p:cBhvr>
+                                <p:to>
+                                  <p:strVal val="visible"/>
+                                </p:to>
+                              </p:set>
+                              <p:animEffect transition="in" filter="fade">
+                                <p:cBhvr>
+                                  <p:cTn id="30" dur="600"/>
+                                  <p:tgtEl>
+                                    <p:spTgt spid="10"/>
+                                  </p:tgtEl>
+                                </p:cBhvr>
+                              </p:animEffect>
+                              <p:anim calcmode="lin" valueType="num">
+                                <p:cBhvr>
+                                  <p:cTn id="31" dur="600" decel="100000" fill="hold"/>
+                                  <p:tgtEl>
+                                    <p:spTgt spid="10"/>
+                                  </p:tgtEl>
+                                  <p:attrNameLst>
+                                    <p:attrName>ppt_y</p:attrName>
+                                  </p:attrNameLst>
+                                </p:cBhvr>
+                                <p:tavLst>
+                                  <p:tav tm="0">
+                                    <p:val>
+                                      <p:strVal val="#ppt_y+0.03"/>
+                                    </p:val>
+                                  </p:tav>
+                                  <p:tav tm="100000">
+                                    <p:val>
+                                      <p:strVal val="#ppt_y"/>
+                                    </p:val>
+                                  </p:tav>
+                                </p:tavLst>
+                              </p:anim>
+                            </p:childTnLst>
+                          </p:cTn>
+                        </p:par>
+                        <p:par>
+                          <p:cTn id="32" presetID="10" presetClass="entr" presetSubtype="0" fill="hold" nodeType="withEffect">
+                            <p:stCondLst>
+                              <p:cond delay="420"/>
+                            </p:stCondLst>
+                            <p:childTnLst>
+                              <p:set>
+                                <p:cBhvr>
+                                  <p:cTn id="33" dur="1" fill="hold">
+                                    <p:stCondLst>
+                                      <p:cond delay="0"/>
+                                    </p:stCondLst>
+                                  </p:cTn>
+                                  <p:tgtEl>
+                                    <p:spTgt spid="11"/>
+                                  </p:tgtEl>
+                                  <p:attrNameLst>
+                                    <p:attrName>style.visibility</p:attrName>
+                                  </p:attrNameLst>
+                                </p:cBhvr>
+                                <p:to>
+                                  <p:strVal val="visible"/>
+                                </p:to>
+                              </p:set>
+                              <p:animEffect transition="in" filter="fade">
+                                <p:cBhvr>
+                                  <p:cTn id="34" dur="600"/>
+                                  <p:tgtEl>
+                                    <p:spTgt spid="11"/>
+                                  </p:tgtEl>
+                                </p:cBhvr>
+                              </p:animEffect>
+                              <p:anim calcmode="lin" valueType="num">
+                                <p:cBhvr>
+                                  <p:cTn id="35" dur="600" decel="100000" fill="hold"/>
+                                  <p:tgtEl>
+                                    <p:spTgt spid="11"/>
+                                  </p:tgtEl>
+                                  <p:attrNameLst>
+                                    <p:attrName>ppt_y</p:attrName>
+                                  </p:attrNameLst>
+                                </p:cBhvr>
+                                <p:tavLst>
+                                  <p:tav tm="0">
+                                    <p:val>
+                                      <p:strVal val="#ppt_y+0.03"/>
+                                    </p:val>
+                                  </p:tav>
+                                  <p:tav tm="100000">
+                                    <p:val>
+                                      <p:strVal val="#ppt_y"/>
+                                    </p:val>
+                                  </p:tav>
+                                </p:tavLst>
+                              </p:anim>
+                            </p:childTnLst>
+                          </p:cTn>
+                        </p:par>
+                        <p:par>
+                          <p:cTn id="36" presetID="10" presetClass="entr" presetSubtype="0" fill="hold" nodeType="withEffect">
+                            <p:stCondLst>
+                              <p:cond delay="480"/>
+                            </p:stCondLst>
+                            <p:childTnLst>
+                              <p:set>
+                                <p:cBhvr>
+                                  <p:cTn id="37" dur="1" fill="hold">
+                                    <p:stCondLst>
+                                      <p:cond delay="0"/>
+                                    </p:stCondLst>
+                                  </p:cTn>
+                                  <p:tgtEl>
+                                    <p:spTgt spid="12"/>
+                                  </p:tgtEl>
+                                  <p:attrNameLst>
+                                    <p:attrName>style.visibility</p:attrName>
+                                  </p:attrNameLst>
+                                </p:cBhvr>
+                                <p:to>
+                                  <p:strVal val="visible"/>
+                                </p:to>
+                              </p:set>
+                              <p:animEffect transition="in" filter="fade">
+                                <p:cBhvr>
+                                  <p:cTn id="38" dur="600"/>
+                                  <p:tgtEl>
+                                    <p:spTgt spid="12"/>
+                                  </p:tgtEl>
+                                </p:cBhvr>
+                              </p:animEffect>
+                              <p:anim calcmode="lin" valueType="num">
+                                <p:cBhvr>
+                                  <p:cTn id="39" dur="600" decel="100000" fill="hold"/>
+                                  <p:tgtEl>
+                                    <p:spTgt spid="12"/>
+                                  </p:tgtEl>
+                                  <p:attrNameLst>
+                                    <p:attrName>ppt_y</p:attrName>
+                                  </p:attrNameLst>
+                                </p:cBhvr>
+                                <p:tavLst>
+                                  <p:tav tm="0">
+                                    <p:val>
+                                      <p:strVal val="#ppt_y+0.03"/>
+                                    </p:val>
+                                  </p:tav>
+                                  <p:tav tm="100000">
+                                    <p:val>
+                                      <p:strVal val="#ppt_y"/>
+                                    </p:val>
+                                  </p:tav>
+                                </p:tavLst>
+                              </p:anim>
+                            </p:childTnLst>
+                          </p:cTn>
+                        </p:par>
+                        <p:par>
+                          <p:cTn id="40" presetID="10" presetClass="entr" presetSubtype="0" fill="hold" nodeType="withEffect">
+                            <p:stCondLst>
+                              <p:cond delay="540"/>
+                            </p:stCondLst>
+                            <p:childTnLst>
+                              <p:set>
+                                <p:cBhvr>
+                                  <p:cTn id="41" dur="1" fill="hold">
+                                    <p:stCondLst>
+                                      <p:cond delay="0"/>
+                                    </p:stCondLst>
+                                  </p:cTn>
+                                  <p:tgtEl>
+                                    <p:spTgt spid="13"/>
+                                  </p:tgtEl>
+                                  <p:attrNameLst>
+                                    <p:attrName>style.visibility</p:attrName>
+                                  </p:attrNameLst>
+                                </p:cBhvr>
+                                <p:to>
+                                  <p:strVal val="visible"/>
+                                </p:to>
+                              </p:set>
+                              <p:animEffect transition="in" filter="fade">
+                                <p:cBhvr>
+                                  <p:cTn id="42" dur="600"/>
+                                  <p:tgtEl>
+                                    <p:spTgt spid="13"/>
+                                  </p:tgtEl>
+                                </p:cBhvr>
+                              </p:animEffect>
+                              <p:anim calcmode="lin" valueType="num">
+                                <p:cBhvr>
+                                  <p:cTn id="43" dur="600" decel="100000" fill="hold"/>
+                                  <p:tgtEl>
+                                    <p:spTgt spid="13"/>
+                                  </p:tgtEl>
+                                  <p:attrNameLst>
+                                    <p:attrName>ppt_y</p:attrName>
+                                  </p:attrNameLst>
+                                </p:cBhvr>
+                                <p:tavLst>
+                                  <p:tav tm="0">
+                                    <p:val>
+                                      <p:strVal val="#ppt_y+0.03"/>
+                                    </p:val>
+                                  </p:tav>
+                                  <p:tav tm="100000">
+                                    <p:val>
+                                      <p:strVal val="#ppt_y"/>
+                                    </p:val>
+                                  </p:tav>
+                                </p:tavLst>
+                              </p:anim>
+                            </p:childTnLst>
+                          </p:cTn>
+                        </p:par>
+                        <p:par>
+                          <p:cTn id="44" presetID="10" presetClass="entr" presetSubtype="0" fill="hold" nodeType="withEffect">
+                            <p:stCondLst>
+                              <p:cond delay="450"/>
+                            </p:stCondLst>
+                            <p:childTnLst>
+                              <p:set>
+                                <p:cBhvr>
+                                  <p:cTn id="45" dur="1" fill="hold">
+                                    <p:stCondLst>
+                                      <p:cond delay="0"/>
+                                    </p:stCondLst>
+                                  </p:cTn>
+                                  <p:tgtEl>
+                                    <p:spTgt spid="14"/>
+                                  </p:tgtEl>
+                                  <p:attrNameLst>
+                                    <p:attrName>style.visibility</p:attrName>
+                                  </p:attrNameLst>
+                                </p:cBhvr>
+                                <p:to>
+                                  <p:strVal val="visible"/>
+                                </p:to>
+                              </p:set>
+                              <p:animEffect transition="in" filter="fade">
+                                <p:cBhvr>
+                                  <p:cTn id="46" dur="600"/>
+                                  <p:tgtEl>
+                                    <p:spTgt spid="14"/>
+                                  </p:tgtEl>
+                                </p:cBhvr>
+                              </p:animEffect>
+                              <p:anim calcmode="lin" valueType="num">
+                                <p:cBhvr>
+                                  <p:cTn id="47" dur="600" decel="100000" fill="hold"/>
+                                  <p:tgtEl>
+                                    <p:spTgt spid="14"/>
+                                  </p:tgtEl>
+                                  <p:attrNameLst>
+                                    <p:attrName>ppt_y</p:attrName>
+                                  </p:attrNameLst>
+                                </p:cBhvr>
+                                <p:tavLst>
+                                  <p:tav tm="0">
+                                    <p:val>
+                                      <p:strVal val="#ppt_y+0.03"/>
+                                    </p:val>
+                                  </p:tav>
+                                  <p:tav tm="100000">
+                                    <p:val>
+                                      <p:strVal val="#ppt_y"/>
+                                    </p:val>
+                                  </p:tav>
+                                </p:tavLst>
+                              </p:anim>
+                            </p:childTnLst>
+                          </p:cTn>
+                        </p:par>
+                        <p:par>
+                          <p:cTn id="48" presetID="10" presetClass="entr" presetSubtype="0" fill="hold" nodeType="withEffect">
+                            <p:stCondLst>
+                              <p:cond delay="510"/>
+                            </p:stCondLst>
+                            <p:childTnLst>
+                              <p:set>
+                                <p:cBhvr>
+                                  <p:cTn id="49" dur="1" fill="hold">
+                                    <p:stCondLst>
+                                      <p:cond delay="0"/>
+                                    </p:stCondLst>
+                                  </p:cTn>
+                                  <p:tgtEl>
+                                    <p:spTgt spid="15"/>
+                                  </p:tgtEl>
+                                  <p:attrNameLst>
+                                    <p:attrName>style.visibility</p:attrName>
+                                  </p:attrNameLst>
+                                </p:cBhvr>
+                                <p:to>
+                                  <p:strVal val="visible"/>
+                                </p:to>
+                              </p:set>
+                              <p:animEffect transition="in" filter="fade">
+                                <p:cBhvr>
+                                  <p:cTn id="50" dur="600"/>
+                                  <p:tgtEl>
+                                    <p:spTgt spid="15"/>
+                                  </p:tgtEl>
+                                </p:cBhvr>
+                              </p:animEffect>
+                              <p:anim calcmode="lin" valueType="num">
+                                <p:cBhvr>
+                                  <p:cTn id="51" dur="600" decel="100000" fill="hold"/>
+                                  <p:tgtEl>
+                                    <p:spTgt spid="15"/>
+                                  </p:tgtEl>
+                                  <p:attrNameLst>
+                                    <p:attrName>ppt_y</p:attrName>
+                                  </p:attrNameLst>
+                                </p:cBhvr>
+                                <p:tavLst>
+                                  <p:tav tm="0">
+                                    <p:val>
+                                      <p:strVal val="#ppt_y+0.03"/>
+                                    </p:val>
+                                  </p:tav>
+                                  <p:tav tm="100000">
+                                    <p:val>
+                                      <p:strVal val="#ppt_y"/>
+                                    </p:val>
+                                  </p:tav>
+                                </p:tavLst>
+                              </p:anim>
+                            </p:childTnLst>
+                          </p:cTn>
+                        </p:par>
+                        <p:par>
+                          <p:cTn id="52" presetID="10" presetClass="entr" presetSubtype="0" fill="hold" nodeType="withEffect">
+                            <p:stCondLst>
+                              <p:cond delay="570"/>
+                            </p:stCondLst>
+                            <p:childTnLst>
+                              <p:set>
+                                <p:cBhvr>
+                                  <p:cTn id="53" dur="1" fill="hold">
+                                    <p:stCondLst>
+                                      <p:cond delay="0"/>
+                                    </p:stCondLst>
+                                  </p:cTn>
+                                  <p:tgtEl>
+                                    <p:spTgt spid="16"/>
+                                  </p:tgtEl>
+                                  <p:attrNameLst>
+                                    <p:attrName>style.visibility</p:attrName>
+                                  </p:attrNameLst>
+                                </p:cBhvr>
+                                <p:to>
+                                  <p:strVal val="visible"/>
+                                </p:to>
+                              </p:set>
+                              <p:animEffect transition="in" filter="fade">
+                                <p:cBhvr>
+                                  <p:cTn id="54" dur="600"/>
+                                  <p:tgtEl>
+                                    <p:spTgt spid="16"/>
+                                  </p:tgtEl>
+                                </p:cBhvr>
+                              </p:animEffect>
+                              <p:anim calcmode="lin" valueType="num">
+                                <p:cBhvr>
+                                  <p:cTn id="55" dur="600" decel="100000" fill="hold"/>
+                                  <p:tgtEl>
+                                    <p:spTgt spid="16"/>
+                                  </p:tgtEl>
+                                  <p:attrNameLst>
+                                    <p:attrName>ppt_y</p:attrName>
+                                  </p:attrNameLst>
+                                </p:cBhvr>
+                                <p:tavLst>
+                                  <p:tav tm="0">
+                                    <p:val>
+                                      <p:strVal val="#ppt_y+0.03"/>
+                                    </p:val>
+                                  </p:tav>
+                                  <p:tav tm="100000">
+                                    <p:val>
+                                      <p:strVal val="#ppt_y"/>
+                                    </p:val>
+                                  </p:tav>
+                                </p:tavLst>
+                              </p:anim>
+                            </p:childTnLst>
+                          </p:cTn>
+                        </p:par>
+                        <p:par>
+                          <p:cTn id="56" presetID="10" presetClass="entr" presetSubtype="0" fill="hold" nodeType="withEffect">
+                            <p:stCondLst>
+                              <p:cond delay="630"/>
+                            </p:stCondLst>
+                            <p:childTnLst>
+                              <p:set>
+                                <p:cBhvr>
+                                  <p:cTn id="57" dur="1" fill="hold">
+                                    <p:stCondLst>
+                                      <p:cond delay="0"/>
+                                    </p:stCondLst>
+                                  </p:cTn>
+                                  <p:tgtEl>
+                                    <p:spTgt spid="17"/>
+                                  </p:tgtEl>
+                                  <p:attrNameLst>
+                                    <p:attrName>style.visibility</p:attrName>
+                                  </p:attrNameLst>
+                                </p:cBhvr>
+                                <p:to>
+                                  <p:strVal val="visible"/>
+                                </p:to>
+                              </p:set>
+                              <p:animEffect transition="in" filter="fade">
+                                <p:cBhvr>
+                                  <p:cTn id="58" dur="600"/>
+                                  <p:tgtEl>
+                                    <p:spTgt spid="17"/>
+                                  </p:tgtEl>
+                                </p:cBhvr>
+                              </p:animEffect>
+                              <p:anim calcmode="lin" valueType="num">
+                                <p:cBhvr>
+                                  <p:cTn id="59" dur="600" decel="100000" fill="hold"/>
+                                  <p:tgtEl>
+                                    <p:spTgt spid="17"/>
+                                  </p:tgtEl>
+                                  <p:attrNameLst>
+                                    <p:attrName>ppt_y</p:attrName>
+                                  </p:attrNameLst>
+                                </p:cBhvr>
+                                <p:tavLst>
+                                  <p:tav tm="0">
+                                    <p:val>
+                                      <p:strVal val="#ppt_y+0.03"/>
+                                    </p:val>
+                                  </p:tav>
+                                  <p:tav tm="100000">
+                                    <p:val>
+                                      <p:strVal val="#ppt_y"/>
+                                    </p:val>
+                                  </p:tav>
+                                </p:tavLst>
+                              </p:anim>
+                            </p:childTnLst>
+                          </p:cTn>
+                        </p:par>
+                        <p:par>
+                          <p:cTn id="60" presetID="10" presetClass="entr" presetSubtype="0" fill="hold" nodeType="withEffect">
+                            <p:stCondLst>
+                              <p:cond delay="690"/>
+                            </p:stCondLst>
+                            <p:childTnLst>
+                              <p:set>
+                                <p:cBhvr>
+                                  <p:cTn id="61" dur="1" fill="hold">
+                                    <p:stCondLst>
+                                      <p:cond delay="0"/>
+                                    </p:stCondLst>
+                                  </p:cTn>
+                                  <p:tgtEl>
+                                    <p:spTgt spid="18"/>
+                                  </p:tgtEl>
+                                  <p:attrNameLst>
+                                    <p:attrName>style.visibility</p:attrName>
+                                  </p:attrNameLst>
+                                </p:cBhvr>
+                                <p:to>
+                                  <p:strVal val="visible"/>
+                                </p:to>
+                              </p:set>
+                              <p:animEffect transition="in" filter="fade">
+                                <p:cBhvr>
+                                  <p:cTn id="62" dur="600"/>
+                                  <p:tgtEl>
+                                    <p:spTgt spid="18"/>
+                                  </p:tgtEl>
+                                </p:cBhvr>
+                              </p:animEffect>
+                              <p:anim calcmode="lin" valueType="num">
+                                <p:cBhvr>
+                                  <p:cTn id="63" dur="600" decel="100000" fill="hold"/>
+                                  <p:tgtEl>
+                                    <p:spTgt spid="18"/>
+                                  </p:tgtEl>
+                                  <p:attrNameLst>
+                                    <p:attrName>ppt_y</p:attrName>
+                                  </p:attrNameLst>
+                                </p:cBhvr>
+                                <p:tavLst>
+                                  <p:tav tm="0">
+                                    <p:val>
+                                      <p:strVal val="#ppt_y+0.03"/>
+                                    </p:val>
+                                  </p:tav>
+                                  <p:tav tm="100000">
+                                    <p:val>
+                                      <p:strVal val="#ppt_y"/>
+                                    </p:val>
+                                  </p:tav>
+                                </p:tavLst>
+                              </p:anim>
+                            </p:childTnLst>
+                          </p:cTn>
+                        </p:par>
+                        <p:par>
+                          <p:cTn id="64" presetID="10" presetClass="entr" presetSubtype="0" fill="hold" nodeType="withEffect">
+                            <p:stCondLst>
+                              <p:cond delay="750"/>
+                            </p:stCondLst>
+                            <p:childTnLst>
+                              <p:set>
+                                <p:cBhvr>
+                                  <p:cTn id="65" dur="1" fill="hold">
+                                    <p:stCondLst>
+                                      <p:cond delay="0"/>
+                                    </p:stCondLst>
+                                  </p:cTn>
+                                  <p:tgtEl>
+                                    <p:spTgt spid="19"/>
+                                  </p:tgtEl>
+                                  <p:attrNameLst>
+                                    <p:attrName>style.visibility</p:attrName>
+                                  </p:attrNameLst>
+                                </p:cBhvr>
+                                <p:to>
+                                  <p:strVal val="visible"/>
+                                </p:to>
+                              </p:set>
+                              <p:animEffect transition="in" filter="fade">
+                                <p:cBhvr>
+                                  <p:cTn id="66" dur="600"/>
+                                  <p:tgtEl>
+                                    <p:spTgt spid="19"/>
+                                  </p:tgtEl>
+                                </p:cBhvr>
+                              </p:animEffect>
+                              <p:anim calcmode="lin" valueType="num">
+                                <p:cBhvr>
+                                  <p:cTn id="67" dur="600" decel="100000" fill="hold"/>
+                                  <p:tgtEl>
+                                    <p:spTgt spid="19"/>
+                                  </p:tgtEl>
+                                  <p:attrNameLst>
+                                    <p:attrName>ppt_y</p:attrName>
+                                  </p:attrNameLst>
+                                </p:cBhvr>
+                                <p:tavLst>
+                                  <p:tav tm="0">
+                                    <p:val>
+                                      <p:strVal val="#ppt_y+0.03"/>
+                                    </p:val>
+                                  </p:tav>
+                                  <p:tav tm="100000">
+                                    <p:val>
+                                      <p:strVal val="#ppt_y"/>
+                                    </p:val>
+                                  </p:tav>
+                                </p:tavLst>
+                              </p:anim>
+                            </p:childTnLst>
+                          </p:cTn>
+                        </p:par>
+                        <p:par>
+                          <p:cTn id="68" presetID="10" presetClass="entr" presetSubtype="0" fill="hold" nodeType="withEffect">
+                            <p:stCondLst>
+                              <p:cond delay="810"/>
+                            </p:stCondLst>
+                            <p:childTnLst>
+                              <p:set>
+                                <p:cBhvr>
+                                  <p:cTn id="69" dur="1" fill="hold">
+                                    <p:stCondLst>
+                                      <p:cond delay="0"/>
+                                    </p:stCondLst>
+                                  </p:cTn>
+                                  <p:tgtEl>
+                                    <p:spTgt spid="20"/>
+                                  </p:tgtEl>
+                                  <p:attrNameLst>
+                                    <p:attrName>style.visibility</p:attrName>
+                                  </p:attrNameLst>
+                                </p:cBhvr>
+                                <p:to>
+                                  <p:strVal val="visible"/>
+                                </p:to>
+                              </p:set>
+                              <p:animEffect transition="in" filter="fade">
+                                <p:cBhvr>
+                                  <p:cTn id="70" dur="600"/>
+                                  <p:tgtEl>
+                                    <p:spTgt spid="20"/>
+                                  </p:tgtEl>
+                                </p:cBhvr>
+                              </p:animEffect>
+                              <p:anim calcmode="lin" valueType="num">
+                                <p:cBhvr>
+                                  <p:cTn id="71" dur="600" decel="100000" fill="hold"/>
+                                  <p:tgtEl>
+                                    <p:spTgt spid="20"/>
+                                  </p:tgtEl>
+                                  <p:attrNameLst>
+                                    <p:attrName>ppt_y</p:attrName>
+                                  </p:attrNameLst>
+                                </p:cBhvr>
+                                <p:tavLst>
+                                  <p:tav tm="0">
+                                    <p:val>
+                                      <p:strVal val="#ppt_y+0.03"/>
+                                    </p:val>
+                                  </p:tav>
+                                  <p:tav tm="100000">
+                                    <p:val>
+                                      <p:strVal val="#ppt_y"/>
+                                    </p:val>
+                                  </p:tav>
+                                </p:tavLst>
+                              </p:anim>
+                            </p:childTnLst>
+                          </p:cTn>
+                        </p:par>
+                        <p:par>
+                          <p:cTn id="72" presetID="10" presetClass="entr" presetSubtype="0" fill="hold" nodeType="withEffect">
+                            <p:stCondLst>
+                              <p:cond delay="870"/>
+                            </p:stCondLst>
+                            <p:childTnLst>
+                              <p:set>
+                                <p:cBhvr>
+                                  <p:cTn id="73" dur="1" fill="hold">
+                                    <p:stCondLst>
+                                      <p:cond delay="0"/>
+                                    </p:stCondLst>
+                                  </p:cTn>
+                                  <p:tgtEl>
+                                    <p:spTgt spid="21"/>
+                                  </p:tgtEl>
+                                  <p:attrNameLst>
+                                    <p:attrName>style.visibility</p:attrName>
+                                  </p:attrNameLst>
+                                </p:cBhvr>
+                                <p:to>
+                                  <p:strVal val="visible"/>
+                                </p:to>
+                              </p:set>
+                              <p:animEffect transition="in" filter="fade">
+                                <p:cBhvr>
+                                  <p:cTn id="74" dur="600"/>
+                                  <p:tgtEl>
+                                    <p:spTgt spid="21"/>
+                                  </p:tgtEl>
+                                </p:cBhvr>
+                              </p:animEffect>
+                              <p:anim calcmode="lin" valueType="num">
+                                <p:cBhvr>
+                                  <p:cTn id="75" dur="600" decel="100000" fill="hold"/>
+                                  <p:tgtEl>
+                                    <p:spTgt spid="21"/>
+                                  </p:tgtEl>
+                                  <p:attrNameLst>
+                                    <p:attrName>ppt_y</p:attrName>
+                                  </p:attrNameLst>
+                                </p:cBhvr>
+                                <p:tavLst>
+                                  <p:tav tm="0">
+                                    <p:val>
+                                      <p:strVal val="#ppt_y+0.03"/>
+                                    </p:val>
+                                  </p:tav>
+                                  <p:tav tm="100000">
+                                    <p:val>
+                                      <p:strVal val="#ppt_y"/>
+                                    </p:val>
+                                  </p:tav>
+                                </p:tavLst>
+                              </p:anim>
+                            </p:childTnLst>
+                          </p:cTn>
+                        </p:par>
+                        <p:par>
+                          <p:cTn id="76" presetID="10" presetClass="entr" presetSubtype="0" fill="hold" nodeType="withEffect">
+                            <p:stCondLst>
+                              <p:cond delay="930"/>
+                            </p:stCondLst>
+                            <p:childTnLst>
+                              <p:set>
+                                <p:cBhvr>
+                                  <p:cTn id="77" dur="1" fill="hold">
+                                    <p:stCondLst>
+                                      <p:cond delay="0"/>
+                                    </p:stCondLst>
+                                  </p:cTn>
+                                  <p:tgtEl>
+                                    <p:spTgt spid="22"/>
+                                  </p:tgtEl>
+                                  <p:attrNameLst>
+                                    <p:attrName>style.visibility</p:attrName>
+                                  </p:attrNameLst>
+                                </p:cBhvr>
+                                <p:to>
+                                  <p:strVal val="visible"/>
+                                </p:to>
+                              </p:set>
+                              <p:animEffect transition="in" filter="fade">
+                                <p:cBhvr>
+                                  <p:cTn id="78" dur="600"/>
+                                  <p:tgtEl>
+                                    <p:spTgt spid="22"/>
+                                  </p:tgtEl>
+                                </p:cBhvr>
+                              </p:animEffect>
+                              <p:anim calcmode="lin" valueType="num">
+                                <p:cBhvr>
+                                  <p:cTn id="79" dur="600" decel="100000" fill="hold"/>
+                                  <p:tgtEl>
+                                    <p:spTgt spid="22"/>
+                                  </p:tgtEl>
+                                  <p:attrNameLst>
+                                    <p:attrName>ppt_y</p:attrName>
+                                  </p:attrNameLst>
+                                </p:cBhvr>
+                                <p:tavLst>
+                                  <p:tav tm="0">
+                                    <p:val>
+                                      <p:strVal val="#ppt_y+0.03"/>
+                                    </p:val>
+                                  </p:tav>
+                                  <p:tav tm="100000">
+                                    <p:val>
+                                      <p:strVal val="#ppt_y"/>
+                                    </p:val>
+                                  </p:tav>
+                                </p:tavLst>
+                              </p:anim>
+                            </p:childTnLst>
+                          </p:cTn>
+                        </p:par>
+                        <p:par>
+                          <p:cTn id="80" presetID="10" presetClass="entr" presetSubtype="0" fill="hold" nodeType="withEffect">
+                            <p:stCondLst>
+                              <p:cond delay="990"/>
+                            </p:stCondLst>
+                            <p:childTnLst>
+                              <p:set>
+                                <p:cBhvr>
+                                  <p:cTn id="81" dur="1" fill="hold">
+                                    <p:stCondLst>
+                                      <p:cond delay="0"/>
+                                    </p:stCondLst>
+                                  </p:cTn>
+                                  <p:tgtEl>
+                                    <p:spTgt spid="23"/>
+                                  </p:tgtEl>
+                                  <p:attrNameLst>
+                                    <p:attrName>style.visibility</p:attrName>
+                                  </p:attrNameLst>
+                                </p:cBhvr>
+                                <p:to>
+                                  <p:strVal val="visible"/>
+                                </p:to>
+                              </p:set>
+                              <p:animEffect transition="in" filter="fade">
+                                <p:cBhvr>
+                                  <p:cTn id="82" dur="600"/>
+                                  <p:tgtEl>
+                                    <p:spTgt spid="23"/>
+                                  </p:tgtEl>
+                                </p:cBhvr>
+                              </p:animEffect>
+                              <p:anim calcmode="lin" valueType="num">
+                                <p:cBhvr>
+                                  <p:cTn id="83" dur="600" decel="100000" fill="hold"/>
+                                  <p:tgtEl>
+                                    <p:spTgt spid="23"/>
+                                  </p:tgtEl>
+                                  <p:attrNameLst>
+                                    <p:attrName>ppt_y</p:attrName>
+                                  </p:attrNameLst>
+                                </p:cBhvr>
+                                <p:tavLst>
+                                  <p:tav tm="0">
+                                    <p:val>
+                                      <p:strVal val="#ppt_y+0.03"/>
+                                    </p:val>
+                                  </p:tav>
+                                  <p:tav tm="100000">
+                                    <p:val>
+                                      <p:strVal val="#ppt_y"/>
+                                    </p:val>
+                                  </p:tav>
+                                </p:tavLst>
+                              </p:anim>
+                            </p:childTnLst>
+                          </p:cTn>
+                        </p:par>
+                        <p:par>
+                          <p:cTn id="84" presetID="10" presetClass="entr" presetSubtype="0" fill="hold" nodeType="withEffect">
+                            <p:stCondLst>
+                              <p:cond delay="900"/>
+                            </p:stCondLst>
+                            <p:childTnLst>
+                              <p:set>
+                                <p:cBhvr>
+                                  <p:cTn id="85" dur="1" fill="hold">
+                                    <p:stCondLst>
+                                      <p:cond delay="0"/>
+                                    </p:stCondLst>
+                                  </p:cTn>
+                                  <p:tgtEl>
+                                    <p:spTgt spid="24"/>
+                                  </p:tgtEl>
+                                  <p:attrNameLst>
+                                    <p:attrName>style.visibility</p:attrName>
+                                  </p:attrNameLst>
+                                </p:cBhvr>
+                                <p:to>
+                                  <p:strVal val="visible"/>
+                                </p:to>
+                              </p:set>
+                              <p:animEffect transition="in" filter="fade">
+                                <p:cBhvr>
+                                  <p:cTn id="86" dur="600"/>
+                                  <p:tgtEl>
+                                    <p:spTgt spid="24"/>
+                                  </p:tgtEl>
+                                </p:cBhvr>
+                              </p:animEffect>
+                              <p:anim calcmode="lin" valueType="num">
+                                <p:cBhvr>
+                                  <p:cTn id="87" dur="600" decel="100000" fill="hold"/>
+                                  <p:tgtEl>
+                                    <p:spTgt spid="24"/>
+                                  </p:tgtEl>
+                                  <p:attrNameLst>
+                                    <p:attrName>ppt_y</p:attrName>
+                                  </p:attrNameLst>
+                                </p:cBhvr>
+                                <p:tavLst>
+                                  <p:tav tm="0">
+                                    <p:val>
+                                      <p:strVal val="#ppt_y+0.03"/>
+                                    </p:val>
+                                  </p:tav>
+                                  <p:tav tm="100000">
+                                    <p:val>
+                                      <p:strVal val="#ppt_y"/>
+                                    </p:val>
+                                  </p:tav>
+                                </p:tavLst>
+                              </p:anim>
+                            </p:childTnLst>
+                          </p:cTn>
+                        </p:par>
+                        <p:par>
+                          <p:cTn id="88" presetID="10" presetClass="entr" presetSubtype="0" fill="hold" nodeType="withEffect">
+                            <p:stCondLst>
+                              <p:cond delay="960"/>
+                            </p:stCondLst>
+                            <p:childTnLst>
+                              <p:set>
+                                <p:cBhvr>
+                                  <p:cTn id="89" dur="1" fill="hold">
+                                    <p:stCondLst>
+                                      <p:cond delay="0"/>
+                                    </p:stCondLst>
+                                  </p:cTn>
+                                  <p:tgtEl>
+                                    <p:spTgt spid="25"/>
+                                  </p:tgtEl>
+                                  <p:attrNameLst>
+                                    <p:attrName>style.visibility</p:attrName>
+                                  </p:attrNameLst>
+                                </p:cBhvr>
+                                <p:to>
+                                  <p:strVal val="visible"/>
+                                </p:to>
+                              </p:set>
+                              <p:animEffect transition="in" filter="fade">
+                                <p:cBhvr>
+                                  <p:cTn id="90" dur="600"/>
+                                  <p:tgtEl>
+                                    <p:spTgt spid="25"/>
+                                  </p:tgtEl>
+                                </p:cBhvr>
+                              </p:animEffect>
+                              <p:anim calcmode="lin" valueType="num">
+                                <p:cBhvr>
+                                  <p:cTn id="91" dur="600" decel="100000" fill="hold"/>
+                                  <p:tgtEl>
+                                    <p:spTgt spid="25"/>
+                                  </p:tgtEl>
+                                  <p:attrNameLst>
+                                    <p:attrName>ppt_y</p:attrName>
+                                  </p:attrNameLst>
+                                </p:cBhvr>
+                                <p:tavLst>
+                                  <p:tav tm="0">
+                                    <p:val>
+                                      <p:strVal val="#ppt_y+0.03"/>
+                                    </p:val>
+                                  </p:tav>
+                                  <p:tav tm="100000">
+                                    <p:val>
+                                      <p:strVal val="#ppt_y"/>
+                                    </p:val>
+                                  </p:tav>
+                                </p:tavLst>
+                              </p:anim>
+                            </p:childTnLst>
+                          </p:cTn>
+                        </p:par>
+                        <p:par>
+                          <p:cTn id="92" presetID="10" presetClass="entr" presetSubtype="0" fill="hold" nodeType="withEffect">
+                            <p:stCondLst>
+                              <p:cond delay="1020"/>
+                            </p:stCondLst>
+                            <p:childTnLst>
+                              <p:set>
+                                <p:cBhvr>
+                                  <p:cTn id="93" dur="1" fill="hold">
+                                    <p:stCondLst>
+                                      <p:cond delay="0"/>
+                                    </p:stCondLst>
+                                  </p:cTn>
+                                  <p:tgtEl>
+                                    <p:spTgt spid="26"/>
+                                  </p:tgtEl>
+                                  <p:attrNameLst>
+                                    <p:attrName>style.visibility</p:attrName>
+                                  </p:attrNameLst>
+                                </p:cBhvr>
+                                <p:to>
+                                  <p:strVal val="visible"/>
+                                </p:to>
+                              </p:set>
+                              <p:animEffect transition="in" filter="fade">
+                                <p:cBhvr>
+                                  <p:cTn id="94" dur="600"/>
+                                  <p:tgtEl>
+                                    <p:spTgt spid="26"/>
+                                  </p:tgtEl>
+                                </p:cBhvr>
+                              </p:animEffect>
+                              <p:anim calcmode="lin" valueType="num">
+                                <p:cBhvr>
+                                  <p:cTn id="95" dur="600" decel="100000" fill="hold"/>
+                                  <p:tgtEl>
+                                    <p:spTgt spid="26"/>
+                                  </p:tgtEl>
+                                  <p:attrNameLst>
+                                    <p:attrName>ppt_y</p:attrName>
+                                  </p:attrNameLst>
+                                </p:cBhvr>
+                                <p:tavLst>
+                                  <p:tav tm="0">
+                                    <p:val>
+                                      <p:strVal val="#ppt_y+0.03"/>
+                                    </p:val>
+                                  </p:tav>
+                                  <p:tav tm="100000">
+                                    <p:val>
+                                      <p:strVal val="#ppt_y"/>
+                                    </p:val>
+                                  </p:tav>
+                                </p:tavLst>
+                              </p:anim>
+                            </p:childTnLst>
+                          </p:cTn>
+                        </p:par>
+                        <p:par>
+                          <p:cTn id="96" presetID="10" presetClass="entr" presetSubtype="0" fill="hold" nodeType="withEffect">
+                            <p:stCondLst>
+                              <p:cond delay="1080"/>
+                            </p:stCondLst>
+                            <p:childTnLst>
+                              <p:set>
+                                <p:cBhvr>
+                                  <p:cTn id="97" dur="1" fill="hold">
+                                    <p:stCondLst>
+                                      <p:cond delay="0"/>
+                                    </p:stCondLst>
+                                  </p:cTn>
+                                  <p:tgtEl>
+                                    <p:spTgt spid="27"/>
+                                  </p:tgtEl>
+                                  <p:attrNameLst>
+                                    <p:attrName>style.visibility</p:attrName>
+                                  </p:attrNameLst>
+                                </p:cBhvr>
+                                <p:to>
+                                  <p:strVal val="visible"/>
+                                </p:to>
+                              </p:set>
+                              <p:animEffect transition="in" filter="fade">
+                                <p:cBhvr>
+                                  <p:cTn id="98" dur="600"/>
+                                  <p:tgtEl>
+                                    <p:spTgt spid="27"/>
+                                  </p:tgtEl>
+                                </p:cBhvr>
+                              </p:animEffect>
+                              <p:anim calcmode="lin" valueType="num">
+                                <p:cBhvr>
+                                  <p:cTn id="99" dur="600" decel="100000" fill="hold"/>
+                                  <p:tgtEl>
+                                    <p:spTgt spid="27"/>
+                                  </p:tgtEl>
+                                  <p:attrNameLst>
+                                    <p:attrName>ppt_y</p:attrName>
+                                  </p:attrNameLst>
+                                </p:cBhvr>
+                                <p:tavLst>
+                                  <p:tav tm="0">
+                                    <p:val>
+                                      <p:strVal val="#ppt_y+0.03"/>
+                                    </p:val>
+                                  </p:tav>
+                                  <p:tav tm="100000">
+                                    <p:val>
+                                      <p:strVal val="#ppt_y"/>
+                                    </p:val>
+                                  </p:tav>
+                                </p:tavLst>
+                              </p:anim>
+                            </p:childTnLst>
+                          </p:cTn>
+                        </p:par>
+                        <p:par>
+                          <p:cTn id="100" presetID="10" presetClass="entr" presetSubtype="0" fill="hold" nodeType="withEffect">
+                            <p:stCondLst>
+                              <p:cond delay="1140"/>
+                            </p:stCondLst>
+                            <p:childTnLst>
+                              <p:set>
+                                <p:cBhvr>
+                                  <p:cTn id="101" dur="1" fill="hold">
+                                    <p:stCondLst>
+                                      <p:cond delay="0"/>
+                                    </p:stCondLst>
+                                  </p:cTn>
+                                  <p:tgtEl>
+                                    <p:spTgt spid="28"/>
+                                  </p:tgtEl>
+                                  <p:attrNameLst>
+                                    <p:attrName>style.visibility</p:attrName>
+                                  </p:attrNameLst>
+                                </p:cBhvr>
+                                <p:to>
+                                  <p:strVal val="visible"/>
+                                </p:to>
+                              </p:set>
+                              <p:animEffect transition="in" filter="fade">
+                                <p:cBhvr>
+                                  <p:cTn id="102" dur="600"/>
+                                  <p:tgtEl>
+                                    <p:spTgt spid="28"/>
+                                  </p:tgtEl>
+                                </p:cBhvr>
+                              </p:animEffect>
+                              <p:anim calcmode="lin" valueType="num">
+                                <p:cBhvr>
+                                  <p:cTn id="103" dur="600" decel="100000" fill="hold"/>
+                                  <p:tgtEl>
+                                    <p:spTgt spid="28"/>
+                                  </p:tgtEl>
+                                  <p:attrNameLst>
+                                    <p:attrName>ppt_y</p:attrName>
+                                  </p:attrNameLst>
+                                </p:cBhvr>
+                                <p:tavLst>
+                                  <p:tav tm="0">
+                                    <p:val>
+                                      <p:strVal val="#ppt_y+0.03"/>
+                                    </p:val>
+                                  </p:tav>
+                                  <p:tav tm="100000">
+                                    <p:val>
+                                      <p:strVal val="#ppt_y"/>
+                                    </p:val>
+                                  </p:tav>
+                                </p:tavLst>
+                              </p:anim>
+                            </p:childTnLst>
+                          </p:cTn>
+                        </p:par>
+                        <p:par>
+                          <p:cTn id="104" presetID="10" presetClass="entr" presetSubtype="0" fill="hold" nodeType="withEffect">
+                            <p:stCondLst>
+                              <p:cond delay="1200"/>
+                            </p:stCondLst>
+                            <p:childTnLst>
+                              <p:set>
+                                <p:cBhvr>
+                                  <p:cTn id="105" dur="1" fill="hold">
+                                    <p:stCondLst>
+                                      <p:cond delay="0"/>
+                                    </p:stCondLst>
+                                  </p:cTn>
+                                  <p:tgtEl>
+                                    <p:spTgt spid="29"/>
+                                  </p:tgtEl>
+                                  <p:attrNameLst>
+                                    <p:attrName>style.visibility</p:attrName>
+                                  </p:attrNameLst>
+                                </p:cBhvr>
+                                <p:to>
+                                  <p:strVal val="visible"/>
+                                </p:to>
+                              </p:set>
+                              <p:animEffect transition="in" filter="fade">
+                                <p:cBhvr>
+                                  <p:cTn id="106" dur="600"/>
+                                  <p:tgtEl>
+                                    <p:spTgt spid="29"/>
+                                  </p:tgtEl>
+                                </p:cBhvr>
+                              </p:animEffect>
+                              <p:anim calcmode="lin" valueType="num">
+                                <p:cBhvr>
+                                  <p:cTn id="107" dur="600" decel="100000" fill="hold"/>
+                                  <p:tgtEl>
+                                    <p:spTgt spid="29"/>
+                                  </p:tgtEl>
+                                  <p:attrNameLst>
+                                    <p:attrName>ppt_y</p:attrName>
+                                  </p:attrNameLst>
+                                </p:cBhvr>
+                                <p:tavLst>
+                                  <p:tav tm="0">
+                                    <p:val>
+                                      <p:strVal val="#ppt_y+0.03"/>
+                                    </p:val>
+                                  </p:tav>
+                                  <p:tav tm="100000">
+                                    <p:val>
+                                      <p:strVal val="#ppt_y"/>
+                                    </p:val>
+                                  </p:tav>
+                                </p:tavLst>
+                              </p:anim>
+                            </p:childTnLst>
+                          </p:cTn>
+                        </p:par>
+                        <p:par>
+                          <p:cTn id="108" presetID="10" presetClass="entr" presetSubtype="0" fill="hold" nodeType="withEffect">
+                            <p:stCondLst>
+                              <p:cond delay="1260"/>
+                            </p:stCondLst>
+                            <p:childTnLst>
+                              <p:set>
+                                <p:cBhvr>
+                                  <p:cTn id="109" dur="1" fill="hold">
+                                    <p:stCondLst>
+                                      <p:cond delay="0"/>
+                                    </p:stCondLst>
+                                  </p:cTn>
+                                  <p:tgtEl>
+                                    <p:spTgt spid="30"/>
+                                  </p:tgtEl>
+                                  <p:attrNameLst>
+                                    <p:attrName>style.visibility</p:attrName>
+                                  </p:attrNameLst>
+                                </p:cBhvr>
+                                <p:to>
+                                  <p:strVal val="visible"/>
+                                </p:to>
+                              </p:set>
+                              <p:animEffect transition="in" filter="fade">
+                                <p:cBhvr>
+                                  <p:cTn id="110" dur="600"/>
+                                  <p:tgtEl>
+                                    <p:spTgt spid="30"/>
+                                  </p:tgtEl>
+                                </p:cBhvr>
+                              </p:animEffect>
+                              <p:anim calcmode="lin" valueType="num">
+                                <p:cBhvr>
+                                  <p:cTn id="111" dur="600" decel="100000" fill="hold"/>
+                                  <p:tgtEl>
+                                    <p:spTgt spid="30"/>
+                                  </p:tgtEl>
+                                  <p:attrNameLst>
+                                    <p:attrName>ppt_y</p:attrName>
+                                  </p:attrNameLst>
+                                </p:cBhvr>
+                                <p:tavLst>
+                                  <p:tav tm="0">
+                                    <p:val>
+                                      <p:strVal val="#ppt_y+0.03"/>
+                                    </p:val>
+                                  </p:tav>
+                                  <p:tav tm="100000">
+                                    <p:val>
+                                      <p:strVal val="#ppt_y"/>
+                                    </p:val>
+                                  </p:tav>
+                                </p:tavLst>
+                              </p:anim>
+                            </p:childTnLst>
+                          </p:cTn>
+                        </p:par>
+                        <p:par>
+                          <p:cTn id="112" presetID="10" presetClass="entr" presetSubtype="0" fill="hold" nodeType="withEffect">
+                            <p:stCondLst>
+                              <p:cond delay="1320"/>
+                            </p:stCondLst>
+                            <p:childTnLst>
+                              <p:set>
+                                <p:cBhvr>
+                                  <p:cTn id="113" dur="1" fill="hold">
+                                    <p:stCondLst>
+                                      <p:cond delay="0"/>
+                                    </p:stCondLst>
+                                  </p:cTn>
+                                  <p:tgtEl>
+                                    <p:spTgt spid="31"/>
+                                  </p:tgtEl>
+                                  <p:attrNameLst>
+                                    <p:attrName>style.visibility</p:attrName>
+                                  </p:attrNameLst>
+                                </p:cBhvr>
+                                <p:to>
+                                  <p:strVal val="visible"/>
+                                </p:to>
+                              </p:set>
+                              <p:animEffect transition="in" filter="fade">
+                                <p:cBhvr>
+                                  <p:cTn id="114" dur="600"/>
+                                  <p:tgtEl>
+                                    <p:spTgt spid="31"/>
+                                  </p:tgtEl>
+                                </p:cBhvr>
+                              </p:animEffect>
+                              <p:anim calcmode="lin" valueType="num">
+                                <p:cBhvr>
+                                  <p:cTn id="115" dur="600" decel="100000" fill="hold"/>
+                                  <p:tgtEl>
+                                    <p:spTgt spid="31"/>
+                                  </p:tgtEl>
+                                  <p:attrNameLst>
+                                    <p:attrName>ppt_y</p:attrName>
+                                  </p:attrNameLst>
+                                </p:cBhvr>
+                                <p:tavLst>
+                                  <p:tav tm="0">
+                                    <p:val>
+                                      <p:strVal val="#ppt_y+0.03"/>
+                                    </p:val>
+                                  </p:tav>
+                                  <p:tav tm="100000">
+                                    <p:val>
+                                      <p:strVal val="#ppt_y"/>
+                                    </p:val>
+                                  </p:tav>
+                                </p:tavLst>
+                              </p:anim>
+                            </p:childTnLst>
+                          </p:cTn>
+                        </p:par>
+                        <p:par>
+                          <p:cTn id="116" presetID="10" presetClass="entr" presetSubtype="0" fill="hold" nodeType="withEffect">
+                            <p:stCondLst>
+                              <p:cond delay="1380"/>
+                            </p:stCondLst>
+                            <p:childTnLst>
+                              <p:set>
+                                <p:cBhvr>
+                                  <p:cTn id="117" dur="1" fill="hold">
+                                    <p:stCondLst>
+                                      <p:cond delay="0"/>
+                                    </p:stCondLst>
+                                  </p:cTn>
+                                  <p:tgtEl>
+                                    <p:spTgt spid="32"/>
+                                  </p:tgtEl>
+                                  <p:attrNameLst>
+                                    <p:attrName>style.visibility</p:attrName>
+                                  </p:attrNameLst>
+                                </p:cBhvr>
+                                <p:to>
+                                  <p:strVal val="visible"/>
+                                </p:to>
+                              </p:set>
+                              <p:animEffect transition="in" filter="fade">
+                                <p:cBhvr>
+                                  <p:cTn id="118" dur="600"/>
+                                  <p:tgtEl>
+                                    <p:spTgt spid="32"/>
+                                  </p:tgtEl>
+                                </p:cBhvr>
+                              </p:animEffect>
+                              <p:anim calcmode="lin" valueType="num">
+                                <p:cBhvr>
+                                  <p:cTn id="119" dur="600" decel="100000" fill="hold"/>
+                                  <p:tgtEl>
+                                    <p:spTgt spid="32"/>
+                                  </p:tgtEl>
+                                  <p:attrNameLst>
+                                    <p:attrName>ppt_y</p:attrName>
+                                  </p:attrNameLst>
+                                </p:cBhvr>
+                                <p:tavLst>
+                                  <p:tav tm="0">
+                                    <p:val>
+                                      <p:strVal val="#ppt_y+0.03"/>
+                                    </p:val>
+                                  </p:tav>
+                                  <p:tav tm="100000">
+                                    <p:val>
+                                      <p:strVal val="#ppt_y"/>
+                                    </p:val>
+                                  </p:tav>
+                                </p:tavLst>
+                              </p:anim>
+                            </p:childTnLst>
+                          </p:cTn>
+                        </p:par>
+                        <p:par>
+                          <p:cTn id="120" presetID="10" presetClass="entr" presetSubtype="0" fill="hold" nodeType="withEffect">
+                            <p:stCondLst>
+                              <p:cond delay="1440"/>
+                            </p:stCondLst>
+                            <p:childTnLst>
+                              <p:set>
+                                <p:cBhvr>
+                                  <p:cTn id="121" dur="1" fill="hold">
+                                    <p:stCondLst>
+                                      <p:cond delay="0"/>
+                                    </p:stCondLst>
+                                  </p:cTn>
+                                  <p:tgtEl>
+                                    <p:spTgt spid="33"/>
+                                  </p:tgtEl>
+                                  <p:attrNameLst>
+                                    <p:attrName>style.visibility</p:attrName>
+                                  </p:attrNameLst>
+                                </p:cBhvr>
+                                <p:to>
+                                  <p:strVal val="visible"/>
+                                </p:to>
+                              </p:set>
+                              <p:animEffect transition="in" filter="fade">
+                                <p:cBhvr>
+                                  <p:cTn id="122" dur="600"/>
+                                  <p:tgtEl>
+                                    <p:spTgt spid="33"/>
+                                  </p:tgtEl>
+                                </p:cBhvr>
+                              </p:animEffect>
+                              <p:anim calcmode="lin" valueType="num">
+                                <p:cBhvr>
+                                  <p:cTn id="123" dur="600" decel="100000" fill="hold"/>
+                                  <p:tgtEl>
+                                    <p:spTgt spid="33"/>
+                                  </p:tgtEl>
+                                  <p:attrNameLst>
+                                    <p:attrName>ppt_y</p:attrName>
+                                  </p:attrNameLst>
+                                </p:cBhvr>
+                                <p:tavLst>
+                                  <p:tav tm="0">
+                                    <p:val>
+                                      <p:strVal val="#ppt_y+0.03"/>
+                                    </p:val>
+                                  </p:tav>
+                                  <p:tav tm="100000">
+                                    <p:val>
+                                      <p:strVal val="#ppt_y"/>
+                                    </p:val>
+                                  </p:tav>
+                                </p:tavLst>
+                              </p:anim>
+                            </p:childTnLst>
+                          </p:cTn>
+                        </p:par>
+                        <p:par>
+                          <p:cTn id="124" presetID="10" presetClass="entr" presetSubtype="0" fill="hold" nodeType="withEffect">
+                            <p:stCondLst>
+                              <p:cond delay="1350"/>
+                            </p:stCondLst>
+                            <p:childTnLst>
+                              <p:set>
+                                <p:cBhvr>
+                                  <p:cTn id="125" dur="1" fill="hold">
+                                    <p:stCondLst>
+                                      <p:cond delay="0"/>
+                                    </p:stCondLst>
+                                  </p:cTn>
+                                  <p:tgtEl>
+                                    <p:spTgt spid="34"/>
+                                  </p:tgtEl>
+                                  <p:attrNameLst>
+                                    <p:attrName>style.visibility</p:attrName>
+                                  </p:attrNameLst>
+                                </p:cBhvr>
+                                <p:to>
+                                  <p:strVal val="visible"/>
+                                </p:to>
+                              </p:set>
+                              <p:animEffect transition="in" filter="fade">
+                                <p:cBhvr>
+                                  <p:cTn id="126" dur="600"/>
+                                  <p:tgtEl>
+                                    <p:spTgt spid="34"/>
+                                  </p:tgtEl>
+                                </p:cBhvr>
+                              </p:animEffect>
+                              <p:anim calcmode="lin" valueType="num">
+                                <p:cBhvr>
+                                  <p:cTn id="127" dur="600" decel="100000" fill="hold"/>
+                                  <p:tgtEl>
+                                    <p:spTgt spid="34"/>
+                                  </p:tgtEl>
+                                  <p:attrNameLst>
+                                    <p:attrName>ppt_y</p:attrName>
+                                  </p:attrNameLst>
+                                </p:cBhvr>
+                                <p:tavLst>
+                                  <p:tav tm="0">
+                                    <p:val>
+                                      <p:strVal val="#ppt_y+0.03"/>
+                                    </p:val>
+                                  </p:tav>
+                                  <p:tav tm="100000">
+                                    <p:val>
+                                      <p:strVal val="#ppt_y"/>
+                                    </p:val>
+                                  </p:tav>
+                                </p:tavLst>
+                              </p:anim>
+                            </p:childTnLst>
+                          </p:cTn>
+                        </p:par>
+                        <p:par>
+                          <p:cTn id="128" presetID="10" presetClass="entr" presetSubtype="0" fill="hold" nodeType="withEffect">
+                            <p:stCondLst>
+                              <p:cond delay="1410"/>
+                            </p:stCondLst>
+                            <p:childTnLst>
+                              <p:set>
+                                <p:cBhvr>
+                                  <p:cTn id="129" dur="1" fill="hold">
+                                    <p:stCondLst>
+                                      <p:cond delay="0"/>
+                                    </p:stCondLst>
+                                  </p:cTn>
+                                  <p:tgtEl>
+                                    <p:spTgt spid="35"/>
+                                  </p:tgtEl>
+                                  <p:attrNameLst>
+                                    <p:attrName>style.visibility</p:attrName>
+                                  </p:attrNameLst>
+                                </p:cBhvr>
+                                <p:to>
+                                  <p:strVal val="visible"/>
+                                </p:to>
+                              </p:set>
+                              <p:animEffect transition="in" filter="fade">
+                                <p:cBhvr>
+                                  <p:cTn id="130" dur="600"/>
+                                  <p:tgtEl>
+                                    <p:spTgt spid="35"/>
+                                  </p:tgtEl>
+                                </p:cBhvr>
+                              </p:animEffect>
+                              <p:anim calcmode="lin" valueType="num">
+                                <p:cBhvr>
+                                  <p:cTn id="131" dur="600" decel="100000" fill="hold"/>
+                                  <p:tgtEl>
+                                    <p:spTgt spid="35"/>
+                                  </p:tgtEl>
+                                  <p:attrNameLst>
+                                    <p:attrName>ppt_y</p:attrName>
+                                  </p:attrNameLst>
+                                </p:cBhvr>
+                                <p:tavLst>
+                                  <p:tav tm="0">
+                                    <p:val>
+                                      <p:strVal val="#ppt_y+0.03"/>
+                                    </p:val>
+                                  </p:tav>
+                                  <p:tav tm="100000">
+                                    <p:val>
+                                      <p:strVal val="#ppt_y"/>
+                                    </p:val>
+                                  </p:tav>
+                                </p:tavLst>
+                              </p:anim>
+                            </p:childTnLst>
+                          </p:cTn>
+                        </p:par>
+                        <p:par>
+                          <p:cTn id="132" presetID="10" presetClass="entr" presetSubtype="0" fill="hold" nodeType="withEffect">
+                            <p:stCondLst>
+                              <p:cond delay="1470"/>
+                            </p:stCondLst>
+                            <p:childTnLst>
+                              <p:set>
+                                <p:cBhvr>
+                                  <p:cTn id="133" dur="1" fill="hold">
+                                    <p:stCondLst>
+                                      <p:cond delay="0"/>
+                                    </p:stCondLst>
+                                  </p:cTn>
+                                  <p:tgtEl>
+                                    <p:spTgt spid="36"/>
+                                  </p:tgtEl>
+                                  <p:attrNameLst>
+                                    <p:attrName>style.visibility</p:attrName>
+                                  </p:attrNameLst>
+                                </p:cBhvr>
+                                <p:to>
+                                  <p:strVal val="visible"/>
+                                </p:to>
+                              </p:set>
+                              <p:animEffect transition="in" filter="fade">
+                                <p:cBhvr>
+                                  <p:cTn id="134" dur="600"/>
+                                  <p:tgtEl>
+                                    <p:spTgt spid="36"/>
+                                  </p:tgtEl>
+                                </p:cBhvr>
+                              </p:animEffect>
+                              <p:anim calcmode="lin" valueType="num">
+                                <p:cBhvr>
+                                  <p:cTn id="135" dur="600" decel="100000" fill="hold"/>
+                                  <p:tgtEl>
+                                    <p:spTgt spid="36"/>
+                                  </p:tgtEl>
+                                  <p:attrNameLst>
+                                    <p:attrName>ppt_y</p:attrName>
+                                  </p:attrNameLst>
+                                </p:cBhvr>
+                                <p:tavLst>
+                                  <p:tav tm="0">
+                                    <p:val>
+                                      <p:strVal val="#ppt_y+0.03"/>
+                                    </p:val>
+                                  </p:tav>
+                                  <p:tav tm="100000">
+                                    <p:val>
+                                      <p:strVal val="#ppt_y"/>
+                                    </p:val>
+                                  </p:tav>
+                                </p:tavLst>
+                              </p:anim>
+                            </p:childTnLst>
+                          </p:cTn>
+                        </p:par>
+                        <p:par>
+                          <p:cTn id="136" presetID="10" presetClass="entr" presetSubtype="0" fill="hold" nodeType="withEffect">
+                            <p:stCondLst>
+                              <p:cond delay="1530"/>
+                            </p:stCondLst>
+                            <p:childTnLst>
+                              <p:set>
+                                <p:cBhvr>
+                                  <p:cTn id="137" dur="1" fill="hold">
+                                    <p:stCondLst>
+                                      <p:cond delay="0"/>
+                                    </p:stCondLst>
+                                  </p:cTn>
+                                  <p:tgtEl>
+                                    <p:spTgt spid="37"/>
+                                  </p:tgtEl>
+                                  <p:attrNameLst>
+                                    <p:attrName>style.visibility</p:attrName>
+                                  </p:attrNameLst>
+                                </p:cBhvr>
+                                <p:to>
+                                  <p:strVal val="visible"/>
+                                </p:to>
+                              </p:set>
+                              <p:animEffect transition="in" filter="fade">
+                                <p:cBhvr>
+                                  <p:cTn id="138" dur="600"/>
+                                  <p:tgtEl>
+                                    <p:spTgt spid="37"/>
+                                  </p:tgtEl>
+                                </p:cBhvr>
+                              </p:animEffect>
+                              <p:anim calcmode="lin" valueType="num">
+                                <p:cBhvr>
+                                  <p:cTn id="139" dur="600" decel="100000" fill="hold"/>
+                                  <p:tgtEl>
+                                    <p:spTgt spid="37"/>
+                                  </p:tgtEl>
+                                  <p:attrNameLst>
+                                    <p:attrName>ppt_y</p:attrName>
+                                  </p:attrNameLst>
+                                </p:cBhvr>
+                                <p:tavLst>
+                                  <p:tav tm="0">
+                                    <p:val>
+                                      <p:strVal val="#ppt_y+0.03"/>
+                                    </p:val>
+                                  </p:tav>
+                                  <p:tav tm="100000">
+                                    <p:val>
+                                      <p:strVal val="#ppt_y"/>
+                                    </p:val>
+                                  </p:tav>
+                                </p:tavLst>
+                              </p:anim>
+                            </p:childTnLst>
+                          </p:cTn>
+                        </p:par>
+                        <p:par>
+                          <p:cTn id="140" presetID="10" presetClass="entr" presetSubtype="0" fill="hold" nodeType="withEffect">
+                            <p:stCondLst>
+                              <p:cond delay="1590"/>
+                            </p:stCondLst>
+                            <p:childTnLst>
+                              <p:set>
+                                <p:cBhvr>
+                                  <p:cTn id="141" dur="1" fill="hold">
+                                    <p:stCondLst>
+                                      <p:cond delay="0"/>
+                                    </p:stCondLst>
+                                  </p:cTn>
+                                  <p:tgtEl>
+                                    <p:spTgt spid="38"/>
+                                  </p:tgtEl>
+                                  <p:attrNameLst>
+                                    <p:attrName>style.visibility</p:attrName>
+                                  </p:attrNameLst>
+                                </p:cBhvr>
+                                <p:to>
+                                  <p:strVal val="visible"/>
+                                </p:to>
+                              </p:set>
+                              <p:animEffect transition="in" filter="fade">
+                                <p:cBhvr>
+                                  <p:cTn id="142" dur="600"/>
+                                  <p:tgtEl>
+                                    <p:spTgt spid="38"/>
+                                  </p:tgtEl>
+                                </p:cBhvr>
+                              </p:animEffect>
+                              <p:anim calcmode="lin" valueType="num">
+                                <p:cBhvr>
+                                  <p:cTn id="143" dur="600" decel="100000" fill="hold"/>
+                                  <p:tgtEl>
+                                    <p:spTgt spid="38"/>
+                                  </p:tgtEl>
+                                  <p:attrNameLst>
+                                    <p:attrName>ppt_y</p:attrName>
+                                  </p:attrNameLst>
+                                </p:cBhvr>
+                                <p:tavLst>
+                                  <p:tav tm="0">
+                                    <p:val>
+                                      <p:strVal val="#ppt_y+0.03"/>
+                                    </p:val>
+                                  </p:tav>
+                                  <p:tav tm="100000">
+                                    <p:val>
+                                      <p:strVal val="#ppt_y"/>
+                                    </p:val>
+                                  </p:tav>
+                                </p:tavLst>
+                              </p:anim>
+                            </p:childTnLst>
+                          </p:cTn>
+                        </p:par>
+                        <p:par>
+                          <p:cTn id="144" presetID="10" presetClass="entr" presetSubtype="0" fill="hold" nodeType="withEffect">
+                            <p:stCondLst>
+                              <p:cond delay="1650"/>
+                            </p:stCondLst>
+                            <p:childTnLst>
+                              <p:set>
+                                <p:cBhvr>
+                                  <p:cTn id="145" dur="1" fill="hold">
+                                    <p:stCondLst>
+                                      <p:cond delay="0"/>
+                                    </p:stCondLst>
+                                  </p:cTn>
+                                  <p:tgtEl>
+                                    <p:spTgt spid="39"/>
+                                  </p:tgtEl>
+                                  <p:attrNameLst>
+                                    <p:attrName>style.visibility</p:attrName>
+                                  </p:attrNameLst>
+                                </p:cBhvr>
+                                <p:to>
+                                  <p:strVal val="visible"/>
+                                </p:to>
+                              </p:set>
+                              <p:animEffect transition="in" filter="fade">
+                                <p:cBhvr>
+                                  <p:cTn id="146" dur="600"/>
+                                  <p:tgtEl>
+                                    <p:spTgt spid="39"/>
+                                  </p:tgtEl>
+                                </p:cBhvr>
+                              </p:animEffect>
+                              <p:anim calcmode="lin" valueType="num">
+                                <p:cBhvr>
+                                  <p:cTn id="147" dur="600" decel="100000" fill="hold"/>
+                                  <p:tgtEl>
+                                    <p:spTgt spid="39"/>
+                                  </p:tgtEl>
+                                  <p:attrNameLst>
+                                    <p:attrName>ppt_y</p:attrName>
+                                  </p:attrNameLst>
+                                </p:cBhvr>
+                                <p:tavLst>
+                                  <p:tav tm="0">
+                                    <p:val>
+                                      <p:strVal val="#ppt_y+0.03"/>
+                                    </p:val>
+                                  </p:tav>
+                                  <p:tav tm="100000">
+                                    <p:val>
+                                      <p:strVal val="#ppt_y"/>
+                                    </p:val>
+                                  </p:tav>
+                                </p:tavLst>
+                              </p:anim>
+                            </p:childTnLst>
+                          </p:cTn>
+                        </p:par>
+                        <p:par>
+                          <p:cTn id="148" presetID="10" presetClass="entr" presetSubtype="0" fill="hold" nodeType="withEffect">
+                            <p:stCondLst>
+                              <p:cond delay="1710"/>
+                            </p:stCondLst>
+                            <p:childTnLst>
+                              <p:set>
+                                <p:cBhvr>
+                                  <p:cTn id="149" dur="1" fill="hold">
+                                    <p:stCondLst>
+                                      <p:cond delay="0"/>
+                                    </p:stCondLst>
+                                  </p:cTn>
+                                  <p:tgtEl>
+                                    <p:spTgt spid="40"/>
+                                  </p:tgtEl>
+                                  <p:attrNameLst>
+                                    <p:attrName>style.visibility</p:attrName>
+                                  </p:attrNameLst>
+                                </p:cBhvr>
+                                <p:to>
+                                  <p:strVal val="visible"/>
+                                </p:to>
+                              </p:set>
+                              <p:animEffect transition="in" filter="fade">
+                                <p:cBhvr>
+                                  <p:cTn id="150" dur="600"/>
+                                  <p:tgtEl>
+                                    <p:spTgt spid="40"/>
+                                  </p:tgtEl>
+                                </p:cBhvr>
+                              </p:animEffect>
+                              <p:anim calcmode="lin" valueType="num">
+                                <p:cBhvr>
+                                  <p:cTn id="151" dur="600" decel="100000" fill="hold"/>
+                                  <p:tgtEl>
+                                    <p:spTgt spid="40"/>
+                                  </p:tgtEl>
+                                  <p:attrNameLst>
+                                    <p:attrName>ppt_y</p:attrName>
+                                  </p:attrNameLst>
+                                </p:cBhvr>
+                                <p:tavLst>
+                                  <p:tav tm="0">
+                                    <p:val>
+                                      <p:strVal val="#ppt_y+0.03"/>
+                                    </p:val>
+                                  </p:tav>
+                                  <p:tav tm="100000">
+                                    <p:val>
+                                      <p:strVal val="#ppt_y"/>
+                                    </p:val>
+                                  </p:tav>
+                                </p:tavLst>
+                              </p:anim>
+                            </p:childTnLst>
+                          </p:cTn>
+                        </p:par>
+                        <p:par>
+                          <p:cTn id="152" presetID="10" presetClass="entr" presetSubtype="0" fill="hold" nodeType="withEffect">
+                            <p:stCondLst>
+                              <p:cond delay="1770"/>
+                            </p:stCondLst>
+                            <p:childTnLst>
+                              <p:set>
+                                <p:cBhvr>
+                                  <p:cTn id="153" dur="1" fill="hold">
+                                    <p:stCondLst>
+                                      <p:cond delay="0"/>
+                                    </p:stCondLst>
+                                  </p:cTn>
+                                  <p:tgtEl>
+                                    <p:spTgt spid="41"/>
+                                  </p:tgtEl>
+                                  <p:attrNameLst>
+                                    <p:attrName>style.visibility</p:attrName>
+                                  </p:attrNameLst>
+                                </p:cBhvr>
+                                <p:to>
+                                  <p:strVal val="visible"/>
+                                </p:to>
+                              </p:set>
+                              <p:animEffect transition="in" filter="fade">
+                                <p:cBhvr>
+                                  <p:cTn id="154" dur="600"/>
+                                  <p:tgtEl>
+                                    <p:spTgt spid="41"/>
+                                  </p:tgtEl>
+                                </p:cBhvr>
+                              </p:animEffect>
+                              <p:anim calcmode="lin" valueType="num">
+                                <p:cBhvr>
+                                  <p:cTn id="155" dur="600" decel="100000" fill="hold"/>
+                                  <p:tgtEl>
+                                    <p:spTgt spid="41"/>
+                                  </p:tgtEl>
+                                  <p:attrNameLst>
+                                    <p:attrName>ppt_y</p:attrName>
+                                  </p:attrNameLst>
+                                </p:cBhvr>
+                                <p:tavLst>
+                                  <p:tav tm="0">
+                                    <p:val>
+                                      <p:strVal val="#ppt_y+0.03"/>
+                                    </p:val>
+                                  </p:tav>
+                                  <p:tav tm="100000">
+                                    <p:val>
+                                      <p:strVal val="#ppt_y"/>
+                                    </p:val>
+                                  </p:tav>
+                                </p:tavLst>
+                              </p:anim>
+                            </p:childTnLst>
+                          </p:cTn>
+                        </p:par>
+                        <p:par>
+                          <p:cTn id="156" presetID="10" presetClass="entr" presetSubtype="0" fill="hold" nodeType="withEffect">
+                            <p:stCondLst>
+                              <p:cond delay="1830"/>
+                            </p:stCondLst>
+                            <p:childTnLst>
+                              <p:set>
+                                <p:cBhvr>
+                                  <p:cTn id="157" dur="1" fill="hold">
+                                    <p:stCondLst>
+                                      <p:cond delay="0"/>
+                                    </p:stCondLst>
+                                  </p:cTn>
+                                  <p:tgtEl>
+                                    <p:spTgt spid="42"/>
+                                  </p:tgtEl>
+                                  <p:attrNameLst>
+                                    <p:attrName>style.visibility</p:attrName>
+                                  </p:attrNameLst>
+                                </p:cBhvr>
+                                <p:to>
+                                  <p:strVal val="visible"/>
+                                </p:to>
+                              </p:set>
+                              <p:animEffect transition="in" filter="fade">
+                                <p:cBhvr>
+                                  <p:cTn id="158" dur="600"/>
+                                  <p:tgtEl>
+                                    <p:spTgt spid="42"/>
+                                  </p:tgtEl>
+                                </p:cBhvr>
+                              </p:animEffect>
+                              <p:anim calcmode="lin" valueType="num">
+                                <p:cBhvr>
+                                  <p:cTn id="159" dur="600" decel="100000" fill="hold"/>
+                                  <p:tgtEl>
+                                    <p:spTgt spid="42"/>
+                                  </p:tgtEl>
+                                  <p:attrNameLst>
+                                    <p:attrName>ppt_y</p:attrName>
+                                  </p:attrNameLst>
+                                </p:cBhvr>
+                                <p:tavLst>
+                                  <p:tav tm="0">
+                                    <p:val>
+                                      <p:strVal val="#ppt_y+0.03"/>
+                                    </p:val>
+                                  </p:tav>
+                                  <p:tav tm="100000">
+                                    <p:val>
+                                      <p:strVal val="#ppt_y"/>
+                                    </p:val>
+                                  </p:tav>
+                                </p:tavLst>
+                              </p:anim>
+                            </p:childTnLst>
+                          </p:cTn>
+                        </p:par>
+                        <p:par>
+                          <p:cTn id="160" presetID="10" presetClass="entr" presetSubtype="0" fill="hold" nodeType="withEffect">
+                            <p:stCondLst>
+                              <p:cond delay="1890"/>
+                            </p:stCondLst>
+                            <p:childTnLst>
+                              <p:set>
+                                <p:cBhvr>
+                                  <p:cTn id="161" dur="1" fill="hold">
+                                    <p:stCondLst>
+                                      <p:cond delay="0"/>
+                                    </p:stCondLst>
+                                  </p:cTn>
+                                  <p:tgtEl>
+                                    <p:spTgt spid="43"/>
+                                  </p:tgtEl>
+                                  <p:attrNameLst>
+                                    <p:attrName>style.visibility</p:attrName>
+                                  </p:attrNameLst>
+                                </p:cBhvr>
+                                <p:to>
+                                  <p:strVal val="visible"/>
+                                </p:to>
+                              </p:set>
+                              <p:animEffect transition="in" filter="fade">
+                                <p:cBhvr>
+                                  <p:cTn id="162" dur="600"/>
+                                  <p:tgtEl>
+                                    <p:spTgt spid="43"/>
+                                  </p:tgtEl>
+                                </p:cBhvr>
+                              </p:animEffect>
+                              <p:anim calcmode="lin" valueType="num">
+                                <p:cBhvr>
+                                  <p:cTn id="163" dur="600" decel="100000" fill="hold"/>
+                                  <p:tgtEl>
+                                    <p:spTgt spid="43"/>
                                   </p:tgtEl>
                                   <p:attrNameLst>
                                     <p:attrName>ppt_y</p:attrName>
@@ -18131,7 +21987,7 @@
                   <a:schemeClr val="bg1"/>
                 </a:solidFill>
               </a:rPr>
-              <a:t>Un parc informatique géré, sécurisé et administrable à distance.</a:t>
+              <a:t>Des ordinateurs bien gérés, protégés et suivis à distance.</a:t>
             </a:r>
             <a:endParaRPr lang="en-US" sz="4000" dirty="0"/>
           </a:p>
@@ -18371,7 +22227,7 @@
                   <a:schemeClr val="tx1"/>
                 </a:solidFill>
               </a:rPr>
-              <a:t>Une infrastructure </a:t>
+              <a:t>Comment ça marche, </a:t>
             </a:r>
             <a:pPr algn="l" indent="0" marL="0">
               <a:buNone/>
@@ -18382,18 +22238,7 @@
                   <a:schemeClr val="accent1"/>
                 </a:solidFill>
               </a:rPr>
-              <a:t>en couches</a:t>
-            </a:r>
-            <a:pPr algn="l" indent="0" marL="0">
-              <a:buNone/>
-            </a:pPr>
-            <a:r>
-              <a:rPr lang="en-US" sz="3200" b="1" dirty="0">
-                <a:solidFill>
-                  <a:schemeClr val="tx1"/>
-                </a:solidFill>
-              </a:rPr>
-              <a:t>, simple et solide</a:t>
+              <a:t>étage par étage</a:t>
             </a:r>
             <a:endParaRPr lang="en-US" sz="3200" dirty="0"/>
           </a:p>
@@ -18453,7 +22298,7 @@
                   <a:schemeClr val="tx2"/>
                 </a:solidFill>
               </a:rPr>
-              <a:t>Serveur physique</a:t>
+              <a:t>Le serveur</a:t>
             </a:r>
             <a:endParaRPr lang="en-US" sz="1600" dirty="0"/>
           </a:p>
@@ -18512,7 +22357,7 @@
                   <a:schemeClr val="accent6"/>
                 </a:solidFill>
               </a:rPr>
-              <a:t>Une machine dédiée, fiable, dans vos locaux</a:t>
+              <a:t>Un ordinateur central, allumé en permanence, dans vos locaux</a:t>
             </a:r>
             <a:endParaRPr lang="en-US" sz="1400" dirty="0"/>
           </a:p>
@@ -18548,7 +22393,7 @@
                   <a:schemeClr val="tx2"/>
                 </a:solidFill>
               </a:rPr>
-              <a:t>Proxmox VE</a:t>
+              <a:t>Proxmox</a:t>
             </a:r>
             <a:endParaRPr lang="en-US" sz="1600" dirty="0"/>
           </a:p>
@@ -18607,7 +22452,7 @@
                   <a:schemeClr val="accent6"/>
                 </a:solidFill>
               </a:rPr>
-              <a:t>Virtualisation gratuite : le serveur peut évoluer</a:t>
+              <a:t>Un logiciel gratuit qui permet d'ajouter des outils plus tard</a:t>
             </a:r>
             <a:endParaRPr lang="en-US" sz="1400" dirty="0"/>
           </a:p>
@@ -18702,7 +22547,7 @@
                   <a:schemeClr val="accent6"/>
                 </a:solidFill>
               </a:rPr>
-              <a:t>Le standard des entreprises pour gérer un réseau</a:t>
+              <a:t>Le « chef d'orchestre » qui gère tous les ordinateurs</a:t>
             </a:r>
             <a:endParaRPr lang="en-US" sz="1400" dirty="0"/>
           </a:p>
@@ -18738,7 +22583,7 @@
                   <a:schemeClr val="tx2"/>
                 </a:solidFill>
               </a:rPr>
-              <a:t>AD · DNS · DHCP</a:t>
+              <a:t>Comptes employés</a:t>
             </a:r>
             <a:endParaRPr lang="en-US" sz="1600" dirty="0"/>
           </a:p>
@@ -18797,7 +22642,7 @@
                   <a:schemeClr val="accent6"/>
                 </a:solidFill>
               </a:rPr>
-              <a:t>Comptes, noms et adresses réseau centralisés</a:t>
+              <a:t>Un identifiant et un mot de passe personnels pour chacun</a:t>
             </a:r>
             <a:endParaRPr lang="en-US" sz="1400" dirty="0"/>
           </a:p>
@@ -18833,7 +22678,7 @@
                   <a:schemeClr val="tx2"/>
                 </a:solidFill>
               </a:rPr>
-              <a:t>Stratégies GPO</a:t>
+              <a:t>Règles automatiques</a:t>
             </a:r>
             <a:endParaRPr lang="en-US" sz="1600" dirty="0"/>
           </a:p>
@@ -18892,7 +22737,7 @@
                   <a:schemeClr val="accent6"/>
                 </a:solidFill>
               </a:rPr>
-              <a:t>Règles de sécurité appliquées automatiquement</a:t>
+              <a:t>Les mêmes réglages de sécurité sur tous les postes</a:t>
             </a:r>
             <a:endParaRPr lang="en-US" sz="1400" dirty="0"/>
           </a:p>
@@ -18987,7 +22832,7 @@
                   <a:schemeClr val="accent6"/>
                 </a:solidFill>
               </a:rPr>
-              <a:t>Chaque employé, son compte, son poste maîtrisé</a:t>
+              <a:t>Chaque employé travaille sur un poste bien réglé</a:t>
             </a:r>
             <a:endParaRPr lang="en-US" sz="1400" dirty="0"/>
           </a:p>
@@ -21068,7 +24913,7 @@
                   <a:schemeClr val="tx1"/>
                 </a:solidFill>
               </a:rPr>
-              <a:t>Installations contrôlées par GPO</a:t>
+              <a:t>Seuls les logiciels autorisés sont installés</a:t>
             </a:r>
             <a:endParaRPr lang="en-US" sz="1400" dirty="0"/>
           </a:p>
@@ -24195,7 +28040,7 @@
                   <a:schemeClr val="accent2"/>
                 </a:solidFill>
               </a:rPr>
-              <a:t>Tunnel chiffré Tailscale</a:t>
+              <a:t>Connexion sécurisée (Tailscale)</a:t>
             </a:r>
             <a:endParaRPr lang="en-US" sz="1300" dirty="0"/>
           </a:p>
@@ -25150,7 +28995,7 @@
                   <a:schemeClr val="accent1"/>
                 </a:solidFill>
               </a:rPr>
-              <a:t>0</a:t>
+              <a:t>Sécurisé</a:t>
             </a:r>
             <a:endParaRPr lang="en-US" sz="2800" dirty="0"/>
           </a:p>
@@ -25186,7 +29031,7 @@
                   <a:schemeClr val="accent6"/>
                 </a:solidFill>
               </a:rPr>
-              <a:t>port ouvert sur Internet</a:t>
+              <a:t>connexion privée et protégée</a:t>
             </a:r>
             <a:endParaRPr lang="en-US" sz="1400" dirty="0"/>
           </a:p>
@@ -28558,7 +32403,7 @@
                   <a:schemeClr val="accent1"/>
                 </a:solidFill>
               </a:rPr>
-              <a:t>éprouvées</a:t>
+              <a:t>fiables</a:t>
             </a:r>
             <a:pPr algn="l" indent="0" marL="0">
               <a:buNone/>
@@ -28739,7 +32584,7 @@
                   <a:schemeClr val="accent6"/>
                 </a:solidFill>
               </a:rPr>
-              <a:t>Proxmox permet d'ajouter d'autres serveurs virtuels plus tard, sans racheter de matériel.</a:t>
+              <a:t>Plus tard, on pourra ajouter de nouveaux outils sur le même serveur, sans racheter de machine.</a:t>
             </a:r>
             <a:endParaRPr lang="en-US" sz="1500" dirty="0"/>
           </a:p>
@@ -28860,7 +32705,7 @@
                   <a:schemeClr val="accent6"/>
                 </a:solidFill>
               </a:rPr>
-              <a:t>Windows Server et Active Directory : la référence pour gérer les postes d'une entreprise.</a:t>
+              <a:t>Windows Server est utilisé par de très nombreuses entreprises : c'est une valeur sûre.</a:t>
             </a:r>
             <a:endParaRPr lang="en-US" sz="1500" dirty="0"/>
           </a:p>
@@ -28981,7 +32826,7 @@
                   <a:schemeClr val="accent6"/>
                 </a:solidFill>
               </a:rPr>
-              <a:t>Proxmox VE et Tailscale sont gratuits : aucun abonnement mensuel à prévoir.</a:t>
+              <a:t>Proxmox et Tailscale sont gratuits : rien à payer chaque mois.</a:t>
             </a:r>
             <a:endParaRPr lang="en-US" sz="1500" dirty="0"/>
           </a:p>
@@ -30209,7 +34054,7 @@
                   <a:schemeClr val="accent6"/>
                 </a:solidFill>
               </a:rPr>
-              <a:t>Installation du serveur et de Proxmox VE</a:t>
+              <a:t>Installation et préparation du serveur</a:t>
             </a:r>
             <a:endParaRPr lang="en-US" sz="1400" dirty="0"/>
           </a:p>
@@ -30400,7 +34245,7 @@
                   <a:schemeClr val="accent6"/>
                 </a:solidFill>
               </a:rPr>
-              <a:t>Active Directory, DNS et DHCP</a:t>
+              <a:t>Création des comptes des employés</a:t>
             </a:r>
             <a:endParaRPr lang="en-US" sz="1400" dirty="0"/>
           </a:p>
@@ -30591,7 +34436,7 @@
                   <a:schemeClr val="accent6"/>
                 </a:solidFill>
               </a:rPr>
-              <a:t>GPO sur mesure : mots de passe, mises à jour, restrictions</a:t>
+              <a:t>Règles automatiques : mots de passe, mises à jour, interdictions</a:t>
             </a:r>
             <a:endParaRPr lang="en-US" sz="1400" dirty="0"/>
           </a:p>
@@ -30782,7 +34627,7 @@
                   <a:schemeClr val="accent6"/>
                 </a:solidFill>
               </a:rPr>
-              <a:t>Intégration de chaque poste au domaine</a:t>
+              <a:t>Chaque ordinateur relié au serveur</a:t>
             </a:r>
             <a:endParaRPr lang="en-US" sz="1400" dirty="0"/>
           </a:p>
@@ -30973,7 +34818,7 @@
                   <a:schemeClr val="accent6"/>
                 </a:solidFill>
               </a:rPr>
-              <a:t>Tailscale configuré et prise en main</a:t>
+              <a:t>Connexion à distance pour l'administrateur</a:t>
             </a:r>
             <a:endParaRPr lang="en-US" sz="1400" dirty="0"/>
           </a:p>

</xml_diff>